<commit_message>
Harden public workshop for reuse
Remove personal metadata, standardize safe examples, clarify security guidance, and exclude local deployment artifacts.

Co-authored-by: Copilot <223556219+Copilot@users.noreply.github.com>
Copilot-Session: 8c02ba17-1398-4d94-b9f2-71766e81e382
</commit_message>
<xml_diff>
--- a/docs/foundry-apim-mcp-workshop.pptx
+++ b/docs/foundry-apim-mcp-workshop.pptx
@@ -1,6 +1,6 @@
 
 <file path=ppt/presentation.xml><?xml version="1.0" encoding="utf-8"?>
-<p:presentation xmlns:a="http://schemas.openxmlformats.org/drawingml/2006/main" xmlns:r="http://schemas.openxmlformats.org/officeDocument/2006/relationships" xmlns:p="http://schemas.openxmlformats.org/presentationml/2006/main" saveSubsetFonts="1" autoCompressPictures="0">
+<p:presentation xmlns:a="http://schemas.openxmlformats.org/drawingml/2006/main" xmlns:r="http://schemas.openxmlformats.org/officeDocument/2006/relationships" xmlns:p="http://schemas.openxmlformats.org/presentationml/2006/main" removePersonalInfoOnSave="1" saveSubsetFonts="1" autoCompressPictures="0">
   <p:sldMasterIdLst>
     <p:sldMasterId id="2147483648" r:id="rId1"/>
   </p:sldMasterIdLst>
@@ -2182,7 +2182,7 @@
           </a:prstGeom>
           <a:extLst>
             <a:ext uri="{C572A759-6A51-4108-AA02-DFA0A04FC94B}">
-              <ma14:wrappingTextBoxFlag xmlns:ma14="http://schemas.microsoft.com/office/mac/drawingml/2011/main" xmlns="" val="0"/>
+              <ma14:wrappingTextBoxFlag xmlns="" xmlns:ma14="http://schemas.microsoft.com/office/mac/drawingml/2011/main" val="0"/>
             </a:ext>
           </a:extLst>
         </p:spPr>
@@ -2260,7 +2260,7 @@
           </a:prstGeom>
           <a:extLst>
             <a:ext uri="{C572A759-6A51-4108-AA02-DFA0A04FC94B}">
-              <ma14:wrappingTextBoxFlag xmlns:ma14="http://schemas.microsoft.com/office/mac/drawingml/2011/main" xmlns="" val="0"/>
+              <ma14:wrappingTextBoxFlag xmlns="" xmlns:ma14="http://schemas.microsoft.com/office/mac/drawingml/2011/main" val="0"/>
             </a:ext>
           </a:extLst>
         </p:spPr>
@@ -4606,7 +4606,7 @@
           </a:prstGeom>
           <a:extLst>
             <a:ext uri="{C572A759-6A51-4108-AA02-DFA0A04FC94B}">
-              <ma14:wrappingTextBoxFlag xmlns:ma14="http://schemas.microsoft.com/office/mac/drawingml/2011/main" xmlns="" val="0"/>
+              <ma14:wrappingTextBoxFlag xmlns="" xmlns:ma14="http://schemas.microsoft.com/office/mac/drawingml/2011/main" val="0"/>
             </a:ext>
           </a:extLst>
         </p:spPr>
@@ -5498,7 +5498,7 @@
           </a:prstGeom>
           <a:extLst>
             <a:ext uri="{C572A759-6A51-4108-AA02-DFA0A04FC94B}">
-              <ma14:wrappingTextBoxFlag xmlns:ma14="http://schemas.microsoft.com/office/mac/drawingml/2011/main" xmlns="" val="0"/>
+              <ma14:wrappingTextBoxFlag xmlns="" xmlns:ma14="http://schemas.microsoft.com/office/mac/drawingml/2011/main" val="0"/>
             </a:ext>
           </a:extLst>
         </p:spPr>
@@ -6462,7 +6462,7 @@
           </a:prstGeom>
           <a:extLst>
             <a:ext uri="{C572A759-6A51-4108-AA02-DFA0A04FC94B}">
-              <ma14:wrappingTextBoxFlag xmlns:ma14="http://schemas.microsoft.com/office/mac/drawingml/2011/main" xmlns="" val="0"/>
+              <ma14:wrappingTextBoxFlag xmlns="" xmlns:ma14="http://schemas.microsoft.com/office/mac/drawingml/2011/main" val="0"/>
             </a:ext>
           </a:extLst>
         </p:spPr>
@@ -7611,7 +7611,7 @@
           </a:prstGeom>
           <a:extLst>
             <a:ext uri="{C572A759-6A51-4108-AA02-DFA0A04FC94B}">
-              <ma14:wrappingTextBoxFlag xmlns:ma14="http://schemas.microsoft.com/office/mac/drawingml/2011/main" xmlns="" val="0"/>
+              <ma14:wrappingTextBoxFlag xmlns="" xmlns:ma14="http://schemas.microsoft.com/office/mac/drawingml/2011/main" val="0"/>
             </a:ext>
           </a:extLst>
         </p:spPr>
@@ -8852,7 +8852,7 @@
           </a:prstGeom>
           <a:extLst>
             <a:ext uri="{C572A759-6A51-4108-AA02-DFA0A04FC94B}">
-              <ma14:wrappingTextBoxFlag xmlns:ma14="http://schemas.microsoft.com/office/mac/drawingml/2011/main" xmlns="" val="0"/>
+              <ma14:wrappingTextBoxFlag xmlns="" xmlns:ma14="http://schemas.microsoft.com/office/mac/drawingml/2011/main" val="0"/>
             </a:ext>
           </a:extLst>
         </p:spPr>
@@ -9741,7 +9741,7 @@
           </a:prstGeom>
           <a:extLst>
             <a:ext uri="{C572A759-6A51-4108-AA02-DFA0A04FC94B}">
-              <ma14:wrappingTextBoxFlag xmlns:ma14="http://schemas.microsoft.com/office/mac/drawingml/2011/main" xmlns="" val="0"/>
+              <ma14:wrappingTextBoxFlag xmlns="" xmlns:ma14="http://schemas.microsoft.com/office/mac/drawingml/2011/main" val="0"/>
             </a:ext>
           </a:extLst>
         </p:spPr>
@@ -10708,7 +10708,7 @@
           </a:prstGeom>
           <a:extLst>
             <a:ext uri="{C572A759-6A51-4108-AA02-DFA0A04FC94B}">
-              <ma14:wrappingTextBoxFlag xmlns:ma14="http://schemas.microsoft.com/office/mac/drawingml/2011/main" xmlns="" val="0"/>
+              <ma14:wrappingTextBoxFlag xmlns="" xmlns:ma14="http://schemas.microsoft.com/office/mac/drawingml/2011/main" val="0"/>
             </a:ext>
           </a:extLst>
         </p:spPr>
@@ -12145,7 +12145,7 @@
           </a:prstGeom>
           <a:extLst>
             <a:ext uri="{C572A759-6A51-4108-AA02-DFA0A04FC94B}">
-              <ma14:wrappingTextBoxFlag xmlns:ma14="http://schemas.microsoft.com/office/mac/drawingml/2011/main" xmlns="" val="0"/>
+              <ma14:wrappingTextBoxFlag xmlns="" xmlns:ma14="http://schemas.microsoft.com/office/mac/drawingml/2011/main" val="0"/>
             </a:ext>
           </a:extLst>
         </p:spPr>
@@ -13275,7 +13275,7 @@
           </a:prstGeom>
           <a:extLst>
             <a:ext uri="{C572A759-6A51-4108-AA02-DFA0A04FC94B}">
-              <ma14:wrappingTextBoxFlag xmlns:ma14="http://schemas.microsoft.com/office/mac/drawingml/2011/main" xmlns="" val="0"/>
+              <ma14:wrappingTextBoxFlag xmlns="" xmlns:ma14="http://schemas.microsoft.com/office/mac/drawingml/2011/main" val="0"/>
             </a:ext>
           </a:extLst>
         </p:spPr>
@@ -14750,7 +14750,7 @@
           </a:prstGeom>
           <a:extLst>
             <a:ext uri="{C572A759-6A51-4108-AA02-DFA0A04FC94B}">
-              <ma14:wrappingTextBoxFlag xmlns:ma14="http://schemas.microsoft.com/office/mac/drawingml/2011/main" xmlns="" val="0"/>
+              <ma14:wrappingTextBoxFlag xmlns="" xmlns:ma14="http://schemas.microsoft.com/office/mac/drawingml/2011/main" val="0"/>
             </a:ext>
           </a:extLst>
         </p:spPr>
@@ -15847,7 +15847,7 @@
           </a:prstGeom>
           <a:extLst>
             <a:ext uri="{C572A759-6A51-4108-AA02-DFA0A04FC94B}">
-              <ma14:wrappingTextBoxFlag xmlns:ma14="http://schemas.microsoft.com/office/mac/drawingml/2011/main" xmlns="" val="0"/>
+              <ma14:wrappingTextBoxFlag xmlns="" xmlns:ma14="http://schemas.microsoft.com/office/mac/drawingml/2011/main" val="0"/>
             </a:ext>
           </a:extLst>
         </p:spPr>
@@ -16948,7 +16948,7 @@
           </a:prstGeom>
           <a:extLst>
             <a:ext uri="{C572A759-6A51-4108-AA02-DFA0A04FC94B}">
-              <ma14:wrappingTextBoxFlag xmlns:ma14="http://schemas.microsoft.com/office/mac/drawingml/2011/main" xmlns="" val="0"/>
+              <ma14:wrappingTextBoxFlag xmlns="" xmlns:ma14="http://schemas.microsoft.com/office/mac/drawingml/2011/main" val="0"/>
             </a:ext>
           </a:extLst>
         </p:spPr>
@@ -17726,9 +17726,7 @@
       </p:sp>
       <p:sp>
         <p:nvSpPr>
-          <p:cNvPr id="23" name="Text 17">
-            <a:hlinkClick r:id="rId7"/>
-          </p:cNvPr>
+          <p:cNvPr id="23" name="Text 17"/>
           <p:cNvSpPr/>
           <p:nvPr/>
         </p:nvSpPr>
@@ -17751,22 +17749,15 @@
               <a:buNone/>
             </a:pPr>
             <a:r>
-              <a:rPr lang="en-US" sz="1050" u="sng" dirty="0">
+              <a:rPr lang="en-US" sz="1050" u="sng">
                 <a:solidFill>
                   <a:srgbClr val="5BD6C5"/>
                 </a:solidFill>
                 <a:latin typeface="Consolas" pitchFamily="34" charset="0"/>
                 <a:ea typeface="Consolas" pitchFamily="34" charset="-122"/>
                 <a:cs typeface="Consolas" pitchFamily="34" charset="-120"/>
-                <a:hlinkClick r:id="rId7">
-                  <a:extLst>
-                    <a:ext uri="{A12FA001-AC4F-418D-AE19-62706E023703}">
-                      <ahyp:hlinkClr xmlns:ahyp="http://schemas.microsoft.com/office/drawing/2018/hyperlinkcolor" val="tx"/>
-                    </a:ext>
-                  </a:extLst>
-                </a:hlinkClick>
-              </a:rPr>
-              <a:t>github.com/yurilausberg/foundry-apim-mcp-workshop</a:t>
+              </a:rPr>
+              <a:t>Open the repository README for workshop files</a:t>
             </a:r>
             <a:endParaRPr lang="en-US" sz="1050" dirty="0"/>
           </a:p>
@@ -19277,7 +19268,7 @@
           </a:prstGeom>
           <a:extLst>
             <a:ext uri="{C572A759-6A51-4108-AA02-DFA0A04FC94B}">
-              <ma14:wrappingTextBoxFlag xmlns:ma14="http://schemas.microsoft.com/office/mac/drawingml/2011/main" xmlns="" val="0"/>
+              <ma14:wrappingTextBoxFlag xmlns="" xmlns:ma14="http://schemas.microsoft.com/office/mac/drawingml/2011/main" val="0"/>
             </a:ext>
           </a:extLst>
         </p:spPr>
@@ -21599,7 +21590,7 @@
           </a:prstGeom>
           <a:extLst>
             <a:ext uri="{C572A759-6A51-4108-AA02-DFA0A04FC94B}">
-              <ma14:wrappingTextBoxFlag xmlns:ma14="http://schemas.microsoft.com/office/mac/drawingml/2011/main" xmlns="" val="0"/>
+              <ma14:wrappingTextBoxFlag xmlns="" xmlns:ma14="http://schemas.microsoft.com/office/mac/drawingml/2011/main" val="0"/>
             </a:ext>
           </a:extLst>
         </p:spPr>
@@ -22624,7 +22615,7 @@
           </a:prstGeom>
           <a:extLst>
             <a:ext uri="{C572A759-6A51-4108-AA02-DFA0A04FC94B}">
-              <ma14:wrappingTextBoxFlag xmlns:ma14="http://schemas.microsoft.com/office/mac/drawingml/2011/main" xmlns="" val="0"/>
+              <ma14:wrappingTextBoxFlag xmlns="" xmlns:ma14="http://schemas.microsoft.com/office/mac/drawingml/2011/main" val="0"/>
             </a:ext>
           </a:extLst>
         </p:spPr>
@@ -23709,7 +23700,7 @@
           </a:prstGeom>
           <a:extLst>
             <a:ext uri="{C572A759-6A51-4108-AA02-DFA0A04FC94B}">
-              <ma14:wrappingTextBoxFlag xmlns:ma14="http://schemas.microsoft.com/office/mac/drawingml/2011/main" xmlns="" val="0"/>
+              <ma14:wrappingTextBoxFlag xmlns="" xmlns:ma14="http://schemas.microsoft.com/office/mac/drawingml/2011/main" val="0"/>
             </a:ext>
           </a:extLst>
         </p:spPr>
@@ -25036,7 +25027,7 @@
           </a:prstGeom>
           <a:extLst>
             <a:ext uri="{C572A759-6A51-4108-AA02-DFA0A04FC94B}">
-              <ma14:wrappingTextBoxFlag xmlns:ma14="http://schemas.microsoft.com/office/mac/drawingml/2011/main" xmlns="" val="0"/>
+              <ma14:wrappingTextBoxFlag xmlns="" xmlns:ma14="http://schemas.microsoft.com/office/mac/drawingml/2011/main" val="0"/>
             </a:ext>
           </a:extLst>
         </p:spPr>
@@ -25974,7 +25965,7 @@
           </a:prstGeom>
           <a:extLst>
             <a:ext uri="{C572A759-6A51-4108-AA02-DFA0A04FC94B}">
-              <ma14:wrappingTextBoxFlag xmlns:ma14="http://schemas.microsoft.com/office/mac/drawingml/2011/main" xmlns="" val="0"/>
+              <ma14:wrappingTextBoxFlag xmlns="" xmlns:ma14="http://schemas.microsoft.com/office/mac/drawingml/2011/main" val="0"/>
             </a:ext>
           </a:extLst>
         </p:spPr>
@@ -27313,7 +27304,7 @@
           </a:prstGeom>
           <a:extLst>
             <a:ext uri="{C572A759-6A51-4108-AA02-DFA0A04FC94B}">
-              <ma14:wrappingTextBoxFlag xmlns:ma14="http://schemas.microsoft.com/office/mac/drawingml/2011/main" xmlns="" val="0"/>
+              <ma14:wrappingTextBoxFlag xmlns="" xmlns:ma14="http://schemas.microsoft.com/office/mac/drawingml/2011/main" val="0"/>
             </a:ext>
           </a:extLst>
         </p:spPr>
@@ -27957,10 +27948,4 @@
     </a:ext>
   </a:extLst>
 </a:theme>
-</file>
-
-<file path=docMetadata/LabelInfo.xml><?xml version="1.0" encoding="utf-8"?>
-<clbl:labelList xmlns:clbl="http://schemas.microsoft.com/office/2020/mipLabelMetadata">
-  <clbl:label id="{f42aa342-8706-4288-bd11-ebb85995028c}" enabled="1" method="Standard" siteId="{72f988bf-86f1-41af-91ab-2d7cd011db47}" contentBits="0" removed="0"/>
-</clbl:labelList>
 </file>
</xml_diff>

<commit_message>
Frame Agent 365 governance in Lab 5
Show Agent 365 as the enterprise governance plane around the workshop's runtime controls and document the enablement and telemetry requirements.

Co-authored-by: Copilot <223556219+Copilot@users.noreply.github.com>
Copilot-Session: 8c02ba17-1398-4d94-b9f2-71766e81e382
</commit_message>
<xml_diff>
--- a/docs/foundry-apim-mcp-workshop.pptx
+++ b/docs/foundry-apim-mcp-workshop.pptx
@@ -824,9 +824,10 @@
           <a:lstStyle/>
           <a:p>
             <a:r>
-              <a:rPr lang="en-US" dirty="0"/>
-              <a:t>Walk from outside to inside. Identity determines who connects. APIM enforces gateway controls. The agent limits tools and asks for approval. Operations teams monitor and respond.</a:t>
-            </a:r>
+              <a:rPr lang="en-US"/>
+              <a:t>Walk from outside to inside. Identity determines who connects. APIM enforces gateway controls. The agent limits tools and asks for approval. Operations teams monitor and respond. The surrounding Microsoft Agent 365 plane adds enterprise inventory, ownership, identity, lifecycle, security, and compliance when it is enabled. It complements these runtime controls rather than replacing them. Published Foundry agents appear in the Agent 365 registry automatically. Activity ingestion and broader security and compliance features require tenant licensing and administrator enablement. Hosted-agent telemetry also requires the Agent 365 SDK and Microsoft Entra permissions.</a:t>
+            </a:r>
+            <a:endParaRPr lang="en-US" dirty="0"/>
           </a:p>
         </p:txBody>
       </p:sp>
@@ -8907,6 +8908,70 @@
       </p:grpSpPr>
       <p:sp>
         <p:nvSpPr>
+          <p:cNvPr id="26" name="Agent 365 Governance Plane">
+            <a:extLst>
+              <a:ext uri="{FF2B5EF4-FFF2-40B4-BE49-F238E27FC236}">
+                <a16:creationId xmlns:a16="http://schemas.microsoft.com/office/drawing/2014/main" id="{10E64F1C-3642-248B-50DC-BD5AEFE18076}"/>
+              </a:ext>
+            </a:extLst>
+          </p:cNvPr>
+          <p:cNvSpPr/>
+          <p:nvPr/>
+        </p:nvSpPr>
+        <p:spPr>
+          <a:xfrm>
+            <a:off x="736600" y="1600200"/>
+            <a:ext cx="10718800" cy="3543300"/>
+          </a:xfrm>
+          <a:prstGeom prst="roundRect">
+            <a:avLst/>
+          </a:prstGeom>
+          <a:noFill/>
+          <a:ln w="22225" cap="flat" cmpd="sng" algn="ctr">
+            <a:solidFill>
+              <a:srgbClr val="7B5FA3"/>
+            </a:solidFill>
+            <a:prstDash val="solid"/>
+            <a:miter lim="800000"/>
+          </a:ln>
+          <a:effectLst/>
+          <a:extLst>
+            <a:ext uri="{909E8E84-426E-40DD-AFC4-6F175D3DCCD1}">
+              <a14:hiddenFill xmlns:a14="http://schemas.microsoft.com/office/drawing/2010/main">
+                <a:solidFill>
+                  <a:schemeClr val="accent1"/>
+                </a:solidFill>
+              </a14:hiddenFill>
+            </a:ext>
+          </a:extLst>
+        </p:spPr>
+        <p:style>
+          <a:lnRef idx="2">
+            <a:schemeClr val="accent1">
+              <a:shade val="15000"/>
+            </a:schemeClr>
+          </a:lnRef>
+          <a:fillRef idx="1">
+            <a:schemeClr val="accent1"/>
+          </a:fillRef>
+          <a:effectRef idx="0">
+            <a:schemeClr val="accent1"/>
+          </a:effectRef>
+          <a:fontRef idx="minor">
+            <a:schemeClr val="lt1"/>
+          </a:fontRef>
+        </p:style>
+        <p:txBody>
+          <a:bodyPr rtlCol="0" anchor="ctr"/>
+          <a:lstStyle/>
+          <a:p>
+            <a:pPr algn="ctr"/>
+            <a:endParaRPr lang="en-US"/>
+          </a:p>
+        </p:txBody>
+      </p:sp>
+      <p:sp>
+        <p:nvSpPr>
           <p:cNvPr id="2" name="Text 0"/>
           <p:cNvSpPr/>
           <p:nvPr/>
@@ -9012,7 +9077,7 @@
               <a:buNone/>
             </a:pPr>
             <a:r>
-              <a:rPr lang="en-US" sz="1250" dirty="0">
+              <a:rPr lang="en-US" sz="1250">
                 <a:solidFill>
                   <a:srgbClr val="4F6474"/>
                 </a:solidFill>
@@ -9020,7 +9085,29 @@
                 <a:ea typeface="Aptos" pitchFamily="34" charset="-122"/>
                 <a:cs typeface="Aptos" pitchFamily="34" charset="-120"/>
               </a:rPr>
-              <a:t> No single control answers every question. Use defense in depth with clear ownership.</a:t>
+              <a:t>Use defense in depth. When enabled, </a:t>
+            </a:r>
+            <a:r>
+              <a:rPr lang="en-US" sz="1250" b="1">
+                <a:solidFill>
+                  <a:srgbClr val="7B5FA3"/>
+                </a:solidFill>
+                <a:latin typeface="Aptos" pitchFamily="34" charset="0"/>
+                <a:ea typeface="Aptos" pitchFamily="34" charset="-122"/>
+                <a:cs typeface="Aptos" pitchFamily="34" charset="-120"/>
+              </a:rPr>
+              <a:t>Agent 365</a:t>
+            </a:r>
+            <a:r>
+              <a:rPr lang="en-US" sz="1250">
+                <a:solidFill>
+                  <a:srgbClr val="4F6474"/>
+                </a:solidFill>
+                <a:latin typeface="Aptos" pitchFamily="34" charset="0"/>
+                <a:ea typeface="Aptos" pitchFamily="34" charset="-122"/>
+                <a:cs typeface="Aptos" pitchFamily="34" charset="-120"/>
+              </a:rPr>
+              <a:t> adds an enterprise governance plane around these runtime controls.</a:t>
             </a:r>
             <a:endParaRPr lang="en-US" sz="1250" dirty="0"/>
           </a:p>
@@ -9539,7 +9626,7 @@
               <a:buNone/>
             </a:pPr>
             <a:r>
-              <a:rPr lang="en-US" sz="1350" b="1" dirty="0">
+              <a:rPr lang="en-US" sz="1350" b="1">
                 <a:solidFill>
                   <a:srgbClr val="102A43"/>
                 </a:solidFill>
@@ -9572,7 +9659,7 @@
         </p:spPr>
         <p:txBody>
           <a:bodyPr wrap="square" lIns="0" tIns="0" rIns="0" bIns="0" rtlCol="0" anchor="ctr">
-            <a:normAutofit/>
+            <a:noAutofit/>
           </a:bodyPr>
           <a:lstStyle/>
           <a:p>
@@ -9580,7 +9667,7 @@
               <a:buNone/>
             </a:pPr>
             <a:r>
-              <a:rPr lang="en-US" sz="930" dirty="0">
+              <a:rPr lang="en-US" sz="930">
                 <a:solidFill>
                   <a:srgbClr val="102A43"/>
                 </a:solidFill>
@@ -9611,7 +9698,7 @@
           <a:noFill/>
           <a:ln w="19050">
             <a:solidFill>
-              <a:srgbClr val="748494"/>
+              <a:srgbClr val="12304A"/>
             </a:solidFill>
             <a:prstDash val="solid"/>
             <a:tailEnd type="triangle"/>
@@ -9707,7 +9794,7 @@
               <a:buNone/>
             </a:pPr>
             <a:r>
-              <a:rPr lang="en-US" sz="750" dirty="0">
+              <a:rPr lang="en-US" sz="750">
                 <a:solidFill>
                   <a:srgbClr val="748494"/>
                 </a:solidFill>
@@ -9766,6 +9853,82 @@
               <a:t>15</a:t>
             </a:fld>
             <a:endParaRPr lang="en-US"/>
+          </a:p>
+        </p:txBody>
+      </p:sp>
+      <p:sp>
+        <p:nvSpPr>
+          <p:cNvPr id="27" name="Agent 365 Governance Label">
+            <a:extLst>
+              <a:ext uri="{FF2B5EF4-FFF2-40B4-BE49-F238E27FC236}">
+                <a16:creationId xmlns:a16="http://schemas.microsoft.com/office/drawing/2014/main" id="{FEF5108F-78D9-4AE1-EB21-75FB3C72645D}"/>
+              </a:ext>
+            </a:extLst>
+          </p:cNvPr>
+          <p:cNvSpPr/>
+          <p:nvPr/>
+        </p:nvSpPr>
+        <p:spPr>
+          <a:xfrm>
+            <a:off x="8255000" y="1460500"/>
+            <a:ext cx="3048000" cy="279400"/>
+          </a:xfrm>
+          <a:prstGeom prst="roundRect">
+            <a:avLst/>
+          </a:prstGeom>
+          <a:solidFill>
+            <a:srgbClr val="7B5FA3"/>
+          </a:solidFill>
+          <a:ln w="12700" cap="flat" cmpd="sng" algn="ctr">
+            <a:noFill/>
+            <a:prstDash val="solid"/>
+            <a:miter lim="800000"/>
+          </a:ln>
+          <a:effectLst/>
+          <a:extLst>
+            <a:ext uri="{91240B29-F687-4F45-9708-019B960494DF}">
+              <a14:hiddenLine xmlns:a14="http://schemas.microsoft.com/office/drawing/2010/main" w="12700" cap="flat" cmpd="sng" algn="ctr">
+                <a:solidFill>
+                  <a:schemeClr val="accent1">
+                    <a:shade val="15000"/>
+                  </a:schemeClr>
+                </a:solidFill>
+                <a:prstDash val="solid"/>
+                <a:miter lim="800000"/>
+              </a14:hiddenLine>
+            </a:ext>
+          </a:extLst>
+        </p:spPr>
+        <p:style>
+          <a:lnRef idx="2">
+            <a:schemeClr val="accent1">
+              <a:shade val="15000"/>
+            </a:schemeClr>
+          </a:lnRef>
+          <a:fillRef idx="1">
+            <a:schemeClr val="accent1"/>
+          </a:fillRef>
+          <a:effectRef idx="0">
+            <a:schemeClr val="accent1"/>
+          </a:effectRef>
+          <a:fontRef idx="minor">
+            <a:schemeClr val="lt1"/>
+          </a:fontRef>
+        </p:style>
+        <p:txBody>
+          <a:bodyPr lIns="50800" tIns="12700" rIns="50800" bIns="12700" rtlCol="0" anchor="ctr"/>
+          <a:lstStyle/>
+          <a:p>
+            <a:pPr algn="ctr"/>
+            <a:r>
+              <a:rPr lang="en-US" sz="850" b="1">
+                <a:solidFill>
+                  <a:srgbClr val="FFFFFF"/>
+                </a:solidFill>
+                <a:latin typeface="Aptos" panose="020B0004020202020204" pitchFamily="34" charset="0"/>
+              </a:rPr>
+              <a:t>AGENT 365 ENTERPRISE GOVERNANCE</a:t>
+            </a:r>
           </a:p>
         </p:txBody>
       </p:sp>

</xml_diff>

<commit_message>
Clarify bearer token and OAuth flow
Distinguish the token presented to APIM from manual and client-managed OAuth acquisition, including Authorization Code with PKCE.

Co-authored-by: Copilot <223556219+Copilot@users.noreply.github.com>
Copilot-Session: 8c02ba17-1398-4d94-b9f2-71766e81e382
</commit_message>
<xml_diff>
--- a/docs/foundry-apim-mcp-workshop.pptx
+++ b/docs/foundry-apim-mcp-workshop.pptx
@@ -912,9 +912,10 @@
           <a:lstStyle/>
           <a:p>
             <a:r>
-              <a:rPr lang="en-US" dirty="0"/>
-              <a:t>This is the most important identity caveat. Validating a bearer token at APIM is useful, but it is not the complete MCP OAuth experience. Discovery and compatible client registration still matter.</a:t>
-            </a:r>
+              <a:rPr lang="en-US"/>
+              <a:t>Bearer is the token presentation method, not an alternative to OAuth. Both authenticated paths send the delegated access token in the Authorization header, and APIM validates the same issuer, audience, client, and scope claims. The middle card is manual token injection for a one-time test. The right card is client-managed MCP OAuth, which uses protected-resource metadata, a 401 challenge, compatible client registration, Authorization Code with PKCE, consent, token caching, and refresh.</a:t>
+            </a:r>
+            <a:endParaRPr lang="en-US" dirty="0"/>
           </a:p>
         </p:txBody>
       </p:sp>
@@ -10023,7 +10024,7 @@
               <a:buNone/>
             </a:pPr>
             <a:r>
-              <a:rPr lang="en-US" sz="2700" b="1" dirty="0">
+              <a:rPr lang="en-US" sz="2700" b="1">
                 <a:solidFill>
                   <a:srgbClr val="102A43"/>
                 </a:solidFill>
@@ -10031,7 +10032,7 @@
                 <a:ea typeface="Aptos Display" pitchFamily="34" charset="-122"/>
                 <a:cs typeface="Aptos Display" pitchFamily="34" charset="-120"/>
               </a:rPr>
-              <a:t>Start simple, then add delegated access deliberately</a:t>
+              <a:t>Choose how the client obtains the delegated access token</a:t>
             </a:r>
             <a:endParaRPr lang="en-US" sz="2700" dirty="0"/>
           </a:p>
@@ -10064,7 +10065,7 @@
               <a:buNone/>
             </a:pPr>
             <a:r>
-              <a:rPr lang="en-US" sz="1250" dirty="0">
+              <a:rPr lang="en-US" sz="1250">
                 <a:solidFill>
                   <a:srgbClr val="4F6474"/>
                 </a:solidFill>
@@ -10072,7 +10073,51 @@
                 <a:ea typeface="Aptos" pitchFamily="34" charset="-122"/>
                 <a:cs typeface="Aptos" pitchFamily="34" charset="-120"/>
               </a:rPr>
-              <a:t> The workshop baseline focuses on the tool flow. Production identity requires client, API, scope, and discovery design.</a:t>
+              <a:t>Both authenticated paths send the </a:t>
+            </a:r>
+            <a:r>
+              <a:rPr lang="en-US" sz="1250" b="1">
+                <a:solidFill>
+                  <a:srgbClr val="4F8BEF"/>
+                </a:solidFill>
+                <a:latin typeface="Aptos" pitchFamily="34" charset="0"/>
+                <a:ea typeface="Aptos" pitchFamily="34" charset="-122"/>
+                <a:cs typeface="Aptos" pitchFamily="34" charset="-120"/>
+              </a:rPr>
+              <a:t>same bearer token</a:t>
+            </a:r>
+            <a:r>
+              <a:rPr lang="en-US" sz="1250">
+                <a:solidFill>
+                  <a:srgbClr val="4F6474"/>
+                </a:solidFill>
+                <a:latin typeface="Aptos" pitchFamily="34" charset="0"/>
+                <a:ea typeface="Aptos" pitchFamily="34" charset="-122"/>
+                <a:cs typeface="Aptos" pitchFamily="34" charset="-120"/>
+              </a:rPr>
+              <a:t>. </a:t>
+            </a:r>
+            <a:r>
+              <a:rPr lang="en-US" sz="1250" b="1">
+                <a:solidFill>
+                  <a:srgbClr val="7B5FA3"/>
+                </a:solidFill>
+                <a:latin typeface="Aptos" pitchFamily="34" charset="0"/>
+                <a:ea typeface="Aptos" pitchFamily="34" charset="-122"/>
+                <a:cs typeface="Aptos" pitchFamily="34" charset="-120"/>
+              </a:rPr>
+              <a:t>OAuth + PKCE</a:t>
+            </a:r>
+            <a:r>
+              <a:rPr lang="en-US" sz="1250">
+                <a:solidFill>
+                  <a:srgbClr val="4F6474"/>
+                </a:solidFill>
+                <a:latin typeface="Aptos" pitchFamily="34" charset="0"/>
+                <a:ea typeface="Aptos" pitchFamily="34" charset="-122"/>
+                <a:cs typeface="Aptos" pitchFamily="34" charset="-120"/>
+              </a:rPr>
+              <a:t> handles discovery, sign-in, consent, and token lifecycle.</a:t>
             </a:r>
             <a:endParaRPr lang="en-US" sz="1250" dirty="0"/>
           </a:p>
@@ -10238,7 +10283,7 @@
               <a:buNone/>
             </a:pPr>
             <a:r>
-              <a:rPr lang="en-US" sz="1050" dirty="0">
+              <a:rPr lang="en-US" sz="1050">
                 <a:solidFill>
                   <a:srgbClr val="4F6474"/>
                 </a:solidFill>
@@ -10246,9 +10291,8 @@
                 <a:ea typeface="Aptos" pitchFamily="34" charset="-122"/>
                 <a:cs typeface="Aptos" pitchFamily="34" charset="-120"/>
               </a:rPr>
-              <a:t>Fastest workshop path.</a:t>
-            </a:r>
-            <a:endParaRPr lang="en-US" sz="1050" dirty="0"/>
+              <a:t>No access token or user identity.</a:t>
+            </a:r>
           </a:p>
           <a:p>
             <a:pPr marL="0" indent="0">
@@ -10257,7 +10301,14 @@
               </a:lnSpc>
               <a:buNone/>
             </a:pPr>
-            <a:endParaRPr lang="en-US" sz="1050" dirty="0"/>
+            <a:endParaRPr lang="en-US" sz="1050">
+              <a:solidFill>
+                <a:srgbClr val="4F6474"/>
+              </a:solidFill>
+              <a:latin typeface="Aptos" pitchFamily="34" charset="0"/>
+              <a:ea typeface="Aptos" pitchFamily="34" charset="-122"/>
+              <a:cs typeface="Aptos" pitchFamily="34" charset="-120"/>
+            </a:endParaRPr>
           </a:p>
           <a:p>
             <a:pPr marL="0" indent="0">
@@ -10267,7 +10318,7 @@
               <a:buNone/>
             </a:pPr>
             <a:r>
-              <a:rPr lang="en-US" sz="1050" dirty="0">
+              <a:rPr lang="en-US" sz="1050">
                 <a:solidFill>
                   <a:srgbClr val="4F6474"/>
                 </a:solidFill>
@@ -10275,9 +10326,8 @@
                 <a:ea typeface="Aptos" pitchFamily="34" charset="-122"/>
                 <a:cs typeface="Aptos" pitchFamily="34" charset="-120"/>
               </a:rPr>
-              <a:t>Use correlation, rate limiting, tracing, and a controlled network boundary.</a:t>
-            </a:r>
-            <a:endParaRPr lang="en-US" sz="1050" dirty="0"/>
+              <a:t>Fastest workshop path.</a:t>
+            </a:r>
           </a:p>
           <a:p>
             <a:pPr marL="0" indent="0">
@@ -10286,7 +10336,14 @@
               </a:lnSpc>
               <a:buNone/>
             </a:pPr>
-            <a:endParaRPr lang="en-US" sz="1050" dirty="0"/>
+            <a:endParaRPr lang="en-US" sz="1050">
+              <a:solidFill>
+                <a:srgbClr val="4F6474"/>
+              </a:solidFill>
+              <a:latin typeface="Aptos" pitchFamily="34" charset="0"/>
+              <a:ea typeface="Aptos" pitchFamily="34" charset="-122"/>
+              <a:cs typeface="Aptos" pitchFamily="34" charset="-120"/>
+            </a:endParaRPr>
           </a:p>
           <a:p>
             <a:pPr marL="0" indent="0">
@@ -10296,7 +10353,42 @@
               <a:buNone/>
             </a:pPr>
             <a:r>
-              <a:rPr lang="en-US" sz="1050" dirty="0">
+              <a:rPr lang="en-US" sz="1050">
+                <a:solidFill>
+                  <a:srgbClr val="4F6474"/>
+                </a:solidFill>
+                <a:latin typeface="Aptos" pitchFamily="34" charset="0"/>
+                <a:ea typeface="Aptos" pitchFamily="34" charset="-122"/>
+                <a:cs typeface="Aptos" pitchFamily="34" charset="-120"/>
+              </a:rPr>
+              <a:t>Use correlation, rate limiting, tracing, and a controlled network boundary.</a:t>
+            </a:r>
+          </a:p>
+          <a:p>
+            <a:pPr marL="0" indent="0">
+              <a:lnSpc>
+                <a:spcPct val="95000"/>
+              </a:lnSpc>
+              <a:buNone/>
+            </a:pPr>
+            <a:endParaRPr lang="en-US" sz="1050">
+              <a:solidFill>
+                <a:srgbClr val="4F6474"/>
+              </a:solidFill>
+              <a:latin typeface="Aptos" pitchFamily="34" charset="0"/>
+              <a:ea typeface="Aptos" pitchFamily="34" charset="-122"/>
+              <a:cs typeface="Aptos" pitchFamily="34" charset="-120"/>
+            </a:endParaRPr>
+          </a:p>
+          <a:p>
+            <a:pPr marL="0" indent="0">
+              <a:lnSpc>
+                <a:spcPct val="95000"/>
+              </a:lnSpc>
+              <a:buNone/>
+            </a:pPr>
+            <a:r>
+              <a:rPr lang="en-US" sz="1050">
                 <a:solidFill>
                   <a:srgbClr val="4F6474"/>
                 </a:solidFill>
@@ -10426,7 +10518,7 @@
               <a:buNone/>
             </a:pPr>
             <a:r>
-              <a:rPr lang="en-US" sz="1500" b="1" dirty="0">
+              <a:rPr lang="en-US" sz="1500" b="1">
                 <a:solidFill>
                   <a:srgbClr val="102A43"/>
                 </a:solidFill>
@@ -10434,7 +10526,7 @@
                 <a:ea typeface="Aptos Display" pitchFamily="34" charset="-122"/>
                 <a:cs typeface="Aptos Display" pitchFamily="34" charset="-120"/>
               </a:rPr>
-              <a:t>Bearer token</a:t>
+              <a:t>Manual token injection</a:t>
             </a:r>
             <a:endParaRPr lang="en-US" sz="1500" dirty="0"/>
           </a:p>
@@ -10470,7 +10562,7 @@
               <a:buNone/>
             </a:pPr>
             <a:r>
-              <a:rPr lang="en-US" sz="1050" dirty="0">
+              <a:rPr lang="en-US" sz="1050">
                 <a:solidFill>
                   <a:srgbClr val="4F6474"/>
                 </a:solidFill>
@@ -10478,9 +10570,8 @@
                 <a:ea typeface="Aptos" pitchFamily="34" charset="-122"/>
                 <a:cs typeface="Aptos" pitchFamily="34" charset="-120"/>
               </a:rPr>
-              <a:t>Acquire a token separately and pass it as an HTTP header.</a:t>
-            </a:r>
-            <a:endParaRPr lang="en-US" sz="1050" dirty="0"/>
+              <a:t>Acquire a delegated access token outside the MCP client.</a:t>
+            </a:r>
           </a:p>
           <a:p>
             <a:pPr marL="0" indent="0">
@@ -10489,7 +10580,14 @@
               </a:lnSpc>
               <a:buNone/>
             </a:pPr>
-            <a:endParaRPr lang="en-US" sz="1050" dirty="0"/>
+            <a:endParaRPr lang="en-US" sz="1050">
+              <a:solidFill>
+                <a:srgbClr val="4F6474"/>
+              </a:solidFill>
+              <a:latin typeface="Aptos" pitchFamily="34" charset="0"/>
+              <a:ea typeface="Aptos" pitchFamily="34" charset="-122"/>
+              <a:cs typeface="Aptos" pitchFamily="34" charset="-120"/>
+            </a:endParaRPr>
           </a:p>
           <a:p>
             <a:pPr marL="0" indent="0">
@@ -10499,7 +10597,7 @@
               <a:buNone/>
             </a:pPr>
             <a:r>
-              <a:rPr lang="en-US" sz="1050" dirty="0">
+              <a:rPr lang="en-US" sz="1050">
                 <a:solidFill>
                   <a:srgbClr val="4F6474"/>
                 </a:solidFill>
@@ -10507,7 +10605,42 @@
                 <a:ea typeface="Aptos" pitchFamily="34" charset="-122"/>
                 <a:cs typeface="Aptos" pitchFamily="34" charset="-120"/>
               </a:rPr>
-              <a:t>APIM validates issuer, audience, signature, and delegated scopes.</a:t>
+              <a:t>Send Authorization: Bearer &lt;access-token&gt;.</a:t>
+            </a:r>
+          </a:p>
+          <a:p>
+            <a:pPr marL="0" indent="0">
+              <a:lnSpc>
+                <a:spcPct val="95000"/>
+              </a:lnSpc>
+              <a:buNone/>
+            </a:pPr>
+            <a:endParaRPr lang="en-US" sz="1050">
+              <a:solidFill>
+                <a:srgbClr val="4F6474"/>
+              </a:solidFill>
+              <a:latin typeface="Aptos" pitchFamily="34" charset="0"/>
+              <a:ea typeface="Aptos" pitchFamily="34" charset="-122"/>
+              <a:cs typeface="Aptos" pitchFamily="34" charset="-120"/>
+            </a:endParaRPr>
+          </a:p>
+          <a:p>
+            <a:pPr marL="0" indent="0">
+              <a:lnSpc>
+                <a:spcPct val="95000"/>
+              </a:lnSpc>
+              <a:buNone/>
+            </a:pPr>
+            <a:r>
+              <a:rPr lang="en-US" sz="1050">
+                <a:solidFill>
+                  <a:srgbClr val="4F6474"/>
+                </a:solidFill>
+                <a:latin typeface="Aptos" pitchFamily="34" charset="0"/>
+                <a:ea typeface="Aptos" pitchFamily="34" charset="-122"/>
+                <a:cs typeface="Aptos" pitchFamily="34" charset="-120"/>
+              </a:rPr>
+              <a:t>Useful for one-time validation, not a production sign-in experience.</a:t>
             </a:r>
             <a:endParaRPr lang="en-US" sz="1050" dirty="0"/>
           </a:p>
@@ -10629,7 +10762,7 @@
               <a:buNone/>
             </a:pPr>
             <a:r>
-              <a:rPr lang="en-US" sz="1500" b="1" dirty="0">
+              <a:rPr lang="en-US" sz="1500" b="1">
                 <a:solidFill>
                   <a:srgbClr val="102A43"/>
                 </a:solidFill>
@@ -10637,7 +10770,7 @@
                 <a:ea typeface="Aptos Display" pitchFamily="34" charset="-122"/>
                 <a:cs typeface="Aptos Display" pitchFamily="34" charset="-120"/>
               </a:rPr>
-              <a:t>Full MCP OAuth</a:t>
+              <a:t>Client-managed OAuth</a:t>
             </a:r>
             <a:endParaRPr lang="en-US" sz="1500" dirty="0"/>
           </a:p>
@@ -10673,7 +10806,7 @@
               <a:buNone/>
             </a:pPr>
             <a:r>
-              <a:rPr lang="en-US" sz="1050" dirty="0">
+              <a:rPr lang="en-US" sz="1050">
                 <a:solidFill>
                   <a:srgbClr val="4F6474"/>
                 </a:solidFill>
@@ -10681,9 +10814,8 @@
                 <a:ea typeface="Aptos" pitchFamily="34" charset="-122"/>
                 <a:cs typeface="Aptos" pitchFamily="34" charset="-120"/>
               </a:rPr>
-              <a:t>Add OAuth discovery metadata and a compatible client registration.</a:t>
-            </a:r>
-            <a:endParaRPr lang="en-US" sz="1050" dirty="0"/>
+              <a:t>Discover the protected resource and authorization server.</a:t>
+            </a:r>
           </a:p>
           <a:p>
             <a:pPr marL="0" indent="0">
@@ -10692,7 +10824,14 @@
               </a:lnSpc>
               <a:buNone/>
             </a:pPr>
-            <a:endParaRPr lang="en-US" sz="1050" dirty="0"/>
+            <a:endParaRPr lang="en-US" sz="1050">
+              <a:solidFill>
+                <a:srgbClr val="4F6474"/>
+              </a:solidFill>
+              <a:latin typeface="Aptos" pitchFamily="34" charset="0"/>
+              <a:ea typeface="Aptos" pitchFamily="34" charset="-122"/>
+              <a:cs typeface="Aptos" pitchFamily="34" charset="-120"/>
+            </a:endParaRPr>
           </a:p>
           <a:p>
             <a:pPr marL="0" indent="0">
@@ -10702,7 +10841,7 @@
               <a:buNone/>
             </a:pPr>
             <a:r>
-              <a:rPr lang="en-US" sz="1050" dirty="0">
+              <a:rPr lang="en-US" sz="1050">
                 <a:solidFill>
                   <a:srgbClr val="4F6474"/>
                 </a:solidFill>
@@ -10710,7 +10849,42 @@
                 <a:ea typeface="Aptos" pitchFamily="34" charset="-122"/>
                 <a:cs typeface="Aptos" pitchFamily="34" charset="-120"/>
               </a:rPr>
-              <a:t>Design sign-in, consent, token acquisition, scope mapping, and lifecycle.</a:t>
+              <a:t>Run interactive sign-in and consent with Authorization Code + PKCE.</a:t>
+            </a:r>
+          </a:p>
+          <a:p>
+            <a:pPr marL="0" indent="0">
+              <a:lnSpc>
+                <a:spcPct val="95000"/>
+              </a:lnSpc>
+              <a:buNone/>
+            </a:pPr>
+            <a:endParaRPr lang="en-US" sz="1050">
+              <a:solidFill>
+                <a:srgbClr val="4F6474"/>
+              </a:solidFill>
+              <a:latin typeface="Aptos" pitchFamily="34" charset="0"/>
+              <a:ea typeface="Aptos" pitchFamily="34" charset="-122"/>
+              <a:cs typeface="Aptos" pitchFamily="34" charset="-120"/>
+            </a:endParaRPr>
+          </a:p>
+          <a:p>
+            <a:pPr marL="0" indent="0">
+              <a:lnSpc>
+                <a:spcPct val="95000"/>
+              </a:lnSpc>
+              <a:buNone/>
+            </a:pPr>
+            <a:r>
+              <a:rPr lang="en-US" sz="1050">
+                <a:solidFill>
+                  <a:srgbClr val="4F6474"/>
+                </a:solidFill>
+                <a:latin typeface="Aptos" pitchFamily="34" charset="0"/>
+                <a:ea typeface="Aptos" pitchFamily="34" charset="-122"/>
+                <a:cs typeface="Aptos" pitchFamily="34" charset="-120"/>
+              </a:rPr>
+              <a:t>Cache and refresh tokens in the client.</a:t>
             </a:r>
             <a:endParaRPr lang="en-US" sz="1050" dirty="0"/>
           </a:p>
@@ -10798,7 +10972,7 @@
               <a:buNone/>
             </a:pPr>
             <a:r>
-              <a:rPr lang="en-US" sz="980" b="1" dirty="0">
+              <a:rPr lang="en-US" sz="980" b="1">
                 <a:solidFill>
                   <a:srgbClr val="102A43"/>
                 </a:solidFill>
@@ -10806,7 +10980,7 @@
                 <a:ea typeface="Aptos" pitchFamily="34" charset="-122"/>
                 <a:cs typeface="Aptos" pitchFamily="34" charset="-120"/>
               </a:rPr>
-              <a:t>APIM token validation alone does not provide automatic MCP OAuth discovery or sign-in.</a:t>
+              <a:t>Same bearer token reaches APIM. Only token acquisition, discovery, and lifecycle differ.</a:t>
             </a:r>
             <a:endParaRPr lang="en-US" sz="980" dirty="0"/>
           </a:p>
@@ -10896,6 +11070,234 @@
               <a:t>16</a:t>
             </a:fld>
             <a:endParaRPr lang="en-US"/>
+          </a:p>
+        </p:txBody>
+      </p:sp>
+      <p:sp>
+        <p:nvSpPr>
+          <p:cNvPr id="24" name="OAuth Path Tag 1">
+            <a:extLst>
+              <a:ext uri="{FF2B5EF4-FFF2-40B4-BE49-F238E27FC236}">
+                <a16:creationId xmlns:a16="http://schemas.microsoft.com/office/drawing/2014/main" id="{C7B78730-4FDE-1D1C-57F2-3305EDDD9BEF}"/>
+              </a:ext>
+            </a:extLst>
+          </p:cNvPr>
+          <p:cNvSpPr/>
+          <p:nvPr/>
+        </p:nvSpPr>
+        <p:spPr>
+          <a:xfrm>
+            <a:off x="877570" y="4800600"/>
+            <a:ext cx="1333500" cy="228600"/>
+          </a:xfrm>
+          <a:prstGeom prst="roundRect">
+            <a:avLst/>
+          </a:prstGeom>
+          <a:solidFill>
+            <a:srgbClr val="F7B337"/>
+          </a:solidFill>
+          <a:ln w="12700" cap="flat" cmpd="sng" algn="ctr">
+            <a:noFill/>
+            <a:prstDash val="solid"/>
+            <a:miter lim="800000"/>
+          </a:ln>
+          <a:effectLst/>
+          <a:extLst>
+            <a:ext uri="{91240B29-F687-4F45-9708-019B960494DF}">
+              <a14:hiddenLine xmlns:a14="http://schemas.microsoft.com/office/drawing/2010/main" w="12700" cap="flat" cmpd="sng" algn="ctr">
+                <a:solidFill>
+                  <a:schemeClr val="accent1">
+                    <a:shade val="15000"/>
+                  </a:schemeClr>
+                </a:solidFill>
+                <a:prstDash val="solid"/>
+                <a:miter lim="800000"/>
+              </a14:hiddenLine>
+            </a:ext>
+          </a:extLst>
+        </p:spPr>
+        <p:style>
+          <a:lnRef idx="2">
+            <a:schemeClr val="accent1">
+              <a:shade val="15000"/>
+            </a:schemeClr>
+          </a:lnRef>
+          <a:fillRef idx="1">
+            <a:schemeClr val="accent1"/>
+          </a:fillRef>
+          <a:effectRef idx="0">
+            <a:schemeClr val="accent1"/>
+          </a:effectRef>
+          <a:fontRef idx="minor">
+            <a:schemeClr val="lt1"/>
+          </a:fontRef>
+        </p:style>
+        <p:txBody>
+          <a:bodyPr lIns="38100" tIns="12700" rIns="38100" bIns="12700" rtlCol="0" anchor="ctr"/>
+          <a:lstStyle/>
+          <a:p>
+            <a:pPr algn="ctr"/>
+            <a:r>
+              <a:rPr lang="en-US" sz="750" b="1">
+                <a:solidFill>
+                  <a:srgbClr val="FFFFFF"/>
+                </a:solidFill>
+                <a:latin typeface="Aptos" panose="020B0004020202020204" pitchFamily="34" charset="0"/>
+              </a:rPr>
+              <a:t>UNAUTHENTICATED</a:t>
+            </a:r>
+          </a:p>
+        </p:txBody>
+      </p:sp>
+      <p:sp>
+        <p:nvSpPr>
+          <p:cNvPr id="26" name="OAuth Path Tag 2">
+            <a:extLst>
+              <a:ext uri="{FF2B5EF4-FFF2-40B4-BE49-F238E27FC236}">
+                <a16:creationId xmlns:a16="http://schemas.microsoft.com/office/drawing/2014/main" id="{86006F59-85CC-BF77-14D8-C5DD4D4CE45D}"/>
+              </a:ext>
+            </a:extLst>
+          </p:cNvPr>
+          <p:cNvSpPr/>
+          <p:nvPr/>
+        </p:nvSpPr>
+        <p:spPr>
+          <a:xfrm>
+            <a:off x="4608830" y="4800600"/>
+            <a:ext cx="1117600" cy="228600"/>
+          </a:xfrm>
+          <a:prstGeom prst="roundRect">
+            <a:avLst/>
+          </a:prstGeom>
+          <a:solidFill>
+            <a:srgbClr val="4F8BEF"/>
+          </a:solidFill>
+          <a:ln w="12700" cap="flat" cmpd="sng" algn="ctr">
+            <a:noFill/>
+            <a:prstDash val="solid"/>
+            <a:miter lim="800000"/>
+          </a:ln>
+          <a:effectLst/>
+          <a:extLst>
+            <a:ext uri="{91240B29-F687-4F45-9708-019B960494DF}">
+              <a14:hiddenLine xmlns:a14="http://schemas.microsoft.com/office/drawing/2010/main" w="12700" cap="flat" cmpd="sng" algn="ctr">
+                <a:solidFill>
+                  <a:schemeClr val="accent1">
+                    <a:shade val="15000"/>
+                  </a:schemeClr>
+                </a:solidFill>
+                <a:prstDash val="solid"/>
+                <a:miter lim="800000"/>
+              </a14:hiddenLine>
+            </a:ext>
+          </a:extLst>
+        </p:spPr>
+        <p:style>
+          <a:lnRef idx="2">
+            <a:schemeClr val="accent1">
+              <a:shade val="15000"/>
+            </a:schemeClr>
+          </a:lnRef>
+          <a:fillRef idx="1">
+            <a:schemeClr val="accent1"/>
+          </a:fillRef>
+          <a:effectRef idx="0">
+            <a:schemeClr val="accent1"/>
+          </a:effectRef>
+          <a:fontRef idx="minor">
+            <a:schemeClr val="lt1"/>
+          </a:fontRef>
+        </p:style>
+        <p:txBody>
+          <a:bodyPr lIns="38100" tIns="12700" rIns="38100" bIns="12700" rtlCol="0" anchor="ctr"/>
+          <a:lstStyle/>
+          <a:p>
+            <a:pPr algn="ctr"/>
+            <a:r>
+              <a:rPr lang="en-US" sz="750" b="1">
+                <a:solidFill>
+                  <a:srgbClr val="FFFFFF"/>
+                </a:solidFill>
+                <a:latin typeface="Aptos" panose="020B0004020202020204" pitchFamily="34" charset="0"/>
+              </a:rPr>
+              <a:t>MANUAL TEST</a:t>
+            </a:r>
+          </a:p>
+        </p:txBody>
+      </p:sp>
+      <p:sp>
+        <p:nvSpPr>
+          <p:cNvPr id="27" name="OAuth Path Tag 3">
+            <a:extLst>
+              <a:ext uri="{FF2B5EF4-FFF2-40B4-BE49-F238E27FC236}">
+                <a16:creationId xmlns:a16="http://schemas.microsoft.com/office/drawing/2014/main" id="{1C4CBE42-02A0-ED14-0DC1-5D5FAACA7E1F}"/>
+              </a:ext>
+            </a:extLst>
+          </p:cNvPr>
+          <p:cNvSpPr/>
+          <p:nvPr/>
+        </p:nvSpPr>
+        <p:spPr>
+          <a:xfrm>
+            <a:off x="8338820" y="4800600"/>
+            <a:ext cx="1320800" cy="228600"/>
+          </a:xfrm>
+          <a:prstGeom prst="roundRect">
+            <a:avLst/>
+          </a:prstGeom>
+          <a:solidFill>
+            <a:srgbClr val="7B5FA3"/>
+          </a:solidFill>
+          <a:ln w="12700" cap="flat" cmpd="sng" algn="ctr">
+            <a:noFill/>
+            <a:prstDash val="solid"/>
+            <a:miter lim="800000"/>
+          </a:ln>
+          <a:effectLst/>
+          <a:extLst>
+            <a:ext uri="{91240B29-F687-4F45-9708-019B960494DF}">
+              <a14:hiddenLine xmlns:a14="http://schemas.microsoft.com/office/drawing/2010/main" w="12700" cap="flat" cmpd="sng" algn="ctr">
+                <a:solidFill>
+                  <a:schemeClr val="accent1">
+                    <a:shade val="15000"/>
+                  </a:schemeClr>
+                </a:solidFill>
+                <a:prstDash val="solid"/>
+                <a:miter lim="800000"/>
+              </a14:hiddenLine>
+            </a:ext>
+          </a:extLst>
+        </p:spPr>
+        <p:style>
+          <a:lnRef idx="2">
+            <a:schemeClr val="accent1">
+              <a:shade val="15000"/>
+            </a:schemeClr>
+          </a:lnRef>
+          <a:fillRef idx="1">
+            <a:schemeClr val="accent1"/>
+          </a:fillRef>
+          <a:effectRef idx="0">
+            <a:schemeClr val="accent1"/>
+          </a:effectRef>
+          <a:fontRef idx="minor">
+            <a:schemeClr val="lt1"/>
+          </a:fontRef>
+        </p:style>
+        <p:txBody>
+          <a:bodyPr lIns="38100" tIns="12700" rIns="38100" bIns="12700" rtlCol="0" anchor="ctr"/>
+          <a:lstStyle/>
+          <a:p>
+            <a:pPr algn="ctr"/>
+            <a:r>
+              <a:rPr lang="en-US" sz="750" b="1">
+                <a:solidFill>
+                  <a:srgbClr val="FFFFFF"/>
+                </a:solidFill>
+                <a:latin typeface="Aptos" panose="020B0004020202020204" pitchFamily="34" charset="0"/>
+              </a:rPr>
+              <a:t>CLIENT-MANAGED</a:t>
+            </a:r>
           </a:p>
         </p:txBody>
       </p:sp>

</xml_diff>

<commit_message>
Connect identity and monitoring slides to Lab 5
Label the optional identity and monitoring verification steps, clarify JWT versus request correlation, and document the APIM-to-backend correlation boundary.

Co-authored-by: Copilot <223556219+Copilot@users.noreply.github.com>
Copilot-Session: 8c02ba17-1398-4d94-b9f2-71766e81e382
</commit_message>
<xml_diff>
--- a/docs/foundry-apim-mcp-workshop.pptx
+++ b/docs/foundry-apim-mcp-workshop.pptx
@@ -913,7 +913,7 @@
           <a:p>
             <a:r>
               <a:rPr lang="en-US"/>
-              <a:t>Bearer is the token presentation method, not an alternative to OAuth. Both authenticated paths send the delegated access token in the Authorization header, and APIM validates the same issuer, audience, client, and scope claims. The middle card is manual token injection for a one-time test. The right card is client-managed MCP OAuth, which uses protected-resource metadata, a 401 challenge, compatible client registration, Authorization Code with PKCE, consent, token caching, and refresh.</a:t>
+              <a:t>Slide 16 is the optional identity extension within Lab 5. Bearer is the token presentation method, not an alternative to OAuth. Both authenticated paths send the delegated access token in the Authorization header, and APIM validates the same issuer, audience, client, and scope claims. The middle card is manual token injection for a one-time test. The right card is client-managed MCP OAuth, which uses protected-resource metadata, a 401 challenge, compatible client registration, Authorization Code with PKCE, consent, token caching, and refresh.</a:t>
             </a:r>
             <a:endParaRPr lang="en-US" dirty="0"/>
           </a:p>
@@ -1000,9 +1000,10 @@
           <a:lstStyle/>
           <a:p>
             <a:r>
-              <a:rPr lang="en-US" dirty="0"/>
-              <a:t>Use a correlation ID to join the client request, agent run, APIM request, API operation, and backend call. Discuss which team owns each signal and who receives alerts.</a:t>
-            </a:r>
+              <a:rPr lang="en-US"/>
+              <a:t>Slide 17 is the monitoring verification within Lab 5. The workshop policy preserves an incoming x-correlation-id or creates a GUID at APIM, records it in trace metadata, and forwards it downstream. This correlation ID is separate from the JWT. The access token establishes identity and authorization; the correlation ID connects telemetry for one request. Because the workshop policy starts at APIM, correlating the client and agent requires an upstream correlation header or additional W3C trace-context instrumentation.</a:t>
+            </a:r>
+            <a:endParaRPr lang="en-US" dirty="0"/>
           </a:p>
         </p:txBody>
       </p:sp>
@@ -9983,7 +9984,7 @@
               <a:buNone/>
             </a:pPr>
             <a:r>
-              <a:rPr lang="en-US" sz="900" b="1" kern="0" spc="140" dirty="0">
+              <a:rPr lang="en-US" sz="900" b="1" kern="0" spc="140">
                 <a:solidFill>
                   <a:srgbClr val="0F8B8D"/>
                 </a:solidFill>
@@ -9991,7 +9992,7 @@
                 <a:ea typeface="Aptos" pitchFamily="34" charset="-122"/>
                 <a:cs typeface="Aptos" pitchFamily="34" charset="-120"/>
               </a:rPr>
-              <a:t> IDENTITY CHOICES</a:t>
+              <a:t>LAB 5 | IDENTITY EXTENSION</a:t>
             </a:r>
             <a:endParaRPr lang="en-US" sz="900" dirty="0"/>
           </a:p>
@@ -10032,7 +10033,7 @@
                 <a:ea typeface="Aptos Display" pitchFamily="34" charset="-122"/>
                 <a:cs typeface="Aptos Display" pitchFamily="34" charset="-120"/>
               </a:rPr>
-              <a:t>Choose how the client obtains the delegated access token</a:t>
+              <a:t>Choose the Lab 5 access path</a:t>
             </a:r>
             <a:endParaRPr lang="en-US" sz="2700" dirty="0"/>
           </a:p>
@@ -10073,51 +10074,7 @@
                 <a:ea typeface="Aptos" pitchFamily="34" charset="-122"/>
                 <a:cs typeface="Aptos" pitchFamily="34" charset="-120"/>
               </a:rPr>
-              <a:t>Both authenticated paths send the </a:t>
-            </a:r>
-            <a:r>
-              <a:rPr lang="en-US" sz="1250" b="1">
-                <a:solidFill>
-                  <a:srgbClr val="4F8BEF"/>
-                </a:solidFill>
-                <a:latin typeface="Aptos" pitchFamily="34" charset="0"/>
-                <a:ea typeface="Aptos" pitchFamily="34" charset="-122"/>
-                <a:cs typeface="Aptos" pitchFamily="34" charset="-120"/>
-              </a:rPr>
-              <a:t>same bearer token</a:t>
-            </a:r>
-            <a:r>
-              <a:rPr lang="en-US" sz="1250">
-                <a:solidFill>
-                  <a:srgbClr val="4F6474"/>
-                </a:solidFill>
-                <a:latin typeface="Aptos" pitchFamily="34" charset="0"/>
-                <a:ea typeface="Aptos" pitchFamily="34" charset="-122"/>
-                <a:cs typeface="Aptos" pitchFamily="34" charset="-120"/>
-              </a:rPr>
-              <a:t>. </a:t>
-            </a:r>
-            <a:r>
-              <a:rPr lang="en-US" sz="1250" b="1">
-                <a:solidFill>
-                  <a:srgbClr val="7B5FA3"/>
-                </a:solidFill>
-                <a:latin typeface="Aptos" pitchFamily="34" charset="0"/>
-                <a:ea typeface="Aptos" pitchFamily="34" charset="-122"/>
-                <a:cs typeface="Aptos" pitchFamily="34" charset="-120"/>
-              </a:rPr>
-              <a:t>OAuth + PKCE</a:t>
-            </a:r>
-            <a:r>
-              <a:rPr lang="en-US" sz="1250">
-                <a:solidFill>
-                  <a:srgbClr val="4F6474"/>
-                </a:solidFill>
-                <a:latin typeface="Aptos" pitchFamily="34" charset="0"/>
-                <a:ea typeface="Aptos" pitchFamily="34" charset="-122"/>
-                <a:cs typeface="Aptos" pitchFamily="34" charset="-120"/>
-              </a:rPr>
-              <a:t> handles discovery, sign-in, consent, and token lifecycle.</a:t>
+              <a:t>Start with the anonymous sandbox. The optional identity extension uses the same bearer token, supplied manually or acquired through OAuth + PKCE.</a:t>
             </a:r>
             <a:endParaRPr lang="en-US" sz="1250" dirty="0"/>
           </a:p>
@@ -11011,7 +10968,7 @@
               <a:buNone/>
             </a:pPr>
             <a:r>
-              <a:rPr lang="en-US" sz="750" dirty="0">
+              <a:rPr lang="en-US" sz="750">
                 <a:solidFill>
                   <a:srgbClr val="748494"/>
                 </a:solidFill>
@@ -11019,7 +10976,7 @@
                 <a:ea typeface="Aptos" pitchFamily="34" charset="-122"/>
                 <a:cs typeface="Aptos" pitchFamily="34" charset="-120"/>
               </a:rPr>
-              <a:t>Optional extension: delegated Microsoft Entra OAuth</a:t>
+              <a:t>Lab 5 optional extension: delegated Microsoft Entra OAuth</a:t>
             </a:r>
             <a:endParaRPr lang="en-US" sz="750" dirty="0"/>
           </a:p>
@@ -11351,7 +11308,7 @@
               <a:buNone/>
             </a:pPr>
             <a:r>
-              <a:rPr lang="en-US" sz="900" b="1" kern="0" spc="140" dirty="0">
+              <a:rPr lang="en-US" sz="900" b="1" kern="0" spc="140">
                 <a:solidFill>
                   <a:srgbClr val="0F8B8D"/>
                 </a:solidFill>
@@ -11359,7 +11316,7 @@
                 <a:ea typeface="Aptos" pitchFamily="34" charset="-122"/>
                 <a:cs typeface="Aptos" pitchFamily="34" charset="-120"/>
               </a:rPr>
-              <a:t> OPERATE THE PATTERN</a:t>
+              <a:t>LAB 5 | MONITOR</a:t>
             </a:r>
             <a:endParaRPr lang="en-US" sz="900" dirty="0"/>
           </a:p>
@@ -11392,7 +11349,7 @@
               <a:buNone/>
             </a:pPr>
             <a:r>
-              <a:rPr lang="en-US" sz="2700" b="1" dirty="0">
+              <a:rPr lang="en-US" sz="2700" b="1">
                 <a:solidFill>
                   <a:srgbClr val="102A43"/>
                 </a:solidFill>
@@ -11400,7 +11357,7 @@
                 <a:ea typeface="Aptos Display" pitchFamily="34" charset="-122"/>
                 <a:cs typeface="Aptos Display" pitchFamily="34" charset="-120"/>
               </a:rPr>
-              <a:t>Observe one request across every boundary</a:t>
+              <a:t>Verify Lab 5 correlation from APIM to the backend</a:t>
             </a:r>
             <a:endParaRPr lang="en-US" sz="2700" dirty="0"/>
           </a:p>
@@ -11433,7 +11390,7 @@
               <a:buNone/>
             </a:pPr>
             <a:r>
-              <a:rPr lang="en-US" sz="1250" dirty="0">
+              <a:rPr lang="en-US" sz="1250">
                 <a:solidFill>
                   <a:srgbClr val="4F6474"/>
                 </a:solidFill>
@@ -11441,7 +11398,7 @@
                 <a:ea typeface="Aptos" pitchFamily="34" charset="-122"/>
                 <a:cs typeface="Aptos" pitchFamily="34" charset="-120"/>
               </a:rPr>
-              <a:t> Correlation turns a multi-service tool call into a supportable system.</a:t>
+              <a:t>Correlation identifies the request path; JWT identifies the caller. APIM creates or preserves x-correlation-id.</a:t>
             </a:r>
             <a:endParaRPr lang="en-US" sz="1250" dirty="0"/>
           </a:p>
@@ -12056,8 +12013,8 @@
         </p:nvSpPr>
         <p:spPr>
           <a:xfrm>
-            <a:off x="841248" y="3611880"/>
-            <a:ext cx="10497312" cy="0"/>
+            <a:off x="5229860" y="3611880"/>
+            <a:ext cx="6108700" cy="0"/>
           </a:xfrm>
           <a:prstGeom prst="line">
             <a:avLst/>
@@ -12080,8 +12037,8 @@
         </p:nvSpPr>
         <p:spPr>
           <a:xfrm>
-            <a:off x="5193792" y="3310128"/>
-            <a:ext cx="1792224" cy="164592"/>
+            <a:off x="6731000" y="3365500"/>
+            <a:ext cx="3810000" cy="164592"/>
           </a:xfrm>
           <a:prstGeom prst="rect">
             <a:avLst/>
@@ -12097,7 +12054,7 @@
               <a:buNone/>
             </a:pPr>
             <a:r>
-              <a:rPr lang="en-US" sz="1000" b="1" dirty="0">
+              <a:rPr lang="en-US" sz="1000" b="1">
                 <a:solidFill>
                   <a:srgbClr val="D95B3E"/>
                 </a:solidFill>
@@ -12105,7 +12062,7 @@
                 <a:ea typeface="Consolas" pitchFamily="34" charset="-122"/>
                 <a:cs typeface="Consolas" pitchFamily="34" charset="-120"/>
               </a:rPr>
-              <a:t>correlation-id</a:t>
+              <a:t>LAB 5: x-correlation-id + trace metadata</a:t>
             </a:r>
             <a:endParaRPr lang="en-US" sz="1000" dirty="0"/>
           </a:p>
@@ -12676,7 +12633,7 @@
               <a:buNone/>
             </a:pPr>
             <a:r>
-              <a:rPr lang="en-US" sz="750" dirty="0">
+              <a:rPr lang="en-US" sz="750">
                 <a:solidFill>
                   <a:srgbClr val="748494"/>
                 </a:solidFill>
@@ -12684,7 +12641,7 @@
                 <a:ea typeface="Aptos" pitchFamily="34" charset="-122"/>
                 <a:cs typeface="Aptos" pitchFamily="34" charset="-120"/>
               </a:rPr>
-              <a:t>Monitoring: one trace, many boundaries</a:t>
+              <a:t>Lab 5 verification: gateway correlation and diagnostics</a:t>
             </a:r>
             <a:endParaRPr lang="en-US" sz="750" dirty="0"/>
           </a:p>
@@ -12738,6 +12695,123 @@
           </a:p>
         </p:txBody>
       </p:sp>
+      <p:sp>
+        <p:nvSpPr>
+          <p:cNvPr id="44" name="Client Agent Trace Note">
+            <a:extLst>
+              <a:ext uri="{FF2B5EF4-FFF2-40B4-BE49-F238E27FC236}">
+                <a16:creationId xmlns:a16="http://schemas.microsoft.com/office/drawing/2014/main" id="{8136A9ED-7D16-568A-20B1-8874FF03D30D}"/>
+              </a:ext>
+            </a:extLst>
+          </p:cNvPr>
+          <p:cNvSpPr/>
+          <p:nvPr/>
+        </p:nvSpPr>
+        <p:spPr>
+          <a:xfrm>
+            <a:off x="825500" y="3289300"/>
+            <a:ext cx="3632200" cy="254000"/>
+          </a:xfrm>
+          <a:prstGeom prst="roundRect">
+            <a:avLst/>
+          </a:prstGeom>
+          <a:solidFill>
+            <a:srgbClr val="E8EEF3"/>
+          </a:solidFill>
+          <a:ln w="12700" cap="flat" cmpd="sng" algn="ctr">
+            <a:noFill/>
+            <a:prstDash val="solid"/>
+            <a:miter lim="800000"/>
+          </a:ln>
+          <a:effectLst/>
+          <a:extLst>
+            <a:ext uri="{91240B29-F687-4F45-9708-019B960494DF}">
+              <a14:hiddenLine xmlns:a14="http://schemas.microsoft.com/office/drawing/2010/main" w="12700" cap="flat" cmpd="sng" algn="ctr">
+                <a:solidFill>
+                  <a:schemeClr val="accent1">
+                    <a:shade val="15000"/>
+                  </a:schemeClr>
+                </a:solidFill>
+                <a:prstDash val="solid"/>
+                <a:miter lim="800000"/>
+              </a14:hiddenLine>
+            </a:ext>
+          </a:extLst>
+        </p:spPr>
+        <p:style>
+          <a:lnRef idx="2">
+            <a:schemeClr val="accent1">
+              <a:shade val="15000"/>
+            </a:schemeClr>
+          </a:lnRef>
+          <a:fillRef idx="1">
+            <a:schemeClr val="accent1"/>
+          </a:fillRef>
+          <a:effectRef idx="0">
+            <a:schemeClr val="accent1"/>
+          </a:effectRef>
+          <a:fontRef idx="minor">
+            <a:schemeClr val="lt1"/>
+          </a:fontRef>
+        </p:style>
+        <p:txBody>
+          <a:bodyPr lIns="50800" tIns="12700" rIns="50800" bIns="12700" rtlCol="0" anchor="ctr"/>
+          <a:lstStyle/>
+          <a:p>
+            <a:pPr algn="ctr"/>
+            <a:r>
+              <a:rPr lang="en-US" sz="800" b="1">
+                <a:solidFill>
+                  <a:srgbClr val="52697A"/>
+                </a:solidFill>
+                <a:latin typeface="Aptos" panose="020B0004020202020204" pitchFamily="34" charset="0"/>
+              </a:rPr>
+              <a:t>Client + agent tracing: production extension</a:t>
+            </a:r>
+          </a:p>
+        </p:txBody>
+      </p:sp>
+      <p:cxnSp>
+        <p:nvCxnSpPr>
+          <p:cNvPr id="45" name="Lab5 Correlation Origin">
+            <a:extLst>
+              <a:ext uri="{FF2B5EF4-FFF2-40B4-BE49-F238E27FC236}">
+                <a16:creationId xmlns:a16="http://schemas.microsoft.com/office/drawing/2014/main" id="{25945851-54CD-0FA0-CBED-CA759F46F30F}"/>
+              </a:ext>
+            </a:extLst>
+          </p:cNvPr>
+          <p:cNvCxnSpPr/>
+          <p:nvPr/>
+        </p:nvCxnSpPr>
+        <p:spPr>
+          <a:xfrm>
+            <a:off x="6075680" y="3172460"/>
+            <a:ext cx="0" cy="439420"/>
+          </a:xfrm>
+          <a:prstGeom prst="line">
+            <a:avLst/>
+          </a:prstGeom>
+          <a:ln w="19050">
+            <a:solidFill>
+              <a:srgbClr val="FF7152"/>
+            </a:solidFill>
+          </a:ln>
+        </p:spPr>
+        <p:style>
+          <a:lnRef idx="1">
+            <a:schemeClr val="accent1"/>
+          </a:lnRef>
+          <a:fillRef idx="0">
+            <a:schemeClr val="accent1"/>
+          </a:fillRef>
+          <a:effectRef idx="0">
+            <a:schemeClr val="accent1"/>
+          </a:effectRef>
+          <a:fontRef idx="minor">
+            <a:schemeClr val="tx1"/>
+          </a:fontRef>
+        </p:style>
+      </p:cxnSp>
     </p:spTree>
   </p:cSld>
   <p:clrMapOvr>

</xml_diff>

<commit_message>
Redesign slide 13 deployment paths
Present Foundry Toolkit and Azure Developer CLI as two left-side options that share azure.yaml and converge on one Foundry Agent Service runtime.

Co-authored-by: Copilot <223556219+Copilot@users.noreply.github.com>
Copilot-Session: 8c02ba17-1398-4d94-b9f2-71766e81e382
</commit_message>
<xml_diff>
--- a/docs/foundry-apim-mcp-workshop.pptx
+++ b/docs/foundry-apim-mcp-workshop.pptx
@@ -650,9 +650,10 @@
           <a:lstStyle/>
           <a:p>
             <a:r>
-              <a:rPr lang="en-US" dirty="0"/>
-              <a:t>Clarify what is deployed. Participants deploy agent code to Foundry Agent Service. They do not build or operate Azure Container Apps or Azure Container Registry for this workshop path.</a:t>
-            </a:r>
+              <a:rPr lang="en-US"/>
+              <a:t>Present Path A and Path B as two interfaces over the same deployment manifest. Foundry Toolkit reads the selected service from azure.yaml and resolves declared values from the source .env or process environment. azd reads the same service definition and resolves values from the selected azd environment. Both paths package the same source and create an immutable hosted-agent version in Foundry Agent Service.</a:t>
+            </a:r>
+            <a:endParaRPr lang="en-US" dirty="0"/>
           </a:p>
         </p:txBody>
       </p:sp>
@@ -6625,7 +6626,7 @@
               <a:buNone/>
             </a:pPr>
             <a:r>
-              <a:rPr lang="en-US" sz="1250" dirty="0">
+              <a:rPr lang="en-US" sz="1250">
                 <a:solidFill>
                   <a:srgbClr val="4F6474"/>
                 </a:solidFill>
@@ -6633,7 +6634,7 @@
                 <a:ea typeface="Aptos" pitchFamily="34" charset="-122"/>
                 <a:cs typeface="Aptos" pitchFamily="34" charset="-120"/>
               </a:rPr>
-              <a:t> Two deployment interfaces target the same code deployment model.</a:t>
+              <a:t>Two deployment interfaces read the same azure.yaml and create the same hosted-agent runtime.</a:t>
             </a:r>
             <a:endParaRPr lang="en-US" sz="1250" dirty="0"/>
           </a:p>
@@ -6647,8 +6648,8 @@
         </p:nvSpPr>
         <p:spPr>
           <a:xfrm>
-            <a:off x="658368" y="1828800"/>
-            <a:ext cx="3657600" cy="3154680"/>
+            <a:off x="657860" y="1659890"/>
+            <a:ext cx="6731000" cy="1841500"/>
           </a:xfrm>
           <a:prstGeom prst="roundRect">
             <a:avLst>
@@ -6681,8 +6682,8 @@
         </p:nvSpPr>
         <p:spPr>
           <a:xfrm>
-            <a:off x="658368" y="1828800"/>
-            <a:ext cx="73152" cy="3154680"/>
+            <a:off x="657860" y="1659890"/>
+            <a:ext cx="73660" cy="1841500"/>
           </a:xfrm>
           <a:prstGeom prst="rect">
             <a:avLst/>
@@ -6720,7 +6721,7 @@
         </p:blipFill>
         <p:spPr>
           <a:xfrm>
-            <a:off x="859536" y="2011680"/>
+            <a:off x="859790" y="1842770"/>
             <a:ext cx="347472" cy="347472"/>
           </a:xfrm>
           <a:prstGeom prst="rect">
@@ -6736,8 +6737,8 @@
         </p:nvSpPr>
         <p:spPr>
           <a:xfrm>
-            <a:off x="1353312" y="2002536"/>
-            <a:ext cx="2761488" cy="292608"/>
+            <a:off x="1353820" y="1833880"/>
+            <a:ext cx="5715000" cy="292608"/>
           </a:xfrm>
           <a:prstGeom prst="rect">
             <a:avLst/>
@@ -6777,8 +6778,8 @@
         </p:nvSpPr>
         <p:spPr>
           <a:xfrm>
-            <a:off x="877824" y="2450592"/>
-            <a:ext cx="3218688" cy="2350008"/>
+            <a:off x="877570" y="2282190"/>
+            <a:ext cx="6223000" cy="1041400"/>
           </a:xfrm>
           <a:prstGeom prst="rect">
             <a:avLst/>
@@ -6799,7 +6800,7 @@
               <a:buNone/>
             </a:pPr>
             <a:r>
-              <a:rPr lang="en-US" sz="1050" dirty="0">
+              <a:rPr lang="en-US" sz="1150">
                 <a:solidFill>
                   <a:srgbClr val="4F6474"/>
                 </a:solidFill>
@@ -6809,7 +6810,6 @@
               </a:rPr>
               <a:t>Use the VS Code deployment experience.</a:t>
             </a:r>
-            <a:endParaRPr lang="en-US" sz="1050" dirty="0"/>
           </a:p>
           <a:p>
             <a:pPr marL="0" indent="0">
@@ -6818,7 +6818,14 @@
               </a:lnSpc>
               <a:buNone/>
             </a:pPr>
-            <a:endParaRPr lang="en-US" sz="1050" dirty="0"/>
+            <a:endParaRPr lang="en-US" sz="1150">
+              <a:solidFill>
+                <a:srgbClr val="4F6474"/>
+              </a:solidFill>
+              <a:latin typeface="Aptos" pitchFamily="34" charset="0"/>
+              <a:ea typeface="Aptos" pitchFamily="34" charset="-122"/>
+              <a:cs typeface="Aptos" pitchFamily="34" charset="-120"/>
+            </a:endParaRPr>
           </a:p>
           <a:p>
             <a:pPr marL="0" indent="0">
@@ -6828,7 +6835,7 @@
               <a:buNone/>
             </a:pPr>
             <a:r>
-              <a:rPr lang="en-US" sz="1050" dirty="0">
+              <a:rPr lang="en-US" sz="1150">
                 <a:solidFill>
                   <a:srgbClr val="4F6474"/>
                 </a:solidFill>
@@ -6836,9 +6843,9 @@
                 <a:ea typeface="Aptos" pitchFamily="34" charset="-122"/>
                 <a:cs typeface="Aptos" pitchFamily="34" charset="-120"/>
               </a:rPr>
-              <a:t>Select the agent service, bind the Foundry project, and deploy from the editor.</a:t>
-            </a:r>
-            <a:endParaRPr lang="en-US" sz="1050" dirty="0"/>
+              <a:t>Read the service from azure.yaml, resolve values from the source .env, then deploy from the editor.</a:t>
+            </a:r>
+            <a:endParaRPr lang="en-US" sz="1150" dirty="0"/>
           </a:p>
         </p:txBody>
       </p:sp>
@@ -6850,8 +6857,8 @@
         </p:nvSpPr>
         <p:spPr>
           <a:xfrm>
-            <a:off x="7872984" y="1828800"/>
-            <a:ext cx="3657600" cy="3154680"/>
+            <a:off x="657860" y="3733800"/>
+            <a:ext cx="6731000" cy="1841500"/>
           </a:xfrm>
           <a:prstGeom prst="roundRect">
             <a:avLst>
@@ -6884,8 +6891,8 @@
         </p:nvSpPr>
         <p:spPr>
           <a:xfrm>
-            <a:off x="7872984" y="1828800"/>
-            <a:ext cx="73152" cy="3154680"/>
+            <a:off x="657860" y="3733800"/>
+            <a:ext cx="73660" cy="1841500"/>
           </a:xfrm>
           <a:prstGeom prst="rect">
             <a:avLst/>
@@ -6923,7 +6930,7 @@
         </p:blipFill>
         <p:spPr>
           <a:xfrm>
-            <a:off x="8074152" y="2011680"/>
+            <a:off x="859790" y="3916680"/>
             <a:ext cx="347472" cy="347472"/>
           </a:xfrm>
           <a:prstGeom prst="rect">
@@ -6939,8 +6946,8 @@
         </p:nvSpPr>
         <p:spPr>
           <a:xfrm>
-            <a:off x="8567928" y="2002536"/>
-            <a:ext cx="2761488" cy="292608"/>
+            <a:off x="1353820" y="3907790"/>
+            <a:ext cx="5715000" cy="292608"/>
           </a:xfrm>
           <a:prstGeom prst="rect">
             <a:avLst/>
@@ -6980,8 +6987,8 @@
         </p:nvSpPr>
         <p:spPr>
           <a:xfrm>
-            <a:off x="8092440" y="2450592"/>
-            <a:ext cx="3218688" cy="2350008"/>
+            <a:off x="877570" y="4356100"/>
+            <a:ext cx="6223000" cy="1041400"/>
           </a:xfrm>
           <a:prstGeom prst="rect">
             <a:avLst/>
@@ -7002,7 +7009,7 @@
               <a:buNone/>
             </a:pPr>
             <a:r>
-              <a:rPr lang="en-US" sz="1050" dirty="0">
+              <a:rPr lang="en-US" sz="1150">
                 <a:solidFill>
                   <a:srgbClr val="4F6474"/>
                 </a:solidFill>
@@ -7010,9 +7017,8 @@
                 <a:ea typeface="Aptos" pitchFamily="34" charset="-122"/>
                 <a:cs typeface="Aptos" pitchFamily="34" charset="-120"/>
               </a:rPr>
-              <a:t>Use the repository's azure.yaml.</a:t>
-            </a:r>
-            <a:endParaRPr lang="en-US" sz="1050" dirty="0"/>
+              <a:t>Use the same azure.yaml from the repository.</a:t>
+            </a:r>
           </a:p>
           <a:p>
             <a:pPr marL="0" indent="0">
@@ -7021,7 +7027,14 @@
               </a:lnSpc>
               <a:buNone/>
             </a:pPr>
-            <a:endParaRPr lang="en-US" sz="1050" dirty="0"/>
+            <a:endParaRPr lang="en-US" sz="1150">
+              <a:solidFill>
+                <a:srgbClr val="4F6474"/>
+              </a:solidFill>
+              <a:latin typeface="Aptos" pitchFamily="34" charset="0"/>
+              <a:ea typeface="Aptos" pitchFamily="34" charset="-122"/>
+              <a:cs typeface="Aptos" pitchFamily="34" charset="-120"/>
+            </a:endParaRPr>
           </a:p>
           <a:p>
             <a:pPr marL="0" indent="0">
@@ -7031,7 +7044,7 @@
               <a:buNone/>
             </a:pPr>
             <a:r>
-              <a:rPr lang="en-US" sz="1050" dirty="0">
+              <a:rPr lang="en-US" sz="1150">
                 <a:solidFill>
                   <a:srgbClr val="4F6474"/>
                 </a:solidFill>
@@ -7039,9 +7052,9 @@
                 <a:ea typeface="Aptos" pitchFamily="34" charset="-122"/>
                 <a:cs typeface="Aptos" pitchFamily="34" charset="-120"/>
               </a:rPr>
-              <a:t>Set the project context, then deploy one named agent service with azd deploy.</a:t>
-            </a:r>
-            <a:endParaRPr lang="en-US" sz="1050" dirty="0"/>
+              <a:t>Resolve values from the selected azd environment, then deploy one named agent service.</a:t>
+            </a:r>
+            <a:endParaRPr lang="en-US" sz="1150" dirty="0"/>
           </a:p>
         </p:txBody>
       </p:sp>
@@ -7053,8 +7066,8 @@
         </p:nvSpPr>
         <p:spPr>
           <a:xfrm>
-            <a:off x="4617720" y="2084832"/>
-            <a:ext cx="2944368" cy="2651760"/>
+            <a:off x="8623300" y="1917700"/>
+            <a:ext cx="2921000" cy="3302000"/>
           </a:xfrm>
           <a:prstGeom prst="roundRect">
             <a:avLst/>
@@ -7099,7 +7112,7 @@
         </p:blipFill>
         <p:spPr>
           <a:xfrm>
-            <a:off x="5715000" y="2404872"/>
+            <a:off x="9726930" y="2357120"/>
             <a:ext cx="713232" cy="713232"/>
           </a:xfrm>
           <a:prstGeom prst="rect">
@@ -7115,7 +7128,7 @@
         </p:nvSpPr>
         <p:spPr>
           <a:xfrm>
-            <a:off x="4956048" y="3310128"/>
+            <a:off x="8940800" y="3263900"/>
             <a:ext cx="2286000" cy="502920"/>
           </a:xfrm>
           <a:prstGeom prst="rect">
@@ -7156,7 +7169,7 @@
         </p:nvSpPr>
         <p:spPr>
           <a:xfrm>
-            <a:off x="5138928" y="3977640"/>
+            <a:off x="9123680" y="4178300"/>
             <a:ext cx="1920240" cy="548640"/>
           </a:xfrm>
           <a:prstGeom prst="rect">
@@ -7175,7 +7188,7 @@
               <a:buNone/>
             </a:pPr>
             <a:r>
-              <a:rPr lang="en-US" sz="950" dirty="0">
+              <a:rPr lang="en-US" sz="1050">
                 <a:solidFill>
                   <a:srgbClr val="DDEAF2"/>
                 </a:solidFill>
@@ -7183,16 +7196,15 @@
                 <a:ea typeface="Aptos" pitchFamily="34" charset="-122"/>
                 <a:cs typeface="Aptos" pitchFamily="34" charset="-120"/>
               </a:rPr>
-              <a:t>Managed compute</a:t>
-            </a:r>
-            <a:endParaRPr lang="en-US" sz="950" dirty="0"/>
+              <a:t>Single shared target</a:t>
+            </a:r>
           </a:p>
           <a:p>
             <a:pPr marL="0" indent="0" algn="ctr">
               <a:buNone/>
             </a:pPr>
             <a:r>
-              <a:rPr lang="en-US" sz="950" dirty="0">
+              <a:rPr lang="en-US" sz="1050">
                 <a:solidFill>
                   <a:srgbClr val="DDEAF2"/>
                 </a:solidFill>
@@ -7200,16 +7212,15 @@
                 <a:ea typeface="Aptos" pitchFamily="34" charset="-122"/>
                 <a:cs typeface="Aptos" pitchFamily="34" charset="-120"/>
               </a:rPr>
-              <a:t>Managed sandbox</a:t>
-            </a:r>
-            <a:endParaRPr lang="en-US" sz="950" dirty="0"/>
+              <a:t>Managed compute + sandbox</a:t>
+            </a:r>
           </a:p>
           <a:p>
             <a:pPr marL="0" indent="0" algn="ctr">
               <a:buNone/>
             </a:pPr>
             <a:r>
-              <a:rPr lang="en-US" sz="950" dirty="0">
+              <a:rPr lang="en-US" sz="1050">
                 <a:solidFill>
                   <a:srgbClr val="DDEAF2"/>
                 </a:solidFill>
@@ -7217,9 +7228,9 @@
                 <a:ea typeface="Aptos" pitchFamily="34" charset="-122"/>
                 <a:cs typeface="Aptos" pitchFamily="34" charset="-120"/>
               </a:rPr>
-              <a:t>Immutable version</a:t>
-            </a:r>
-            <a:endParaRPr lang="en-US" sz="950" dirty="0"/>
+              <a:t>Immutable agent version</a:t>
+            </a:r>
+            <a:endParaRPr lang="en-US" sz="1050" dirty="0"/>
           </a:p>
         </p:txBody>
       </p:sp>
@@ -7231,8 +7242,8 @@
         </p:nvSpPr>
         <p:spPr>
           <a:xfrm>
-            <a:off x="4361688" y="3346704"/>
-            <a:ext cx="256032" cy="0"/>
+            <a:off x="7416800" y="2580640"/>
+            <a:ext cx="1155700" cy="0"/>
           </a:xfrm>
           <a:prstGeom prst="line">
             <a:avLst/>
@@ -7243,6 +7254,7 @@
               <a:srgbClr val="4F8EF7"/>
             </a:solidFill>
             <a:prstDash val="solid"/>
+            <a:headEnd type="none"/>
             <a:tailEnd type="triangle"/>
           </a:ln>
         </p:spPr>
@@ -7255,8 +7267,8 @@
         </p:nvSpPr>
         <p:spPr>
           <a:xfrm>
-            <a:off x="7580376" y="3346704"/>
-            <a:ext cx="256032" cy="0"/>
+            <a:off x="7416800" y="4654550"/>
+            <a:ext cx="1155700" cy="0"/>
           </a:xfrm>
           <a:prstGeom prst="line">
             <a:avLst/>
@@ -7267,7 +7279,8 @@
               <a:srgbClr val="0F8B8D"/>
             </a:solidFill>
             <a:prstDash val="solid"/>
-            <a:headEnd type="triangle"/>
+            <a:headEnd type="none"/>
+            <a:tailEnd type="triangle"/>
           </a:ln>
         </p:spPr>
       </p:sp>
@@ -7293,7 +7306,7 @@
         </p:blipFill>
         <p:spPr>
           <a:xfrm>
-            <a:off x="822960" y="5394960"/>
+            <a:off x="822960" y="5892800"/>
             <a:ext cx="256032" cy="256032"/>
           </a:xfrm>
           <a:prstGeom prst="rect">
@@ -7309,7 +7322,7 @@
         </p:nvSpPr>
         <p:spPr>
           <a:xfrm>
-            <a:off x="1188720" y="5413248"/>
+            <a:off x="1188720" y="5910580"/>
             <a:ext cx="2240280" cy="201168"/>
           </a:xfrm>
           <a:prstGeom prst="rect">
@@ -7364,7 +7377,7 @@
         </p:blipFill>
         <p:spPr>
           <a:xfrm>
-            <a:off x="3657600" y="5394960"/>
+            <a:off x="3657600" y="5892800"/>
             <a:ext cx="256032" cy="256032"/>
           </a:xfrm>
           <a:prstGeom prst="rect">
@@ -7380,7 +7393,7 @@
         </p:nvSpPr>
         <p:spPr>
           <a:xfrm>
-            <a:off x="4023360" y="5413248"/>
+            <a:off x="4023360" y="5910580"/>
             <a:ext cx="2240280" cy="201168"/>
           </a:xfrm>
           <a:prstGeom prst="rect">
@@ -7435,7 +7448,7 @@
         </p:blipFill>
         <p:spPr>
           <a:xfrm>
-            <a:off x="6492240" y="5394960"/>
+            <a:off x="6492240" y="5892800"/>
             <a:ext cx="256032" cy="256032"/>
           </a:xfrm>
           <a:prstGeom prst="rect">
@@ -7451,7 +7464,7 @@
         </p:nvSpPr>
         <p:spPr>
           <a:xfrm>
-            <a:off x="6858000" y="5413248"/>
+            <a:off x="6858000" y="5910580"/>
             <a:ext cx="2240280" cy="201168"/>
           </a:xfrm>
           <a:prstGeom prst="rect">
@@ -7506,7 +7519,7 @@
         </p:blipFill>
         <p:spPr>
           <a:xfrm>
-            <a:off x="9326880" y="5394960"/>
+            <a:off x="9326880" y="5892800"/>
             <a:ext cx="256032" cy="256032"/>
           </a:xfrm>
           <a:prstGeom prst="rect">
@@ -7522,7 +7535,7 @@
         </p:nvSpPr>
         <p:spPr>
           <a:xfrm>
-            <a:off x="9692640" y="5413248"/>
+            <a:off x="9692640" y="5910580"/>
             <a:ext cx="2240280" cy="201168"/>
           </a:xfrm>
           <a:prstGeom prst="rect">
@@ -7639,6 +7652,46 @@
               <a:t>13</a:t>
             </a:fld>
             <a:endParaRPr lang="en-US"/>
+          </a:p>
+        </p:txBody>
+      </p:sp>
+      <p:sp>
+        <p:nvSpPr>
+          <p:cNvPr id="31" name="Both Paths Label">
+            <a:extLst>
+              <a:ext uri="{FF2B5EF4-FFF2-40B4-BE49-F238E27FC236}">
+                <a16:creationId xmlns:a16="http://schemas.microsoft.com/office/drawing/2014/main" id="{43FB57FF-6A77-6135-546E-ADC4BED961C8}"/>
+              </a:ext>
+            </a:extLst>
+          </p:cNvPr>
+          <p:cNvSpPr txBox="1"/>
+          <p:nvPr/>
+        </p:nvSpPr>
+        <p:spPr>
+          <a:xfrm>
+            <a:off x="825500" y="5613400"/>
+            <a:ext cx="2286000" cy="115416"/>
+          </a:xfrm>
+          <a:prstGeom prst="rect">
+            <a:avLst/>
+          </a:prstGeom>
+          <a:noFill/>
+        </p:spPr>
+        <p:txBody>
+          <a:bodyPr vert="horz" lIns="0" tIns="0" rIns="0" bIns="0" rtlCol="0">
+            <a:spAutoFit/>
+          </a:bodyPr>
+          <a:lstStyle/>
+          <a:p>
+            <a:r>
+              <a:rPr lang="en-US" sz="750" b="1">
+                <a:solidFill>
+                  <a:srgbClr val="008B8B"/>
+                </a:solidFill>
+                <a:latin typeface="Aptos" panose="020B0004020202020204" pitchFamily="34" charset="0"/>
+              </a:rPr>
+              <a:t>BOTH PATHS INCLUDE</a:t>
+            </a:r>
           </a:p>
         </p:txBody>
       </p:sp>

</xml_diff>

<commit_message>
Converge slide 13 deployment paths
Join the Toolkit and azd lines at one junction before a shared arrow enters Foundry Agent Service.

Co-authored-by: Copilot <223556219+Copilot@users.noreply.github.com>
Copilot-Session: 8c02ba17-1398-4d94-b9f2-71766e81e382
</commit_message>
<xml_diff>
--- a/docs/foundry-apim-mcp-workshop.pptx
+++ b/docs/foundry-apim-mcp-workshop.pptx
@@ -2186,7 +2186,7 @@
           </a:prstGeom>
           <a:extLst>
             <a:ext uri="{C572A759-6A51-4108-AA02-DFA0A04FC94B}">
-              <ma14:wrappingTextBoxFlag xmlns="" xmlns:ma14="http://schemas.microsoft.com/office/mac/drawingml/2011/main" val="0"/>
+              <ma14:wrappingTextBoxFlag xmlns:ma14="http://schemas.microsoft.com/office/mac/drawingml/2011/main" xmlns="" val="0"/>
             </a:ext>
           </a:extLst>
         </p:spPr>
@@ -2264,7 +2264,7 @@
           </a:prstGeom>
           <a:extLst>
             <a:ext uri="{C572A759-6A51-4108-AA02-DFA0A04FC94B}">
-              <ma14:wrappingTextBoxFlag xmlns="" xmlns:ma14="http://schemas.microsoft.com/office/mac/drawingml/2011/main" val="0"/>
+              <ma14:wrappingTextBoxFlag xmlns:ma14="http://schemas.microsoft.com/office/mac/drawingml/2011/main" xmlns="" val="0"/>
             </a:ext>
           </a:extLst>
         </p:spPr>
@@ -4610,7 +4610,7 @@
           </a:prstGeom>
           <a:extLst>
             <a:ext uri="{C572A759-6A51-4108-AA02-DFA0A04FC94B}">
-              <ma14:wrappingTextBoxFlag xmlns="" xmlns:ma14="http://schemas.microsoft.com/office/mac/drawingml/2011/main" val="0"/>
+              <ma14:wrappingTextBoxFlag xmlns:ma14="http://schemas.microsoft.com/office/mac/drawingml/2011/main" xmlns="" val="0"/>
             </a:ext>
           </a:extLst>
         </p:spPr>
@@ -5502,7 +5502,7 @@
           </a:prstGeom>
           <a:extLst>
             <a:ext uri="{C572A759-6A51-4108-AA02-DFA0A04FC94B}">
-              <ma14:wrappingTextBoxFlag xmlns="" xmlns:ma14="http://schemas.microsoft.com/office/mac/drawingml/2011/main" val="0"/>
+              <ma14:wrappingTextBoxFlag xmlns:ma14="http://schemas.microsoft.com/office/mac/drawingml/2011/main" xmlns="" val="0"/>
             </a:ext>
           </a:extLst>
         </p:spPr>
@@ -6466,7 +6466,7 @@
           </a:prstGeom>
           <a:extLst>
             <a:ext uri="{C572A759-6A51-4108-AA02-DFA0A04FC94B}">
-              <ma14:wrappingTextBoxFlag xmlns="" xmlns:ma14="http://schemas.microsoft.com/office/mac/drawingml/2011/main" val="0"/>
+              <ma14:wrappingTextBoxFlag xmlns:ma14="http://schemas.microsoft.com/office/mac/drawingml/2011/main" xmlns="" val="0"/>
             </a:ext>
           </a:extLst>
         </p:spPr>
@@ -7234,56 +7234,6 @@
           </a:p>
         </p:txBody>
       </p:sp>
-      <p:sp>
-        <p:nvSpPr>
-          <p:cNvPr id="19" name="Shape 14"/>
-          <p:cNvSpPr/>
-          <p:nvPr/>
-        </p:nvSpPr>
-        <p:spPr>
-          <a:xfrm>
-            <a:off x="7416800" y="2580640"/>
-            <a:ext cx="1155700" cy="0"/>
-          </a:xfrm>
-          <a:prstGeom prst="line">
-            <a:avLst/>
-          </a:prstGeom>
-          <a:noFill/>
-          <a:ln w="25400">
-            <a:solidFill>
-              <a:srgbClr val="4F8EF7"/>
-            </a:solidFill>
-            <a:prstDash val="solid"/>
-            <a:headEnd type="none"/>
-            <a:tailEnd type="triangle"/>
-          </a:ln>
-        </p:spPr>
-      </p:sp>
-      <p:sp>
-        <p:nvSpPr>
-          <p:cNvPr id="20" name="Shape 15"/>
-          <p:cNvSpPr/>
-          <p:nvPr/>
-        </p:nvSpPr>
-        <p:spPr>
-          <a:xfrm>
-            <a:off x="7416800" y="4654550"/>
-            <a:ext cx="1155700" cy="0"/>
-          </a:xfrm>
-          <a:prstGeom prst="line">
-            <a:avLst/>
-          </a:prstGeom>
-          <a:noFill/>
-          <a:ln w="25400">
-            <a:solidFill>
-              <a:srgbClr val="0F8B8D"/>
-            </a:solidFill>
-            <a:prstDash val="solid"/>
-            <a:headEnd type="none"/>
-            <a:tailEnd type="triangle"/>
-          </a:ln>
-        </p:spPr>
-      </p:sp>
       <p:pic>
         <p:nvPicPr>
           <p:cNvPr id="21" name="Image 3" descr="preencoded.png"/>
@@ -7627,7 +7577,7 @@
           </a:prstGeom>
           <a:extLst>
             <a:ext uri="{C572A759-6A51-4108-AA02-DFA0A04FC94B}">
-              <ma14:wrappingTextBoxFlag xmlns="" xmlns:ma14="http://schemas.microsoft.com/office/mac/drawingml/2011/main" val="0"/>
+              <ma14:wrappingTextBoxFlag xmlns:ma14="http://schemas.microsoft.com/office/mac/drawingml/2011/main" xmlns="" val="0"/>
             </a:ext>
           </a:extLst>
         </p:spPr>
@@ -7692,6 +7642,198 @@
               </a:rPr>
               <a:t>BOTH PATHS INCLUDE</a:t>
             </a:r>
+          </a:p>
+        </p:txBody>
+      </p:sp>
+      <p:cxnSp>
+        <p:nvCxnSpPr>
+          <p:cNvPr id="32" name="Path A Merge">
+            <a:extLst>
+              <a:ext uri="{FF2B5EF4-FFF2-40B4-BE49-F238E27FC236}">
+                <a16:creationId xmlns:a16="http://schemas.microsoft.com/office/drawing/2014/main" id="{8ED5DBD5-75C2-391A-41F7-74BAE2B20076}"/>
+              </a:ext>
+            </a:extLst>
+          </p:cNvPr>
+          <p:cNvCxnSpPr/>
+          <p:nvPr/>
+        </p:nvCxnSpPr>
+        <p:spPr>
+          <a:xfrm>
+            <a:off x="7388860" y="2580640"/>
+            <a:ext cx="815340" cy="988060"/>
+          </a:xfrm>
+          <a:prstGeom prst="line">
+            <a:avLst/>
+          </a:prstGeom>
+          <a:ln w="19050">
+            <a:solidFill>
+              <a:srgbClr val="4F8BEF"/>
+            </a:solidFill>
+          </a:ln>
+        </p:spPr>
+        <p:style>
+          <a:lnRef idx="1">
+            <a:schemeClr val="accent1"/>
+          </a:lnRef>
+          <a:fillRef idx="0">
+            <a:schemeClr val="accent1"/>
+          </a:fillRef>
+          <a:effectRef idx="0">
+            <a:schemeClr val="accent1"/>
+          </a:effectRef>
+          <a:fontRef idx="minor">
+            <a:schemeClr val="tx1"/>
+          </a:fontRef>
+        </p:style>
+      </p:cxnSp>
+      <p:cxnSp>
+        <p:nvCxnSpPr>
+          <p:cNvPr id="33" name="Path B Merge">
+            <a:extLst>
+              <a:ext uri="{FF2B5EF4-FFF2-40B4-BE49-F238E27FC236}">
+                <a16:creationId xmlns:a16="http://schemas.microsoft.com/office/drawing/2014/main" id="{F0A31E5F-A2DC-0CE6-ABA3-755073804560}"/>
+              </a:ext>
+            </a:extLst>
+          </p:cNvPr>
+          <p:cNvCxnSpPr/>
+          <p:nvPr/>
+        </p:nvCxnSpPr>
+        <p:spPr>
+          <a:xfrm flipV="1">
+            <a:off x="7388860" y="3568700"/>
+            <a:ext cx="815340" cy="1085850"/>
+          </a:xfrm>
+          <a:prstGeom prst="line">
+            <a:avLst/>
+          </a:prstGeom>
+          <a:ln w="19050">
+            <a:solidFill>
+              <a:srgbClr val="008B8B"/>
+            </a:solidFill>
+          </a:ln>
+        </p:spPr>
+        <p:style>
+          <a:lnRef idx="1">
+            <a:schemeClr val="accent1"/>
+          </a:lnRef>
+          <a:fillRef idx="0">
+            <a:schemeClr val="accent1"/>
+          </a:fillRef>
+          <a:effectRef idx="0">
+            <a:schemeClr val="accent1"/>
+          </a:effectRef>
+          <a:fontRef idx="minor">
+            <a:schemeClr val="tx1"/>
+          </a:fontRef>
+        </p:style>
+      </p:cxnSp>
+      <p:cxnSp>
+        <p:nvCxnSpPr>
+          <p:cNvPr id="34" name="Shared Target Arrow">
+            <a:extLst>
+              <a:ext uri="{FF2B5EF4-FFF2-40B4-BE49-F238E27FC236}">
+                <a16:creationId xmlns:a16="http://schemas.microsoft.com/office/drawing/2014/main" id="{8AC23DF8-2986-6446-63AA-C903017D2F62}"/>
+              </a:ext>
+            </a:extLst>
+          </p:cNvPr>
+          <p:cNvCxnSpPr/>
+          <p:nvPr/>
+        </p:nvCxnSpPr>
+        <p:spPr>
+          <a:xfrm>
+            <a:off x="8204200" y="3568700"/>
+            <a:ext cx="419100" cy="0"/>
+          </a:xfrm>
+          <a:prstGeom prst="line">
+            <a:avLst/>
+          </a:prstGeom>
+          <a:ln w="22225">
+            <a:solidFill>
+              <a:srgbClr val="12304A"/>
+            </a:solidFill>
+            <a:tailEnd type="triangle"/>
+          </a:ln>
+        </p:spPr>
+        <p:style>
+          <a:lnRef idx="1">
+            <a:schemeClr val="accent1"/>
+          </a:lnRef>
+          <a:fillRef idx="0">
+            <a:schemeClr val="accent1"/>
+          </a:fillRef>
+          <a:effectRef idx="0">
+            <a:schemeClr val="accent1"/>
+          </a:effectRef>
+          <a:fontRef idx="minor">
+            <a:schemeClr val="tx1"/>
+          </a:fontRef>
+        </p:style>
+      </p:cxnSp>
+      <p:sp>
+        <p:nvSpPr>
+          <p:cNvPr id="35" name="Path Merge Junction">
+            <a:extLst>
+              <a:ext uri="{FF2B5EF4-FFF2-40B4-BE49-F238E27FC236}">
+                <a16:creationId xmlns:a16="http://schemas.microsoft.com/office/drawing/2014/main" id="{04051500-A30C-FFF9-91D7-C23CAB22013D}"/>
+              </a:ext>
+            </a:extLst>
+          </p:cNvPr>
+          <p:cNvSpPr/>
+          <p:nvPr/>
+        </p:nvSpPr>
+        <p:spPr>
+          <a:xfrm>
+            <a:off x="8159750" y="3524250"/>
+            <a:ext cx="88900" cy="88900"/>
+          </a:xfrm>
+          <a:prstGeom prst="ellipse">
+            <a:avLst/>
+          </a:prstGeom>
+          <a:solidFill>
+            <a:srgbClr val="12304A"/>
+          </a:solidFill>
+          <a:ln w="12700" cap="flat" cmpd="sng" algn="ctr">
+            <a:noFill/>
+            <a:prstDash val="solid"/>
+            <a:miter lim="800000"/>
+          </a:ln>
+          <a:effectLst/>
+          <a:extLst>
+            <a:ext uri="{91240B29-F687-4F45-9708-019B960494DF}">
+              <a14:hiddenLine xmlns:a14="http://schemas.microsoft.com/office/drawing/2010/main" w="12700" cap="flat" cmpd="sng" algn="ctr">
+                <a:solidFill>
+                  <a:schemeClr val="accent1">
+                    <a:shade val="15000"/>
+                  </a:schemeClr>
+                </a:solidFill>
+                <a:prstDash val="solid"/>
+                <a:miter lim="800000"/>
+              </a14:hiddenLine>
+            </a:ext>
+          </a:extLst>
+        </p:spPr>
+        <p:style>
+          <a:lnRef idx="2">
+            <a:schemeClr val="accent1">
+              <a:shade val="15000"/>
+            </a:schemeClr>
+          </a:lnRef>
+          <a:fillRef idx="1">
+            <a:schemeClr val="accent1"/>
+          </a:fillRef>
+          <a:effectRef idx="0">
+            <a:schemeClr val="accent1"/>
+          </a:effectRef>
+          <a:fontRef idx="minor">
+            <a:schemeClr val="lt1"/>
+          </a:fontRef>
+        </p:style>
+        <p:txBody>
+          <a:bodyPr rtlCol="0" anchor="ctr"/>
+          <a:lstStyle/>
+          <a:p>
+            <a:pPr algn="ctr"/>
+            <a:endParaRPr lang="en-US"/>
           </a:p>
         </p:txBody>
       </p:sp>
@@ -8908,7 +9050,7 @@
           </a:prstGeom>
           <a:extLst>
             <a:ext uri="{C572A759-6A51-4108-AA02-DFA0A04FC94B}">
-              <ma14:wrappingTextBoxFlag xmlns="" xmlns:ma14="http://schemas.microsoft.com/office/mac/drawingml/2011/main" val="0"/>
+              <ma14:wrappingTextBoxFlag xmlns:ma14="http://schemas.microsoft.com/office/mac/drawingml/2011/main" xmlns="" val="0"/>
             </a:ext>
           </a:extLst>
         </p:spPr>
@@ -9883,7 +10025,7 @@
           </a:prstGeom>
           <a:extLst>
             <a:ext uri="{C572A759-6A51-4108-AA02-DFA0A04FC94B}">
-              <ma14:wrappingTextBoxFlag xmlns="" xmlns:ma14="http://schemas.microsoft.com/office/mac/drawingml/2011/main" val="0"/>
+              <ma14:wrappingTextBoxFlag xmlns:ma14="http://schemas.microsoft.com/office/mac/drawingml/2011/main" xmlns="" val="0"/>
             </a:ext>
           </a:extLst>
         </p:spPr>
@@ -11055,7 +11197,7 @@
           </a:prstGeom>
           <a:extLst>
             <a:ext uri="{C572A759-6A51-4108-AA02-DFA0A04FC94B}">
-              <ma14:wrappingTextBoxFlag xmlns="" xmlns:ma14="http://schemas.microsoft.com/office/mac/drawingml/2011/main" val="0"/>
+              <ma14:wrappingTextBoxFlag xmlns:ma14="http://schemas.microsoft.com/office/mac/drawingml/2011/main" xmlns="" val="0"/>
             </a:ext>
           </a:extLst>
         </p:spPr>
@@ -12720,7 +12862,7 @@
           </a:prstGeom>
           <a:extLst>
             <a:ext uri="{C572A759-6A51-4108-AA02-DFA0A04FC94B}">
-              <ma14:wrappingTextBoxFlag xmlns="" xmlns:ma14="http://schemas.microsoft.com/office/mac/drawingml/2011/main" val="0"/>
+              <ma14:wrappingTextBoxFlag xmlns:ma14="http://schemas.microsoft.com/office/mac/drawingml/2011/main" xmlns="" val="0"/>
             </a:ext>
           </a:extLst>
         </p:spPr>
@@ -13967,7 +14109,7 @@
           </a:prstGeom>
           <a:extLst>
             <a:ext uri="{C572A759-6A51-4108-AA02-DFA0A04FC94B}">
-              <ma14:wrappingTextBoxFlag xmlns="" xmlns:ma14="http://schemas.microsoft.com/office/mac/drawingml/2011/main" val="0"/>
+              <ma14:wrappingTextBoxFlag xmlns:ma14="http://schemas.microsoft.com/office/mac/drawingml/2011/main" xmlns="" val="0"/>
             </a:ext>
           </a:extLst>
         </p:spPr>
@@ -15442,7 +15584,7 @@
           </a:prstGeom>
           <a:extLst>
             <a:ext uri="{C572A759-6A51-4108-AA02-DFA0A04FC94B}">
-              <ma14:wrappingTextBoxFlag xmlns="" xmlns:ma14="http://schemas.microsoft.com/office/mac/drawingml/2011/main" val="0"/>
+              <ma14:wrappingTextBoxFlag xmlns:ma14="http://schemas.microsoft.com/office/mac/drawingml/2011/main" xmlns="" val="0"/>
             </a:ext>
           </a:extLst>
         </p:spPr>
@@ -16539,7 +16681,7 @@
           </a:prstGeom>
           <a:extLst>
             <a:ext uri="{C572A759-6A51-4108-AA02-DFA0A04FC94B}">
-              <ma14:wrappingTextBoxFlag xmlns="" xmlns:ma14="http://schemas.microsoft.com/office/mac/drawingml/2011/main" val="0"/>
+              <ma14:wrappingTextBoxFlag xmlns:ma14="http://schemas.microsoft.com/office/mac/drawingml/2011/main" xmlns="" val="0"/>
             </a:ext>
           </a:extLst>
         </p:spPr>
@@ -17640,7 +17782,7 @@
           </a:prstGeom>
           <a:extLst>
             <a:ext uri="{C572A759-6A51-4108-AA02-DFA0A04FC94B}">
-              <ma14:wrappingTextBoxFlag xmlns="" xmlns:ma14="http://schemas.microsoft.com/office/mac/drawingml/2011/main" val="0"/>
+              <ma14:wrappingTextBoxFlag xmlns:ma14="http://schemas.microsoft.com/office/mac/drawingml/2011/main" xmlns="" val="0"/>
             </a:ext>
           </a:extLst>
         </p:spPr>
@@ -19960,7 +20102,7 @@
           </a:prstGeom>
           <a:extLst>
             <a:ext uri="{C572A759-6A51-4108-AA02-DFA0A04FC94B}">
-              <ma14:wrappingTextBoxFlag xmlns="" xmlns:ma14="http://schemas.microsoft.com/office/mac/drawingml/2011/main" val="0"/>
+              <ma14:wrappingTextBoxFlag xmlns:ma14="http://schemas.microsoft.com/office/mac/drawingml/2011/main" xmlns="" val="0"/>
             </a:ext>
           </a:extLst>
         </p:spPr>
@@ -22282,7 +22424,7 @@
           </a:prstGeom>
           <a:extLst>
             <a:ext uri="{C572A759-6A51-4108-AA02-DFA0A04FC94B}">
-              <ma14:wrappingTextBoxFlag xmlns="" xmlns:ma14="http://schemas.microsoft.com/office/mac/drawingml/2011/main" val="0"/>
+              <ma14:wrappingTextBoxFlag xmlns:ma14="http://schemas.microsoft.com/office/mac/drawingml/2011/main" xmlns="" val="0"/>
             </a:ext>
           </a:extLst>
         </p:spPr>
@@ -23307,7 +23449,7 @@
           </a:prstGeom>
           <a:extLst>
             <a:ext uri="{C572A759-6A51-4108-AA02-DFA0A04FC94B}">
-              <ma14:wrappingTextBoxFlag xmlns="" xmlns:ma14="http://schemas.microsoft.com/office/mac/drawingml/2011/main" val="0"/>
+              <ma14:wrappingTextBoxFlag xmlns:ma14="http://schemas.microsoft.com/office/mac/drawingml/2011/main" xmlns="" val="0"/>
             </a:ext>
           </a:extLst>
         </p:spPr>
@@ -24392,7 +24534,7 @@
           </a:prstGeom>
           <a:extLst>
             <a:ext uri="{C572A759-6A51-4108-AA02-DFA0A04FC94B}">
-              <ma14:wrappingTextBoxFlag xmlns="" xmlns:ma14="http://schemas.microsoft.com/office/mac/drawingml/2011/main" val="0"/>
+              <ma14:wrappingTextBoxFlag xmlns:ma14="http://schemas.microsoft.com/office/mac/drawingml/2011/main" xmlns="" val="0"/>
             </a:ext>
           </a:extLst>
         </p:spPr>
@@ -25719,7 +25861,7 @@
           </a:prstGeom>
           <a:extLst>
             <a:ext uri="{C572A759-6A51-4108-AA02-DFA0A04FC94B}">
-              <ma14:wrappingTextBoxFlag xmlns="" xmlns:ma14="http://schemas.microsoft.com/office/mac/drawingml/2011/main" val="0"/>
+              <ma14:wrappingTextBoxFlag xmlns:ma14="http://schemas.microsoft.com/office/mac/drawingml/2011/main" xmlns="" val="0"/>
             </a:ext>
           </a:extLst>
         </p:spPr>
@@ -26657,7 +26799,7 @@
           </a:prstGeom>
           <a:extLst>
             <a:ext uri="{C572A759-6A51-4108-AA02-DFA0A04FC94B}">
-              <ma14:wrappingTextBoxFlag xmlns="" xmlns:ma14="http://schemas.microsoft.com/office/mac/drawingml/2011/main" val="0"/>
+              <ma14:wrappingTextBoxFlag xmlns:ma14="http://schemas.microsoft.com/office/mac/drawingml/2011/main" xmlns="" val="0"/>
             </a:ext>
           </a:extLst>
         </p:spPr>
@@ -27996,7 +28138,7 @@
           </a:prstGeom>
           <a:extLst>
             <a:ext uri="{C572A759-6A51-4108-AA02-DFA0A04FC94B}">
-              <ma14:wrappingTextBoxFlag xmlns="" xmlns:ma14="http://schemas.microsoft.com/office/mac/drawingml/2011/main" val="0"/>
+              <ma14:wrappingTextBoxFlag xmlns:ma14="http://schemas.microsoft.com/office/mac/drawingml/2011/main" xmlns="" val="0"/>
             </a:ext>
           </a:extLst>
         </p:spPr>

</xml_diff>

<commit_message>
Mirror slide 12 arrow style on slide 13
Replace the junction and stem with two direct angled arrows that converge on the shared Foundry Agent Service target.

Co-authored-by: Copilot <223556219+Copilot@users.noreply.github.com>
Copilot-Session: 8c02ba17-1398-4d94-b9f2-71766e81e382
</commit_message>
<xml_diff>
--- a/docs/foundry-apim-mcp-workshop.pptx
+++ b/docs/foundry-apim-mcp-workshop.pptx
@@ -2186,7 +2186,7 @@
           </a:prstGeom>
           <a:extLst>
             <a:ext uri="{C572A759-6A51-4108-AA02-DFA0A04FC94B}">
-              <ma14:wrappingTextBoxFlag xmlns:ma14="http://schemas.microsoft.com/office/mac/drawingml/2011/main" xmlns="" val="0"/>
+              <ma14:wrappingTextBoxFlag xmlns="" xmlns:ma14="http://schemas.microsoft.com/office/mac/drawingml/2011/main" val="0"/>
             </a:ext>
           </a:extLst>
         </p:spPr>
@@ -2264,7 +2264,7 @@
           </a:prstGeom>
           <a:extLst>
             <a:ext uri="{C572A759-6A51-4108-AA02-DFA0A04FC94B}">
-              <ma14:wrappingTextBoxFlag xmlns:ma14="http://schemas.microsoft.com/office/mac/drawingml/2011/main" xmlns="" val="0"/>
+              <ma14:wrappingTextBoxFlag xmlns="" xmlns:ma14="http://schemas.microsoft.com/office/mac/drawingml/2011/main" val="0"/>
             </a:ext>
           </a:extLst>
         </p:spPr>
@@ -2606,6 +2606,13 @@
             <a:prstDash val="solid"/>
           </a:ln>
         </p:spPr>
+        <p:txBody>
+          <a:bodyPr/>
+          <a:lstStyle/>
+          <a:p>
+            <a:endParaRPr lang="en-US"/>
+          </a:p>
+        </p:txBody>
       </p:sp>
       <p:sp>
         <p:nvSpPr>
@@ -2635,6 +2642,13 @@
             <a:prstDash val="solid"/>
           </a:ln>
         </p:spPr>
+        <p:txBody>
+          <a:bodyPr/>
+          <a:lstStyle/>
+          <a:p>
+            <a:endParaRPr lang="en-US"/>
+          </a:p>
+        </p:txBody>
       </p:sp>
       <p:sp>
         <p:nvSpPr>
@@ -2660,6 +2674,13 @@
             <a:prstDash val="solid"/>
           </a:ln>
         </p:spPr>
+        <p:txBody>
+          <a:bodyPr/>
+          <a:lstStyle/>
+          <a:p>
+            <a:endParaRPr lang="en-US"/>
+          </a:p>
+        </p:txBody>
       </p:sp>
       <p:sp>
         <p:nvSpPr>
@@ -2685,6 +2706,13 @@
             <a:prstDash val="solid"/>
           </a:ln>
         </p:spPr>
+        <p:txBody>
+          <a:bodyPr/>
+          <a:lstStyle/>
+          <a:p>
+            <a:endParaRPr lang="en-US"/>
+          </a:p>
+        </p:txBody>
       </p:sp>
       <p:pic>
         <p:nvPicPr>
@@ -2832,6 +2860,13 @@
             <a:prstDash val="solid"/>
           </a:ln>
         </p:spPr>
+        <p:txBody>
+          <a:bodyPr/>
+          <a:lstStyle/>
+          <a:p>
+            <a:endParaRPr lang="en-US"/>
+          </a:p>
+        </p:txBody>
       </p:sp>
       <p:sp>
         <p:nvSpPr>
@@ -3001,6 +3036,13 @@
             <a:prstDash val="solid"/>
           </a:ln>
         </p:spPr>
+        <p:txBody>
+          <a:bodyPr/>
+          <a:lstStyle/>
+          <a:p>
+            <a:endParaRPr lang="en-US"/>
+          </a:p>
+        </p:txBody>
       </p:sp>
       <p:sp>
         <p:nvSpPr>
@@ -3291,6 +3333,13 @@
             <a:prstDash val="solid"/>
           </a:ln>
         </p:spPr>
+        <p:txBody>
+          <a:bodyPr/>
+          <a:lstStyle/>
+          <a:p>
+            <a:endParaRPr lang="en-US"/>
+          </a:p>
+        </p:txBody>
       </p:sp>
       <p:pic>
         <p:nvPicPr>
@@ -3425,6 +3474,13 @@
             <a:tailEnd type="triangle"/>
           </a:ln>
         </p:spPr>
+        <p:txBody>
+          <a:bodyPr/>
+          <a:lstStyle/>
+          <a:p>
+            <a:endParaRPr lang="en-US"/>
+          </a:p>
+        </p:txBody>
       </p:sp>
       <p:sp>
         <p:nvSpPr>
@@ -3450,6 +3506,13 @@
             <a:prstDash val="solid"/>
           </a:ln>
         </p:spPr>
+        <p:txBody>
+          <a:bodyPr/>
+          <a:lstStyle/>
+          <a:p>
+            <a:endParaRPr lang="en-US"/>
+          </a:p>
+        </p:txBody>
       </p:sp>
       <p:pic>
         <p:nvPicPr>
@@ -3584,6 +3647,13 @@
             <a:tailEnd type="triangle"/>
           </a:ln>
         </p:spPr>
+        <p:txBody>
+          <a:bodyPr/>
+          <a:lstStyle/>
+          <a:p>
+            <a:endParaRPr lang="en-US"/>
+          </a:p>
+        </p:txBody>
       </p:sp>
       <p:sp>
         <p:nvSpPr>
@@ -3609,6 +3679,13 @@
             <a:prstDash val="solid"/>
           </a:ln>
         </p:spPr>
+        <p:txBody>
+          <a:bodyPr/>
+          <a:lstStyle/>
+          <a:p>
+            <a:endParaRPr lang="en-US"/>
+          </a:p>
+        </p:txBody>
       </p:sp>
       <p:pic>
         <p:nvPicPr>
@@ -3743,6 +3820,13 @@
             <a:tailEnd type="triangle"/>
           </a:ln>
         </p:spPr>
+        <p:txBody>
+          <a:bodyPr/>
+          <a:lstStyle/>
+          <a:p>
+            <a:endParaRPr lang="en-US"/>
+          </a:p>
+        </p:txBody>
       </p:sp>
       <p:sp>
         <p:nvSpPr>
@@ -3768,6 +3852,13 @@
             <a:prstDash val="solid"/>
           </a:ln>
         </p:spPr>
+        <p:txBody>
+          <a:bodyPr/>
+          <a:lstStyle/>
+          <a:p>
+            <a:endParaRPr lang="en-US"/>
+          </a:p>
+        </p:txBody>
       </p:sp>
       <p:pic>
         <p:nvPicPr>
@@ -3902,6 +3993,13 @@
             <a:tailEnd type="triangle"/>
           </a:ln>
         </p:spPr>
+        <p:txBody>
+          <a:bodyPr/>
+          <a:lstStyle/>
+          <a:p>
+            <a:endParaRPr lang="en-US"/>
+          </a:p>
+        </p:txBody>
       </p:sp>
       <p:sp>
         <p:nvSpPr>
@@ -3927,6 +4025,13 @@
             <a:prstDash val="solid"/>
           </a:ln>
         </p:spPr>
+        <p:txBody>
+          <a:bodyPr/>
+          <a:lstStyle/>
+          <a:p>
+            <a:endParaRPr lang="en-US"/>
+          </a:p>
+        </p:txBody>
       </p:sp>
       <p:pic>
         <p:nvPicPr>
@@ -4069,6 +4174,13 @@
             </a:outerShdw>
           </a:effectLst>
         </p:spPr>
+        <p:txBody>
+          <a:bodyPr/>
+          <a:lstStyle/>
+          <a:p>
+            <a:endParaRPr lang="en-US"/>
+          </a:p>
+        </p:txBody>
       </p:sp>
       <p:pic>
         <p:nvPicPr>
@@ -4167,6 +4279,13 @@
             <a:prstDash val="solid"/>
           </a:ln>
         </p:spPr>
+        <p:txBody>
+          <a:bodyPr/>
+          <a:lstStyle/>
+          <a:p>
+            <a:endParaRPr lang="en-US"/>
+          </a:p>
+        </p:txBody>
       </p:sp>
       <p:sp>
         <p:nvSpPr>
@@ -4240,6 +4359,13 @@
             </a:outerShdw>
           </a:effectLst>
         </p:spPr>
+        <p:txBody>
+          <a:bodyPr/>
+          <a:lstStyle/>
+          <a:p>
+            <a:endParaRPr lang="en-US"/>
+          </a:p>
+        </p:txBody>
       </p:sp>
       <p:pic>
         <p:nvPicPr>
@@ -4338,6 +4464,13 @@
             <a:prstDash val="solid"/>
           </a:ln>
         </p:spPr>
+        <p:txBody>
+          <a:bodyPr/>
+          <a:lstStyle/>
+          <a:p>
+            <a:endParaRPr lang="en-US"/>
+          </a:p>
+        </p:txBody>
       </p:sp>
       <p:sp>
         <p:nvSpPr>
@@ -4411,6 +4544,13 @@
             </a:outerShdw>
           </a:effectLst>
         </p:spPr>
+        <p:txBody>
+          <a:bodyPr/>
+          <a:lstStyle/>
+          <a:p>
+            <a:endParaRPr lang="en-US"/>
+          </a:p>
+        </p:txBody>
       </p:sp>
       <p:pic>
         <p:nvPicPr>
@@ -4509,6 +4649,13 @@
             <a:prstDash val="solid"/>
           </a:ln>
         </p:spPr>
+        <p:txBody>
+          <a:bodyPr/>
+          <a:lstStyle/>
+          <a:p>
+            <a:endParaRPr lang="en-US"/>
+          </a:p>
+        </p:txBody>
       </p:sp>
       <p:sp>
         <p:nvSpPr>
@@ -4610,7 +4757,7 @@
           </a:prstGeom>
           <a:extLst>
             <a:ext uri="{C572A759-6A51-4108-AA02-DFA0A04FC94B}">
-              <ma14:wrappingTextBoxFlag xmlns:ma14="http://schemas.microsoft.com/office/mac/drawingml/2011/main" xmlns="" val="0"/>
+              <ma14:wrappingTextBoxFlag xmlns="" xmlns:ma14="http://schemas.microsoft.com/office/mac/drawingml/2011/main" val="0"/>
             </a:ext>
           </a:extLst>
         </p:spPr>
@@ -4817,6 +4964,13 @@
             </a:outerShdw>
           </a:effectLst>
         </p:spPr>
+        <p:txBody>
+          <a:bodyPr/>
+          <a:lstStyle/>
+          <a:p>
+            <a:endParaRPr lang="en-US"/>
+          </a:p>
+        </p:txBody>
       </p:sp>
       <p:sp>
         <p:nvSpPr>
@@ -4842,6 +4996,13 @@
             <a:prstDash val="solid"/>
           </a:ln>
         </p:spPr>
+        <p:txBody>
+          <a:bodyPr/>
+          <a:lstStyle/>
+          <a:p>
+            <a:endParaRPr lang="en-US"/>
+          </a:p>
+        </p:txBody>
       </p:sp>
       <p:pic>
         <p:nvPicPr>
@@ -5040,6 +5201,13 @@
             <a:prstDash val="solid"/>
           </a:ln>
         </p:spPr>
+        <p:txBody>
+          <a:bodyPr/>
+          <a:lstStyle/>
+          <a:p>
+            <a:endParaRPr lang="en-US"/>
+          </a:p>
+        </p:txBody>
       </p:sp>
       <p:sp>
         <p:nvSpPr>
@@ -5113,6 +5281,13 @@
             </a:outerShdw>
           </a:effectLst>
         </p:spPr>
+        <p:txBody>
+          <a:bodyPr/>
+          <a:lstStyle/>
+          <a:p>
+            <a:endParaRPr lang="en-US"/>
+          </a:p>
+        </p:txBody>
       </p:sp>
       <p:sp>
         <p:nvSpPr>
@@ -5138,6 +5313,13 @@
             <a:prstDash val="solid"/>
           </a:ln>
         </p:spPr>
+        <p:txBody>
+          <a:bodyPr/>
+          <a:lstStyle/>
+          <a:p>
+            <a:endParaRPr lang="en-US"/>
+          </a:p>
+        </p:txBody>
       </p:sp>
       <p:pic>
         <p:nvPicPr>
@@ -5307,6 +5489,13 @@
             <a:prstDash val="solid"/>
           </a:ln>
         </p:spPr>
+        <p:txBody>
+          <a:bodyPr/>
+          <a:lstStyle/>
+          <a:p>
+            <a:endParaRPr lang="en-US"/>
+          </a:p>
+        </p:txBody>
       </p:sp>
       <p:sp>
         <p:nvSpPr>
@@ -5371,6 +5560,13 @@
             <a:prstDash val="solid"/>
           </a:ln>
         </p:spPr>
+        <p:txBody>
+          <a:bodyPr/>
+          <a:lstStyle/>
+          <a:p>
+            <a:endParaRPr lang="en-US"/>
+          </a:p>
+        </p:txBody>
       </p:sp>
       <p:pic>
         <p:nvPicPr>
@@ -5502,7 +5698,7 @@
           </a:prstGeom>
           <a:extLst>
             <a:ext uri="{C572A759-6A51-4108-AA02-DFA0A04FC94B}">
-              <ma14:wrappingTextBoxFlag xmlns:ma14="http://schemas.microsoft.com/office/mac/drawingml/2011/main" xmlns="" val="0"/>
+              <ma14:wrappingTextBoxFlag xmlns="" xmlns:ma14="http://schemas.microsoft.com/office/mac/drawingml/2011/main" val="0"/>
             </a:ext>
           </a:extLst>
         </p:spPr>
@@ -5707,6 +5903,13 @@
             </a:outerShdw>
           </a:effectLst>
         </p:spPr>
+        <p:txBody>
+          <a:bodyPr/>
+          <a:lstStyle/>
+          <a:p>
+            <a:endParaRPr lang="en-US"/>
+          </a:p>
+        </p:txBody>
       </p:sp>
       <p:pic>
         <p:nvPicPr>
@@ -5875,6 +6078,13 @@
             <a:tailEnd type="triangle"/>
           </a:ln>
         </p:spPr>
+        <p:txBody>
+          <a:bodyPr/>
+          <a:lstStyle/>
+          <a:p>
+            <a:endParaRPr lang="en-US"/>
+          </a:p>
+        </p:txBody>
       </p:sp>
       <p:sp>
         <p:nvSpPr>
@@ -5899,6 +6109,13 @@
             <a:tailEnd type="triangle"/>
           </a:ln>
         </p:spPr>
+        <p:txBody>
+          <a:bodyPr/>
+          <a:lstStyle/>
+          <a:p>
+            <a:endParaRPr lang="en-US"/>
+          </a:p>
+        </p:txBody>
       </p:sp>
       <p:sp>
         <p:nvSpPr>
@@ -5933,6 +6150,13 @@
             </a:outerShdw>
           </a:effectLst>
         </p:spPr>
+        <p:txBody>
+          <a:bodyPr/>
+          <a:lstStyle/>
+          <a:p>
+            <a:endParaRPr lang="en-US"/>
+          </a:p>
+        </p:txBody>
       </p:sp>
       <p:sp>
         <p:nvSpPr>
@@ -5958,6 +6182,13 @@
             <a:prstDash val="solid"/>
           </a:ln>
         </p:spPr>
+        <p:txBody>
+          <a:bodyPr/>
+          <a:lstStyle/>
+          <a:p>
+            <a:endParaRPr lang="en-US"/>
+          </a:p>
+        </p:txBody>
       </p:sp>
       <p:pic>
         <p:nvPicPr>
@@ -6167,6 +6398,13 @@
             </a:outerShdw>
           </a:effectLst>
         </p:spPr>
+        <p:txBody>
+          <a:bodyPr/>
+          <a:lstStyle/>
+          <a:p>
+            <a:endParaRPr lang="en-US"/>
+          </a:p>
+        </p:txBody>
       </p:sp>
       <p:sp>
         <p:nvSpPr>
@@ -6192,6 +6430,13 @@
             <a:prstDash val="solid"/>
           </a:ln>
         </p:spPr>
+        <p:txBody>
+          <a:bodyPr/>
+          <a:lstStyle/>
+          <a:p>
+            <a:endParaRPr lang="en-US"/>
+          </a:p>
+        </p:txBody>
       </p:sp>
       <p:pic>
         <p:nvPicPr>
@@ -6466,7 +6711,7 @@
           </a:prstGeom>
           <a:extLst>
             <a:ext uri="{C572A759-6A51-4108-AA02-DFA0A04FC94B}">
-              <ma14:wrappingTextBoxFlag xmlns:ma14="http://schemas.microsoft.com/office/mac/drawingml/2011/main" xmlns="" val="0"/>
+              <ma14:wrappingTextBoxFlag xmlns="" xmlns:ma14="http://schemas.microsoft.com/office/mac/drawingml/2011/main" val="0"/>
             </a:ext>
           </a:extLst>
         </p:spPr>
@@ -6673,6 +6918,13 @@
             </a:outerShdw>
           </a:effectLst>
         </p:spPr>
+        <p:txBody>
+          <a:bodyPr/>
+          <a:lstStyle/>
+          <a:p>
+            <a:endParaRPr lang="en-US"/>
+          </a:p>
+        </p:txBody>
       </p:sp>
       <p:sp>
         <p:nvSpPr>
@@ -6698,6 +6950,13 @@
             <a:prstDash val="solid"/>
           </a:ln>
         </p:spPr>
+        <p:txBody>
+          <a:bodyPr/>
+          <a:lstStyle/>
+          <a:p>
+            <a:endParaRPr lang="en-US"/>
+          </a:p>
+        </p:txBody>
       </p:sp>
       <p:pic>
         <p:nvPicPr>
@@ -6882,6 +7141,13 @@
             </a:outerShdw>
           </a:effectLst>
         </p:spPr>
+        <p:txBody>
+          <a:bodyPr/>
+          <a:lstStyle/>
+          <a:p>
+            <a:endParaRPr lang="en-US"/>
+          </a:p>
+        </p:txBody>
       </p:sp>
       <p:sp>
         <p:nvSpPr>
@@ -6907,6 +7173,13 @@
             <a:prstDash val="solid"/>
           </a:ln>
         </p:spPr>
+        <p:txBody>
+          <a:bodyPr/>
+          <a:lstStyle/>
+          <a:p>
+            <a:endParaRPr lang="en-US"/>
+          </a:p>
+        </p:txBody>
       </p:sp>
       <p:pic>
         <p:nvPicPr>
@@ -7089,6 +7362,13 @@
             </a:outerShdw>
           </a:effectLst>
         </p:spPr>
+        <p:txBody>
+          <a:bodyPr/>
+          <a:lstStyle/>
+          <a:p>
+            <a:endParaRPr lang="en-US"/>
+          </a:p>
+        </p:txBody>
       </p:sp>
       <p:pic>
         <p:nvPicPr>
@@ -7577,7 +7857,7 @@
           </a:prstGeom>
           <a:extLst>
             <a:ext uri="{C572A759-6A51-4108-AA02-DFA0A04FC94B}">
-              <ma14:wrappingTextBoxFlag xmlns:ma14="http://schemas.microsoft.com/office/mac/drawingml/2011/main" xmlns="" val="0"/>
+              <ma14:wrappingTextBoxFlag xmlns="" xmlns:ma14="http://schemas.microsoft.com/office/mac/drawingml/2011/main" val="0"/>
             </a:ext>
           </a:extLst>
         </p:spPr>
@@ -7647,10 +7927,10 @@
       </p:sp>
       <p:cxnSp>
         <p:nvCxnSpPr>
-          <p:cNvPr id="32" name="Path A Merge">
+          <p:cNvPr id="19" name="Path A Direct Arrow">
             <a:extLst>
               <a:ext uri="{FF2B5EF4-FFF2-40B4-BE49-F238E27FC236}">
-                <a16:creationId xmlns:a16="http://schemas.microsoft.com/office/drawing/2014/main" id="{8ED5DBD5-75C2-391A-41F7-74BAE2B20076}"/>
+                <a16:creationId xmlns:a16="http://schemas.microsoft.com/office/drawing/2014/main" id="{3FAA1174-B7CC-01C1-9A04-872126AFF9F7}"/>
               </a:ext>
             </a:extLst>
           </p:cNvPr>
@@ -7660,7 +7940,7 @@
         <p:spPr>
           <a:xfrm>
             <a:off x="7388860" y="2580640"/>
-            <a:ext cx="815340" cy="988060"/>
+            <a:ext cx="1234440" cy="988060"/>
           </a:xfrm>
           <a:prstGeom prst="line">
             <a:avLst/>
@@ -7669,6 +7949,7 @@
             <a:solidFill>
               <a:srgbClr val="4F8BEF"/>
             </a:solidFill>
+            <a:tailEnd type="triangle"/>
           </a:ln>
         </p:spPr>
         <p:style>
@@ -7688,10 +7969,10 @@
       </p:cxnSp>
       <p:cxnSp>
         <p:nvCxnSpPr>
-          <p:cNvPr id="33" name="Path B Merge">
+          <p:cNvPr id="20" name="Path B Direct Arrow">
             <a:extLst>
               <a:ext uri="{FF2B5EF4-FFF2-40B4-BE49-F238E27FC236}">
-                <a16:creationId xmlns:a16="http://schemas.microsoft.com/office/drawing/2014/main" id="{F0A31E5F-A2DC-0CE6-ABA3-755073804560}"/>
+                <a16:creationId xmlns:a16="http://schemas.microsoft.com/office/drawing/2014/main" id="{76947109-DAB5-1AD9-E6BE-91C1D9300453}"/>
               </a:ext>
             </a:extLst>
           </p:cNvPr>
@@ -7701,7 +7982,7 @@
         <p:spPr>
           <a:xfrm flipV="1">
             <a:off x="7388860" y="3568700"/>
-            <a:ext cx="815340" cy="1085850"/>
+            <a:ext cx="1234440" cy="1085850"/>
           </a:xfrm>
           <a:prstGeom prst="line">
             <a:avLst/>
@@ -7710,6 +7991,7 @@
             <a:solidFill>
               <a:srgbClr val="008B8B"/>
             </a:solidFill>
+            <a:tailEnd type="triangle"/>
           </a:ln>
         </p:spPr>
         <p:style>
@@ -7727,116 +8009,6 @@
           </a:fontRef>
         </p:style>
       </p:cxnSp>
-      <p:cxnSp>
-        <p:nvCxnSpPr>
-          <p:cNvPr id="34" name="Shared Target Arrow">
-            <a:extLst>
-              <a:ext uri="{FF2B5EF4-FFF2-40B4-BE49-F238E27FC236}">
-                <a16:creationId xmlns:a16="http://schemas.microsoft.com/office/drawing/2014/main" id="{8AC23DF8-2986-6446-63AA-C903017D2F62}"/>
-              </a:ext>
-            </a:extLst>
-          </p:cNvPr>
-          <p:cNvCxnSpPr/>
-          <p:nvPr/>
-        </p:nvCxnSpPr>
-        <p:spPr>
-          <a:xfrm>
-            <a:off x="8204200" y="3568700"/>
-            <a:ext cx="419100" cy="0"/>
-          </a:xfrm>
-          <a:prstGeom prst="line">
-            <a:avLst/>
-          </a:prstGeom>
-          <a:ln w="22225">
-            <a:solidFill>
-              <a:srgbClr val="12304A"/>
-            </a:solidFill>
-            <a:tailEnd type="triangle"/>
-          </a:ln>
-        </p:spPr>
-        <p:style>
-          <a:lnRef idx="1">
-            <a:schemeClr val="accent1"/>
-          </a:lnRef>
-          <a:fillRef idx="0">
-            <a:schemeClr val="accent1"/>
-          </a:fillRef>
-          <a:effectRef idx="0">
-            <a:schemeClr val="accent1"/>
-          </a:effectRef>
-          <a:fontRef idx="minor">
-            <a:schemeClr val="tx1"/>
-          </a:fontRef>
-        </p:style>
-      </p:cxnSp>
-      <p:sp>
-        <p:nvSpPr>
-          <p:cNvPr id="35" name="Path Merge Junction">
-            <a:extLst>
-              <a:ext uri="{FF2B5EF4-FFF2-40B4-BE49-F238E27FC236}">
-                <a16:creationId xmlns:a16="http://schemas.microsoft.com/office/drawing/2014/main" id="{04051500-A30C-FFF9-91D7-C23CAB22013D}"/>
-              </a:ext>
-            </a:extLst>
-          </p:cNvPr>
-          <p:cNvSpPr/>
-          <p:nvPr/>
-        </p:nvSpPr>
-        <p:spPr>
-          <a:xfrm>
-            <a:off x="8159750" y="3524250"/>
-            <a:ext cx="88900" cy="88900"/>
-          </a:xfrm>
-          <a:prstGeom prst="ellipse">
-            <a:avLst/>
-          </a:prstGeom>
-          <a:solidFill>
-            <a:srgbClr val="12304A"/>
-          </a:solidFill>
-          <a:ln w="12700" cap="flat" cmpd="sng" algn="ctr">
-            <a:noFill/>
-            <a:prstDash val="solid"/>
-            <a:miter lim="800000"/>
-          </a:ln>
-          <a:effectLst/>
-          <a:extLst>
-            <a:ext uri="{91240B29-F687-4F45-9708-019B960494DF}">
-              <a14:hiddenLine xmlns:a14="http://schemas.microsoft.com/office/drawing/2010/main" w="12700" cap="flat" cmpd="sng" algn="ctr">
-                <a:solidFill>
-                  <a:schemeClr val="accent1">
-                    <a:shade val="15000"/>
-                  </a:schemeClr>
-                </a:solidFill>
-                <a:prstDash val="solid"/>
-                <a:miter lim="800000"/>
-              </a14:hiddenLine>
-            </a:ext>
-          </a:extLst>
-        </p:spPr>
-        <p:style>
-          <a:lnRef idx="2">
-            <a:schemeClr val="accent1">
-              <a:shade val="15000"/>
-            </a:schemeClr>
-          </a:lnRef>
-          <a:fillRef idx="1">
-            <a:schemeClr val="accent1"/>
-          </a:fillRef>
-          <a:effectRef idx="0">
-            <a:schemeClr val="accent1"/>
-          </a:effectRef>
-          <a:fontRef idx="minor">
-            <a:schemeClr val="lt1"/>
-          </a:fontRef>
-        </p:style>
-        <p:txBody>
-          <a:bodyPr rtlCol="0" anchor="ctr"/>
-          <a:lstStyle/>
-          <a:p>
-            <a:pPr algn="ctr"/>
-            <a:endParaRPr lang="en-US"/>
-          </a:p>
-        </p:txBody>
-      </p:sp>
     </p:spTree>
   </p:cSld>
   <p:clrMapOvr>
@@ -8014,6 +8186,13 @@
             </a:outerShdw>
           </a:effectLst>
         </p:spPr>
+        <p:txBody>
+          <a:bodyPr/>
+          <a:lstStyle/>
+          <a:p>
+            <a:endParaRPr lang="en-US"/>
+          </a:p>
+        </p:txBody>
       </p:sp>
       <p:sp>
         <p:nvSpPr>
@@ -8039,6 +8218,13 @@
             <a:prstDash val="solid"/>
           </a:ln>
         </p:spPr>
+        <p:txBody>
+          <a:bodyPr/>
+          <a:lstStyle/>
+          <a:p>
+            <a:endParaRPr lang="en-US"/>
+          </a:p>
+        </p:txBody>
       </p:sp>
       <p:pic>
         <p:nvPicPr>
@@ -8241,6 +8427,13 @@
             <a:prstDash val="solid"/>
           </a:ln>
         </p:spPr>
+        <p:txBody>
+          <a:bodyPr/>
+          <a:lstStyle/>
+          <a:p>
+            <a:endParaRPr lang="en-US"/>
+          </a:p>
+        </p:txBody>
       </p:sp>
       <p:sp>
         <p:nvSpPr>
@@ -8383,6 +8576,13 @@
             <a:prstDash val="solid"/>
           </a:ln>
         </p:spPr>
+        <p:txBody>
+          <a:bodyPr/>
+          <a:lstStyle/>
+          <a:p>
+            <a:endParaRPr lang="en-US"/>
+          </a:p>
+        </p:txBody>
       </p:sp>
       <p:sp>
         <p:nvSpPr>
@@ -8525,6 +8725,13 @@
             <a:prstDash val="solid"/>
           </a:ln>
         </p:spPr>
+        <p:txBody>
+          <a:bodyPr/>
+          <a:lstStyle/>
+          <a:p>
+            <a:endParaRPr lang="en-US"/>
+          </a:p>
+        </p:txBody>
       </p:sp>
       <p:sp>
         <p:nvSpPr>
@@ -8667,6 +8874,13 @@
             <a:prstDash val="solid"/>
           </a:ln>
         </p:spPr>
+        <p:txBody>
+          <a:bodyPr/>
+          <a:lstStyle/>
+          <a:p>
+            <a:endParaRPr lang="en-US"/>
+          </a:p>
+        </p:txBody>
       </p:sp>
       <p:sp>
         <p:nvSpPr>
@@ -8809,6 +9023,13 @@
             <a:prstDash val="solid"/>
           </a:ln>
         </p:spPr>
+        <p:txBody>
+          <a:bodyPr/>
+          <a:lstStyle/>
+          <a:p>
+            <a:endParaRPr lang="en-US"/>
+          </a:p>
+        </p:txBody>
       </p:sp>
       <p:sp>
         <p:nvSpPr>
@@ -8951,6 +9172,13 @@
             <a:prstDash val="solid"/>
           </a:ln>
         </p:spPr>
+        <p:txBody>
+          <a:bodyPr/>
+          <a:lstStyle/>
+          <a:p>
+            <a:endParaRPr lang="en-US"/>
+          </a:p>
+        </p:txBody>
       </p:sp>
       <p:sp>
         <p:nvSpPr>
@@ -9050,7 +9278,7 @@
           </a:prstGeom>
           <a:extLst>
             <a:ext uri="{C572A759-6A51-4108-AA02-DFA0A04FC94B}">
-              <ma14:wrappingTextBoxFlag xmlns:ma14="http://schemas.microsoft.com/office/mac/drawingml/2011/main" xmlns="" val="0"/>
+              <ma14:wrappingTextBoxFlag xmlns="" xmlns:ma14="http://schemas.microsoft.com/office/mac/drawingml/2011/main" val="0"/>
             </a:ext>
           </a:extLst>
         </p:spPr>
@@ -9341,6 +9569,13 @@
             </a:outerShdw>
           </a:effectLst>
         </p:spPr>
+        <p:txBody>
+          <a:bodyPr/>
+          <a:lstStyle/>
+          <a:p>
+            <a:endParaRPr lang="en-US"/>
+          </a:p>
+        </p:txBody>
       </p:sp>
       <p:pic>
         <p:nvPicPr>
@@ -9483,6 +9718,13 @@
             </a:outerShdw>
           </a:effectLst>
         </p:spPr>
+        <p:txBody>
+          <a:bodyPr/>
+          <a:lstStyle/>
+          <a:p>
+            <a:endParaRPr lang="en-US"/>
+          </a:p>
+        </p:txBody>
       </p:sp>
       <p:pic>
         <p:nvPicPr>
@@ -9625,6 +9867,13 @@
             </a:outerShdw>
           </a:effectLst>
         </p:spPr>
+        <p:txBody>
+          <a:bodyPr/>
+          <a:lstStyle/>
+          <a:p>
+            <a:endParaRPr lang="en-US"/>
+          </a:p>
+        </p:txBody>
       </p:sp>
       <p:pic>
         <p:nvPicPr>
@@ -9767,6 +10016,13 @@
             </a:outerShdw>
           </a:effectLst>
         </p:spPr>
+        <p:txBody>
+          <a:bodyPr/>
+          <a:lstStyle/>
+          <a:p>
+            <a:endParaRPr lang="en-US"/>
+          </a:p>
+        </p:txBody>
       </p:sp>
       <p:pic>
         <p:nvPicPr>
@@ -9901,6 +10157,13 @@
             <a:tailEnd type="triangle"/>
           </a:ln>
         </p:spPr>
+        <p:txBody>
+          <a:bodyPr/>
+          <a:lstStyle/>
+          <a:p>
+            <a:endParaRPr lang="en-US"/>
+          </a:p>
+        </p:txBody>
       </p:sp>
       <p:sp>
         <p:nvSpPr>
@@ -9926,6 +10189,13 @@
             <a:prstDash val="solid"/>
           </a:ln>
         </p:spPr>
+        <p:txBody>
+          <a:bodyPr/>
+          <a:lstStyle/>
+          <a:p>
+            <a:endParaRPr lang="en-US"/>
+          </a:p>
+        </p:txBody>
       </p:sp>
       <p:sp>
         <p:nvSpPr>
@@ -10025,7 +10295,7 @@
           </a:prstGeom>
           <a:extLst>
             <a:ext uri="{C572A759-6A51-4108-AA02-DFA0A04FC94B}">
-              <ma14:wrappingTextBoxFlag xmlns:ma14="http://schemas.microsoft.com/office/mac/drawingml/2011/main" xmlns="" val="0"/>
+              <ma14:wrappingTextBoxFlag xmlns="" xmlns:ma14="http://schemas.microsoft.com/office/mac/drawingml/2011/main" val="0"/>
             </a:ext>
           </a:extLst>
         </p:spPr>
@@ -10308,6 +10578,13 @@
             </a:outerShdw>
           </a:effectLst>
         </p:spPr>
+        <p:txBody>
+          <a:bodyPr/>
+          <a:lstStyle/>
+          <a:p>
+            <a:endParaRPr lang="en-US"/>
+          </a:p>
+        </p:txBody>
       </p:sp>
       <p:sp>
         <p:nvSpPr>
@@ -10333,6 +10610,13 @@
             <a:prstDash val="solid"/>
           </a:ln>
         </p:spPr>
+        <p:txBody>
+          <a:bodyPr/>
+          <a:lstStyle/>
+          <a:p>
+            <a:endParaRPr lang="en-US"/>
+          </a:p>
+        </p:txBody>
       </p:sp>
       <p:pic>
         <p:nvPicPr>
@@ -10587,6 +10871,13 @@
             </a:outerShdw>
           </a:effectLst>
         </p:spPr>
+        <p:txBody>
+          <a:bodyPr/>
+          <a:lstStyle/>
+          <a:p>
+            <a:endParaRPr lang="en-US"/>
+          </a:p>
+        </p:txBody>
       </p:sp>
       <p:sp>
         <p:nvSpPr>
@@ -10612,6 +10903,13 @@
             <a:prstDash val="solid"/>
           </a:ln>
         </p:spPr>
+        <p:txBody>
+          <a:bodyPr/>
+          <a:lstStyle/>
+          <a:p>
+            <a:endParaRPr lang="en-US"/>
+          </a:p>
+        </p:txBody>
       </p:sp>
       <p:pic>
         <p:nvPicPr>
@@ -10831,6 +11129,13 @@
             </a:outerShdw>
           </a:effectLst>
         </p:spPr>
+        <p:txBody>
+          <a:bodyPr/>
+          <a:lstStyle/>
+          <a:p>
+            <a:endParaRPr lang="en-US"/>
+          </a:p>
+        </p:txBody>
       </p:sp>
       <p:sp>
         <p:nvSpPr>
@@ -10856,6 +11161,13 @@
             <a:prstDash val="solid"/>
           </a:ln>
         </p:spPr>
+        <p:txBody>
+          <a:bodyPr/>
+          <a:lstStyle/>
+          <a:p>
+            <a:endParaRPr lang="en-US"/>
+          </a:p>
+        </p:txBody>
       </p:sp>
       <p:pic>
         <p:nvPicPr>
@@ -11066,6 +11378,13 @@
             <a:prstDash val="solid"/>
           </a:ln>
         </p:spPr>
+        <p:txBody>
+          <a:bodyPr/>
+          <a:lstStyle/>
+          <a:p>
+            <a:endParaRPr lang="en-US"/>
+          </a:p>
+        </p:txBody>
       </p:sp>
       <p:pic>
         <p:nvPicPr>
@@ -11197,7 +11516,7 @@
           </a:prstGeom>
           <a:extLst>
             <a:ext uri="{C572A759-6A51-4108-AA02-DFA0A04FC94B}">
-              <ma14:wrappingTextBoxFlag xmlns:ma14="http://schemas.microsoft.com/office/mac/drawingml/2011/main" xmlns="" val="0"/>
+              <ma14:wrappingTextBoxFlag xmlns="" xmlns:ma14="http://schemas.microsoft.com/office/mac/drawingml/2011/main" val="0"/>
             </a:ext>
           </a:extLst>
         </p:spPr>
@@ -11630,6 +11949,13 @@
             </a:outerShdw>
           </a:effectLst>
         </p:spPr>
+        <p:txBody>
+          <a:bodyPr/>
+          <a:lstStyle/>
+          <a:p>
+            <a:endParaRPr lang="en-US"/>
+          </a:p>
+        </p:txBody>
       </p:sp>
       <p:pic>
         <p:nvPicPr>
@@ -11723,6 +12049,13 @@
             <a:tailEnd type="triangle"/>
           </a:ln>
         </p:spPr>
+        <p:txBody>
+          <a:bodyPr/>
+          <a:lstStyle/>
+          <a:p>
+            <a:endParaRPr lang="en-US"/>
+          </a:p>
+        </p:txBody>
       </p:sp>
       <p:sp>
         <p:nvSpPr>
@@ -11755,6 +12088,13 @@
             </a:outerShdw>
           </a:effectLst>
         </p:spPr>
+        <p:txBody>
+          <a:bodyPr/>
+          <a:lstStyle/>
+          <a:p>
+            <a:endParaRPr lang="en-US"/>
+          </a:p>
+        </p:txBody>
       </p:sp>
       <p:pic>
         <p:nvPicPr>
@@ -11848,6 +12188,13 @@
             <a:tailEnd type="triangle"/>
           </a:ln>
         </p:spPr>
+        <p:txBody>
+          <a:bodyPr/>
+          <a:lstStyle/>
+          <a:p>
+            <a:endParaRPr lang="en-US"/>
+          </a:p>
+        </p:txBody>
       </p:sp>
       <p:sp>
         <p:nvSpPr>
@@ -11880,6 +12227,13 @@
             </a:outerShdw>
           </a:effectLst>
         </p:spPr>
+        <p:txBody>
+          <a:bodyPr/>
+          <a:lstStyle/>
+          <a:p>
+            <a:endParaRPr lang="en-US"/>
+          </a:p>
+        </p:txBody>
       </p:sp>
       <p:pic>
         <p:nvPicPr>
@@ -11973,6 +12327,13 @@
             <a:tailEnd type="triangle"/>
           </a:ln>
         </p:spPr>
+        <p:txBody>
+          <a:bodyPr/>
+          <a:lstStyle/>
+          <a:p>
+            <a:endParaRPr lang="en-US"/>
+          </a:p>
+        </p:txBody>
       </p:sp>
       <p:sp>
         <p:nvSpPr>
@@ -12005,6 +12366,13 @@
             </a:outerShdw>
           </a:effectLst>
         </p:spPr>
+        <p:txBody>
+          <a:bodyPr/>
+          <a:lstStyle/>
+          <a:p>
+            <a:endParaRPr lang="en-US"/>
+          </a:p>
+        </p:txBody>
       </p:sp>
       <p:pic>
         <p:nvPicPr>
@@ -12098,6 +12466,13 @@
             <a:tailEnd type="triangle"/>
           </a:ln>
         </p:spPr>
+        <p:txBody>
+          <a:bodyPr/>
+          <a:lstStyle/>
+          <a:p>
+            <a:endParaRPr lang="en-US"/>
+          </a:p>
+        </p:txBody>
       </p:sp>
       <p:sp>
         <p:nvSpPr>
@@ -12130,6 +12505,13 @@
             </a:outerShdw>
           </a:effectLst>
         </p:spPr>
+        <p:txBody>
+          <a:bodyPr/>
+          <a:lstStyle/>
+          <a:p>
+            <a:endParaRPr lang="en-US"/>
+          </a:p>
+        </p:txBody>
       </p:sp>
       <p:pic>
         <p:nvPicPr>
@@ -12223,6 +12605,13 @@
             <a:tailEnd type="triangle"/>
           </a:ln>
         </p:spPr>
+        <p:txBody>
+          <a:bodyPr/>
+          <a:lstStyle/>
+          <a:p>
+            <a:endParaRPr lang="en-US"/>
+          </a:p>
+        </p:txBody>
       </p:sp>
       <p:sp>
         <p:nvSpPr>
@@ -12287,6 +12676,13 @@
             <a:prstDash val="solid"/>
           </a:ln>
         </p:spPr>
+        <p:txBody>
+          <a:bodyPr/>
+          <a:lstStyle/>
+          <a:p>
+            <a:endParaRPr lang="en-US"/>
+          </a:p>
+        </p:txBody>
       </p:sp>
       <p:pic>
         <p:nvPicPr>
@@ -12422,6 +12818,13 @@
             <a:prstDash val="solid"/>
           </a:ln>
         </p:spPr>
+        <p:txBody>
+          <a:bodyPr/>
+          <a:lstStyle/>
+          <a:p>
+            <a:endParaRPr lang="en-US"/>
+          </a:p>
+        </p:txBody>
       </p:sp>
       <p:pic>
         <p:nvPicPr>
@@ -12557,6 +12960,13 @@
             <a:prstDash val="solid"/>
           </a:ln>
         </p:spPr>
+        <p:txBody>
+          <a:bodyPr/>
+          <a:lstStyle/>
+          <a:p>
+            <a:endParaRPr lang="en-US"/>
+          </a:p>
+        </p:txBody>
       </p:sp>
       <p:pic>
         <p:nvPicPr>
@@ -12692,6 +13102,13 @@
             <a:prstDash val="solid"/>
           </a:ln>
         </p:spPr>
+        <p:txBody>
+          <a:bodyPr/>
+          <a:lstStyle/>
+          <a:p>
+            <a:endParaRPr lang="en-US"/>
+          </a:p>
+        </p:txBody>
       </p:sp>
       <p:pic>
         <p:nvPicPr>
@@ -12862,7 +13279,7 @@
           </a:prstGeom>
           <a:extLst>
             <a:ext uri="{C572A759-6A51-4108-AA02-DFA0A04FC94B}">
-              <ma14:wrappingTextBoxFlag xmlns:ma14="http://schemas.microsoft.com/office/mac/drawingml/2011/main" xmlns="" val="0"/>
+              <ma14:wrappingTextBoxFlag xmlns="" xmlns:ma14="http://schemas.microsoft.com/office/mac/drawingml/2011/main" val="0"/>
             </a:ext>
           </a:extLst>
         </p:spPr>
@@ -13184,6 +13601,13 @@
             </a:outerShdw>
           </a:effectLst>
         </p:spPr>
+        <p:txBody>
+          <a:bodyPr/>
+          <a:lstStyle/>
+          <a:p>
+            <a:endParaRPr lang="en-US"/>
+          </a:p>
+        </p:txBody>
       </p:sp>
       <p:sp>
         <p:nvSpPr>
@@ -13209,6 +13633,13 @@
             <a:prstDash val="solid"/>
           </a:ln>
         </p:spPr>
+        <p:txBody>
+          <a:bodyPr/>
+          <a:lstStyle/>
+          <a:p>
+            <a:endParaRPr lang="en-US"/>
+          </a:p>
+        </p:txBody>
       </p:sp>
       <p:sp>
         <p:nvSpPr>
@@ -13342,6 +13773,13 @@
             <a:prstDash val="solid"/>
           </a:ln>
         </p:spPr>
+        <p:txBody>
+          <a:bodyPr/>
+          <a:lstStyle/>
+          <a:p>
+            <a:endParaRPr lang="en-US"/>
+          </a:p>
+        </p:txBody>
       </p:sp>
       <p:sp>
         <p:nvSpPr>
@@ -13410,6 +13848,13 @@
             <a:prstDash val="solid"/>
           </a:ln>
         </p:spPr>
+        <p:txBody>
+          <a:bodyPr/>
+          <a:lstStyle/>
+          <a:p>
+            <a:endParaRPr lang="en-US"/>
+          </a:p>
+        </p:txBody>
       </p:sp>
       <p:sp>
         <p:nvSpPr>
@@ -13483,6 +13928,13 @@
             </a:outerShdw>
           </a:effectLst>
         </p:spPr>
+        <p:txBody>
+          <a:bodyPr/>
+          <a:lstStyle/>
+          <a:p>
+            <a:endParaRPr lang="en-US"/>
+          </a:p>
+        </p:txBody>
       </p:sp>
       <p:sp>
         <p:nvSpPr>
@@ -13508,6 +13960,13 @@
             <a:prstDash val="solid"/>
           </a:ln>
         </p:spPr>
+        <p:txBody>
+          <a:bodyPr/>
+          <a:lstStyle/>
+          <a:p>
+            <a:endParaRPr lang="en-US"/>
+          </a:p>
+        </p:txBody>
       </p:sp>
       <p:sp>
         <p:nvSpPr>
@@ -13641,6 +14100,13 @@
             <a:prstDash val="solid"/>
           </a:ln>
         </p:spPr>
+        <p:txBody>
+          <a:bodyPr/>
+          <a:lstStyle/>
+          <a:p>
+            <a:endParaRPr lang="en-US"/>
+          </a:p>
+        </p:txBody>
       </p:sp>
       <p:sp>
         <p:nvSpPr>
@@ -13709,6 +14175,13 @@
             <a:prstDash val="solid"/>
           </a:ln>
         </p:spPr>
+        <p:txBody>
+          <a:bodyPr/>
+          <a:lstStyle/>
+          <a:p>
+            <a:endParaRPr lang="en-US"/>
+          </a:p>
+        </p:txBody>
       </p:sp>
       <p:sp>
         <p:nvSpPr>
@@ -13782,6 +14255,13 @@
             </a:outerShdw>
           </a:effectLst>
         </p:spPr>
+        <p:txBody>
+          <a:bodyPr/>
+          <a:lstStyle/>
+          <a:p>
+            <a:endParaRPr lang="en-US"/>
+          </a:p>
+        </p:txBody>
       </p:sp>
       <p:sp>
         <p:nvSpPr>
@@ -13807,6 +14287,13 @@
             <a:prstDash val="solid"/>
           </a:ln>
         </p:spPr>
+        <p:txBody>
+          <a:bodyPr/>
+          <a:lstStyle/>
+          <a:p>
+            <a:endParaRPr lang="en-US"/>
+          </a:p>
+        </p:txBody>
       </p:sp>
       <p:sp>
         <p:nvSpPr>
@@ -13940,6 +14427,13 @@
             <a:prstDash val="solid"/>
           </a:ln>
         </p:spPr>
+        <p:txBody>
+          <a:bodyPr/>
+          <a:lstStyle/>
+          <a:p>
+            <a:endParaRPr lang="en-US"/>
+          </a:p>
+        </p:txBody>
       </p:sp>
       <p:sp>
         <p:nvSpPr>
@@ -14008,6 +14502,13 @@
             <a:prstDash val="solid"/>
           </a:ln>
         </p:spPr>
+        <p:txBody>
+          <a:bodyPr/>
+          <a:lstStyle/>
+          <a:p>
+            <a:endParaRPr lang="en-US"/>
+          </a:p>
+        </p:txBody>
       </p:sp>
       <p:sp>
         <p:nvSpPr>
@@ -14109,7 +14610,7 @@
           </a:prstGeom>
           <a:extLst>
             <a:ext uri="{C572A759-6A51-4108-AA02-DFA0A04FC94B}">
-              <ma14:wrappingTextBoxFlag xmlns:ma14="http://schemas.microsoft.com/office/mac/drawingml/2011/main" xmlns="" val="0"/>
+              <ma14:wrappingTextBoxFlag xmlns="" xmlns:ma14="http://schemas.microsoft.com/office/mac/drawingml/2011/main" val="0"/>
             </a:ext>
           </a:extLst>
         </p:spPr>
@@ -14385,6 +14886,13 @@
             <a:prstDash val="solid"/>
           </a:ln>
         </p:spPr>
+        <p:txBody>
+          <a:bodyPr/>
+          <a:lstStyle/>
+          <a:p>
+            <a:endParaRPr lang="en-US"/>
+          </a:p>
+        </p:txBody>
       </p:sp>
       <p:sp>
         <p:nvSpPr>
@@ -14449,6 +14957,13 @@
             <a:prstDash val="solid"/>
           </a:ln>
         </p:spPr>
+        <p:txBody>
+          <a:bodyPr/>
+          <a:lstStyle/>
+          <a:p>
+            <a:endParaRPr lang="en-US"/>
+          </a:p>
+        </p:txBody>
       </p:sp>
       <p:sp>
         <p:nvSpPr>
@@ -14514,6 +15029,13 @@
             <a:tailEnd type="triangle"/>
           </a:ln>
         </p:spPr>
+        <p:txBody>
+          <a:bodyPr/>
+          <a:lstStyle/>
+          <a:p>
+            <a:endParaRPr lang="en-US"/>
+          </a:p>
+        </p:txBody>
       </p:sp>
       <p:sp>
         <p:nvSpPr>
@@ -14539,6 +15061,13 @@
             <a:prstDash val="solid"/>
           </a:ln>
         </p:spPr>
+        <p:txBody>
+          <a:bodyPr/>
+          <a:lstStyle/>
+          <a:p>
+            <a:endParaRPr lang="en-US"/>
+          </a:p>
+        </p:txBody>
       </p:sp>
       <p:sp>
         <p:nvSpPr>
@@ -14605,6 +15134,13 @@
             <a:prstDash val="solid"/>
           </a:ln>
         </p:spPr>
+        <p:txBody>
+          <a:bodyPr/>
+          <a:lstStyle/>
+          <a:p>
+            <a:endParaRPr lang="en-US"/>
+          </a:p>
+        </p:txBody>
       </p:sp>
       <p:sp>
         <p:nvSpPr>
@@ -14669,6 +15205,13 @@
             <a:prstDash val="solid"/>
           </a:ln>
         </p:spPr>
+        <p:txBody>
+          <a:bodyPr/>
+          <a:lstStyle/>
+          <a:p>
+            <a:endParaRPr lang="en-US"/>
+          </a:p>
+        </p:txBody>
       </p:sp>
       <p:sp>
         <p:nvSpPr>
@@ -14734,6 +15277,13 @@
             <a:tailEnd type="triangle"/>
           </a:ln>
         </p:spPr>
+        <p:txBody>
+          <a:bodyPr/>
+          <a:lstStyle/>
+          <a:p>
+            <a:endParaRPr lang="en-US"/>
+          </a:p>
+        </p:txBody>
       </p:sp>
       <p:sp>
         <p:nvSpPr>
@@ -14759,6 +15309,13 @@
             <a:prstDash val="solid"/>
           </a:ln>
         </p:spPr>
+        <p:txBody>
+          <a:bodyPr/>
+          <a:lstStyle/>
+          <a:p>
+            <a:endParaRPr lang="en-US"/>
+          </a:p>
+        </p:txBody>
       </p:sp>
       <p:sp>
         <p:nvSpPr>
@@ -14825,6 +15382,13 @@
             <a:prstDash val="solid"/>
           </a:ln>
         </p:spPr>
+        <p:txBody>
+          <a:bodyPr/>
+          <a:lstStyle/>
+          <a:p>
+            <a:endParaRPr lang="en-US"/>
+          </a:p>
+        </p:txBody>
       </p:sp>
       <p:sp>
         <p:nvSpPr>
@@ -14889,6 +15453,13 @@
             <a:prstDash val="solid"/>
           </a:ln>
         </p:spPr>
+        <p:txBody>
+          <a:bodyPr/>
+          <a:lstStyle/>
+          <a:p>
+            <a:endParaRPr lang="en-US"/>
+          </a:p>
+        </p:txBody>
       </p:sp>
       <p:sp>
         <p:nvSpPr>
@@ -14954,6 +15525,13 @@
             <a:tailEnd type="triangle"/>
           </a:ln>
         </p:spPr>
+        <p:txBody>
+          <a:bodyPr/>
+          <a:lstStyle/>
+          <a:p>
+            <a:endParaRPr lang="en-US"/>
+          </a:p>
+        </p:txBody>
       </p:sp>
       <p:sp>
         <p:nvSpPr>
@@ -14979,6 +15557,13 @@
             <a:prstDash val="solid"/>
           </a:ln>
         </p:spPr>
+        <p:txBody>
+          <a:bodyPr/>
+          <a:lstStyle/>
+          <a:p>
+            <a:endParaRPr lang="en-US"/>
+          </a:p>
+        </p:txBody>
       </p:sp>
       <p:sp>
         <p:nvSpPr>
@@ -15045,6 +15630,13 @@
             <a:prstDash val="solid"/>
           </a:ln>
         </p:spPr>
+        <p:txBody>
+          <a:bodyPr/>
+          <a:lstStyle/>
+          <a:p>
+            <a:endParaRPr lang="en-US"/>
+          </a:p>
+        </p:txBody>
       </p:sp>
       <p:sp>
         <p:nvSpPr>
@@ -15109,6 +15701,13 @@
             <a:prstDash val="solid"/>
           </a:ln>
         </p:spPr>
+        <p:txBody>
+          <a:bodyPr/>
+          <a:lstStyle/>
+          <a:p>
+            <a:endParaRPr lang="en-US"/>
+          </a:p>
+        </p:txBody>
       </p:sp>
       <p:sp>
         <p:nvSpPr>
@@ -15174,6 +15773,13 @@
             <a:tailEnd type="triangle"/>
           </a:ln>
         </p:spPr>
+        <p:txBody>
+          <a:bodyPr/>
+          <a:lstStyle/>
+          <a:p>
+            <a:endParaRPr lang="en-US"/>
+          </a:p>
+        </p:txBody>
       </p:sp>
       <p:sp>
         <p:nvSpPr>
@@ -15199,6 +15805,13 @@
             <a:prstDash val="solid"/>
           </a:ln>
         </p:spPr>
+        <p:txBody>
+          <a:bodyPr/>
+          <a:lstStyle/>
+          <a:p>
+            <a:endParaRPr lang="en-US"/>
+          </a:p>
+        </p:txBody>
       </p:sp>
       <p:sp>
         <p:nvSpPr>
@@ -15265,6 +15878,13 @@
             <a:prstDash val="solid"/>
           </a:ln>
         </p:spPr>
+        <p:txBody>
+          <a:bodyPr/>
+          <a:lstStyle/>
+          <a:p>
+            <a:endParaRPr lang="en-US"/>
+          </a:p>
+        </p:txBody>
       </p:sp>
       <p:sp>
         <p:nvSpPr>
@@ -15329,6 +15949,13 @@
             <a:prstDash val="solid"/>
           </a:ln>
         </p:spPr>
+        <p:txBody>
+          <a:bodyPr/>
+          <a:lstStyle/>
+          <a:p>
+            <a:endParaRPr lang="en-US"/>
+          </a:p>
+        </p:txBody>
       </p:sp>
       <p:sp>
         <p:nvSpPr>
@@ -15394,6 +16021,13 @@
             <a:tailEnd type="triangle"/>
           </a:ln>
         </p:spPr>
+        <p:txBody>
+          <a:bodyPr/>
+          <a:lstStyle/>
+          <a:p>
+            <a:endParaRPr lang="en-US"/>
+          </a:p>
+        </p:txBody>
       </p:sp>
       <p:sp>
         <p:nvSpPr>
@@ -15419,6 +16053,13 @@
             <a:prstDash val="solid"/>
           </a:ln>
         </p:spPr>
+        <p:txBody>
+          <a:bodyPr/>
+          <a:lstStyle/>
+          <a:p>
+            <a:endParaRPr lang="en-US"/>
+          </a:p>
+        </p:txBody>
       </p:sp>
       <p:sp>
         <p:nvSpPr>
@@ -15485,6 +16126,13 @@
             <a:prstDash val="solid"/>
           </a:ln>
         </p:spPr>
+        <p:txBody>
+          <a:bodyPr/>
+          <a:lstStyle/>
+          <a:p>
+            <a:endParaRPr lang="en-US"/>
+          </a:p>
+        </p:txBody>
       </p:sp>
       <p:sp>
         <p:nvSpPr>
@@ -15584,7 +16232,7 @@
           </a:prstGeom>
           <a:extLst>
             <a:ext uri="{C572A759-6A51-4108-AA02-DFA0A04FC94B}">
-              <ma14:wrappingTextBoxFlag xmlns:ma14="http://schemas.microsoft.com/office/mac/drawingml/2011/main" xmlns="" val="0"/>
+              <ma14:wrappingTextBoxFlag xmlns="" xmlns:ma14="http://schemas.microsoft.com/office/mac/drawingml/2011/main" val="0"/>
             </a:ext>
           </a:extLst>
         </p:spPr>
@@ -15791,6 +16439,13 @@
             </a:outerShdw>
           </a:effectLst>
         </p:spPr>
+        <p:txBody>
+          <a:bodyPr/>
+          <a:lstStyle/>
+          <a:p>
+            <a:endParaRPr lang="en-US"/>
+          </a:p>
+        </p:txBody>
       </p:sp>
       <p:sp>
         <p:nvSpPr>
@@ -15816,6 +16471,13 @@
             <a:prstDash val="solid"/>
           </a:ln>
         </p:spPr>
+        <p:txBody>
+          <a:bodyPr/>
+          <a:lstStyle/>
+          <a:p>
+            <a:endParaRPr lang="en-US"/>
+          </a:p>
+        </p:txBody>
       </p:sp>
       <p:pic>
         <p:nvPicPr>
@@ -15955,6 +16617,13 @@
             <a:tailEnd type="triangle"/>
           </a:ln>
         </p:spPr>
+        <p:txBody>
+          <a:bodyPr/>
+          <a:lstStyle/>
+          <a:p>
+            <a:endParaRPr lang="en-US"/>
+          </a:p>
+        </p:txBody>
       </p:sp>
       <p:sp>
         <p:nvSpPr>
@@ -15989,6 +16658,13 @@
             </a:outerShdw>
           </a:effectLst>
         </p:spPr>
+        <p:txBody>
+          <a:bodyPr/>
+          <a:lstStyle/>
+          <a:p>
+            <a:endParaRPr lang="en-US"/>
+          </a:p>
+        </p:txBody>
       </p:sp>
       <p:sp>
         <p:nvSpPr>
@@ -16014,6 +16690,13 @@
             <a:prstDash val="solid"/>
           </a:ln>
         </p:spPr>
+        <p:txBody>
+          <a:bodyPr/>
+          <a:lstStyle/>
+          <a:p>
+            <a:endParaRPr lang="en-US"/>
+          </a:p>
+        </p:txBody>
       </p:sp>
       <p:pic>
         <p:nvPicPr>
@@ -16153,6 +16836,13 @@
             <a:tailEnd type="triangle"/>
           </a:ln>
         </p:spPr>
+        <p:txBody>
+          <a:bodyPr/>
+          <a:lstStyle/>
+          <a:p>
+            <a:endParaRPr lang="en-US"/>
+          </a:p>
+        </p:txBody>
       </p:sp>
       <p:sp>
         <p:nvSpPr>
@@ -16187,6 +16877,13 @@
             </a:outerShdw>
           </a:effectLst>
         </p:spPr>
+        <p:txBody>
+          <a:bodyPr/>
+          <a:lstStyle/>
+          <a:p>
+            <a:endParaRPr lang="en-US"/>
+          </a:p>
+        </p:txBody>
       </p:sp>
       <p:sp>
         <p:nvSpPr>
@@ -16212,6 +16909,13 @@
             <a:prstDash val="solid"/>
           </a:ln>
         </p:spPr>
+        <p:txBody>
+          <a:bodyPr/>
+          <a:lstStyle/>
+          <a:p>
+            <a:endParaRPr lang="en-US"/>
+          </a:p>
+        </p:txBody>
       </p:sp>
       <p:pic>
         <p:nvPicPr>
@@ -16351,6 +17055,13 @@
             <a:tailEnd type="triangle"/>
           </a:ln>
         </p:spPr>
+        <p:txBody>
+          <a:bodyPr/>
+          <a:lstStyle/>
+          <a:p>
+            <a:endParaRPr lang="en-US"/>
+          </a:p>
+        </p:txBody>
       </p:sp>
       <p:sp>
         <p:nvSpPr>
@@ -16385,6 +17096,13 @@
             </a:outerShdw>
           </a:effectLst>
         </p:spPr>
+        <p:txBody>
+          <a:bodyPr/>
+          <a:lstStyle/>
+          <a:p>
+            <a:endParaRPr lang="en-US"/>
+          </a:p>
+        </p:txBody>
       </p:sp>
       <p:sp>
         <p:nvSpPr>
@@ -16410,6 +17128,13 @@
             <a:prstDash val="solid"/>
           </a:ln>
         </p:spPr>
+        <p:txBody>
+          <a:bodyPr/>
+          <a:lstStyle/>
+          <a:p>
+            <a:endParaRPr lang="en-US"/>
+          </a:p>
+        </p:txBody>
       </p:sp>
       <p:pic>
         <p:nvPicPr>
@@ -16550,6 +17275,13 @@
             <a:prstDash val="solid"/>
           </a:ln>
         </p:spPr>
+        <p:txBody>
+          <a:bodyPr/>
+          <a:lstStyle/>
+          <a:p>
+            <a:endParaRPr lang="en-US"/>
+          </a:p>
+        </p:txBody>
       </p:sp>
       <p:pic>
         <p:nvPicPr>
@@ -16600,7 +17332,7 @@
         </p:spPr>
         <p:txBody>
           <a:bodyPr wrap="square" lIns="0" tIns="0" rIns="0" bIns="0" rtlCol="0" anchor="ctr">
-            <a:normAutofit/>
+            <a:normAutofit fontScale="92500" lnSpcReduction="10000"/>
           </a:bodyPr>
           <a:lstStyle/>
           <a:p>
@@ -16681,7 +17413,7 @@
           </a:prstGeom>
           <a:extLst>
             <a:ext uri="{C572A759-6A51-4108-AA02-DFA0A04FC94B}">
-              <ma14:wrappingTextBoxFlag xmlns:ma14="http://schemas.microsoft.com/office/mac/drawingml/2011/main" xmlns="" val="0"/>
+              <ma14:wrappingTextBoxFlag xmlns="" xmlns:ma14="http://schemas.microsoft.com/office/mac/drawingml/2011/main" val="0"/>
             </a:ext>
           </a:extLst>
         </p:spPr>
@@ -16879,6 +17611,13 @@
             <a:prstDash val="solid"/>
           </a:ln>
         </p:spPr>
+        <p:txBody>
+          <a:bodyPr/>
+          <a:lstStyle/>
+          <a:p>
+            <a:endParaRPr lang="en-US"/>
+          </a:p>
+        </p:txBody>
       </p:sp>
       <p:pic>
         <p:nvPicPr>
@@ -16974,6 +17713,13 @@
             <a:tailEnd type="triangle"/>
           </a:ln>
         </p:spPr>
+        <p:txBody>
+          <a:bodyPr/>
+          <a:lstStyle/>
+          <a:p>
+            <a:endParaRPr lang="en-US"/>
+          </a:p>
+        </p:txBody>
       </p:sp>
       <p:sp>
         <p:nvSpPr>
@@ -17006,6 +17752,13 @@
             </a:outerShdw>
           </a:effectLst>
         </p:spPr>
+        <p:txBody>
+          <a:bodyPr/>
+          <a:lstStyle/>
+          <a:p>
+            <a:endParaRPr lang="en-US"/>
+          </a:p>
+        </p:txBody>
       </p:sp>
       <p:sp>
         <p:nvSpPr>
@@ -17072,6 +17825,13 @@
             <a:prstDash val="solid"/>
           </a:ln>
         </p:spPr>
+        <p:txBody>
+          <a:bodyPr/>
+          <a:lstStyle/>
+          <a:p>
+            <a:endParaRPr lang="en-US"/>
+          </a:p>
+        </p:txBody>
       </p:sp>
       <p:pic>
         <p:nvPicPr>
@@ -17167,6 +17927,13 @@
             <a:tailEnd type="triangle"/>
           </a:ln>
         </p:spPr>
+        <p:txBody>
+          <a:bodyPr/>
+          <a:lstStyle/>
+          <a:p>
+            <a:endParaRPr lang="en-US"/>
+          </a:p>
+        </p:txBody>
       </p:sp>
       <p:sp>
         <p:nvSpPr>
@@ -17199,6 +17966,13 @@
             </a:outerShdw>
           </a:effectLst>
         </p:spPr>
+        <p:txBody>
+          <a:bodyPr/>
+          <a:lstStyle/>
+          <a:p>
+            <a:endParaRPr lang="en-US"/>
+          </a:p>
+        </p:txBody>
       </p:sp>
       <p:sp>
         <p:nvSpPr>
@@ -17265,6 +18039,13 @@
             <a:prstDash val="solid"/>
           </a:ln>
         </p:spPr>
+        <p:txBody>
+          <a:bodyPr/>
+          <a:lstStyle/>
+          <a:p>
+            <a:endParaRPr lang="en-US"/>
+          </a:p>
+        </p:txBody>
       </p:sp>
       <p:pic>
         <p:nvPicPr>
@@ -17360,6 +18141,13 @@
             <a:tailEnd type="triangle"/>
           </a:ln>
         </p:spPr>
+        <p:txBody>
+          <a:bodyPr/>
+          <a:lstStyle/>
+          <a:p>
+            <a:endParaRPr lang="en-US"/>
+          </a:p>
+        </p:txBody>
       </p:sp>
       <p:sp>
         <p:nvSpPr>
@@ -17392,6 +18180,13 @@
             </a:outerShdw>
           </a:effectLst>
         </p:spPr>
+        <p:txBody>
+          <a:bodyPr/>
+          <a:lstStyle/>
+          <a:p>
+            <a:endParaRPr lang="en-US"/>
+          </a:p>
+        </p:txBody>
       </p:sp>
       <p:sp>
         <p:nvSpPr>
@@ -17458,6 +18253,13 @@
             <a:prstDash val="solid"/>
           </a:ln>
         </p:spPr>
+        <p:txBody>
+          <a:bodyPr/>
+          <a:lstStyle/>
+          <a:p>
+            <a:endParaRPr lang="en-US"/>
+          </a:p>
+        </p:txBody>
       </p:sp>
       <p:pic>
         <p:nvPicPr>
@@ -17553,6 +18355,13 @@
             <a:tailEnd type="triangle"/>
           </a:ln>
         </p:spPr>
+        <p:txBody>
+          <a:bodyPr/>
+          <a:lstStyle/>
+          <a:p>
+            <a:endParaRPr lang="en-US"/>
+          </a:p>
+        </p:txBody>
       </p:sp>
       <p:sp>
         <p:nvSpPr>
@@ -17585,6 +18394,13 @@
             </a:outerShdw>
           </a:effectLst>
         </p:spPr>
+        <p:txBody>
+          <a:bodyPr/>
+          <a:lstStyle/>
+          <a:p>
+            <a:endParaRPr lang="en-US"/>
+          </a:p>
+        </p:txBody>
       </p:sp>
       <p:sp>
         <p:nvSpPr>
@@ -17651,6 +18467,13 @@
             <a:prstDash val="solid"/>
           </a:ln>
         </p:spPr>
+        <p:txBody>
+          <a:bodyPr/>
+          <a:lstStyle/>
+          <a:p>
+            <a:endParaRPr lang="en-US"/>
+          </a:p>
+        </p:txBody>
       </p:sp>
       <p:pic>
         <p:nvPicPr>
@@ -17782,7 +18605,7 @@
           </a:prstGeom>
           <a:extLst>
             <a:ext uri="{C572A759-6A51-4108-AA02-DFA0A04FC94B}">
-              <ma14:wrappingTextBoxFlag xmlns:ma14="http://schemas.microsoft.com/office/mac/drawingml/2011/main" xmlns="" val="0"/>
+              <ma14:wrappingTextBoxFlag xmlns="" xmlns:ma14="http://schemas.microsoft.com/office/mac/drawingml/2011/main" val="0"/>
             </a:ext>
           </a:extLst>
         </p:spPr>
@@ -17871,6 +18694,13 @@
             <a:prstDash val="solid"/>
           </a:ln>
         </p:spPr>
+        <p:txBody>
+          <a:bodyPr/>
+          <a:lstStyle/>
+          <a:p>
+            <a:endParaRPr lang="en-US"/>
+          </a:p>
+        </p:txBody>
       </p:sp>
       <p:sp>
         <p:nvSpPr>
@@ -17900,6 +18730,13 @@
             <a:prstDash val="solid"/>
           </a:ln>
         </p:spPr>
+        <p:txBody>
+          <a:bodyPr/>
+          <a:lstStyle/>
+          <a:p>
+            <a:endParaRPr lang="en-US"/>
+          </a:p>
+        </p:txBody>
       </p:sp>
       <p:sp>
         <p:nvSpPr>
@@ -17927,6 +18764,13 @@
             <a:prstDash val="solid"/>
           </a:ln>
         </p:spPr>
+        <p:txBody>
+          <a:bodyPr/>
+          <a:lstStyle/>
+          <a:p>
+            <a:endParaRPr lang="en-US"/>
+          </a:p>
+        </p:txBody>
       </p:sp>
       <p:sp>
         <p:nvSpPr>
@@ -18075,6 +18919,13 @@
             <a:prstDash val="solid"/>
           </a:ln>
         </p:spPr>
+        <p:txBody>
+          <a:bodyPr/>
+          <a:lstStyle/>
+          <a:p>
+            <a:endParaRPr lang="en-US"/>
+          </a:p>
+        </p:txBody>
       </p:sp>
       <p:pic>
         <p:nvPicPr>
@@ -18212,6 +19063,13 @@
             <a:prstDash val="solid"/>
           </a:ln>
         </p:spPr>
+        <p:txBody>
+          <a:bodyPr/>
+          <a:lstStyle/>
+          <a:p>
+            <a:endParaRPr lang="en-US"/>
+          </a:p>
+        </p:txBody>
       </p:sp>
       <p:pic>
         <p:nvPicPr>
@@ -18349,6 +19207,13 @@
             <a:prstDash val="solid"/>
           </a:ln>
         </p:spPr>
+        <p:txBody>
+          <a:bodyPr/>
+          <a:lstStyle/>
+          <a:p>
+            <a:endParaRPr lang="en-US"/>
+          </a:p>
+        </p:txBody>
       </p:sp>
       <p:pic>
         <p:nvPicPr>
@@ -18488,6 +19353,13 @@
             <a:prstDash val="solid"/>
           </a:ln>
         </p:spPr>
+        <p:txBody>
+          <a:bodyPr/>
+          <a:lstStyle/>
+          <a:p>
+            <a:endParaRPr lang="en-US"/>
+          </a:p>
+        </p:txBody>
       </p:sp>
       <p:pic>
         <p:nvPicPr>
@@ -18813,6 +19685,13 @@
             </a:outerShdw>
           </a:effectLst>
         </p:spPr>
+        <p:txBody>
+          <a:bodyPr/>
+          <a:lstStyle/>
+          <a:p>
+            <a:endParaRPr lang="en-US"/>
+          </a:p>
+        </p:txBody>
       </p:sp>
       <p:sp>
         <p:nvSpPr>
@@ -18838,6 +19717,13 @@
             <a:prstDash val="solid"/>
           </a:ln>
         </p:spPr>
+        <p:txBody>
+          <a:bodyPr/>
+          <a:lstStyle/>
+          <a:p>
+            <a:endParaRPr lang="en-US"/>
+          </a:p>
+        </p:txBody>
       </p:sp>
       <p:pic>
         <p:nvPicPr>
@@ -18974,6 +19860,13 @@
             <a:tailEnd type="triangle"/>
           </a:ln>
         </p:spPr>
+        <p:txBody>
+          <a:bodyPr/>
+          <a:lstStyle/>
+          <a:p>
+            <a:endParaRPr lang="en-US"/>
+          </a:p>
+        </p:txBody>
       </p:sp>
       <p:sp>
         <p:nvSpPr>
@@ -19006,6 +19899,13 @@
             </a:outerShdw>
           </a:effectLst>
         </p:spPr>
+        <p:txBody>
+          <a:bodyPr/>
+          <a:lstStyle/>
+          <a:p>
+            <a:endParaRPr lang="en-US"/>
+          </a:p>
+        </p:txBody>
       </p:sp>
       <p:sp>
         <p:nvSpPr>
@@ -19031,6 +19931,13 @@
             <a:prstDash val="solid"/>
           </a:ln>
         </p:spPr>
+        <p:txBody>
+          <a:bodyPr/>
+          <a:lstStyle/>
+          <a:p>
+            <a:endParaRPr lang="en-US"/>
+          </a:p>
+        </p:txBody>
       </p:sp>
       <p:pic>
         <p:nvPicPr>
@@ -19167,6 +20074,13 @@
             <a:tailEnd type="triangle"/>
           </a:ln>
         </p:spPr>
+        <p:txBody>
+          <a:bodyPr/>
+          <a:lstStyle/>
+          <a:p>
+            <a:endParaRPr lang="en-US"/>
+          </a:p>
+        </p:txBody>
       </p:sp>
       <p:sp>
         <p:nvSpPr>
@@ -19199,6 +20113,13 @@
             </a:outerShdw>
           </a:effectLst>
         </p:spPr>
+        <p:txBody>
+          <a:bodyPr/>
+          <a:lstStyle/>
+          <a:p>
+            <a:endParaRPr lang="en-US"/>
+          </a:p>
+        </p:txBody>
       </p:sp>
       <p:sp>
         <p:nvSpPr>
@@ -19224,6 +20145,13 @@
             <a:prstDash val="solid"/>
           </a:ln>
         </p:spPr>
+        <p:txBody>
+          <a:bodyPr/>
+          <a:lstStyle/>
+          <a:p>
+            <a:endParaRPr lang="en-US"/>
+          </a:p>
+        </p:txBody>
       </p:sp>
       <p:pic>
         <p:nvPicPr>
@@ -19360,6 +20288,13 @@
             <a:tailEnd type="triangle"/>
           </a:ln>
         </p:spPr>
+        <p:txBody>
+          <a:bodyPr/>
+          <a:lstStyle/>
+          <a:p>
+            <a:endParaRPr lang="en-US"/>
+          </a:p>
+        </p:txBody>
       </p:sp>
       <p:sp>
         <p:nvSpPr>
@@ -19392,6 +20327,13 @@
             </a:outerShdw>
           </a:effectLst>
         </p:spPr>
+        <p:txBody>
+          <a:bodyPr/>
+          <a:lstStyle/>
+          <a:p>
+            <a:endParaRPr lang="en-US"/>
+          </a:p>
+        </p:txBody>
       </p:sp>
       <p:sp>
         <p:nvSpPr>
@@ -19417,6 +20359,13 @@
             <a:prstDash val="solid"/>
           </a:ln>
         </p:spPr>
+        <p:txBody>
+          <a:bodyPr/>
+          <a:lstStyle/>
+          <a:p>
+            <a:endParaRPr lang="en-US"/>
+          </a:p>
+        </p:txBody>
       </p:sp>
       <p:pic>
         <p:nvPicPr>
@@ -19553,6 +20502,13 @@
             <a:tailEnd type="triangle"/>
           </a:ln>
         </p:spPr>
+        <p:txBody>
+          <a:bodyPr/>
+          <a:lstStyle/>
+          <a:p>
+            <a:endParaRPr lang="en-US"/>
+          </a:p>
+        </p:txBody>
       </p:sp>
       <p:sp>
         <p:nvSpPr>
@@ -19585,6 +20541,13 @@
             </a:outerShdw>
           </a:effectLst>
         </p:spPr>
+        <p:txBody>
+          <a:bodyPr/>
+          <a:lstStyle/>
+          <a:p>
+            <a:endParaRPr lang="en-US"/>
+          </a:p>
+        </p:txBody>
       </p:sp>
       <p:sp>
         <p:nvSpPr>
@@ -19610,6 +20573,13 @@
             <a:prstDash val="solid"/>
           </a:ln>
         </p:spPr>
+        <p:txBody>
+          <a:bodyPr/>
+          <a:lstStyle/>
+          <a:p>
+            <a:endParaRPr lang="en-US"/>
+          </a:p>
+        </p:txBody>
       </p:sp>
       <p:pic>
         <p:nvPicPr>
@@ -19747,6 +20717,13 @@
             <a:prstDash val="solid"/>
           </a:ln>
         </p:spPr>
+        <p:txBody>
+          <a:bodyPr/>
+          <a:lstStyle/>
+          <a:p>
+            <a:endParaRPr lang="en-US"/>
+          </a:p>
+        </p:txBody>
       </p:sp>
       <p:pic>
         <p:nvPicPr>
@@ -19836,7 +20813,7 @@
         </p:spPr>
         <p:txBody>
           <a:bodyPr wrap="square" lIns="0" tIns="0" rIns="0" bIns="0" rtlCol="0" anchor="ctr">
-            <a:normAutofit/>
+            <a:normAutofit lnSpcReduction="10000"/>
           </a:bodyPr>
           <a:lstStyle/>
           <a:p>
@@ -19881,6 +20858,13 @@
             <a:headEnd type="triangle"/>
           </a:ln>
         </p:spPr>
+        <p:txBody>
+          <a:bodyPr/>
+          <a:lstStyle/>
+          <a:p>
+            <a:endParaRPr lang="en-US"/>
+          </a:p>
+        </p:txBody>
       </p:sp>
       <p:sp>
         <p:nvSpPr>
@@ -19906,6 +20890,13 @@
             <a:prstDash val="solid"/>
           </a:ln>
         </p:spPr>
+        <p:txBody>
+          <a:bodyPr/>
+          <a:lstStyle/>
+          <a:p>
+            <a:endParaRPr lang="en-US"/>
+          </a:p>
+        </p:txBody>
       </p:sp>
       <p:pic>
         <p:nvPicPr>
@@ -19956,7 +20947,7 @@
         </p:spPr>
         <p:txBody>
           <a:bodyPr wrap="square" lIns="0" tIns="0" rIns="0" bIns="0" rtlCol="0" anchor="ctr">
-            <a:normAutofit/>
+            <a:normAutofit fontScale="92500"/>
           </a:bodyPr>
           <a:lstStyle/>
           <a:p>
@@ -20042,6 +21033,13 @@
             <a:tailEnd type="triangle"/>
           </a:ln>
         </p:spPr>
+        <p:txBody>
+          <a:bodyPr/>
+          <a:lstStyle/>
+          <a:p>
+            <a:endParaRPr lang="en-US"/>
+          </a:p>
+        </p:txBody>
       </p:sp>
       <p:sp>
         <p:nvSpPr>
@@ -20102,7 +21100,7 @@
           </a:prstGeom>
           <a:extLst>
             <a:ext uri="{C572A759-6A51-4108-AA02-DFA0A04FC94B}">
-              <ma14:wrappingTextBoxFlag xmlns:ma14="http://schemas.microsoft.com/office/mac/drawingml/2011/main" xmlns="" val="0"/>
+              <ma14:wrappingTextBoxFlag xmlns="" xmlns:ma14="http://schemas.microsoft.com/office/mac/drawingml/2011/main" val="0"/>
             </a:ext>
           </a:extLst>
         </p:spPr>
@@ -20300,6 +21298,13 @@
             <a:prstDash val="solid"/>
           </a:ln>
         </p:spPr>
+        <p:txBody>
+          <a:bodyPr/>
+          <a:lstStyle/>
+          <a:p>
+            <a:endParaRPr lang="en-US"/>
+          </a:p>
+        </p:txBody>
       </p:sp>
       <p:sp>
         <p:nvSpPr>
@@ -20381,6 +21386,13 @@
             <a:prstDash val="solid"/>
           </a:ln>
         </p:spPr>
+        <p:txBody>
+          <a:bodyPr/>
+          <a:lstStyle/>
+          <a:p>
+            <a:endParaRPr lang="en-US"/>
+          </a:p>
+        </p:txBody>
       </p:sp>
       <p:sp>
         <p:nvSpPr>
@@ -20406,6 +21418,13 @@
             <a:prstDash val="solid"/>
           </a:ln>
         </p:spPr>
+        <p:txBody>
+          <a:bodyPr/>
+          <a:lstStyle/>
+          <a:p>
+            <a:endParaRPr lang="en-US"/>
+          </a:p>
+        </p:txBody>
       </p:sp>
       <p:sp>
         <p:nvSpPr>
@@ -20487,6 +21506,13 @@
             <a:prstDash val="solid"/>
           </a:ln>
         </p:spPr>
+        <p:txBody>
+          <a:bodyPr/>
+          <a:lstStyle/>
+          <a:p>
+            <a:endParaRPr lang="en-US"/>
+          </a:p>
+        </p:txBody>
       </p:sp>
       <p:sp>
         <p:nvSpPr>
@@ -20512,6 +21538,13 @@
             <a:prstDash val="solid"/>
           </a:ln>
         </p:spPr>
+        <p:txBody>
+          <a:bodyPr/>
+          <a:lstStyle/>
+          <a:p>
+            <a:endParaRPr lang="en-US"/>
+          </a:p>
+        </p:txBody>
       </p:sp>
       <p:sp>
         <p:nvSpPr>
@@ -20593,6 +21626,13 @@
             <a:prstDash val="solid"/>
           </a:ln>
         </p:spPr>
+        <p:txBody>
+          <a:bodyPr/>
+          <a:lstStyle/>
+          <a:p>
+            <a:endParaRPr lang="en-US"/>
+          </a:p>
+        </p:txBody>
       </p:sp>
       <p:sp>
         <p:nvSpPr>
@@ -20618,6 +21658,13 @@
             <a:prstDash val="solid"/>
           </a:ln>
         </p:spPr>
+        <p:txBody>
+          <a:bodyPr/>
+          <a:lstStyle/>
+          <a:p>
+            <a:endParaRPr lang="en-US"/>
+          </a:p>
+        </p:txBody>
       </p:sp>
       <p:sp>
         <p:nvSpPr>
@@ -20699,6 +21746,13 @@
             <a:prstDash val="solid"/>
           </a:ln>
         </p:spPr>
+        <p:txBody>
+          <a:bodyPr/>
+          <a:lstStyle/>
+          <a:p>
+            <a:endParaRPr lang="en-US"/>
+          </a:p>
+        </p:txBody>
       </p:sp>
       <p:sp>
         <p:nvSpPr>
@@ -20724,6 +21778,13 @@
             <a:prstDash val="solid"/>
           </a:ln>
         </p:spPr>
+        <p:txBody>
+          <a:bodyPr/>
+          <a:lstStyle/>
+          <a:p>
+            <a:endParaRPr lang="en-US"/>
+          </a:p>
+        </p:txBody>
       </p:sp>
       <p:sp>
         <p:nvSpPr>
@@ -20805,6 +21866,13 @@
             <a:prstDash val="solid"/>
           </a:ln>
         </p:spPr>
+        <p:txBody>
+          <a:bodyPr/>
+          <a:lstStyle/>
+          <a:p>
+            <a:endParaRPr lang="en-US"/>
+          </a:p>
+        </p:txBody>
       </p:sp>
       <p:sp>
         <p:nvSpPr>
@@ -20830,6 +21898,13 @@
             <a:prstDash val="solid"/>
           </a:ln>
         </p:spPr>
+        <p:txBody>
+          <a:bodyPr/>
+          <a:lstStyle/>
+          <a:p>
+            <a:endParaRPr lang="en-US"/>
+          </a:p>
+        </p:txBody>
       </p:sp>
       <p:sp>
         <p:nvSpPr>
@@ -20920,6 +21995,13 @@
             </a:outerShdw>
           </a:effectLst>
         </p:spPr>
+        <p:txBody>
+          <a:bodyPr/>
+          <a:lstStyle/>
+          <a:p>
+            <a:endParaRPr lang="en-US"/>
+          </a:p>
+        </p:txBody>
       </p:sp>
       <p:sp>
         <p:nvSpPr>
@@ -20945,6 +22027,13 @@
             <a:prstDash val="solid"/>
           </a:ln>
         </p:spPr>
+        <p:txBody>
+          <a:bodyPr/>
+          <a:lstStyle/>
+          <a:p>
+            <a:endParaRPr lang="en-US"/>
+          </a:p>
+        </p:txBody>
       </p:sp>
       <p:sp>
         <p:nvSpPr>
@@ -21093,6 +22182,13 @@
             <a:prstDash val="solid"/>
           </a:ln>
         </p:spPr>
+        <p:txBody>
+          <a:bodyPr/>
+          <a:lstStyle/>
+          <a:p>
+            <a:endParaRPr lang="en-US"/>
+          </a:p>
+        </p:txBody>
       </p:sp>
       <p:sp>
         <p:nvSpPr>
@@ -21166,6 +22262,13 @@
             </a:outerShdw>
           </a:effectLst>
         </p:spPr>
+        <p:txBody>
+          <a:bodyPr/>
+          <a:lstStyle/>
+          <a:p>
+            <a:endParaRPr lang="en-US"/>
+          </a:p>
+        </p:txBody>
       </p:sp>
       <p:sp>
         <p:nvSpPr>
@@ -21191,6 +22294,13 @@
             <a:prstDash val="solid"/>
           </a:ln>
         </p:spPr>
+        <p:txBody>
+          <a:bodyPr/>
+          <a:lstStyle/>
+          <a:p>
+            <a:endParaRPr lang="en-US"/>
+          </a:p>
+        </p:txBody>
       </p:sp>
       <p:sp>
         <p:nvSpPr>
@@ -21339,6 +22449,13 @@
             <a:prstDash val="solid"/>
           </a:ln>
         </p:spPr>
+        <p:txBody>
+          <a:bodyPr/>
+          <a:lstStyle/>
+          <a:p>
+            <a:endParaRPr lang="en-US"/>
+          </a:p>
+        </p:txBody>
       </p:sp>
       <p:sp>
         <p:nvSpPr>
@@ -21412,6 +22529,13 @@
             </a:outerShdw>
           </a:effectLst>
         </p:spPr>
+        <p:txBody>
+          <a:bodyPr/>
+          <a:lstStyle/>
+          <a:p>
+            <a:endParaRPr lang="en-US"/>
+          </a:p>
+        </p:txBody>
       </p:sp>
       <p:sp>
         <p:nvSpPr>
@@ -21437,6 +22561,13 @@
             <a:prstDash val="solid"/>
           </a:ln>
         </p:spPr>
+        <p:txBody>
+          <a:bodyPr/>
+          <a:lstStyle/>
+          <a:p>
+            <a:endParaRPr lang="en-US"/>
+          </a:p>
+        </p:txBody>
       </p:sp>
       <p:sp>
         <p:nvSpPr>
@@ -21585,6 +22716,13 @@
             <a:prstDash val="solid"/>
           </a:ln>
         </p:spPr>
+        <p:txBody>
+          <a:bodyPr/>
+          <a:lstStyle/>
+          <a:p>
+            <a:endParaRPr lang="en-US"/>
+          </a:p>
+        </p:txBody>
       </p:sp>
       <p:sp>
         <p:nvSpPr>
@@ -21658,6 +22796,13 @@
             </a:outerShdw>
           </a:effectLst>
         </p:spPr>
+        <p:txBody>
+          <a:bodyPr/>
+          <a:lstStyle/>
+          <a:p>
+            <a:endParaRPr lang="en-US"/>
+          </a:p>
+        </p:txBody>
       </p:sp>
       <p:sp>
         <p:nvSpPr>
@@ -21683,6 +22828,13 @@
             <a:prstDash val="solid"/>
           </a:ln>
         </p:spPr>
+        <p:txBody>
+          <a:bodyPr/>
+          <a:lstStyle/>
+          <a:p>
+            <a:endParaRPr lang="en-US"/>
+          </a:p>
+        </p:txBody>
       </p:sp>
       <p:sp>
         <p:nvSpPr>
@@ -21831,6 +22983,13 @@
             <a:prstDash val="solid"/>
           </a:ln>
         </p:spPr>
+        <p:txBody>
+          <a:bodyPr/>
+          <a:lstStyle/>
+          <a:p>
+            <a:endParaRPr lang="en-US"/>
+          </a:p>
+        </p:txBody>
       </p:sp>
       <p:sp>
         <p:nvSpPr>
@@ -21904,6 +23063,13 @@
             </a:outerShdw>
           </a:effectLst>
         </p:spPr>
+        <p:txBody>
+          <a:bodyPr/>
+          <a:lstStyle/>
+          <a:p>
+            <a:endParaRPr lang="en-US"/>
+          </a:p>
+        </p:txBody>
       </p:sp>
       <p:sp>
         <p:nvSpPr>
@@ -21929,6 +23095,13 @@
             <a:prstDash val="solid"/>
           </a:ln>
         </p:spPr>
+        <p:txBody>
+          <a:bodyPr/>
+          <a:lstStyle/>
+          <a:p>
+            <a:endParaRPr lang="en-US"/>
+          </a:p>
+        </p:txBody>
       </p:sp>
       <p:sp>
         <p:nvSpPr>
@@ -22077,6 +23250,13 @@
             <a:prstDash val="solid"/>
           </a:ln>
         </p:spPr>
+        <p:txBody>
+          <a:bodyPr/>
+          <a:lstStyle/>
+          <a:p>
+            <a:endParaRPr lang="en-US"/>
+          </a:p>
+        </p:txBody>
       </p:sp>
       <p:sp>
         <p:nvSpPr>
@@ -22150,6 +23330,13 @@
             </a:outerShdw>
           </a:effectLst>
         </p:spPr>
+        <p:txBody>
+          <a:bodyPr/>
+          <a:lstStyle/>
+          <a:p>
+            <a:endParaRPr lang="en-US"/>
+          </a:p>
+        </p:txBody>
       </p:sp>
       <p:sp>
         <p:nvSpPr>
@@ -22175,6 +23362,13 @@
             <a:prstDash val="solid"/>
           </a:ln>
         </p:spPr>
+        <p:txBody>
+          <a:bodyPr/>
+          <a:lstStyle/>
+          <a:p>
+            <a:endParaRPr lang="en-US"/>
+          </a:p>
+        </p:txBody>
       </p:sp>
       <p:sp>
         <p:nvSpPr>
@@ -22323,6 +23517,13 @@
             <a:prstDash val="solid"/>
           </a:ln>
         </p:spPr>
+        <p:txBody>
+          <a:bodyPr/>
+          <a:lstStyle/>
+          <a:p>
+            <a:endParaRPr lang="en-US"/>
+          </a:p>
+        </p:txBody>
       </p:sp>
       <p:sp>
         <p:nvSpPr>
@@ -22424,7 +23625,7 @@
           </a:prstGeom>
           <a:extLst>
             <a:ext uri="{C572A759-6A51-4108-AA02-DFA0A04FC94B}">
-              <ma14:wrappingTextBoxFlag xmlns:ma14="http://schemas.microsoft.com/office/mac/drawingml/2011/main" xmlns="" val="0"/>
+              <ma14:wrappingTextBoxFlag xmlns="" xmlns:ma14="http://schemas.microsoft.com/office/mac/drawingml/2011/main" val="0"/>
             </a:ext>
           </a:extLst>
         </p:spPr>
@@ -22631,6 +23832,13 @@
             </a:outerShdw>
           </a:effectLst>
         </p:spPr>
+        <p:txBody>
+          <a:bodyPr/>
+          <a:lstStyle/>
+          <a:p>
+            <a:endParaRPr lang="en-US"/>
+          </a:p>
+        </p:txBody>
       </p:sp>
       <p:sp>
         <p:nvSpPr>
@@ -22656,6 +23864,13 @@
             <a:prstDash val="solid"/>
           </a:ln>
         </p:spPr>
+        <p:txBody>
+          <a:bodyPr/>
+          <a:lstStyle/>
+          <a:p>
+            <a:endParaRPr lang="en-US"/>
+          </a:p>
+        </p:txBody>
       </p:sp>
       <p:pic>
         <p:nvPicPr>
@@ -22805,6 +24020,13 @@
             </a:outerShdw>
           </a:effectLst>
         </p:spPr>
+        <p:txBody>
+          <a:bodyPr/>
+          <a:lstStyle/>
+          <a:p>
+            <a:endParaRPr lang="en-US"/>
+          </a:p>
+        </p:txBody>
       </p:sp>
       <p:sp>
         <p:nvSpPr>
@@ -22830,6 +24052,13 @@
             <a:prstDash val="solid"/>
           </a:ln>
         </p:spPr>
+        <p:txBody>
+          <a:bodyPr/>
+          <a:lstStyle/>
+          <a:p>
+            <a:endParaRPr lang="en-US"/>
+          </a:p>
+        </p:txBody>
       </p:sp>
       <p:pic>
         <p:nvPicPr>
@@ -22979,6 +24208,13 @@
             </a:outerShdw>
           </a:effectLst>
         </p:spPr>
+        <p:txBody>
+          <a:bodyPr/>
+          <a:lstStyle/>
+          <a:p>
+            <a:endParaRPr lang="en-US"/>
+          </a:p>
+        </p:txBody>
       </p:sp>
       <p:sp>
         <p:nvSpPr>
@@ -23004,6 +24240,13 @@
             <a:prstDash val="solid"/>
           </a:ln>
         </p:spPr>
+        <p:txBody>
+          <a:bodyPr/>
+          <a:lstStyle/>
+          <a:p>
+            <a:endParaRPr lang="en-US"/>
+          </a:p>
+        </p:txBody>
       </p:sp>
       <p:pic>
         <p:nvPicPr>
@@ -23153,6 +24396,13 @@
             </a:outerShdw>
           </a:effectLst>
         </p:spPr>
+        <p:txBody>
+          <a:bodyPr/>
+          <a:lstStyle/>
+          <a:p>
+            <a:endParaRPr lang="en-US"/>
+          </a:p>
+        </p:txBody>
       </p:sp>
       <p:sp>
         <p:nvSpPr>
@@ -23178,6 +24428,13 @@
             <a:prstDash val="solid"/>
           </a:ln>
         </p:spPr>
+        <p:txBody>
+          <a:bodyPr/>
+          <a:lstStyle/>
+          <a:p>
+            <a:endParaRPr lang="en-US"/>
+          </a:p>
+        </p:txBody>
       </p:sp>
       <p:pic>
         <p:nvPicPr>
@@ -23318,6 +24575,13 @@
             <a:prstDash val="solid"/>
           </a:ln>
         </p:spPr>
+        <p:txBody>
+          <a:bodyPr/>
+          <a:lstStyle/>
+          <a:p>
+            <a:endParaRPr lang="en-US"/>
+          </a:p>
+        </p:txBody>
       </p:sp>
       <p:pic>
         <p:nvPicPr>
@@ -23449,7 +24713,7 @@
           </a:prstGeom>
           <a:extLst>
             <a:ext uri="{C572A759-6A51-4108-AA02-DFA0A04FC94B}">
-              <ma14:wrappingTextBoxFlag xmlns:ma14="http://schemas.microsoft.com/office/mac/drawingml/2011/main" xmlns="" val="0"/>
+              <ma14:wrappingTextBoxFlag xmlns="" xmlns:ma14="http://schemas.microsoft.com/office/mac/drawingml/2011/main" val="0"/>
             </a:ext>
           </a:extLst>
         </p:spPr>
@@ -23654,6 +24918,13 @@
             </a:outerShdw>
           </a:effectLst>
         </p:spPr>
+        <p:txBody>
+          <a:bodyPr/>
+          <a:lstStyle/>
+          <a:p>
+            <a:endParaRPr lang="en-US"/>
+          </a:p>
+        </p:txBody>
       </p:sp>
       <p:sp>
         <p:nvSpPr>
@@ -23679,6 +24950,13 @@
             <a:prstDash val="solid"/>
           </a:ln>
         </p:spPr>
+        <p:txBody>
+          <a:bodyPr/>
+          <a:lstStyle/>
+          <a:p>
+            <a:endParaRPr lang="en-US"/>
+          </a:p>
+        </p:txBody>
       </p:sp>
       <p:sp>
         <p:nvSpPr>
@@ -23832,6 +25110,13 @@
             </a:outerShdw>
           </a:effectLst>
         </p:spPr>
+        <p:txBody>
+          <a:bodyPr/>
+          <a:lstStyle/>
+          <a:p>
+            <a:endParaRPr lang="en-US"/>
+          </a:p>
+        </p:txBody>
       </p:sp>
       <p:sp>
         <p:nvSpPr>
@@ -23857,6 +25142,13 @@
             <a:prstDash val="solid"/>
           </a:ln>
         </p:spPr>
+        <p:txBody>
+          <a:bodyPr/>
+          <a:lstStyle/>
+          <a:p>
+            <a:endParaRPr lang="en-US"/>
+          </a:p>
+        </p:txBody>
       </p:sp>
       <p:sp>
         <p:nvSpPr>
@@ -24010,6 +25302,13 @@
             </a:outerShdw>
           </a:effectLst>
         </p:spPr>
+        <p:txBody>
+          <a:bodyPr/>
+          <a:lstStyle/>
+          <a:p>
+            <a:endParaRPr lang="en-US"/>
+          </a:p>
+        </p:txBody>
       </p:sp>
       <p:sp>
         <p:nvSpPr>
@@ -24035,6 +25334,13 @@
             <a:prstDash val="solid"/>
           </a:ln>
         </p:spPr>
+        <p:txBody>
+          <a:bodyPr/>
+          <a:lstStyle/>
+          <a:p>
+            <a:endParaRPr lang="en-US"/>
+          </a:p>
+        </p:txBody>
       </p:sp>
       <p:sp>
         <p:nvSpPr>
@@ -24180,6 +25486,13 @@
             <a:tailEnd type="triangle"/>
           </a:ln>
         </p:spPr>
+        <p:txBody>
+          <a:bodyPr/>
+          <a:lstStyle/>
+          <a:p>
+            <a:endParaRPr lang="en-US"/>
+          </a:p>
+        </p:txBody>
       </p:sp>
       <p:sp>
         <p:nvSpPr>
@@ -24204,6 +25517,13 @@
             <a:tailEnd type="triangle"/>
           </a:ln>
         </p:spPr>
+        <p:txBody>
+          <a:bodyPr/>
+          <a:lstStyle/>
+          <a:p>
+            <a:endParaRPr lang="en-US"/>
+          </a:p>
+        </p:txBody>
       </p:sp>
       <p:sp>
         <p:nvSpPr>
@@ -24229,6 +25549,13 @@
             <a:prstDash val="solid"/>
           </a:ln>
         </p:spPr>
+        <p:txBody>
+          <a:bodyPr/>
+          <a:lstStyle/>
+          <a:p>
+            <a:endParaRPr lang="en-US"/>
+          </a:p>
+        </p:txBody>
       </p:sp>
       <p:pic>
         <p:nvPicPr>
@@ -24364,6 +25691,13 @@
             <a:prstDash val="solid"/>
           </a:ln>
         </p:spPr>
+        <p:txBody>
+          <a:bodyPr/>
+          <a:lstStyle/>
+          <a:p>
+            <a:endParaRPr lang="en-US"/>
+          </a:p>
+        </p:txBody>
       </p:sp>
       <p:pic>
         <p:nvPicPr>
@@ -24534,7 +25868,7 @@
           </a:prstGeom>
           <a:extLst>
             <a:ext uri="{C572A759-6A51-4108-AA02-DFA0A04FC94B}">
-              <ma14:wrappingTextBoxFlag xmlns:ma14="http://schemas.microsoft.com/office/mac/drawingml/2011/main" xmlns="" val="0"/>
+              <ma14:wrappingTextBoxFlag xmlns="" xmlns:ma14="http://schemas.microsoft.com/office/mac/drawingml/2011/main" val="0"/>
             </a:ext>
           </a:extLst>
         </p:spPr>
@@ -24739,6 +26073,13 @@
             </a:outerShdw>
           </a:effectLst>
         </p:spPr>
+        <p:txBody>
+          <a:bodyPr/>
+          <a:lstStyle/>
+          <a:p>
+            <a:endParaRPr lang="en-US"/>
+          </a:p>
+        </p:txBody>
       </p:sp>
       <p:pic>
         <p:nvPicPr>
@@ -24835,6 +26176,13 @@
             <a:prstDash val="solid"/>
           </a:ln>
         </p:spPr>
+        <p:txBody>
+          <a:bodyPr/>
+          <a:lstStyle/>
+          <a:p>
+            <a:endParaRPr lang="en-US"/>
+          </a:p>
+        </p:txBody>
       </p:sp>
       <p:sp>
         <p:nvSpPr>
@@ -24944,6 +26292,13 @@
             <a:prstDash val="solid"/>
           </a:ln>
         </p:spPr>
+        <p:txBody>
+          <a:bodyPr/>
+          <a:lstStyle/>
+          <a:p>
+            <a:endParaRPr lang="en-US"/>
+          </a:p>
+        </p:txBody>
       </p:sp>
       <p:sp>
         <p:nvSpPr>
@@ -25053,6 +26408,13 @@
             <a:prstDash val="solid"/>
           </a:ln>
         </p:spPr>
+        <p:txBody>
+          <a:bodyPr/>
+          <a:lstStyle/>
+          <a:p>
+            <a:endParaRPr lang="en-US"/>
+          </a:p>
+        </p:txBody>
       </p:sp>
       <p:sp>
         <p:nvSpPr>
@@ -25114,7 +26476,7 @@
         </p:spPr>
         <p:txBody>
           <a:bodyPr wrap="square" lIns="0" tIns="0" rIns="0" bIns="0" rtlCol="0" anchor="ctr">
-            <a:normAutofit/>
+            <a:normAutofit fontScale="92500"/>
           </a:bodyPr>
           <a:lstStyle/>
           <a:p>
@@ -25160,6 +26522,13 @@
             <a:prstDash val="solid"/>
           </a:ln>
         </p:spPr>
+        <p:txBody>
+          <a:bodyPr/>
+          <a:lstStyle/>
+          <a:p>
+            <a:endParaRPr lang="en-US"/>
+          </a:p>
+        </p:txBody>
       </p:sp>
       <p:sp>
         <p:nvSpPr>
@@ -25250,6 +26619,13 @@
             </a:outerShdw>
           </a:effectLst>
         </p:spPr>
+        <p:txBody>
+          <a:bodyPr/>
+          <a:lstStyle/>
+          <a:p>
+            <a:endParaRPr lang="en-US"/>
+          </a:p>
+        </p:txBody>
       </p:sp>
       <p:pic>
         <p:nvPicPr>
@@ -25344,6 +26720,13 @@
             <a:prstDash val="solid"/>
           </a:ln>
         </p:spPr>
+        <p:txBody>
+          <a:bodyPr/>
+          <a:lstStyle/>
+          <a:p>
+            <a:endParaRPr lang="en-US"/>
+          </a:p>
+        </p:txBody>
       </p:sp>
       <p:sp>
         <p:nvSpPr>
@@ -25371,6 +26754,13 @@
             <a:prstDash val="solid"/>
           </a:ln>
         </p:spPr>
+        <p:txBody>
+          <a:bodyPr/>
+          <a:lstStyle/>
+          <a:p>
+            <a:endParaRPr lang="en-US"/>
+          </a:p>
+        </p:txBody>
       </p:sp>
       <p:sp>
         <p:nvSpPr>
@@ -25478,6 +26868,13 @@
             <a:prstDash val="solid"/>
           </a:ln>
         </p:spPr>
+        <p:txBody>
+          <a:bodyPr/>
+          <a:lstStyle/>
+          <a:p>
+            <a:endParaRPr lang="en-US"/>
+          </a:p>
+        </p:txBody>
       </p:sp>
       <p:sp>
         <p:nvSpPr>
@@ -25505,6 +26902,13 @@
             <a:prstDash val="solid"/>
           </a:ln>
         </p:spPr>
+        <p:txBody>
+          <a:bodyPr/>
+          <a:lstStyle/>
+          <a:p>
+            <a:endParaRPr lang="en-US"/>
+          </a:p>
+        </p:txBody>
       </p:sp>
       <p:sp>
         <p:nvSpPr>
@@ -25612,6 +27016,13 @@
             <a:prstDash val="solid"/>
           </a:ln>
         </p:spPr>
+        <p:txBody>
+          <a:bodyPr/>
+          <a:lstStyle/>
+          <a:p>
+            <a:endParaRPr lang="en-US"/>
+          </a:p>
+        </p:txBody>
       </p:sp>
       <p:sp>
         <p:nvSpPr>
@@ -25639,6 +27050,13 @@
             <a:prstDash val="solid"/>
           </a:ln>
         </p:spPr>
+        <p:txBody>
+          <a:bodyPr/>
+          <a:lstStyle/>
+          <a:p>
+            <a:endParaRPr lang="en-US"/>
+          </a:p>
+        </p:txBody>
       </p:sp>
       <p:sp>
         <p:nvSpPr>
@@ -25861,7 +27279,7 @@
           </a:prstGeom>
           <a:extLst>
             <a:ext uri="{C572A759-6A51-4108-AA02-DFA0A04FC94B}">
-              <ma14:wrappingTextBoxFlag xmlns:ma14="http://schemas.microsoft.com/office/mac/drawingml/2011/main" xmlns="" val="0"/>
+              <ma14:wrappingTextBoxFlag xmlns="" xmlns:ma14="http://schemas.microsoft.com/office/mac/drawingml/2011/main" val="0"/>
             </a:ext>
           </a:extLst>
         </p:spPr>
@@ -26068,6 +27486,13 @@
             </a:outerShdw>
           </a:effectLst>
         </p:spPr>
+        <p:txBody>
+          <a:bodyPr/>
+          <a:lstStyle/>
+          <a:p>
+            <a:endParaRPr lang="en-US"/>
+          </a:p>
+        </p:txBody>
       </p:sp>
       <p:sp>
         <p:nvSpPr>
@@ -26093,6 +27518,13 @@
             <a:prstDash val="solid"/>
           </a:ln>
         </p:spPr>
+        <p:txBody>
+          <a:bodyPr/>
+          <a:lstStyle/>
+          <a:p>
+            <a:endParaRPr lang="en-US"/>
+          </a:p>
+        </p:txBody>
       </p:sp>
       <p:pic>
         <p:nvPicPr>
@@ -26271,6 +27703,13 @@
             </a:outerShdw>
           </a:effectLst>
         </p:spPr>
+        <p:txBody>
+          <a:bodyPr/>
+          <a:lstStyle/>
+          <a:p>
+            <a:endParaRPr lang="en-US"/>
+          </a:p>
+        </p:txBody>
       </p:sp>
       <p:sp>
         <p:nvSpPr>
@@ -26296,6 +27735,13 @@
             <a:prstDash val="solid"/>
           </a:ln>
         </p:spPr>
+        <p:txBody>
+          <a:bodyPr/>
+          <a:lstStyle/>
+          <a:p>
+            <a:endParaRPr lang="en-US"/>
+          </a:p>
+        </p:txBody>
       </p:sp>
       <p:pic>
         <p:nvPicPr>
@@ -26474,6 +27920,13 @@
             </a:outerShdw>
           </a:effectLst>
         </p:spPr>
+        <p:txBody>
+          <a:bodyPr/>
+          <a:lstStyle/>
+          <a:p>
+            <a:endParaRPr lang="en-US"/>
+          </a:p>
+        </p:txBody>
       </p:sp>
       <p:sp>
         <p:nvSpPr>
@@ -26499,6 +27952,13 @@
             <a:prstDash val="solid"/>
           </a:ln>
         </p:spPr>
+        <p:txBody>
+          <a:bodyPr/>
+          <a:lstStyle/>
+          <a:p>
+            <a:endParaRPr lang="en-US"/>
+          </a:p>
+        </p:txBody>
       </p:sp>
       <p:pic>
         <p:nvPicPr>
@@ -26668,6 +28128,13 @@
             <a:prstDash val="solid"/>
           </a:ln>
         </p:spPr>
+        <p:txBody>
+          <a:bodyPr/>
+          <a:lstStyle/>
+          <a:p>
+            <a:endParaRPr lang="en-US"/>
+          </a:p>
+        </p:txBody>
       </p:sp>
       <p:pic>
         <p:nvPicPr>
@@ -26799,7 +28266,7 @@
           </a:prstGeom>
           <a:extLst>
             <a:ext uri="{C572A759-6A51-4108-AA02-DFA0A04FC94B}">
-              <ma14:wrappingTextBoxFlag xmlns:ma14="http://schemas.microsoft.com/office/mac/drawingml/2011/main" xmlns="" val="0"/>
+              <ma14:wrappingTextBoxFlag xmlns="" xmlns:ma14="http://schemas.microsoft.com/office/mac/drawingml/2011/main" val="0"/>
             </a:ext>
           </a:extLst>
         </p:spPr>
@@ -27004,6 +28471,13 @@
             </a:outerShdw>
           </a:effectLst>
         </p:spPr>
+        <p:txBody>
+          <a:bodyPr/>
+          <a:lstStyle/>
+          <a:p>
+            <a:endParaRPr lang="en-US"/>
+          </a:p>
+        </p:txBody>
       </p:sp>
       <p:pic>
         <p:nvPicPr>
@@ -27492,6 +28966,13 @@
             <a:prstDash val="solid"/>
           </a:ln>
         </p:spPr>
+        <p:txBody>
+          <a:bodyPr/>
+          <a:lstStyle/>
+          <a:p>
+            <a:endParaRPr lang="en-US"/>
+          </a:p>
+        </p:txBody>
       </p:sp>
       <p:sp>
         <p:nvSpPr>
@@ -27595,6 +29076,13 @@
             <a:prstDash val="solid"/>
           </a:ln>
         </p:spPr>
+        <p:txBody>
+          <a:bodyPr/>
+          <a:lstStyle/>
+          <a:p>
+            <a:endParaRPr lang="en-US"/>
+          </a:p>
+        </p:txBody>
       </p:sp>
       <p:sp>
         <p:nvSpPr>
@@ -27698,6 +29186,13 @@
             <a:prstDash val="solid"/>
           </a:ln>
         </p:spPr>
+        <p:txBody>
+          <a:bodyPr/>
+          <a:lstStyle/>
+          <a:p>
+            <a:endParaRPr lang="en-US"/>
+          </a:p>
+        </p:txBody>
       </p:sp>
       <p:sp>
         <p:nvSpPr>
@@ -27801,6 +29296,13 @@
             <a:prstDash val="solid"/>
           </a:ln>
         </p:spPr>
+        <p:txBody>
+          <a:bodyPr/>
+          <a:lstStyle/>
+          <a:p>
+            <a:endParaRPr lang="en-US"/>
+          </a:p>
+        </p:txBody>
       </p:sp>
       <p:sp>
         <p:nvSpPr>
@@ -27904,6 +29406,13 @@
             <a:prstDash val="solid"/>
           </a:ln>
         </p:spPr>
+        <p:txBody>
+          <a:bodyPr/>
+          <a:lstStyle/>
+          <a:p>
+            <a:endParaRPr lang="en-US"/>
+          </a:p>
+        </p:txBody>
       </p:sp>
       <p:sp>
         <p:nvSpPr>
@@ -28007,6 +29516,13 @@
             <a:prstDash val="solid"/>
           </a:ln>
         </p:spPr>
+        <p:txBody>
+          <a:bodyPr/>
+          <a:lstStyle/>
+          <a:p>
+            <a:endParaRPr lang="en-US"/>
+          </a:p>
+        </p:txBody>
       </p:sp>
       <p:pic>
         <p:nvPicPr>
@@ -28138,7 +29654,7 @@
           </a:prstGeom>
           <a:extLst>
             <a:ext uri="{C572A759-6A51-4108-AA02-DFA0A04FC94B}">
-              <ma14:wrappingTextBoxFlag xmlns:ma14="http://schemas.microsoft.com/office/mac/drawingml/2011/main" xmlns="" val="0"/>
+              <ma14:wrappingTextBoxFlag xmlns="" xmlns:ma14="http://schemas.microsoft.com/office/mac/drawingml/2011/main" val="0"/>
             </a:ext>
           </a:extLst>
         </p:spPr>

</xml_diff>

<commit_message>
Use Microsoft Foundry logo on deployment slide
Co-authored-by: Copilot <223556219+Copilot@users.noreply.github.com>

Copilot-Session: 8c02ba17-1398-4d94-b9f2-71766e81e382
</commit_message>
<xml_diff>
--- a/docs/foundry-apim-mcp-workshop.pptx
+++ b/docs/foundry-apim-mcp-workshop.pptx
@@ -2186,7 +2186,7 @@
           </a:prstGeom>
           <a:extLst>
             <a:ext uri="{C572A759-6A51-4108-AA02-DFA0A04FC94B}">
-              <ma14:wrappingTextBoxFlag xmlns="" xmlns:ma14="http://schemas.microsoft.com/office/mac/drawingml/2011/main" val="0"/>
+              <ma14:wrappingTextBoxFlag xmlns:ma14="http://schemas.microsoft.com/office/mac/drawingml/2011/main" xmlns="" val="0"/>
             </a:ext>
           </a:extLst>
         </p:spPr>
@@ -2264,7 +2264,7 @@
           </a:prstGeom>
           <a:extLst>
             <a:ext uri="{C572A759-6A51-4108-AA02-DFA0A04FC94B}">
-              <ma14:wrappingTextBoxFlag xmlns="" xmlns:ma14="http://schemas.microsoft.com/office/mac/drawingml/2011/main" val="0"/>
+              <ma14:wrappingTextBoxFlag xmlns:ma14="http://schemas.microsoft.com/office/mac/drawingml/2011/main" xmlns="" val="0"/>
             </a:ext>
           </a:extLst>
         </p:spPr>
@@ -4757,7 +4757,7 @@
           </a:prstGeom>
           <a:extLst>
             <a:ext uri="{C572A759-6A51-4108-AA02-DFA0A04FC94B}">
-              <ma14:wrappingTextBoxFlag xmlns="" xmlns:ma14="http://schemas.microsoft.com/office/mac/drawingml/2011/main" val="0"/>
+              <ma14:wrappingTextBoxFlag xmlns:ma14="http://schemas.microsoft.com/office/mac/drawingml/2011/main" xmlns="" val="0"/>
             </a:ext>
           </a:extLst>
         </p:spPr>
@@ -5698,7 +5698,7 @@
           </a:prstGeom>
           <a:extLst>
             <a:ext uri="{C572A759-6A51-4108-AA02-DFA0A04FC94B}">
-              <ma14:wrappingTextBoxFlag xmlns="" xmlns:ma14="http://schemas.microsoft.com/office/mac/drawingml/2011/main" val="0"/>
+              <ma14:wrappingTextBoxFlag xmlns:ma14="http://schemas.microsoft.com/office/mac/drawingml/2011/main" xmlns="" val="0"/>
             </a:ext>
           </a:extLst>
         </p:spPr>
@@ -6711,7 +6711,7 @@
           </a:prstGeom>
           <a:extLst>
             <a:ext uri="{C572A759-6A51-4108-AA02-DFA0A04FC94B}">
-              <ma14:wrappingTextBoxFlag xmlns="" xmlns:ma14="http://schemas.microsoft.com/office/mac/drawingml/2011/main" val="0"/>
+              <ma14:wrappingTextBoxFlag xmlns:ma14="http://schemas.microsoft.com/office/mac/drawingml/2011/main" xmlns="" val="0"/>
             </a:ext>
           </a:extLst>
         </p:spPr>
@@ -7370,9 +7370,123 @@
           </a:p>
         </p:txBody>
       </p:sp>
+      <p:sp>
+        <p:nvSpPr>
+          <p:cNvPr id="17" name="Text 12"/>
+          <p:cNvSpPr/>
+          <p:nvPr/>
+        </p:nvSpPr>
+        <p:spPr>
+          <a:xfrm>
+            <a:off x="8940800" y="3263900"/>
+            <a:ext cx="2286000" cy="502920"/>
+          </a:xfrm>
+          <a:prstGeom prst="rect">
+            <a:avLst/>
+          </a:prstGeom>
+          <a:noFill/>
+          <a:ln/>
+        </p:spPr>
+        <p:txBody>
+          <a:bodyPr wrap="square" lIns="0" tIns="0" rIns="0" bIns="0" rtlCol="0" anchor="ctr">
+            <a:normAutofit/>
+          </a:bodyPr>
+          <a:lstStyle/>
+          <a:p>
+            <a:pPr marL="0" indent="0" algn="ctr">
+              <a:buNone/>
+            </a:pPr>
+            <a:r>
+              <a:rPr lang="en-US" sz="1700" b="1" dirty="0">
+                <a:solidFill>
+                  <a:srgbClr val="FFFFFF"/>
+                </a:solidFill>
+                <a:latin typeface="Aptos Display" pitchFamily="34" charset="0"/>
+                <a:ea typeface="Aptos Display" pitchFamily="34" charset="-122"/>
+                <a:cs typeface="Aptos Display" pitchFamily="34" charset="-120"/>
+              </a:rPr>
+              <a:t>Foundry Agent Service</a:t>
+            </a:r>
+            <a:endParaRPr lang="en-US" sz="1700" dirty="0"/>
+          </a:p>
+        </p:txBody>
+      </p:sp>
+      <p:sp>
+        <p:nvSpPr>
+          <p:cNvPr id="18" name="Text 13"/>
+          <p:cNvSpPr/>
+          <p:nvPr/>
+        </p:nvSpPr>
+        <p:spPr>
+          <a:xfrm>
+            <a:off x="9123680" y="4178300"/>
+            <a:ext cx="1920240" cy="548640"/>
+          </a:xfrm>
+          <a:prstGeom prst="rect">
+            <a:avLst/>
+          </a:prstGeom>
+          <a:noFill/>
+          <a:ln/>
+        </p:spPr>
+        <p:txBody>
+          <a:bodyPr wrap="square" lIns="0" tIns="0" rIns="0" bIns="0" rtlCol="0" anchor="ctr">
+            <a:normAutofit/>
+          </a:bodyPr>
+          <a:lstStyle/>
+          <a:p>
+            <a:pPr marL="0" indent="0" algn="ctr">
+              <a:buNone/>
+            </a:pPr>
+            <a:r>
+              <a:rPr lang="en-US" sz="1050">
+                <a:solidFill>
+                  <a:srgbClr val="DDEAF2"/>
+                </a:solidFill>
+                <a:latin typeface="Aptos" pitchFamily="34" charset="0"/>
+                <a:ea typeface="Aptos" pitchFamily="34" charset="-122"/>
+                <a:cs typeface="Aptos" pitchFamily="34" charset="-120"/>
+              </a:rPr>
+              <a:t>Single shared target</a:t>
+            </a:r>
+          </a:p>
+          <a:p>
+            <a:pPr marL="0" indent="0" algn="ctr">
+              <a:buNone/>
+            </a:pPr>
+            <a:r>
+              <a:rPr lang="en-US" sz="1050">
+                <a:solidFill>
+                  <a:srgbClr val="DDEAF2"/>
+                </a:solidFill>
+                <a:latin typeface="Aptos" pitchFamily="34" charset="0"/>
+                <a:ea typeface="Aptos" pitchFamily="34" charset="-122"/>
+                <a:cs typeface="Aptos" pitchFamily="34" charset="-120"/>
+              </a:rPr>
+              <a:t>Managed compute + sandbox</a:t>
+            </a:r>
+          </a:p>
+          <a:p>
+            <a:pPr marL="0" indent="0" algn="ctr">
+              <a:buNone/>
+            </a:pPr>
+            <a:r>
+              <a:rPr lang="en-US" sz="1050">
+                <a:solidFill>
+                  <a:srgbClr val="DDEAF2"/>
+                </a:solidFill>
+                <a:latin typeface="Aptos" pitchFamily="34" charset="0"/>
+                <a:ea typeface="Aptos" pitchFamily="34" charset="-122"/>
+                <a:cs typeface="Aptos" pitchFamily="34" charset="-120"/>
+              </a:rPr>
+              <a:t>Immutable agent version</a:t>
+            </a:r>
+            <a:endParaRPr lang="en-US" sz="1050" dirty="0"/>
+          </a:p>
+        </p:txBody>
+      </p:sp>
       <p:pic>
         <p:nvPicPr>
-          <p:cNvPr id="16" name="Image 2" descr="preencoded.png"/>
+          <p:cNvPr id="21" name="Image 3" descr="preencoded.png"/>
           <p:cNvPicPr>
             <a:picLocks noChangeAspect="1"/>
           </p:cNvPicPr>
@@ -7392,8 +7506,8 @@
         </p:blipFill>
         <p:spPr>
           <a:xfrm>
-            <a:off x="9726930" y="2357120"/>
-            <a:ext cx="713232" cy="713232"/>
+            <a:off x="822960" y="5892800"/>
+            <a:ext cx="256032" cy="256032"/>
           </a:xfrm>
           <a:prstGeom prst="rect">
             <a:avLst/>
@@ -7402,14 +7516,14 @@
       </p:pic>
       <p:sp>
         <p:nvSpPr>
-          <p:cNvPr id="17" name="Text 12"/>
-          <p:cNvSpPr/>
-          <p:nvPr/>
-        </p:nvSpPr>
-        <p:spPr>
-          <a:xfrm>
-            <a:off x="8940800" y="3263900"/>
-            <a:ext cx="2286000" cy="502920"/>
+          <p:cNvPr id="22" name="Text 16"/>
+          <p:cNvSpPr/>
+          <p:nvPr/>
+        </p:nvSpPr>
+        <p:spPr>
+          <a:xfrm>
+            <a:off x="1188720" y="5910580"/>
+            <a:ext cx="2240280" cy="201168"/>
           </a:xfrm>
           <a:prstGeom prst="rect">
             <a:avLst/>
@@ -7423,100 +7537,27 @@
           </a:bodyPr>
           <a:lstStyle/>
           <a:p>
-            <a:pPr marL="0" indent="0" algn="ctr">
-              <a:buNone/>
-            </a:pPr>
-            <a:r>
-              <a:rPr lang="en-US" sz="1700" b="1" dirty="0">
-                <a:solidFill>
-                  <a:srgbClr val="FFFFFF"/>
-                </a:solidFill>
-                <a:latin typeface="Aptos Display" pitchFamily="34" charset="0"/>
-                <a:ea typeface="Aptos Display" pitchFamily="34" charset="-122"/>
-                <a:cs typeface="Aptos Display" pitchFamily="34" charset="-120"/>
-              </a:rPr>
-              <a:t>Foundry Agent Service</a:t>
-            </a:r>
-            <a:endParaRPr lang="en-US" sz="1700" dirty="0"/>
-          </a:p>
-        </p:txBody>
-      </p:sp>
-      <p:sp>
-        <p:nvSpPr>
-          <p:cNvPr id="18" name="Text 13"/>
-          <p:cNvSpPr/>
-          <p:nvPr/>
-        </p:nvSpPr>
-        <p:spPr>
-          <a:xfrm>
-            <a:off x="9123680" y="4178300"/>
-            <a:ext cx="1920240" cy="548640"/>
-          </a:xfrm>
-          <a:prstGeom prst="rect">
-            <a:avLst/>
-          </a:prstGeom>
-          <a:noFill/>
-          <a:ln/>
-        </p:spPr>
-        <p:txBody>
-          <a:bodyPr wrap="square" lIns="0" tIns="0" rIns="0" bIns="0" rtlCol="0" anchor="ctr">
-            <a:normAutofit/>
-          </a:bodyPr>
-          <a:lstStyle/>
-          <a:p>
-            <a:pPr marL="0" indent="0" algn="ctr">
-              <a:buNone/>
-            </a:pPr>
-            <a:r>
-              <a:rPr lang="en-US" sz="1050">
-                <a:solidFill>
-                  <a:srgbClr val="DDEAF2"/>
+            <a:pPr marL="0" indent="0">
+              <a:buNone/>
+            </a:pPr>
+            <a:r>
+              <a:rPr lang="en-US" sz="920" b="1" dirty="0">
+                <a:solidFill>
+                  <a:srgbClr val="102A43"/>
                 </a:solidFill>
                 <a:latin typeface="Aptos" pitchFamily="34" charset="0"/>
                 <a:ea typeface="Aptos" pitchFamily="34" charset="-122"/>
                 <a:cs typeface="Aptos" pitchFamily="34" charset="-120"/>
               </a:rPr>
-              <a:t>Single shared target</a:t>
-            </a:r>
-          </a:p>
-          <a:p>
-            <a:pPr marL="0" indent="0" algn="ctr">
-              <a:buNone/>
-            </a:pPr>
-            <a:r>
-              <a:rPr lang="en-US" sz="1050">
-                <a:solidFill>
-                  <a:srgbClr val="DDEAF2"/>
-                </a:solidFill>
-                <a:latin typeface="Aptos" pitchFamily="34" charset="0"/>
-                <a:ea typeface="Aptos" pitchFamily="34" charset="-122"/>
-                <a:cs typeface="Aptos" pitchFamily="34" charset="-120"/>
-              </a:rPr>
-              <a:t>Managed compute + sandbox</a:t>
-            </a:r>
-          </a:p>
-          <a:p>
-            <a:pPr marL="0" indent="0" algn="ctr">
-              <a:buNone/>
-            </a:pPr>
-            <a:r>
-              <a:rPr lang="en-US" sz="1050">
-                <a:solidFill>
-                  <a:srgbClr val="DDEAF2"/>
-                </a:solidFill>
-                <a:latin typeface="Aptos" pitchFamily="34" charset="0"/>
-                <a:ea typeface="Aptos" pitchFamily="34" charset="-122"/>
-                <a:cs typeface="Aptos" pitchFamily="34" charset="-120"/>
-              </a:rPr>
-              <a:t>Immutable agent version</a:t>
-            </a:r>
-            <a:endParaRPr lang="en-US" sz="1050" dirty="0"/>
+              <a:t>Code deployment</a:t>
+            </a:r>
+            <a:endParaRPr lang="en-US" sz="920" dirty="0"/>
           </a:p>
         </p:txBody>
       </p:sp>
       <p:pic>
         <p:nvPicPr>
-          <p:cNvPr id="21" name="Image 3" descr="preencoded.png"/>
+          <p:cNvPr id="23" name="Image 4" descr="preencoded.png"/>
           <p:cNvPicPr>
             <a:picLocks noChangeAspect="1"/>
           </p:cNvPicPr>
@@ -7536,7 +7577,7 @@
         </p:blipFill>
         <p:spPr>
           <a:xfrm>
-            <a:off x="822960" y="5892800"/>
+            <a:off x="3657600" y="5892800"/>
             <a:ext cx="256032" cy="256032"/>
           </a:xfrm>
           <a:prstGeom prst="rect">
@@ -7546,13 +7587,13 @@
       </p:pic>
       <p:sp>
         <p:nvSpPr>
-          <p:cNvPr id="22" name="Text 16"/>
-          <p:cNvSpPr/>
-          <p:nvPr/>
-        </p:nvSpPr>
-        <p:spPr>
-          <a:xfrm>
-            <a:off x="1188720" y="5910580"/>
+          <p:cNvPr id="24" name="Text 17"/>
+          <p:cNvSpPr/>
+          <p:nvPr/>
+        </p:nvSpPr>
+        <p:spPr>
+          <a:xfrm>
+            <a:off x="4023360" y="5910580"/>
             <a:ext cx="2240280" cy="201168"/>
           </a:xfrm>
           <a:prstGeom prst="rect">
@@ -7579,7 +7620,7 @@
                 <a:ea typeface="Aptos" pitchFamily="34" charset="-122"/>
                 <a:cs typeface="Aptos" pitchFamily="34" charset="-120"/>
               </a:rPr>
-              <a:t>Code deployment</a:t>
+              <a:t>Remote dependency resolution</a:t>
             </a:r>
             <a:endParaRPr lang="en-US" sz="920" dirty="0"/>
           </a:p>
@@ -7587,7 +7628,7 @@
       </p:sp>
       <p:pic>
         <p:nvPicPr>
-          <p:cNvPr id="23" name="Image 4" descr="preencoded.png"/>
+          <p:cNvPr id="25" name="Image 5" descr="preencoded.png"/>
           <p:cNvPicPr>
             <a:picLocks noChangeAspect="1"/>
           </p:cNvPicPr>
@@ -7607,7 +7648,7 @@
         </p:blipFill>
         <p:spPr>
           <a:xfrm>
-            <a:off x="3657600" y="5892800"/>
+            <a:off x="6492240" y="5892800"/>
             <a:ext cx="256032" cy="256032"/>
           </a:xfrm>
           <a:prstGeom prst="rect">
@@ -7617,13 +7658,13 @@
       </p:pic>
       <p:sp>
         <p:nvSpPr>
-          <p:cNvPr id="24" name="Text 17"/>
-          <p:cNvSpPr/>
-          <p:nvPr/>
-        </p:nvSpPr>
-        <p:spPr>
-          <a:xfrm>
-            <a:off x="4023360" y="5910580"/>
+          <p:cNvPr id="26" name="Text 18"/>
+          <p:cNvSpPr/>
+          <p:nvPr/>
+        </p:nvSpPr>
+        <p:spPr>
+          <a:xfrm>
+            <a:off x="6858000" y="5910580"/>
             <a:ext cx="2240280" cy="201168"/>
           </a:xfrm>
           <a:prstGeom prst="rect">
@@ -7650,7 +7691,7 @@
                 <a:ea typeface="Aptos" pitchFamily="34" charset="-122"/>
                 <a:cs typeface="Aptos" pitchFamily="34" charset="-120"/>
               </a:rPr>
-              <a:t>Remote dependency resolution</a:t>
+              <a:t>No participant-managed ACA or ACR</a:t>
             </a:r>
             <a:endParaRPr lang="en-US" sz="920" dirty="0"/>
           </a:p>
@@ -7658,7 +7699,7 @@
       </p:sp>
       <p:pic>
         <p:nvPicPr>
-          <p:cNvPr id="25" name="Image 5" descr="preencoded.png"/>
+          <p:cNvPr id="27" name="Image 6" descr="preencoded.png"/>
           <p:cNvPicPr>
             <a:picLocks noChangeAspect="1"/>
           </p:cNvPicPr>
@@ -7678,77 +7719,6 @@
         </p:blipFill>
         <p:spPr>
           <a:xfrm>
-            <a:off x="6492240" y="5892800"/>
-            <a:ext cx="256032" cy="256032"/>
-          </a:xfrm>
-          <a:prstGeom prst="rect">
-            <a:avLst/>
-          </a:prstGeom>
-        </p:spPr>
-      </p:pic>
-      <p:sp>
-        <p:nvSpPr>
-          <p:cNvPr id="26" name="Text 18"/>
-          <p:cNvSpPr/>
-          <p:nvPr/>
-        </p:nvSpPr>
-        <p:spPr>
-          <a:xfrm>
-            <a:off x="6858000" y="5910580"/>
-            <a:ext cx="2240280" cy="201168"/>
-          </a:xfrm>
-          <a:prstGeom prst="rect">
-            <a:avLst/>
-          </a:prstGeom>
-          <a:noFill/>
-          <a:ln/>
-        </p:spPr>
-        <p:txBody>
-          <a:bodyPr wrap="square" lIns="0" tIns="0" rIns="0" bIns="0" rtlCol="0" anchor="ctr">
-            <a:normAutofit/>
-          </a:bodyPr>
-          <a:lstStyle/>
-          <a:p>
-            <a:pPr marL="0" indent="0">
-              <a:buNone/>
-            </a:pPr>
-            <a:r>
-              <a:rPr lang="en-US" sz="920" b="1" dirty="0">
-                <a:solidFill>
-                  <a:srgbClr val="102A43"/>
-                </a:solidFill>
-                <a:latin typeface="Aptos" pitchFamily="34" charset="0"/>
-                <a:ea typeface="Aptos" pitchFamily="34" charset="-122"/>
-                <a:cs typeface="Aptos" pitchFamily="34" charset="-120"/>
-              </a:rPr>
-              <a:t>No participant-managed ACA or ACR</a:t>
-            </a:r>
-            <a:endParaRPr lang="en-US" sz="920" dirty="0"/>
-          </a:p>
-        </p:txBody>
-      </p:sp>
-      <p:pic>
-        <p:nvPicPr>
-          <p:cNvPr id="27" name="Image 6" descr="preencoded.png"/>
-          <p:cNvPicPr>
-            <a:picLocks noChangeAspect="1"/>
-          </p:cNvPicPr>
-          <p:nvPr/>
-        </p:nvPicPr>
-        <p:blipFill>
-          <a:blip>
-            <a:extLst>
-              <a:ext uri="{96DAC541-7B7A-43D3-8B79-37D633B846F1}">
-                <asvg:svgBlip xmlns:asvg="http://schemas.microsoft.com/office/drawing/2016/SVG/main" r:embed="rId9"/>
-              </a:ext>
-            </a:extLst>
-          </a:blip>
-          <a:stretch>
-            <a:fillRect/>
-          </a:stretch>
-        </p:blipFill>
-        <p:spPr>
-          <a:xfrm>
             <a:off x="9326880" y="5892800"/>
             <a:ext cx="256032" cy="256032"/>
           </a:xfrm>
@@ -7857,7 +7827,7 @@
           </a:prstGeom>
           <a:extLst>
             <a:ext uri="{C572A759-6A51-4108-AA02-DFA0A04FC94B}">
-              <ma14:wrappingTextBoxFlag xmlns="" xmlns:ma14="http://schemas.microsoft.com/office/mac/drawingml/2011/main" val="0"/>
+              <ma14:wrappingTextBoxFlag xmlns:ma14="http://schemas.microsoft.com/office/mac/drawingml/2011/main" xmlns="" val="0"/>
             </a:ext>
           </a:extLst>
         </p:spPr>
@@ -8009,6 +7979,42 @@
           </a:fontRef>
         </p:style>
       </p:cxnSp>
+      <p:pic>
+        <p:nvPicPr>
+          <p:cNvPr id="33" name="Microsoft Foundry Logo" descr="Microsoft Foundry logo">
+            <a:extLst>
+              <a:ext uri="{FF2B5EF4-FFF2-40B4-BE49-F238E27FC236}">
+                <a16:creationId xmlns:a16="http://schemas.microsoft.com/office/drawing/2014/main" id="{43D4787C-7CE1-4882-EAF0-465DE7DC05EE}"/>
+              </a:ext>
+            </a:extLst>
+          </p:cNvPr>
+          <p:cNvPicPr>
+            <a:picLocks/>
+          </p:cNvPicPr>
+          <p:nvPr/>
+        </p:nvPicPr>
+        <p:blipFill>
+          <a:blip>
+            <a:extLst>
+              <a:ext uri="{96DAC541-7B7A-43D3-8B79-37D633B846F1}">
+                <asvg:svgBlip xmlns:asvg="http://schemas.microsoft.com/office/drawing/2016/SVG/main" r:embed="rId9"/>
+              </a:ext>
+            </a:extLst>
+          </a:blip>
+          <a:stretch>
+            <a:fillRect/>
+          </a:stretch>
+        </p:blipFill>
+        <p:spPr>
+          <a:xfrm>
+            <a:off x="9726930" y="2357120"/>
+            <a:ext cx="713232" cy="713232"/>
+          </a:xfrm>
+          <a:prstGeom prst="rect">
+            <a:avLst/>
+          </a:prstGeom>
+        </p:spPr>
+      </p:pic>
     </p:spTree>
   </p:cSld>
   <p:clrMapOvr>
@@ -9278,7 +9284,7 @@
           </a:prstGeom>
           <a:extLst>
             <a:ext uri="{C572A759-6A51-4108-AA02-DFA0A04FC94B}">
-              <ma14:wrappingTextBoxFlag xmlns="" xmlns:ma14="http://schemas.microsoft.com/office/mac/drawingml/2011/main" val="0"/>
+              <ma14:wrappingTextBoxFlag xmlns:ma14="http://schemas.microsoft.com/office/mac/drawingml/2011/main" xmlns="" val="0"/>
             </a:ext>
           </a:extLst>
         </p:spPr>
@@ -10295,7 +10301,7 @@
           </a:prstGeom>
           <a:extLst>
             <a:ext uri="{C572A759-6A51-4108-AA02-DFA0A04FC94B}">
-              <ma14:wrappingTextBoxFlag xmlns="" xmlns:ma14="http://schemas.microsoft.com/office/mac/drawingml/2011/main" val="0"/>
+              <ma14:wrappingTextBoxFlag xmlns:ma14="http://schemas.microsoft.com/office/mac/drawingml/2011/main" xmlns="" val="0"/>
             </a:ext>
           </a:extLst>
         </p:spPr>
@@ -11516,7 +11522,7 @@
           </a:prstGeom>
           <a:extLst>
             <a:ext uri="{C572A759-6A51-4108-AA02-DFA0A04FC94B}">
-              <ma14:wrappingTextBoxFlag xmlns="" xmlns:ma14="http://schemas.microsoft.com/office/mac/drawingml/2011/main" val="0"/>
+              <ma14:wrappingTextBoxFlag xmlns:ma14="http://schemas.microsoft.com/office/mac/drawingml/2011/main" xmlns="" val="0"/>
             </a:ext>
           </a:extLst>
         </p:spPr>
@@ -13279,7 +13285,7 @@
           </a:prstGeom>
           <a:extLst>
             <a:ext uri="{C572A759-6A51-4108-AA02-DFA0A04FC94B}">
-              <ma14:wrappingTextBoxFlag xmlns="" xmlns:ma14="http://schemas.microsoft.com/office/mac/drawingml/2011/main" val="0"/>
+              <ma14:wrappingTextBoxFlag xmlns:ma14="http://schemas.microsoft.com/office/mac/drawingml/2011/main" xmlns="" val="0"/>
             </a:ext>
           </a:extLst>
         </p:spPr>
@@ -14610,7 +14616,7 @@
           </a:prstGeom>
           <a:extLst>
             <a:ext uri="{C572A759-6A51-4108-AA02-DFA0A04FC94B}">
-              <ma14:wrappingTextBoxFlag xmlns="" xmlns:ma14="http://schemas.microsoft.com/office/mac/drawingml/2011/main" val="0"/>
+              <ma14:wrappingTextBoxFlag xmlns:ma14="http://schemas.microsoft.com/office/mac/drawingml/2011/main" xmlns="" val="0"/>
             </a:ext>
           </a:extLst>
         </p:spPr>
@@ -16232,7 +16238,7 @@
           </a:prstGeom>
           <a:extLst>
             <a:ext uri="{C572A759-6A51-4108-AA02-DFA0A04FC94B}">
-              <ma14:wrappingTextBoxFlag xmlns="" xmlns:ma14="http://schemas.microsoft.com/office/mac/drawingml/2011/main" val="0"/>
+              <ma14:wrappingTextBoxFlag xmlns:ma14="http://schemas.microsoft.com/office/mac/drawingml/2011/main" xmlns="" val="0"/>
             </a:ext>
           </a:extLst>
         </p:spPr>
@@ -17413,7 +17419,7 @@
           </a:prstGeom>
           <a:extLst>
             <a:ext uri="{C572A759-6A51-4108-AA02-DFA0A04FC94B}">
-              <ma14:wrappingTextBoxFlag xmlns="" xmlns:ma14="http://schemas.microsoft.com/office/mac/drawingml/2011/main" val="0"/>
+              <ma14:wrappingTextBoxFlag xmlns:ma14="http://schemas.microsoft.com/office/mac/drawingml/2011/main" xmlns="" val="0"/>
             </a:ext>
           </a:extLst>
         </p:spPr>
@@ -18605,7 +18611,7 @@
           </a:prstGeom>
           <a:extLst>
             <a:ext uri="{C572A759-6A51-4108-AA02-DFA0A04FC94B}">
-              <ma14:wrappingTextBoxFlag xmlns="" xmlns:ma14="http://schemas.microsoft.com/office/mac/drawingml/2011/main" val="0"/>
+              <ma14:wrappingTextBoxFlag xmlns:ma14="http://schemas.microsoft.com/office/mac/drawingml/2011/main" xmlns="" val="0"/>
             </a:ext>
           </a:extLst>
         </p:spPr>
@@ -21100,7 +21106,7 @@
           </a:prstGeom>
           <a:extLst>
             <a:ext uri="{C572A759-6A51-4108-AA02-DFA0A04FC94B}">
-              <ma14:wrappingTextBoxFlag xmlns="" xmlns:ma14="http://schemas.microsoft.com/office/mac/drawingml/2011/main" val="0"/>
+              <ma14:wrappingTextBoxFlag xmlns:ma14="http://schemas.microsoft.com/office/mac/drawingml/2011/main" xmlns="" val="0"/>
             </a:ext>
           </a:extLst>
         </p:spPr>
@@ -23625,7 +23631,7 @@
           </a:prstGeom>
           <a:extLst>
             <a:ext uri="{C572A759-6A51-4108-AA02-DFA0A04FC94B}">
-              <ma14:wrappingTextBoxFlag xmlns="" xmlns:ma14="http://schemas.microsoft.com/office/mac/drawingml/2011/main" val="0"/>
+              <ma14:wrappingTextBoxFlag xmlns:ma14="http://schemas.microsoft.com/office/mac/drawingml/2011/main" xmlns="" val="0"/>
             </a:ext>
           </a:extLst>
         </p:spPr>
@@ -24713,7 +24719,7 @@
           </a:prstGeom>
           <a:extLst>
             <a:ext uri="{C572A759-6A51-4108-AA02-DFA0A04FC94B}">
-              <ma14:wrappingTextBoxFlag xmlns="" xmlns:ma14="http://schemas.microsoft.com/office/mac/drawingml/2011/main" val="0"/>
+              <ma14:wrappingTextBoxFlag xmlns:ma14="http://schemas.microsoft.com/office/mac/drawingml/2011/main" xmlns="" val="0"/>
             </a:ext>
           </a:extLst>
         </p:spPr>
@@ -25868,7 +25874,7 @@
           </a:prstGeom>
           <a:extLst>
             <a:ext uri="{C572A759-6A51-4108-AA02-DFA0A04FC94B}">
-              <ma14:wrappingTextBoxFlag xmlns="" xmlns:ma14="http://schemas.microsoft.com/office/mac/drawingml/2011/main" val="0"/>
+              <ma14:wrappingTextBoxFlag xmlns:ma14="http://schemas.microsoft.com/office/mac/drawingml/2011/main" xmlns="" val="0"/>
             </a:ext>
           </a:extLst>
         </p:spPr>
@@ -27279,7 +27285,7 @@
           </a:prstGeom>
           <a:extLst>
             <a:ext uri="{C572A759-6A51-4108-AA02-DFA0A04FC94B}">
-              <ma14:wrappingTextBoxFlag xmlns="" xmlns:ma14="http://schemas.microsoft.com/office/mac/drawingml/2011/main" val="0"/>
+              <ma14:wrappingTextBoxFlag xmlns:ma14="http://schemas.microsoft.com/office/mac/drawingml/2011/main" xmlns="" val="0"/>
             </a:ext>
           </a:extLst>
         </p:spPr>
@@ -28266,7 +28272,7 @@
           </a:prstGeom>
           <a:extLst>
             <a:ext uri="{C572A759-6A51-4108-AA02-DFA0A04FC94B}">
-              <ma14:wrappingTextBoxFlag xmlns="" xmlns:ma14="http://schemas.microsoft.com/office/mac/drawingml/2011/main" val="0"/>
+              <ma14:wrappingTextBoxFlag xmlns:ma14="http://schemas.microsoft.com/office/mac/drawingml/2011/main" xmlns="" val="0"/>
             </a:ext>
           </a:extLst>
         </p:spPr>
@@ -29654,7 +29660,7 @@
           </a:prstGeom>
           <a:extLst>
             <a:ext uri="{C572A759-6A51-4108-AA02-DFA0A04FC94B}">
-              <ma14:wrappingTextBoxFlag xmlns="" xmlns:ma14="http://schemas.microsoft.com/office/mac/drawingml/2011/main" val="0"/>
+              <ma14:wrappingTextBoxFlag xmlns:ma14="http://schemas.microsoft.com/office/mac/drawingml/2011/main" xmlns="" val="0"/>
             </a:ext>
           </a:extLst>
         </p:spPr>

</xml_diff>

<commit_message>
Align Lab 2 and Lab 3 slide tags
Co-authored-by: Copilot <223556219+Copilot@users.noreply.github.com>

Copilot-Session: 8c02ba17-1398-4d94-b9f2-71766e81e382
</commit_message>
<xml_diff>
--- a/docs/foundry-apim-mcp-workshop.pptx
+++ b/docs/foundry-apim-mcp-workshop.pptx
@@ -3213,7 +3213,7 @@
               <a:buNone/>
             </a:pPr>
             <a:r>
-              <a:rPr lang="en-US" sz="900" b="1" kern="0" spc="140" dirty="0">
+              <a:rPr lang="en-US" sz="900" b="1" kern="0" spc="140">
                 <a:solidFill>
                   <a:srgbClr val="0F8B8D"/>
                 </a:solidFill>
@@ -3221,7 +3221,7 @@
                 <a:ea typeface="Aptos" pitchFamily="34" charset="-122"/>
                 <a:cs typeface="Aptos" pitchFamily="34" charset="-120"/>
               </a:rPr>
-              <a:t> AGENT BEHAVIOR</a:t>
+              <a:t>LAB 3 | AGENT BEHAVIOR</a:t>
             </a:r>
             <a:endParaRPr lang="en-US" sz="900" dirty="0"/>
           </a:p>
@@ -27363,7 +27363,7 @@
               <a:buNone/>
             </a:pPr>
             <a:r>
-              <a:rPr lang="en-US" sz="900" b="1" kern="0" spc="140" dirty="0">
+              <a:rPr lang="en-US" sz="900" b="1" kern="0" spc="140">
                 <a:solidFill>
                   <a:srgbClr val="0F8B8D"/>
                 </a:solidFill>
@@ -27371,7 +27371,7 @@
                 <a:ea typeface="Aptos" pitchFamily="34" charset="-122"/>
                 <a:cs typeface="Aptos" pitchFamily="34" charset="-120"/>
               </a:rPr>
-              <a:t> VALIDATION CHECKPOINT</a:t>
+              <a:t>LAB 2 | VALIDATE</a:t>
             </a:r>
             <a:endParaRPr lang="en-US" sz="900" dirty="0"/>
           </a:p>

</xml_diff>

<commit_message>
Clarify local Responses API startup flow
Co-authored-by: Copilot <223556219+Copilot@users.noreply.github.com>

Copilot-Session: 8c02ba17-1398-4d94-b9f2-71766e81e382
</commit_message>
<xml_diff>
--- a/docs/foundry-apim-mcp-workshop.pptx
+++ b/docs/foundry-apim-mcp-workshop.pptx
@@ -476,9 +476,10 @@
           <a:lstStyle/>
           <a:p>
             <a:r>
-              <a:rPr lang="en-US" dirty="0"/>
-              <a:t>Demonstrate both methods. PowerShell is the fastest pass or fail check. Agent Inspector is the teaching view because it exposes the complete run and approval behavior.</a:t>
-            </a:r>
+              <a:rPr lang="en-US"/>
+              <a:t>Run the ASP.NET Core web project first. Confirm that the Responses API is listening at http://localhost:8088/responses before opening either client. Use PowerShell for the fastest pass or fail check. Open Agent Inspector from Foundry Toolkit for the teaching view because it exposes model input, tool discovery, tool calls, approvals, and the final response.</a:t>
+            </a:r>
+            <a:endParaRPr lang="en-US" dirty="0"/>
           </a:p>
         </p:txBody>
       </p:sp>
@@ -4876,7 +4877,7 @@
               <a:buNone/>
             </a:pPr>
             <a:r>
-              <a:rPr lang="en-US" sz="2700" b="1" dirty="0">
+              <a:rPr lang="en-US" sz="2700" b="1">
                 <a:solidFill>
                   <a:srgbClr val="102A43"/>
                 </a:solidFill>
@@ -4884,7 +4885,7 @@
                 <a:ea typeface="Aptos Display" pitchFamily="34" charset="-122"/>
                 <a:cs typeface="Aptos Display" pitchFamily="34" charset="-120"/>
               </a:rPr>
-              <a:t>Use two views to test the same Responses endpoint</a:t>
+              <a:t>Start the Responses API, then test it two ways</a:t>
             </a:r>
             <a:endParaRPr lang="en-US" sz="2700" dirty="0"/>
           </a:p>
@@ -4917,7 +4918,7 @@
               <a:buNone/>
             </a:pPr>
             <a:r>
-              <a:rPr lang="en-US" sz="1250" dirty="0">
+              <a:rPr lang="en-US" sz="1250">
                 <a:solidFill>
                   <a:srgbClr val="4F6474"/>
                 </a:solidFill>
@@ -4925,7 +4926,7 @@
                 <a:ea typeface="Aptos" pitchFamily="34" charset="-122"/>
                 <a:cs typeface="Aptos" pitchFamily="34" charset="-120"/>
               </a:rPr>
-              <a:t> Command-line calls prove behavior. Agent Inspector makes the run understandable.</a:t>
+              <a:t>Run the ASP.NET Core host on port 8088 before connecting PowerShell or Agent Inspector.</a:t>
             </a:r>
             <a:endParaRPr lang="en-US" sz="1250" dirty="0"/>
           </a:p>
@@ -4939,8 +4940,8 @@
         </p:nvSpPr>
         <p:spPr>
           <a:xfrm>
-            <a:off x="658368" y="1847088"/>
-            <a:ext cx="5074920" cy="3337560"/>
+            <a:off x="658368" y="2743200"/>
+            <a:ext cx="5074920" cy="2755900"/>
           </a:xfrm>
           <a:prstGeom prst="roundRect">
             <a:avLst>
@@ -4980,8 +4981,8 @@
         </p:nvSpPr>
         <p:spPr>
           <a:xfrm>
-            <a:off x="658368" y="1847088"/>
-            <a:ext cx="73152" cy="3337560"/>
+            <a:off x="658368" y="2743200"/>
+            <a:ext cx="73152" cy="2755900"/>
           </a:xfrm>
           <a:prstGeom prst="rect">
             <a:avLst/>
@@ -5026,7 +5027,7 @@
         </p:blipFill>
         <p:spPr>
           <a:xfrm>
-            <a:off x="859536" y="2029968"/>
+            <a:off x="859536" y="2926080"/>
             <a:ext cx="347472" cy="347472"/>
           </a:xfrm>
           <a:prstGeom prst="rect">
@@ -5042,7 +5043,7 @@
         </p:nvSpPr>
         <p:spPr>
           <a:xfrm>
-            <a:off x="1353312" y="2020824"/>
+            <a:off x="1353312" y="2917190"/>
             <a:ext cx="4178808" cy="292608"/>
           </a:xfrm>
           <a:prstGeom prst="rect">
@@ -5061,7 +5062,7 @@
               <a:buNone/>
             </a:pPr>
             <a:r>
-              <a:rPr lang="en-US" sz="1500" b="1" dirty="0">
+              <a:rPr lang="en-US" sz="1500" b="1">
                 <a:solidFill>
                   <a:srgbClr val="102A43"/>
                 </a:solidFill>
@@ -5069,7 +5070,7 @@
                 <a:ea typeface="Aptos Display" pitchFamily="34" charset="-122"/>
                 <a:cs typeface="Aptos Display" pitchFamily="34" charset="-120"/>
               </a:rPr>
-              <a:t>PowerShell smoke test</a:t>
+              <a:t>2A. PowerShell smoke test</a:t>
             </a:r>
             <a:endParaRPr lang="en-US" sz="1500" dirty="0"/>
           </a:p>
@@ -5083,8 +5084,8 @@
         </p:nvSpPr>
         <p:spPr>
           <a:xfrm>
-            <a:off x="877824" y="2468880"/>
-            <a:ext cx="4636008" cy="2532888"/>
+            <a:off x="877824" y="3365500"/>
+            <a:ext cx="4636008" cy="1117600"/>
           </a:xfrm>
           <a:prstGeom prst="rect">
             <a:avLst/>
@@ -5105,7 +5106,7 @@
               <a:buNone/>
             </a:pPr>
             <a:r>
-              <a:rPr lang="en-US" sz="1050" dirty="0">
+              <a:rPr lang="en-US" sz="1050">
                 <a:solidFill>
                   <a:srgbClr val="4F6474"/>
                 </a:solidFill>
@@ -5113,9 +5114,8 @@
                 <a:ea typeface="Aptos" pitchFamily="34" charset="-122"/>
                 <a:cs typeface="Aptos" pitchFamily="34" charset="-120"/>
               </a:rPr>
-              <a:t>Start the agent on localhost.</a:t>
-            </a:r>
-            <a:endParaRPr lang="en-US" sz="1050" dirty="0"/>
+              <a:t>POST a work-request prompt to the running Responses API.</a:t>
+            </a:r>
           </a:p>
           <a:p>
             <a:pPr marL="0" indent="0">
@@ -5124,7 +5124,14 @@
               </a:lnSpc>
               <a:buNone/>
             </a:pPr>
-            <a:endParaRPr lang="en-US" sz="1050" dirty="0"/>
+            <a:endParaRPr lang="en-US" sz="1050">
+              <a:solidFill>
+                <a:srgbClr val="4F6474"/>
+              </a:solidFill>
+              <a:latin typeface="Aptos" pitchFamily="34" charset="0"/>
+              <a:ea typeface="Aptos" pitchFamily="34" charset="-122"/>
+              <a:cs typeface="Aptos" pitchFamily="34" charset="-120"/>
+            </a:endParaRPr>
           </a:p>
           <a:p>
             <a:pPr marL="0" indent="0">
@@ -5134,7 +5141,7 @@
               <a:buNone/>
             </a:pPr>
             <a:r>
-              <a:rPr lang="en-US" sz="1050" dirty="0">
+              <a:rPr lang="en-US" sz="1050">
                 <a:solidFill>
                   <a:srgbClr val="4F6474"/>
                 </a:solidFill>
@@ -5142,39 +5149,10 @@
                 <a:ea typeface="Aptos" pitchFamily="34" charset="-122"/>
                 <a:cs typeface="Aptos" pitchFamily="34" charset="-120"/>
               </a:rPr>
-              <a:t>Send a Responses request with a work-request prompt.</a:t>
+              <a:t>Confirm the expected MCP tool is selected and the response is grounded.</a:t>
             </a:r>
             <a:endParaRPr lang="en-US" sz="1050" dirty="0"/>
           </a:p>
-          <a:p>
-            <a:pPr marL="0" indent="0">
-              <a:lnSpc>
-                <a:spcPct val="95000"/>
-              </a:lnSpc>
-              <a:buNone/>
-            </a:pPr>
-            <a:endParaRPr lang="en-US" sz="1050" dirty="0"/>
-          </a:p>
-          <a:p>
-            <a:pPr marL="0" indent="0">
-              <a:lnSpc>
-                <a:spcPct val="95000"/>
-              </a:lnSpc>
-              <a:buNone/>
-            </a:pPr>
-            <a:r>
-              <a:rPr lang="en-US" sz="1050" dirty="0">
-                <a:solidFill>
-                  <a:srgbClr val="4F6474"/>
-                </a:solidFill>
-                <a:latin typeface="Aptos" pitchFamily="34" charset="0"/>
-                <a:ea typeface="Aptos" pitchFamily="34" charset="-122"/>
-                <a:cs typeface="Aptos" pitchFamily="34" charset="-120"/>
-              </a:rPr>
-              <a:t>Confirm the model selects the expected MCP tool and returns a grounded recommendation.</a:t>
-            </a:r>
-            <a:endParaRPr lang="en-US" sz="1050" dirty="0"/>
-          </a:p>
         </p:txBody>
       </p:sp>
       <p:sp>
@@ -5185,8 +5163,8 @@
         </p:nvSpPr>
         <p:spPr>
           <a:xfrm>
-            <a:off x="987552" y="4151376"/>
-            <a:ext cx="4407408" cy="640080"/>
+            <a:off x="987552" y="4635500"/>
+            <a:ext cx="4407408" cy="558800"/>
           </a:xfrm>
           <a:prstGeom prst="roundRect">
             <a:avLst/>
@@ -5217,7 +5195,7 @@
         </p:nvSpPr>
         <p:spPr>
           <a:xfrm>
-            <a:off x="1170432" y="4370832"/>
+            <a:off x="1170432" y="4822190"/>
             <a:ext cx="4041648" cy="182880"/>
           </a:xfrm>
           <a:prstGeom prst="rect">
@@ -5234,7 +5212,7 @@
               <a:buNone/>
             </a:pPr>
             <a:r>
-              <a:rPr lang="en-US" sz="1050" dirty="0">
+              <a:rPr lang="nn-NO" sz="1050">
                 <a:solidFill>
                   <a:srgbClr val="5BD6C5"/>
                 </a:solidFill>
@@ -5242,7 +5220,7 @@
                 <a:ea typeface="Consolas" pitchFamily="34" charset="-122"/>
                 <a:cs typeface="Consolas" pitchFamily="34" charset="-120"/>
               </a:rPr>
-              <a:t>http://localhost:8090/v1/responses</a:t>
+              <a:t>POST http://localhost:8088/responses</a:t>
             </a:r>
             <a:endParaRPr lang="en-US" sz="1050" dirty="0"/>
           </a:p>
@@ -5256,8 +5234,8 @@
         </p:nvSpPr>
         <p:spPr>
           <a:xfrm>
-            <a:off x="6437376" y="1847088"/>
-            <a:ext cx="5074920" cy="3337560"/>
+            <a:off x="6437376" y="2743200"/>
+            <a:ext cx="5074920" cy="2755900"/>
           </a:xfrm>
           <a:prstGeom prst="roundRect">
             <a:avLst>
@@ -5297,8 +5275,8 @@
         </p:nvSpPr>
         <p:spPr>
           <a:xfrm>
-            <a:off x="6437376" y="1847088"/>
-            <a:ext cx="73152" cy="3337560"/>
+            <a:off x="6437376" y="2743200"/>
+            <a:ext cx="73152" cy="2755900"/>
           </a:xfrm>
           <a:prstGeom prst="rect">
             <a:avLst/>
@@ -5343,7 +5321,7 @@
         </p:blipFill>
         <p:spPr>
           <a:xfrm>
-            <a:off x="6638544" y="2029968"/>
+            <a:off x="6638544" y="2926080"/>
             <a:ext cx="347472" cy="347472"/>
           </a:xfrm>
           <a:prstGeom prst="rect">
@@ -5359,7 +5337,7 @@
         </p:nvSpPr>
         <p:spPr>
           <a:xfrm>
-            <a:off x="7132320" y="2020824"/>
+            <a:off x="7132320" y="2917190"/>
             <a:ext cx="4178808" cy="292608"/>
           </a:xfrm>
           <a:prstGeom prst="rect">
@@ -5378,7 +5356,7 @@
               <a:buNone/>
             </a:pPr>
             <a:r>
-              <a:rPr lang="en-US" sz="1500" b="1" dirty="0">
+              <a:rPr lang="en-US" sz="1500" b="1">
                 <a:solidFill>
                   <a:srgbClr val="102A43"/>
                 </a:solidFill>
@@ -5386,7 +5364,7 @@
                 <a:ea typeface="Aptos Display" pitchFamily="34" charset="-122"/>
                 <a:cs typeface="Aptos Display" pitchFamily="34" charset="-120"/>
               </a:rPr>
-              <a:t>Foundry Agent Inspector</a:t>
+              <a:t>2B. Foundry Agent Inspector</a:t>
             </a:r>
             <a:endParaRPr lang="en-US" sz="1500" dirty="0"/>
           </a:p>
@@ -5400,8 +5378,8 @@
         </p:nvSpPr>
         <p:spPr>
           <a:xfrm>
-            <a:off x="6656832" y="2468880"/>
-            <a:ext cx="4636008" cy="2532888"/>
+            <a:off x="6656832" y="3365500"/>
+            <a:ext cx="4636008" cy="1117600"/>
           </a:xfrm>
           <a:prstGeom prst="rect">
             <a:avLst/>
@@ -5422,7 +5400,7 @@
               <a:buNone/>
             </a:pPr>
             <a:r>
-              <a:rPr lang="en-US" sz="1050" dirty="0">
+              <a:rPr lang="en-US" sz="1050">
                 <a:solidFill>
                   <a:srgbClr val="4F6474"/>
                 </a:solidFill>
@@ -5430,9 +5408,8 @@
                 <a:ea typeface="Aptos" pitchFamily="34" charset="-122"/>
                 <a:cs typeface="Aptos" pitchFamily="34" charset="-120"/>
               </a:rPr>
-              <a:t>Connect the Foundry Toolkit to localhost.</a:t>
-            </a:r>
-            <a:endParaRPr lang="en-US" sz="1050" dirty="0"/>
+              <a:t>Open Agent Inspector from Foundry Toolkit and connect to http://localhost:8088.</a:t>
+            </a:r>
           </a:p>
           <a:p>
             <a:pPr marL="0" indent="0">
@@ -5441,7 +5418,14 @@
               </a:lnSpc>
               <a:buNone/>
             </a:pPr>
-            <a:endParaRPr lang="en-US" sz="1050" dirty="0"/>
+            <a:endParaRPr lang="en-US" sz="1050">
+              <a:solidFill>
+                <a:srgbClr val="4F6474"/>
+              </a:solidFill>
+              <a:latin typeface="Aptos" pitchFamily="34" charset="0"/>
+              <a:ea typeface="Aptos" pitchFamily="34" charset="-122"/>
+              <a:cs typeface="Aptos" pitchFamily="34" charset="-120"/>
+            </a:endParaRPr>
           </a:p>
           <a:p>
             <a:pPr marL="0" indent="0">
@@ -5451,7 +5435,7 @@
               <a:buNone/>
             </a:pPr>
             <a:r>
-              <a:rPr lang="en-US" sz="1050" dirty="0">
+              <a:rPr lang="en-US" sz="1050">
                 <a:solidFill>
                   <a:srgbClr val="4F6474"/>
                 </a:solidFill>
@@ -5459,7 +5443,7 @@
                 <a:ea typeface="Aptos" pitchFamily="34" charset="-122"/>
                 <a:cs typeface="Aptos" pitchFamily="34" charset="-120"/>
               </a:rPr>
-              <a:t>Inspect model input, tool discovery, tool calls, approvals, and the final response in one visual run.</a:t>
+              <a:t>Use /responses if the connection form requires the full endpoint, then inspect the complete run.</a:t>
             </a:r>
             <a:endParaRPr lang="en-US" sz="1050" dirty="0"/>
           </a:p>
@@ -5473,8 +5457,8 @@
         </p:nvSpPr>
         <p:spPr>
           <a:xfrm>
-            <a:off x="6766560" y="4151376"/>
-            <a:ext cx="4407408" cy="640080"/>
+            <a:off x="6766560" y="4635500"/>
+            <a:ext cx="4407408" cy="558800"/>
           </a:xfrm>
           <a:prstGeom prst="roundRect">
             <a:avLst/>
@@ -5505,7 +5489,7 @@
         </p:nvSpPr>
         <p:spPr>
           <a:xfrm>
-            <a:off x="6949440" y="4370832"/>
+            <a:off x="6949440" y="4822190"/>
             <a:ext cx="4041648" cy="182880"/>
           </a:xfrm>
           <a:prstGeom prst="rect">
@@ -5544,7 +5528,7 @@
         </p:nvSpPr>
         <p:spPr>
           <a:xfrm>
-            <a:off x="2148840" y="5413248"/>
+            <a:off x="2148840" y="5715000"/>
             <a:ext cx="7909560" cy="402336"/>
           </a:xfrm>
           <a:prstGeom prst="roundRect">
@@ -5590,7 +5574,7 @@
         </p:blipFill>
         <p:spPr>
           <a:xfrm>
-            <a:off x="2359152" y="5504688"/>
+            <a:off x="2359152" y="5806440"/>
             <a:ext cx="210312" cy="210312"/>
           </a:xfrm>
           <a:prstGeom prst="rect">
@@ -5606,7 +5590,7 @@
         </p:nvSpPr>
         <p:spPr>
           <a:xfrm>
-            <a:off x="2724912" y="5522976"/>
+            <a:off x="2724912" y="5825490"/>
             <a:ext cx="7040880" cy="155448"/>
           </a:xfrm>
           <a:prstGeom prst="rect">
@@ -5723,6 +5707,209 @@
               <a:t>11</a:t>
             </a:fld>
             <a:endParaRPr lang="en-US"/>
+          </a:p>
+        </p:txBody>
+      </p:sp>
+      <p:sp>
+        <p:nvSpPr>
+          <p:cNvPr id="23" name="Run First Background">
+            <a:extLst>
+              <a:ext uri="{FF2B5EF4-FFF2-40B4-BE49-F238E27FC236}">
+                <a16:creationId xmlns:a16="http://schemas.microsoft.com/office/drawing/2014/main" id="{F727555A-5A48-80B7-50A1-3464F7467A99}"/>
+              </a:ext>
+            </a:extLst>
+          </p:cNvPr>
+          <p:cNvSpPr/>
+          <p:nvPr/>
+        </p:nvSpPr>
+        <p:spPr>
+          <a:xfrm>
+            <a:off x="657860" y="1625600"/>
+            <a:ext cx="10854690" cy="914400"/>
+          </a:xfrm>
+          <a:prstGeom prst="roundRect">
+            <a:avLst/>
+          </a:prstGeom>
+          <a:solidFill>
+            <a:srgbClr val="102A43"/>
+          </a:solidFill>
+          <a:ln w="12700">
+            <a:solidFill>
+              <a:srgbClr val="102A43"/>
+            </a:solidFill>
+            <a:prstDash val="solid"/>
+          </a:ln>
+        </p:spPr>
+        <p:txBody>
+          <a:bodyPr/>
+          <a:lstStyle/>
+          <a:p>
+            <a:endParaRPr lang="en-US"/>
+          </a:p>
+        </p:txBody>
+      </p:sp>
+      <p:sp>
+        <p:nvSpPr>
+          <p:cNvPr id="24" name="Run First Heading">
+            <a:extLst>
+              <a:ext uri="{FF2B5EF4-FFF2-40B4-BE49-F238E27FC236}">
+                <a16:creationId xmlns:a16="http://schemas.microsoft.com/office/drawing/2014/main" id="{6A085B01-A6FF-5F40-465D-0739CCFFD804}"/>
+              </a:ext>
+            </a:extLst>
+          </p:cNvPr>
+          <p:cNvSpPr/>
+          <p:nvPr/>
+        </p:nvSpPr>
+        <p:spPr>
+          <a:xfrm>
+            <a:off x="877570" y="1765300"/>
+            <a:ext cx="5207000" cy="279400"/>
+          </a:xfrm>
+          <a:prstGeom prst="rect">
+            <a:avLst/>
+          </a:prstGeom>
+          <a:noFill/>
+          <a:ln/>
+        </p:spPr>
+        <p:txBody>
+          <a:bodyPr wrap="square" lIns="0" tIns="0" rIns="0" bIns="0" rtlCol="0" anchor="ctr">
+            <a:normAutofit/>
+          </a:bodyPr>
+          <a:lstStyle/>
+          <a:p>
+            <a:pPr marL="0" indent="0">
+              <a:buNone/>
+            </a:pPr>
+            <a:r>
+              <a:rPr lang="en-US" sz="1500" b="1">
+                <a:solidFill>
+                  <a:srgbClr val="FFFFFF"/>
+                </a:solidFill>
+                <a:latin typeface="Aptos Display" pitchFamily="34" charset="0"/>
+                <a:ea typeface="Aptos Display" pitchFamily="34" charset="-122"/>
+                <a:cs typeface="Aptos Display" pitchFamily="34" charset="-120"/>
+              </a:rPr>
+              <a:t>1. Run the ASP.NET Core web project</a:t>
+            </a:r>
+            <a:endParaRPr lang="en-US" sz="1500" dirty="0">
+              <a:solidFill>
+                <a:srgbClr val="FFFFFF"/>
+              </a:solidFill>
+            </a:endParaRPr>
+          </a:p>
+        </p:txBody>
+      </p:sp>
+      <p:sp>
+        <p:nvSpPr>
+          <p:cNvPr id="26" name="Run First Command">
+            <a:extLst>
+              <a:ext uri="{FF2B5EF4-FFF2-40B4-BE49-F238E27FC236}">
+                <a16:creationId xmlns:a16="http://schemas.microsoft.com/office/drawing/2014/main" id="{C65A9F33-8C2C-2FDB-6E6B-1F643513A72A}"/>
+              </a:ext>
+            </a:extLst>
+          </p:cNvPr>
+          <p:cNvSpPr/>
+          <p:nvPr/>
+        </p:nvSpPr>
+        <p:spPr>
+          <a:xfrm>
+            <a:off x="877570" y="2146300"/>
+            <a:ext cx="6604000" cy="190500"/>
+          </a:xfrm>
+          <a:prstGeom prst="rect">
+            <a:avLst/>
+          </a:prstGeom>
+          <a:noFill/>
+          <a:ln/>
+        </p:spPr>
+        <p:txBody>
+          <a:bodyPr wrap="square" lIns="0" tIns="0" rIns="0" bIns="0" rtlCol="0" anchor="ctr"/>
+          <a:lstStyle/>
+          <a:p>
+            <a:pPr marL="0" indent="0">
+              <a:buNone/>
+            </a:pPr>
+            <a:r>
+              <a:rPr lang="en-US" sz="1050">
+                <a:solidFill>
+                  <a:srgbClr val="4DD6C9"/>
+                </a:solidFill>
+                <a:latin typeface="Consolas" pitchFamily="34" charset="0"/>
+                <a:ea typeface="Consolas" pitchFamily="34" charset="-122"/>
+                <a:cs typeface="Consolas" pitchFamily="34" charset="-120"/>
+              </a:rPr>
+              <a:t>dotnet run --project .\src\Workshop.Agent\Workshop.Agent.csproj</a:t>
+            </a:r>
+            <a:endParaRPr lang="en-US" sz="1050" dirty="0">
+              <a:solidFill>
+                <a:srgbClr val="4DD6C9"/>
+              </a:solidFill>
+            </a:endParaRPr>
+          </a:p>
+        </p:txBody>
+      </p:sp>
+      <p:sp>
+        <p:nvSpPr>
+          <p:cNvPr id="27" name="Run First Endpoint">
+            <a:extLst>
+              <a:ext uri="{FF2B5EF4-FFF2-40B4-BE49-F238E27FC236}">
+                <a16:creationId xmlns:a16="http://schemas.microsoft.com/office/drawing/2014/main" id="{4A60DA5C-F5CC-5C41-C47E-C86662935B79}"/>
+              </a:ext>
+            </a:extLst>
+          </p:cNvPr>
+          <p:cNvSpPr/>
+          <p:nvPr/>
+        </p:nvSpPr>
+        <p:spPr>
+          <a:xfrm>
+            <a:off x="7747000" y="1943100"/>
+            <a:ext cx="3429000" cy="393700"/>
+          </a:xfrm>
+          <a:prstGeom prst="rect">
+            <a:avLst/>
+          </a:prstGeom>
+          <a:noFill/>
+          <a:ln/>
+        </p:spPr>
+        <p:txBody>
+          <a:bodyPr wrap="square" lIns="0" tIns="0" rIns="0" bIns="0" rtlCol="0" anchor="ctr"/>
+          <a:lstStyle/>
+          <a:p>
+            <a:pPr marL="0" indent="0" algn="ctr">
+              <a:buNone/>
+            </a:pPr>
+            <a:r>
+              <a:rPr lang="en-US" sz="1050">
+                <a:solidFill>
+                  <a:srgbClr val="FFFFFF"/>
+                </a:solidFill>
+                <a:latin typeface="Consolas" pitchFamily="34" charset="0"/>
+                <a:ea typeface="Consolas" pitchFamily="34" charset="-122"/>
+                <a:cs typeface="Consolas" pitchFamily="34" charset="-120"/>
+              </a:rPr>
+              <a:t>Responses endpoint</a:t>
+            </a:r>
+          </a:p>
+          <a:p>
+            <a:pPr marL="0" indent="0" algn="ctr">
+              <a:buNone/>
+            </a:pPr>
+            <a:r>
+              <a:rPr lang="en-US" sz="1050">
+                <a:solidFill>
+                  <a:srgbClr val="FFFFFF"/>
+                </a:solidFill>
+                <a:latin typeface="Consolas" pitchFamily="34" charset="0"/>
+                <a:ea typeface="Consolas" pitchFamily="34" charset="-122"/>
+                <a:cs typeface="Consolas" pitchFamily="34" charset="-120"/>
+              </a:rPr>
+              <a:t>http://localhost:8088/responses</a:t>
+            </a:r>
+            <a:endParaRPr lang="en-US" sz="1050" dirty="0">
+              <a:solidFill>
+                <a:srgbClr val="FFFFFF"/>
+              </a:solidFill>
+            </a:endParaRPr>
           </a:p>
         </p:txBody>
       </p:sp>

</xml_diff>

<commit_message>
Show PowerShell Responses API smoke test
Co-authored-by: Copilot <223556219+Copilot@users.noreply.github.com>

Copilot-Session: 8c02ba17-1398-4d94-b9f2-71766e81e382
</commit_message>
<xml_diff>
--- a/docs/foundry-apim-mcp-workshop.pptx
+++ b/docs/foundry-apim-mcp-workshop.pptx
@@ -477,7 +477,7 @@
           <a:p>
             <a:r>
               <a:rPr lang="en-US"/>
-              <a:t>Run the ASP.NET Core web project first. Confirm that the Responses API is listening at http://localhost:8088/responses before opening either client. Use PowerShell for the fastest pass or fail check. Open Agent Inspector from Foundry Toolkit for the teaching view because it exposes model input, tool discovery, tool calls, approvals, and the final response.</a:t>
+              <a:t>Run the ASP.NET Core web project first. Confirm that the Responses API is listening at http://localhost:8088/responses before opening either client. For the PowerShell smoke test, prepare $body from the lab request payload and run the displayed Invoke-RestMethod command. Open Agent Inspector from Foundry Toolkit for the teaching view because it exposes model input, tool discovery, tool calls, approvals, and the final response.</a:t>
             </a:r>
             <a:endParaRPr lang="en-US" dirty="0"/>
           </a:p>
@@ -5085,7 +5085,7 @@
         <p:spPr>
           <a:xfrm>
             <a:off x="877824" y="3365500"/>
-            <a:ext cx="4636008" cy="1117600"/>
+            <a:ext cx="4636008" cy="812800"/>
           </a:xfrm>
           <a:prstGeom prst="rect">
             <a:avLst/>
@@ -5114,7 +5114,7 @@
                 <a:ea typeface="Aptos" pitchFamily="34" charset="-122"/>
                 <a:cs typeface="Aptos" pitchFamily="34" charset="-120"/>
               </a:rPr>
-              <a:t>POST a work-request prompt to the running Responses API.</a:t>
+              <a:t>Create $body from the lab payload, then call the running API.</a:t>
             </a:r>
           </a:p>
           <a:p>
@@ -5124,22 +5124,6 @@
               </a:lnSpc>
               <a:buNone/>
             </a:pPr>
-            <a:endParaRPr lang="en-US" sz="1050">
-              <a:solidFill>
-                <a:srgbClr val="4F6474"/>
-              </a:solidFill>
-              <a:latin typeface="Aptos" pitchFamily="34" charset="0"/>
-              <a:ea typeface="Aptos" pitchFamily="34" charset="-122"/>
-              <a:cs typeface="Aptos" pitchFamily="34" charset="-120"/>
-            </a:endParaRPr>
-          </a:p>
-          <a:p>
-            <a:pPr marL="0" indent="0">
-              <a:lnSpc>
-                <a:spcPct val="95000"/>
-              </a:lnSpc>
-              <a:buNone/>
-            </a:pPr>
             <a:r>
               <a:rPr lang="en-US" sz="1050">
                 <a:solidFill>
@@ -5149,7 +5133,7 @@
                 <a:ea typeface="Aptos" pitchFamily="34" charset="-122"/>
                 <a:cs typeface="Aptos" pitchFamily="34" charset="-120"/>
               </a:rPr>
-              <a:t>Confirm the expected MCP tool is selected and the response is grounded.</a:t>
+              <a:t>Confirm the expected tool is selected and the response is grounded.</a:t>
             </a:r>
             <a:endParaRPr lang="en-US" sz="1050" dirty="0"/>
           </a:p>
@@ -5163,8 +5147,8 @@
         </p:nvSpPr>
         <p:spPr>
           <a:xfrm>
-            <a:off x="987552" y="4635500"/>
-            <a:ext cx="4407408" cy="558800"/>
+            <a:off x="987552" y="4356100"/>
+            <a:ext cx="4407408" cy="914400"/>
           </a:xfrm>
           <a:prstGeom prst="roundRect">
             <a:avLst/>
@@ -5195,8 +5179,8 @@
         </p:nvSpPr>
         <p:spPr>
           <a:xfrm>
-            <a:off x="1170432" y="4822190"/>
-            <a:ext cx="4041648" cy="182880"/>
+            <a:off x="1170940" y="4457700"/>
+            <a:ext cx="4041140" cy="698500"/>
           </a:xfrm>
           <a:prstGeom prst="rect">
             <a:avLst/>
@@ -5208,21 +5192,71 @@
           <a:bodyPr wrap="square" lIns="0" tIns="0" rIns="0" bIns="0" rtlCol="0" anchor="ctr"/>
           <a:lstStyle/>
           <a:p>
-            <a:pPr marL="0" indent="0" algn="ctr">
-              <a:buNone/>
-            </a:pPr>
-            <a:r>
-              <a:rPr lang="nn-NO" sz="1050">
+            <a:pPr marL="0" indent="0">
+              <a:buNone/>
+            </a:pPr>
+            <a:r>
+              <a:rPr lang="en-US" sz="1050">
                 <a:solidFill>
                   <a:srgbClr val="5BD6C5"/>
                 </a:solidFill>
-                <a:latin typeface="Consolas" pitchFamily="34" charset="0"/>
+                <a:latin typeface="Consolas" panose="020B0609020204030204" pitchFamily="49" charset="0"/>
                 <a:ea typeface="Consolas" pitchFamily="34" charset="-122"/>
                 <a:cs typeface="Consolas" pitchFamily="34" charset="-120"/>
               </a:rPr>
-              <a:t>POST http://localhost:8088/responses</a:t>
-            </a:r>
-            <a:endParaRPr lang="en-US" sz="1050" dirty="0"/>
+              <a:t>Invoke-RestMethod -Method Post `</a:t>
+            </a:r>
+          </a:p>
+          <a:p>
+            <a:pPr marL="0" indent="0">
+              <a:buNone/>
+            </a:pPr>
+            <a:r>
+              <a:rPr lang="en-US" sz="1050">
+                <a:solidFill>
+                  <a:srgbClr val="5BD6C5"/>
+                </a:solidFill>
+                <a:latin typeface="Consolas" panose="020B0609020204030204" pitchFamily="49" charset="0"/>
+                <a:ea typeface="Consolas" pitchFamily="34" charset="-122"/>
+                <a:cs typeface="Consolas" pitchFamily="34" charset="-120"/>
+              </a:rPr>
+              <a:t>  -Uri "http://localhost:8088/responses" `</a:t>
+            </a:r>
+          </a:p>
+          <a:p>
+            <a:pPr marL="0" indent="0">
+              <a:buNone/>
+            </a:pPr>
+            <a:r>
+              <a:rPr lang="en-US" sz="1050">
+                <a:solidFill>
+                  <a:srgbClr val="5BD6C5"/>
+                </a:solidFill>
+                <a:latin typeface="Consolas" panose="020B0609020204030204" pitchFamily="49" charset="0"/>
+                <a:ea typeface="Consolas" pitchFamily="34" charset="-122"/>
+                <a:cs typeface="Consolas" pitchFamily="34" charset="-120"/>
+              </a:rPr>
+              <a:t>  -ContentType "application/json" `</a:t>
+            </a:r>
+          </a:p>
+          <a:p>
+            <a:pPr marL="0" indent="0">
+              <a:buNone/>
+            </a:pPr>
+            <a:r>
+              <a:rPr lang="en-US" sz="1050">
+                <a:solidFill>
+                  <a:srgbClr val="5BD6C5"/>
+                </a:solidFill>
+                <a:latin typeface="Consolas" panose="020B0609020204030204" pitchFamily="49" charset="0"/>
+                <a:ea typeface="Consolas" pitchFamily="34" charset="-122"/>
+                <a:cs typeface="Consolas" pitchFamily="34" charset="-120"/>
+              </a:rPr>
+              <a:t>  -Body $body</a:t>
+            </a:r>
+            <a:endParaRPr lang="en-US" sz="1050" dirty="0">
+              <a:latin typeface="Consolas" panose="020B0609020204030204" pitchFamily="49" charset="0"/>
+            </a:endParaRPr>
           </a:p>
         </p:txBody>
       </p:sp>

</xml_diff>

<commit_message>
Clarify Foundry Toolkit inspector action
Co-authored-by: Copilot <223556219+Copilot@users.noreply.github.com>

Copilot-Session: 8c02ba17-1398-4d94-b9f2-71766e81e382
</commit_message>
<xml_diff>
--- a/docs/foundry-apim-mcp-workshop.pptx
+++ b/docs/foundry-apim-mcp-workshop.pptx
@@ -2187,7 +2187,7 @@
           </a:prstGeom>
           <a:extLst>
             <a:ext uri="{C572A759-6A51-4108-AA02-DFA0A04FC94B}">
-              <ma14:wrappingTextBoxFlag xmlns:ma14="http://schemas.microsoft.com/office/mac/drawingml/2011/main" xmlns="" val="0"/>
+              <ma14:wrappingTextBoxFlag xmlns="" xmlns:ma14="http://schemas.microsoft.com/office/mac/drawingml/2011/main" val="0"/>
             </a:ext>
           </a:extLst>
         </p:spPr>
@@ -2265,7 +2265,7 @@
           </a:prstGeom>
           <a:extLst>
             <a:ext uri="{C572A759-6A51-4108-AA02-DFA0A04FC94B}">
-              <ma14:wrappingTextBoxFlag xmlns:ma14="http://schemas.microsoft.com/office/mac/drawingml/2011/main" xmlns="" val="0"/>
+              <ma14:wrappingTextBoxFlag xmlns="" xmlns:ma14="http://schemas.microsoft.com/office/mac/drawingml/2011/main" val="0"/>
             </a:ext>
           </a:extLst>
         </p:spPr>
@@ -4758,7 +4758,7 @@
           </a:prstGeom>
           <a:extLst>
             <a:ext uri="{C572A759-6A51-4108-AA02-DFA0A04FC94B}">
-              <ma14:wrappingTextBoxFlag xmlns:ma14="http://schemas.microsoft.com/office/mac/drawingml/2011/main" xmlns="" val="0"/>
+              <ma14:wrappingTextBoxFlag xmlns="" xmlns:ma14="http://schemas.microsoft.com/office/mac/drawingml/2011/main" val="0"/>
             </a:ext>
           </a:extLst>
         </p:spPr>
@@ -5540,7 +5540,7 @@
               <a:buNone/>
             </a:pPr>
             <a:r>
-              <a:rPr lang="en-US" sz="1050" b="1" dirty="0">
+              <a:rPr lang="en-US" sz="1050" b="1">
                 <a:solidFill>
                   <a:srgbClr val="775DA6"/>
                 </a:solidFill>
@@ -5548,7 +5548,7 @@
                 <a:ea typeface="Aptos" pitchFamily="34" charset="-122"/>
                 <a:cs typeface="Aptos" pitchFamily="34" charset="-120"/>
               </a:rPr>
-              <a:t>Toolkit: Open Agent Inspector</a:t>
+              <a:t>Foundry Toolkit: Open Agent Inspector</a:t>
             </a:r>
             <a:endParaRPr lang="en-US" sz="1050" dirty="0"/>
           </a:p>
@@ -5716,7 +5716,7 @@
           </a:prstGeom>
           <a:extLst>
             <a:ext uri="{C572A759-6A51-4108-AA02-DFA0A04FC94B}">
-              <ma14:wrappingTextBoxFlag xmlns:ma14="http://schemas.microsoft.com/office/mac/drawingml/2011/main" xmlns="" val="0"/>
+              <ma14:wrappingTextBoxFlag xmlns="" xmlns:ma14="http://schemas.microsoft.com/office/mac/drawingml/2011/main" val="0"/>
             </a:ext>
           </a:extLst>
         </p:spPr>
@@ -6932,7 +6932,7 @@
           </a:prstGeom>
           <a:extLst>
             <a:ext uri="{C572A759-6A51-4108-AA02-DFA0A04FC94B}">
-              <ma14:wrappingTextBoxFlag xmlns:ma14="http://schemas.microsoft.com/office/mac/drawingml/2011/main" xmlns="" val="0"/>
+              <ma14:wrappingTextBoxFlag xmlns="" xmlns:ma14="http://schemas.microsoft.com/office/mac/drawingml/2011/main" val="0"/>
             </a:ext>
           </a:extLst>
         </p:spPr>
@@ -8048,7 +8048,7 @@
           </a:prstGeom>
           <a:extLst>
             <a:ext uri="{C572A759-6A51-4108-AA02-DFA0A04FC94B}">
-              <ma14:wrappingTextBoxFlag xmlns:ma14="http://schemas.microsoft.com/office/mac/drawingml/2011/main" xmlns="" val="0"/>
+              <ma14:wrappingTextBoxFlag xmlns="" xmlns:ma14="http://schemas.microsoft.com/office/mac/drawingml/2011/main" val="0"/>
             </a:ext>
           </a:extLst>
         </p:spPr>
@@ -9505,7 +9505,7 @@
           </a:prstGeom>
           <a:extLst>
             <a:ext uri="{C572A759-6A51-4108-AA02-DFA0A04FC94B}">
-              <ma14:wrappingTextBoxFlag xmlns:ma14="http://schemas.microsoft.com/office/mac/drawingml/2011/main" xmlns="" val="0"/>
+              <ma14:wrappingTextBoxFlag xmlns="" xmlns:ma14="http://schemas.microsoft.com/office/mac/drawingml/2011/main" val="0"/>
             </a:ext>
           </a:extLst>
         </p:spPr>
@@ -10522,7 +10522,7 @@
           </a:prstGeom>
           <a:extLst>
             <a:ext uri="{C572A759-6A51-4108-AA02-DFA0A04FC94B}">
-              <ma14:wrappingTextBoxFlag xmlns:ma14="http://schemas.microsoft.com/office/mac/drawingml/2011/main" xmlns="" val="0"/>
+              <ma14:wrappingTextBoxFlag xmlns="" xmlns:ma14="http://schemas.microsoft.com/office/mac/drawingml/2011/main" val="0"/>
             </a:ext>
           </a:extLst>
         </p:spPr>
@@ -11743,7 +11743,7 @@
           </a:prstGeom>
           <a:extLst>
             <a:ext uri="{C572A759-6A51-4108-AA02-DFA0A04FC94B}">
-              <ma14:wrappingTextBoxFlag xmlns:ma14="http://schemas.microsoft.com/office/mac/drawingml/2011/main" xmlns="" val="0"/>
+              <ma14:wrappingTextBoxFlag xmlns="" xmlns:ma14="http://schemas.microsoft.com/office/mac/drawingml/2011/main" val="0"/>
             </a:ext>
           </a:extLst>
         </p:spPr>
@@ -13506,7 +13506,7 @@
           </a:prstGeom>
           <a:extLst>
             <a:ext uri="{C572A759-6A51-4108-AA02-DFA0A04FC94B}">
-              <ma14:wrappingTextBoxFlag xmlns:ma14="http://schemas.microsoft.com/office/mac/drawingml/2011/main" xmlns="" val="0"/>
+              <ma14:wrappingTextBoxFlag xmlns="" xmlns:ma14="http://schemas.microsoft.com/office/mac/drawingml/2011/main" val="0"/>
             </a:ext>
           </a:extLst>
         </p:spPr>
@@ -14837,7 +14837,7 @@
           </a:prstGeom>
           <a:extLst>
             <a:ext uri="{C572A759-6A51-4108-AA02-DFA0A04FC94B}">
-              <ma14:wrappingTextBoxFlag xmlns:ma14="http://schemas.microsoft.com/office/mac/drawingml/2011/main" xmlns="" val="0"/>
+              <ma14:wrappingTextBoxFlag xmlns="" xmlns:ma14="http://schemas.microsoft.com/office/mac/drawingml/2011/main" val="0"/>
             </a:ext>
           </a:extLst>
         </p:spPr>
@@ -16459,7 +16459,7 @@
           </a:prstGeom>
           <a:extLst>
             <a:ext uri="{C572A759-6A51-4108-AA02-DFA0A04FC94B}">
-              <ma14:wrappingTextBoxFlag xmlns:ma14="http://schemas.microsoft.com/office/mac/drawingml/2011/main" xmlns="" val="0"/>
+              <ma14:wrappingTextBoxFlag xmlns="" xmlns:ma14="http://schemas.microsoft.com/office/mac/drawingml/2011/main" val="0"/>
             </a:ext>
           </a:extLst>
         </p:spPr>
@@ -17640,7 +17640,7 @@
           </a:prstGeom>
           <a:extLst>
             <a:ext uri="{C572A759-6A51-4108-AA02-DFA0A04FC94B}">
-              <ma14:wrappingTextBoxFlag xmlns:ma14="http://schemas.microsoft.com/office/mac/drawingml/2011/main" xmlns="" val="0"/>
+              <ma14:wrappingTextBoxFlag xmlns="" xmlns:ma14="http://schemas.microsoft.com/office/mac/drawingml/2011/main" val="0"/>
             </a:ext>
           </a:extLst>
         </p:spPr>
@@ -18832,7 +18832,7 @@
           </a:prstGeom>
           <a:extLst>
             <a:ext uri="{C572A759-6A51-4108-AA02-DFA0A04FC94B}">
-              <ma14:wrappingTextBoxFlag xmlns:ma14="http://schemas.microsoft.com/office/mac/drawingml/2011/main" xmlns="" val="0"/>
+              <ma14:wrappingTextBoxFlag xmlns="" xmlns:ma14="http://schemas.microsoft.com/office/mac/drawingml/2011/main" val="0"/>
             </a:ext>
           </a:extLst>
         </p:spPr>
@@ -21327,7 +21327,7 @@
           </a:prstGeom>
           <a:extLst>
             <a:ext uri="{C572A759-6A51-4108-AA02-DFA0A04FC94B}">
-              <ma14:wrappingTextBoxFlag xmlns:ma14="http://schemas.microsoft.com/office/mac/drawingml/2011/main" xmlns="" val="0"/>
+              <ma14:wrappingTextBoxFlag xmlns="" xmlns:ma14="http://schemas.microsoft.com/office/mac/drawingml/2011/main" val="0"/>
             </a:ext>
           </a:extLst>
         </p:spPr>
@@ -23852,7 +23852,7 @@
           </a:prstGeom>
           <a:extLst>
             <a:ext uri="{C572A759-6A51-4108-AA02-DFA0A04FC94B}">
-              <ma14:wrappingTextBoxFlag xmlns:ma14="http://schemas.microsoft.com/office/mac/drawingml/2011/main" xmlns="" val="0"/>
+              <ma14:wrappingTextBoxFlag xmlns="" xmlns:ma14="http://schemas.microsoft.com/office/mac/drawingml/2011/main" val="0"/>
             </a:ext>
           </a:extLst>
         </p:spPr>
@@ -24940,7 +24940,7 @@
           </a:prstGeom>
           <a:extLst>
             <a:ext uri="{C572A759-6A51-4108-AA02-DFA0A04FC94B}">
-              <ma14:wrappingTextBoxFlag xmlns:ma14="http://schemas.microsoft.com/office/mac/drawingml/2011/main" xmlns="" val="0"/>
+              <ma14:wrappingTextBoxFlag xmlns="" xmlns:ma14="http://schemas.microsoft.com/office/mac/drawingml/2011/main" val="0"/>
             </a:ext>
           </a:extLst>
         </p:spPr>
@@ -26095,7 +26095,7 @@
           </a:prstGeom>
           <a:extLst>
             <a:ext uri="{C572A759-6A51-4108-AA02-DFA0A04FC94B}">
-              <ma14:wrappingTextBoxFlag xmlns:ma14="http://schemas.microsoft.com/office/mac/drawingml/2011/main" xmlns="" val="0"/>
+              <ma14:wrappingTextBoxFlag xmlns="" xmlns:ma14="http://schemas.microsoft.com/office/mac/drawingml/2011/main" val="0"/>
             </a:ext>
           </a:extLst>
         </p:spPr>
@@ -27506,7 +27506,7 @@
           </a:prstGeom>
           <a:extLst>
             <a:ext uri="{C572A759-6A51-4108-AA02-DFA0A04FC94B}">
-              <ma14:wrappingTextBoxFlag xmlns:ma14="http://schemas.microsoft.com/office/mac/drawingml/2011/main" xmlns="" val="0"/>
+              <ma14:wrappingTextBoxFlag xmlns="" xmlns:ma14="http://schemas.microsoft.com/office/mac/drawingml/2011/main" val="0"/>
             </a:ext>
           </a:extLst>
         </p:spPr>
@@ -28493,7 +28493,7 @@
           </a:prstGeom>
           <a:extLst>
             <a:ext uri="{C572A759-6A51-4108-AA02-DFA0A04FC94B}">
-              <ma14:wrappingTextBoxFlag xmlns:ma14="http://schemas.microsoft.com/office/mac/drawingml/2011/main" xmlns="" val="0"/>
+              <ma14:wrappingTextBoxFlag xmlns="" xmlns:ma14="http://schemas.microsoft.com/office/mac/drawingml/2011/main" val="0"/>
             </a:ext>
           </a:extLst>
         </p:spPr>
@@ -29881,7 +29881,7 @@
           </a:prstGeom>
           <a:extLst>
             <a:ext uri="{C572A759-6A51-4108-AA02-DFA0A04FC94B}">
-              <ma14:wrappingTextBoxFlag xmlns:ma14="http://schemas.microsoft.com/office/mac/drawingml/2011/main" xmlns="" val="0"/>
+              <ma14:wrappingTextBoxFlag xmlns="" xmlns:ma14="http://schemas.microsoft.com/office/mac/drawingml/2011/main" val="0"/>
             </a:ext>
           </a:extLst>
         </p:spPr>

</xml_diff>

<commit_message>
Update slide 3 product icons
Use official Microsoft Foundry Agent Service, Copilot Studio, and Azure API Management artwork in the reference architecture.

Co-authored-by: Copilot <223556219+Copilot@users.noreply.github.com>
Copilot-Session: aa1a2148-b4d0-4cc5-94ea-497594b4b72a
</commit_message>
<xml_diff>
--- a/docs/foundry-apim-mcp-workshop.pptx
+++ b/docs/foundry-apim-mcp-workshop.pptx
@@ -20136,68 +20136,6 @@
       </p:sp>
       <p:sp>
         <p:nvSpPr>
-          <p:cNvPr id="12" name="Shape 9"/>
-          <p:cNvSpPr/>
-          <p:nvPr/>
-        </p:nvSpPr>
-        <p:spPr>
-          <a:xfrm>
-            <a:off x="3218688" y="2331720"/>
-            <a:ext cx="530352" cy="530352"/>
-          </a:xfrm>
-          <a:prstGeom prst="ellipse">
-            <a:avLst/>
-          </a:prstGeom>
-          <a:solidFill>
-            <a:srgbClr val="775DA6"/>
-          </a:solidFill>
-          <a:ln w="12700">
-            <a:solidFill>
-              <a:srgbClr val="775DA6"/>
-            </a:solidFill>
-            <a:prstDash val="solid"/>
-          </a:ln>
-        </p:spPr>
-        <p:txBody>
-          <a:bodyPr/>
-          <a:lstStyle/>
-          <a:p>
-            <a:endParaRPr lang="en-US"/>
-          </a:p>
-        </p:txBody>
-      </p:sp>
-      <p:pic>
-        <p:nvPicPr>
-          <p:cNvPr id="13" name="Image 1" descr="preencoded.png"/>
-          <p:cNvPicPr>
-            <a:picLocks noChangeAspect="1"/>
-          </p:cNvPicPr>
-          <p:nvPr/>
-        </p:nvPicPr>
-        <p:blipFill>
-          <a:blip>
-            <a:extLst>
-              <a:ext uri="{96DAC541-7B7A-43D3-8B79-37D633B846F1}">
-                <asvg:svgBlip xmlns:asvg="http://schemas.microsoft.com/office/drawing/2016/SVG/main" r:embed="rId4"/>
-              </a:ext>
-            </a:extLst>
-          </a:blip>
-          <a:stretch>
-            <a:fillRect/>
-          </a:stretch>
-        </p:blipFill>
-        <p:spPr>
-          <a:xfrm>
-            <a:off x="3346704" y="2459736"/>
-            <a:ext cx="274320" cy="274320"/>
-          </a:xfrm>
-          <a:prstGeom prst="rect">
-            <a:avLst/>
-          </a:prstGeom>
-        </p:spPr>
-      </p:pic>
-      <p:sp>
-        <p:nvSpPr>
           <p:cNvPr id="14" name="Text 10"/>
           <p:cNvSpPr/>
           <p:nvPr/>
@@ -20350,68 +20288,6 @@
       </p:sp>
       <p:sp>
         <p:nvSpPr>
-          <p:cNvPr id="18" name="Shape 14"/>
-          <p:cNvSpPr/>
-          <p:nvPr/>
-        </p:nvSpPr>
-        <p:spPr>
-          <a:xfrm>
-            <a:off x="5591556" y="2331720"/>
-            <a:ext cx="530352" cy="530352"/>
-          </a:xfrm>
-          <a:prstGeom prst="ellipse">
-            <a:avLst/>
-          </a:prstGeom>
-          <a:solidFill>
-            <a:srgbClr val="0F8B8D"/>
-          </a:solidFill>
-          <a:ln w="12700">
-            <a:solidFill>
-              <a:srgbClr val="0F8B8D"/>
-            </a:solidFill>
-            <a:prstDash val="solid"/>
-          </a:ln>
-        </p:spPr>
-        <p:txBody>
-          <a:bodyPr/>
-          <a:lstStyle/>
-          <a:p>
-            <a:endParaRPr lang="en-US"/>
-          </a:p>
-        </p:txBody>
-      </p:sp>
-      <p:pic>
-        <p:nvPicPr>
-          <p:cNvPr id="19" name="Image 2" descr="preencoded.png"/>
-          <p:cNvPicPr>
-            <a:picLocks noChangeAspect="1"/>
-          </p:cNvPicPr>
-          <p:nvPr/>
-        </p:nvPicPr>
-        <p:blipFill>
-          <a:blip>
-            <a:extLst>
-              <a:ext uri="{96DAC541-7B7A-43D3-8B79-37D633B846F1}">
-                <asvg:svgBlip xmlns:asvg="http://schemas.microsoft.com/office/drawing/2016/SVG/main" r:embed="rId5"/>
-              </a:ext>
-            </a:extLst>
-          </a:blip>
-          <a:stretch>
-            <a:fillRect/>
-          </a:stretch>
-        </p:blipFill>
-        <p:spPr>
-          <a:xfrm>
-            <a:off x="5719572" y="2459736"/>
-            <a:ext cx="274320" cy="274320"/>
-          </a:xfrm>
-          <a:prstGeom prst="rect">
-            <a:avLst/>
-          </a:prstGeom>
-        </p:spPr>
-      </p:pic>
-      <p:sp>
-        <p:nvSpPr>
           <p:cNvPr id="20" name="Text 15"/>
           <p:cNvSpPr/>
           <p:nvPr/>
@@ -20606,7 +20482,7 @@
           <a:blip>
             <a:extLst>
               <a:ext uri="{96DAC541-7B7A-43D3-8B79-37D633B846F1}">
-                <asvg:svgBlip xmlns:asvg="http://schemas.microsoft.com/office/drawing/2016/SVG/main" r:embed="rId6"/>
+                <asvg:svgBlip xmlns:asvg="http://schemas.microsoft.com/office/drawing/2016/SVG/main" r:embed="rId4"/>
               </a:ext>
             </a:extLst>
           </a:blip>
@@ -20820,7 +20696,7 @@
           <a:blip>
             <a:extLst>
               <a:ext uri="{96DAC541-7B7A-43D3-8B79-37D633B846F1}">
-                <asvg:svgBlip xmlns:asvg="http://schemas.microsoft.com/office/drawing/2016/SVG/main" r:embed="rId7"/>
+                <asvg:svgBlip xmlns:asvg="http://schemas.microsoft.com/office/drawing/2016/SVG/main" r:embed="rId5"/>
               </a:ext>
             </a:extLst>
           </a:blip>
@@ -20957,6 +20833,415 @@
           <p:cNvPr id="35" name="Image 5" descr="preencoded.png"/>
           <p:cNvPicPr>
             <a:picLocks noChangeAspect="1"/>
+          </p:cNvPicPr>
+          <p:nvPr/>
+        </p:nvPicPr>
+        <p:blipFill>
+          <a:blip>
+            <a:extLst>
+              <a:ext uri="{96DAC541-7B7A-43D3-8B79-37D633B846F1}">
+                <asvg:svgBlip xmlns:asvg="http://schemas.microsoft.com/office/drawing/2016/SVG/main" r:embed="rId6"/>
+              </a:ext>
+            </a:extLst>
+          </a:blip>
+          <a:stretch>
+            <a:fillRect/>
+          </a:stretch>
+        </p:blipFill>
+        <p:spPr>
+          <a:xfrm>
+            <a:off x="4645152" y="4480560"/>
+            <a:ext cx="347472" cy="347472"/>
+          </a:xfrm>
+          <a:prstGeom prst="rect">
+            <a:avLst/>
+          </a:prstGeom>
+        </p:spPr>
+      </p:pic>
+      <p:sp>
+        <p:nvSpPr>
+          <p:cNvPr id="36" name="Text 28"/>
+          <p:cNvSpPr/>
+          <p:nvPr/>
+        </p:nvSpPr>
+        <p:spPr>
+          <a:xfrm>
+            <a:off x="5120640" y="4370832"/>
+            <a:ext cx="1938528" cy="228600"/>
+          </a:xfrm>
+          <a:prstGeom prst="rect">
+            <a:avLst/>
+          </a:prstGeom>
+          <a:noFill/>
+          <a:ln/>
+        </p:spPr>
+        <p:txBody>
+          <a:bodyPr wrap="square" lIns="0" tIns="0" rIns="0" bIns="0" rtlCol="0" anchor="ctr"/>
+          <a:lstStyle/>
+          <a:p>
+            <a:pPr marL="0" indent="0">
+              <a:buNone/>
+            </a:pPr>
+            <a:r>
+              <a:rPr lang="en-US" sz="1400" b="1" dirty="0">
+                <a:solidFill>
+                  <a:srgbClr val="FFFFFF"/>
+                </a:solidFill>
+                <a:latin typeface="Aptos Display" pitchFamily="34" charset="0"/>
+                <a:ea typeface="Aptos Display" pitchFamily="34" charset="-122"/>
+                <a:cs typeface="Aptos Display" pitchFamily="34" charset="-120"/>
+              </a:rPr>
+              <a:t>Policies and approvals</a:t>
+            </a:r>
+            <a:endParaRPr lang="en-US" sz="1400" dirty="0"/>
+          </a:p>
+        </p:txBody>
+      </p:sp>
+      <p:sp>
+        <p:nvSpPr>
+          <p:cNvPr id="37" name="Text 29"/>
+          <p:cNvSpPr/>
+          <p:nvPr/>
+        </p:nvSpPr>
+        <p:spPr>
+          <a:xfrm>
+            <a:off x="5120640" y="4645152"/>
+            <a:ext cx="1901952" cy="393192"/>
+          </a:xfrm>
+          <a:prstGeom prst="rect">
+            <a:avLst/>
+          </a:prstGeom>
+          <a:noFill/>
+          <a:ln/>
+        </p:spPr>
+        <p:txBody>
+          <a:bodyPr wrap="square" lIns="0" tIns="0" rIns="0" bIns="0" rtlCol="0" anchor="ctr">
+            <a:normAutofit lnSpcReduction="10000"/>
+          </a:bodyPr>
+          <a:lstStyle/>
+          <a:p>
+            <a:pPr marL="0" indent="0">
+              <a:buNone/>
+            </a:pPr>
+            <a:r>
+              <a:rPr lang="en-US" sz="870" dirty="0">
+                <a:solidFill>
+                  <a:srgbClr val="DDEAF2"/>
+                </a:solidFill>
+                <a:latin typeface="Aptos" pitchFamily="34" charset="0"/>
+                <a:ea typeface="Aptos" pitchFamily="34" charset="-122"/>
+                <a:cs typeface="Aptos" pitchFamily="34" charset="-120"/>
+              </a:rPr>
+              <a:t>Authentication, rate limits, correlation, tracing, logging, and state-change consent</a:t>
+            </a:r>
+            <a:endParaRPr lang="en-US" sz="870" dirty="0"/>
+          </a:p>
+        </p:txBody>
+      </p:sp>
+      <p:sp>
+        <p:nvSpPr>
+          <p:cNvPr id="38" name="Shape 30"/>
+          <p:cNvSpPr/>
+          <p:nvPr/>
+        </p:nvSpPr>
+        <p:spPr>
+          <a:xfrm>
+            <a:off x="5870448" y="3758184"/>
+            <a:ext cx="0" cy="457200"/>
+          </a:xfrm>
+          <a:prstGeom prst="line">
+            <a:avLst/>
+          </a:prstGeom>
+          <a:noFill/>
+          <a:ln w="25400">
+            <a:solidFill>
+              <a:srgbClr val="5BD6C5"/>
+            </a:solidFill>
+            <a:prstDash val="solid"/>
+            <a:headEnd type="triangle"/>
+          </a:ln>
+        </p:spPr>
+        <p:txBody>
+          <a:bodyPr/>
+          <a:lstStyle/>
+          <a:p>
+            <a:endParaRPr lang="en-US"/>
+          </a:p>
+        </p:txBody>
+      </p:sp>
+      <p:sp>
+        <p:nvSpPr>
+          <p:cNvPr id="39" name="Shape 31"/>
+          <p:cNvSpPr/>
+          <p:nvPr/>
+        </p:nvSpPr>
+        <p:spPr>
+          <a:xfrm>
+            <a:off x="7680960" y="4224528"/>
+            <a:ext cx="2880360" cy="1042416"/>
+          </a:xfrm>
+          <a:prstGeom prst="roundRect">
+            <a:avLst/>
+          </a:prstGeom>
+          <a:solidFill>
+            <a:srgbClr val="FFFFFF"/>
+          </a:solidFill>
+          <a:ln w="12700">
+            <a:solidFill>
+              <a:srgbClr val="DDE6EC"/>
+            </a:solidFill>
+            <a:prstDash val="solid"/>
+          </a:ln>
+        </p:spPr>
+        <p:txBody>
+          <a:bodyPr/>
+          <a:lstStyle/>
+          <a:p>
+            <a:endParaRPr lang="en-US"/>
+          </a:p>
+        </p:txBody>
+      </p:sp>
+      <p:pic>
+        <p:nvPicPr>
+          <p:cNvPr id="40" name="Image 6" descr="preencoded.png"/>
+          <p:cNvPicPr>
+            <a:picLocks noChangeAspect="1"/>
+          </p:cNvPicPr>
+          <p:nvPr/>
+        </p:nvPicPr>
+        <p:blipFill>
+          <a:blip>
+            <a:extLst>
+              <a:ext uri="{96DAC541-7B7A-43D3-8B79-37D633B846F1}">
+                <asvg:svgBlip xmlns:asvg="http://schemas.microsoft.com/office/drawing/2016/SVG/main" r:embed="rId7"/>
+              </a:ext>
+            </a:extLst>
+          </a:blip>
+          <a:stretch>
+            <a:fillRect/>
+          </a:stretch>
+        </p:blipFill>
+        <p:spPr>
+          <a:xfrm>
+            <a:off x="7936992" y="4480560"/>
+            <a:ext cx="329184" cy="329184"/>
+          </a:xfrm>
+          <a:prstGeom prst="rect">
+            <a:avLst/>
+          </a:prstGeom>
+        </p:spPr>
+      </p:pic>
+      <p:sp>
+        <p:nvSpPr>
+          <p:cNvPr id="41" name="Text 32"/>
+          <p:cNvSpPr/>
+          <p:nvPr/>
+        </p:nvSpPr>
+        <p:spPr>
+          <a:xfrm>
+            <a:off x="8394192" y="4370832"/>
+            <a:ext cx="1874520" cy="228600"/>
+          </a:xfrm>
+          <a:prstGeom prst="rect">
+            <a:avLst/>
+          </a:prstGeom>
+          <a:noFill/>
+          <a:ln/>
+        </p:spPr>
+        <p:txBody>
+          <a:bodyPr wrap="square" lIns="0" tIns="0" rIns="0" bIns="0" rtlCol="0" anchor="ctr">
+            <a:normAutofit fontScale="92500"/>
+          </a:bodyPr>
+          <a:lstStyle/>
+          <a:p>
+            <a:pPr marL="0" indent="0">
+              <a:buNone/>
+            </a:pPr>
+            <a:r>
+              <a:rPr lang="en-US" sz="1300" b="1" dirty="0">
+                <a:solidFill>
+                  <a:srgbClr val="102A43"/>
+                </a:solidFill>
+                <a:latin typeface="Aptos Display" pitchFamily="34" charset="0"/>
+                <a:ea typeface="Aptos Display" pitchFamily="34" charset="-122"/>
+                <a:cs typeface="Aptos Display" pitchFamily="34" charset="-120"/>
+              </a:rPr>
+              <a:t>Azure Monitor + App Insights</a:t>
+            </a:r>
+            <a:endParaRPr lang="en-US" sz="1300" dirty="0"/>
+          </a:p>
+        </p:txBody>
+      </p:sp>
+      <p:sp>
+        <p:nvSpPr>
+          <p:cNvPr id="42" name="Text 33"/>
+          <p:cNvSpPr/>
+          <p:nvPr/>
+        </p:nvSpPr>
+        <p:spPr>
+          <a:xfrm>
+            <a:off x="8394192" y="4645152"/>
+            <a:ext cx="1874520" cy="365760"/>
+          </a:xfrm>
+          <a:prstGeom prst="rect">
+            <a:avLst/>
+          </a:prstGeom>
+          <a:noFill/>
+          <a:ln/>
+        </p:spPr>
+        <p:txBody>
+          <a:bodyPr wrap="square" lIns="0" tIns="0" rIns="0" bIns="0" rtlCol="0" anchor="ctr">
+            <a:normAutofit/>
+          </a:bodyPr>
+          <a:lstStyle/>
+          <a:p>
+            <a:pPr marL="0" indent="0">
+              <a:buNone/>
+            </a:pPr>
+            <a:r>
+              <a:rPr lang="en-US" sz="870" dirty="0">
+                <a:solidFill>
+                  <a:srgbClr val="4F6474"/>
+                </a:solidFill>
+                <a:latin typeface="Aptos" pitchFamily="34" charset="0"/>
+                <a:ea typeface="Aptos" pitchFamily="34" charset="-122"/>
+                <a:cs typeface="Aptos" pitchFamily="34" charset="-120"/>
+              </a:rPr>
+              <a:t>Latency, failures, usage, request correlation, and audit evidence</a:t>
+            </a:r>
+            <a:endParaRPr lang="en-US" sz="870" dirty="0"/>
+          </a:p>
+        </p:txBody>
+      </p:sp>
+      <p:sp>
+        <p:nvSpPr>
+          <p:cNvPr id="43" name="Shape 34"/>
+          <p:cNvSpPr/>
+          <p:nvPr/>
+        </p:nvSpPr>
+        <p:spPr>
+          <a:xfrm>
+            <a:off x="6858000" y="3749040"/>
+            <a:ext cx="1691640" cy="475488"/>
+          </a:xfrm>
+          <a:prstGeom prst="line">
+            <a:avLst/>
+          </a:prstGeom>
+          <a:noFill/>
+          <a:ln w="19050">
+            <a:solidFill>
+              <a:srgbClr val="FF7A59"/>
+            </a:solidFill>
+            <a:prstDash val="solid"/>
+            <a:tailEnd type="triangle"/>
+          </a:ln>
+        </p:spPr>
+        <p:txBody>
+          <a:bodyPr/>
+          <a:lstStyle/>
+          <a:p>
+            <a:endParaRPr lang="en-US"/>
+          </a:p>
+        </p:txBody>
+      </p:sp>
+      <p:sp>
+        <p:nvSpPr>
+          <p:cNvPr id="44" name="Text 35"/>
+          <p:cNvSpPr/>
+          <p:nvPr/>
+        </p:nvSpPr>
+        <p:spPr>
+          <a:xfrm>
+            <a:off x="566928" y="6528816"/>
+            <a:ext cx="4389120" cy="146304"/>
+          </a:xfrm>
+          <a:prstGeom prst="rect">
+            <a:avLst/>
+          </a:prstGeom>
+          <a:noFill/>
+          <a:ln/>
+        </p:spPr>
+        <p:txBody>
+          <a:bodyPr wrap="square" lIns="0" tIns="0" rIns="0" bIns="0" rtlCol="0" anchor="ctr"/>
+          <a:lstStyle/>
+          <a:p>
+            <a:pPr marL="0" indent="0">
+              <a:buNone/>
+            </a:pPr>
+            <a:r>
+              <a:rPr lang="en-US" sz="750" dirty="0">
+                <a:solidFill>
+                  <a:srgbClr val="748494"/>
+                </a:solidFill>
+                <a:latin typeface="Aptos" pitchFamily="34" charset="0"/>
+                <a:ea typeface="Aptos" pitchFamily="34" charset="-122"/>
+                <a:cs typeface="Aptos" pitchFamily="34" charset="-120"/>
+              </a:rPr>
+              <a:t>Architecture: intent stays with the agent, controls stay at the boundary</a:t>
+            </a:r>
+            <a:endParaRPr lang="en-US" sz="750" dirty="0"/>
+          </a:p>
+        </p:txBody>
+      </p:sp>
+      <p:sp>
+        <p:nvSpPr>
+          <p:cNvPr id="45" name="Slide Number Placeholder 0"/>
+          <p:cNvSpPr>
+            <a:spLocks noGrp="1"/>
+          </p:cNvSpPr>
+          <p:nvPr>
+            <p:ph type="sldNum" sz="quarter" idx="4294967295"/>
+          </p:nvPr>
+        </p:nvSpPr>
+        <p:spPr>
+          <a:xfrm>
+            <a:off x="11109960" y="6510528"/>
+            <a:ext cx="548640" cy="164592"/>
+          </a:xfrm>
+          <a:prstGeom prst="rect">
+            <a:avLst/>
+          </a:prstGeom>
+          <a:extLst>
+            <a:ext uri="{C572A759-6A51-4108-AA02-DFA0A04FC94B}">
+              <ma14:wrappingTextBoxFlag xmlns="" xmlns:ma14="http://schemas.microsoft.com/office/mac/drawingml/2011/main" val="0"/>
+            </a:ext>
+          </a:extLst>
+        </p:spPr>
+        <p:txBody>
+          <a:bodyPr/>
+          <a:lstStyle>
+            <a:lvl1pPr>
+              <a:defRPr sz="800">
+                <a:solidFill>
+                  <a:srgbClr val="748494"/>
+                </a:solidFill>
+                <a:latin typeface="Aptos"/>
+                <a:ea typeface="Aptos"/>
+                <a:cs typeface="Aptos"/>
+              </a:defRPr>
+            </a:lvl1pPr>
+          </a:lstStyle>
+          <a:p>
+            <a:pPr algn="r"/>
+            <a:fld id="{F7021451-1387-4CA6-816F-3879F97B5CBC}" type="slidenum">
+              <a:rPr lang="en-US" b="0"/>
+              <a:t>3</a:t>
+            </a:fld>
+            <a:endParaRPr lang="en-US"/>
+          </a:p>
+        </p:txBody>
+      </p:sp>
+      <p:pic>
+        <p:nvPicPr>
+          <p:cNvPr id="49" name="Microsoft Copilot Studio Icon">
+            <a:extLst>
+              <a:ext uri="{FF2B5EF4-FFF2-40B4-BE49-F238E27FC236}">
+                <a16:creationId xmlns:a16="http://schemas.microsoft.com/office/drawing/2014/main" id="{7D163EBB-95FE-D701-C53B-0FDA5E90DB9F}"/>
+              </a:ext>
+            </a:extLst>
+          </p:cNvPr>
+          <p:cNvPicPr>
+            <a:picLocks/>
           </p:cNvPicPr>
           <p:nvPr/>
         </p:nvPicPr>
@@ -20974,162 +21259,25 @@
         </p:blipFill>
         <p:spPr>
           <a:xfrm>
-            <a:off x="4645152" y="4480560"/>
-            <a:ext cx="347472" cy="347472"/>
+            <a:off x="3528314" y="2431796"/>
+            <a:ext cx="330200" cy="330200"/>
           </a:xfrm>
           <a:prstGeom prst="rect">
             <a:avLst/>
           </a:prstGeom>
         </p:spPr>
       </p:pic>
-      <p:sp>
-        <p:nvSpPr>
-          <p:cNvPr id="36" name="Text 28"/>
-          <p:cNvSpPr/>
-          <p:nvPr/>
-        </p:nvSpPr>
-        <p:spPr>
-          <a:xfrm>
-            <a:off x="5120640" y="4370832"/>
-            <a:ext cx="1938528" cy="228600"/>
-          </a:xfrm>
-          <a:prstGeom prst="rect">
-            <a:avLst/>
-          </a:prstGeom>
-          <a:noFill/>
-          <a:ln/>
-        </p:spPr>
-        <p:txBody>
-          <a:bodyPr wrap="square" lIns="0" tIns="0" rIns="0" bIns="0" rtlCol="0" anchor="ctr"/>
-          <a:lstStyle/>
-          <a:p>
-            <a:pPr marL="0" indent="0">
-              <a:buNone/>
-            </a:pPr>
-            <a:r>
-              <a:rPr lang="en-US" sz="1400" b="1" dirty="0">
-                <a:solidFill>
-                  <a:srgbClr val="FFFFFF"/>
-                </a:solidFill>
-                <a:latin typeface="Aptos Display" pitchFamily="34" charset="0"/>
-                <a:ea typeface="Aptos Display" pitchFamily="34" charset="-122"/>
-                <a:cs typeface="Aptos Display" pitchFamily="34" charset="-120"/>
-              </a:rPr>
-              <a:t>Policies and approvals</a:t>
-            </a:r>
-            <a:endParaRPr lang="en-US" sz="1400" dirty="0"/>
-          </a:p>
-        </p:txBody>
-      </p:sp>
-      <p:sp>
-        <p:nvSpPr>
-          <p:cNvPr id="37" name="Text 29"/>
-          <p:cNvSpPr/>
-          <p:nvPr/>
-        </p:nvSpPr>
-        <p:spPr>
-          <a:xfrm>
-            <a:off x="5120640" y="4645152"/>
-            <a:ext cx="1901952" cy="393192"/>
-          </a:xfrm>
-          <a:prstGeom prst="rect">
-            <a:avLst/>
-          </a:prstGeom>
-          <a:noFill/>
-          <a:ln/>
-        </p:spPr>
-        <p:txBody>
-          <a:bodyPr wrap="square" lIns="0" tIns="0" rIns="0" bIns="0" rtlCol="0" anchor="ctr">
-            <a:normAutofit lnSpcReduction="10000"/>
-          </a:bodyPr>
-          <a:lstStyle/>
-          <a:p>
-            <a:pPr marL="0" indent="0">
-              <a:buNone/>
-            </a:pPr>
-            <a:r>
-              <a:rPr lang="en-US" sz="870" dirty="0">
-                <a:solidFill>
-                  <a:srgbClr val="DDEAF2"/>
-                </a:solidFill>
-                <a:latin typeface="Aptos" pitchFamily="34" charset="0"/>
-                <a:ea typeface="Aptos" pitchFamily="34" charset="-122"/>
-                <a:cs typeface="Aptos" pitchFamily="34" charset="-120"/>
-              </a:rPr>
-              <a:t>Authentication, rate limits, correlation, tracing, logging, and state-change consent</a:t>
-            </a:r>
-            <a:endParaRPr lang="en-US" sz="870" dirty="0"/>
-          </a:p>
-        </p:txBody>
-      </p:sp>
-      <p:sp>
-        <p:nvSpPr>
-          <p:cNvPr id="38" name="Shape 30"/>
-          <p:cNvSpPr/>
-          <p:nvPr/>
-        </p:nvSpPr>
-        <p:spPr>
-          <a:xfrm>
-            <a:off x="5870448" y="3758184"/>
-            <a:ext cx="0" cy="457200"/>
-          </a:xfrm>
-          <a:prstGeom prst="line">
-            <a:avLst/>
-          </a:prstGeom>
-          <a:noFill/>
-          <a:ln w="25400">
-            <a:solidFill>
-              <a:srgbClr val="5BD6C5"/>
-            </a:solidFill>
-            <a:prstDash val="solid"/>
-            <a:headEnd type="triangle"/>
-          </a:ln>
-        </p:spPr>
-        <p:txBody>
-          <a:bodyPr/>
-          <a:lstStyle/>
-          <a:p>
-            <a:endParaRPr lang="en-US"/>
-          </a:p>
-        </p:txBody>
-      </p:sp>
-      <p:sp>
-        <p:nvSpPr>
-          <p:cNvPr id="39" name="Shape 31"/>
-          <p:cNvSpPr/>
-          <p:nvPr/>
-        </p:nvSpPr>
-        <p:spPr>
-          <a:xfrm>
-            <a:off x="7680960" y="4224528"/>
-            <a:ext cx="2880360" cy="1042416"/>
-          </a:xfrm>
-          <a:prstGeom prst="roundRect">
-            <a:avLst/>
-          </a:prstGeom>
-          <a:solidFill>
-            <a:srgbClr val="FFFFFF"/>
-          </a:solidFill>
-          <a:ln w="12700">
-            <a:solidFill>
-              <a:srgbClr val="DDE6EC"/>
-            </a:solidFill>
-            <a:prstDash val="solid"/>
-          </a:ln>
-        </p:spPr>
-        <p:txBody>
-          <a:bodyPr/>
-          <a:lstStyle/>
-          <a:p>
-            <a:endParaRPr lang="en-US"/>
-          </a:p>
-        </p:txBody>
-      </p:sp>
       <p:pic>
         <p:nvPicPr>
-          <p:cNvPr id="40" name="Image 6" descr="preencoded.png"/>
+          <p:cNvPr id="51" name="Azure API Management Icon">
+            <a:extLst>
+              <a:ext uri="{FF2B5EF4-FFF2-40B4-BE49-F238E27FC236}">
+                <a16:creationId xmlns:a16="http://schemas.microsoft.com/office/drawing/2014/main" id="{AAFB1189-5C1B-9BD4-7D9F-53793DC99227}"/>
+              </a:ext>
+            </a:extLst>
+          </p:cNvPr>
           <p:cNvPicPr>
-            <a:picLocks noChangeAspect="1"/>
+            <a:picLocks/>
           </p:cNvPicPr>
           <p:nvPr/>
         </p:nvPicPr>
@@ -21147,214 +21295,50 @@
         </p:blipFill>
         <p:spPr>
           <a:xfrm>
-            <a:off x="7936992" y="4480560"/>
-            <a:ext cx="329184" cy="329184"/>
+            <a:off x="5590032" y="2330196"/>
+            <a:ext cx="533400" cy="533400"/>
           </a:xfrm>
           <a:prstGeom prst="rect">
             <a:avLst/>
           </a:prstGeom>
         </p:spPr>
       </p:pic>
-      <p:sp>
-        <p:nvSpPr>
-          <p:cNvPr id="41" name="Text 32"/>
-          <p:cNvSpPr/>
-          <p:nvPr/>
-        </p:nvSpPr>
-        <p:spPr>
-          <a:xfrm>
-            <a:off x="8394192" y="4370832"/>
-            <a:ext cx="1874520" cy="228600"/>
-          </a:xfrm>
-          <a:prstGeom prst="rect">
-            <a:avLst/>
-          </a:prstGeom>
-          <a:noFill/>
-          <a:ln/>
-        </p:spPr>
-        <p:txBody>
-          <a:bodyPr wrap="square" lIns="0" tIns="0" rIns="0" bIns="0" rtlCol="0" anchor="ctr">
-            <a:normAutofit fontScale="92500"/>
-          </a:bodyPr>
-          <a:lstStyle/>
-          <a:p>
-            <a:pPr marL="0" indent="0">
-              <a:buNone/>
-            </a:pPr>
-            <a:r>
-              <a:rPr lang="en-US" sz="1300" b="1" dirty="0">
-                <a:solidFill>
-                  <a:srgbClr val="102A43"/>
-                </a:solidFill>
-                <a:latin typeface="Aptos Display" pitchFamily="34" charset="0"/>
-                <a:ea typeface="Aptos Display" pitchFamily="34" charset="-122"/>
-                <a:cs typeface="Aptos Display" pitchFamily="34" charset="-120"/>
-              </a:rPr>
-              <a:t>Azure Monitor + App Insights</a:t>
-            </a:r>
-            <a:endParaRPr lang="en-US" sz="1300" dirty="0"/>
-          </a:p>
-        </p:txBody>
-      </p:sp>
-      <p:sp>
-        <p:nvSpPr>
-          <p:cNvPr id="42" name="Text 33"/>
-          <p:cNvSpPr/>
-          <p:nvPr/>
-        </p:nvSpPr>
-        <p:spPr>
-          <a:xfrm>
-            <a:off x="8394192" y="4645152"/>
-            <a:ext cx="1874520" cy="365760"/>
-          </a:xfrm>
-          <a:prstGeom prst="rect">
-            <a:avLst/>
-          </a:prstGeom>
-          <a:noFill/>
-          <a:ln/>
-        </p:spPr>
-        <p:txBody>
-          <a:bodyPr wrap="square" lIns="0" tIns="0" rIns="0" bIns="0" rtlCol="0" anchor="ctr">
-            <a:normAutofit/>
-          </a:bodyPr>
-          <a:lstStyle/>
-          <a:p>
-            <a:pPr marL="0" indent="0">
-              <a:buNone/>
-            </a:pPr>
-            <a:r>
-              <a:rPr lang="en-US" sz="870" dirty="0">
-                <a:solidFill>
-                  <a:srgbClr val="4F6474"/>
-                </a:solidFill>
-                <a:latin typeface="Aptos" pitchFamily="34" charset="0"/>
-                <a:ea typeface="Aptos" pitchFamily="34" charset="-122"/>
-                <a:cs typeface="Aptos" pitchFamily="34" charset="-120"/>
-              </a:rPr>
-              <a:t>Latency, failures, usage, request correlation, and audit evidence</a:t>
-            </a:r>
-            <a:endParaRPr lang="en-US" sz="870" dirty="0"/>
-          </a:p>
-        </p:txBody>
-      </p:sp>
-      <p:sp>
-        <p:nvSpPr>
-          <p:cNvPr id="43" name="Shape 34"/>
-          <p:cNvSpPr/>
-          <p:nvPr/>
-        </p:nvSpPr>
-        <p:spPr>
-          <a:xfrm>
-            <a:off x="6858000" y="3749040"/>
-            <a:ext cx="1691640" cy="475488"/>
-          </a:xfrm>
-          <a:prstGeom prst="line">
-            <a:avLst/>
-          </a:prstGeom>
-          <a:noFill/>
-          <a:ln w="19050">
-            <a:solidFill>
-              <a:srgbClr val="FF7A59"/>
-            </a:solidFill>
-            <a:prstDash val="solid"/>
-            <a:tailEnd type="triangle"/>
-          </a:ln>
-        </p:spPr>
-        <p:txBody>
-          <a:bodyPr/>
-          <a:lstStyle/>
-          <a:p>
-            <a:endParaRPr lang="en-US"/>
-          </a:p>
-        </p:txBody>
-      </p:sp>
-      <p:sp>
-        <p:nvSpPr>
-          <p:cNvPr id="44" name="Text 35"/>
-          <p:cNvSpPr/>
-          <p:nvPr/>
-        </p:nvSpPr>
-        <p:spPr>
-          <a:xfrm>
-            <a:off x="566928" y="6528816"/>
-            <a:ext cx="4389120" cy="146304"/>
-          </a:xfrm>
-          <a:prstGeom prst="rect">
-            <a:avLst/>
-          </a:prstGeom>
-          <a:noFill/>
-          <a:ln/>
-        </p:spPr>
-        <p:txBody>
-          <a:bodyPr wrap="square" lIns="0" tIns="0" rIns="0" bIns="0" rtlCol="0" anchor="ctr"/>
-          <a:lstStyle/>
-          <a:p>
-            <a:pPr marL="0" indent="0">
-              <a:buNone/>
-            </a:pPr>
-            <a:r>
-              <a:rPr lang="en-US" sz="750" dirty="0">
-                <a:solidFill>
-                  <a:srgbClr val="748494"/>
-                </a:solidFill>
-                <a:latin typeface="Aptos" pitchFamily="34" charset="0"/>
-                <a:ea typeface="Aptos" pitchFamily="34" charset="-122"/>
-                <a:cs typeface="Aptos" pitchFamily="34" charset="-120"/>
-              </a:rPr>
-              <a:t>Architecture: intent stays with the agent, controls stay at the boundary</a:t>
-            </a:r>
-            <a:endParaRPr lang="en-US" sz="750" dirty="0"/>
-          </a:p>
-        </p:txBody>
-      </p:sp>
-      <p:sp>
-        <p:nvSpPr>
-          <p:cNvPr id="45" name="Slide Number Placeholder 0"/>
-          <p:cNvSpPr>
-            <a:spLocks noGrp="1"/>
-          </p:cNvSpPr>
-          <p:nvPr>
-            <p:ph type="sldNum" sz="quarter" idx="4294967295"/>
-          </p:nvPr>
-        </p:nvSpPr>
-        <p:spPr>
-          <a:xfrm>
-            <a:off x="11109960" y="6510528"/>
-            <a:ext cx="548640" cy="164592"/>
-          </a:xfrm>
-          <a:prstGeom prst="rect">
-            <a:avLst/>
-          </a:prstGeom>
-          <a:extLst>
-            <a:ext uri="{C572A759-6A51-4108-AA02-DFA0A04FC94B}">
-              <ma14:wrappingTextBoxFlag xmlns="" xmlns:ma14="http://schemas.microsoft.com/office/mac/drawingml/2011/main" val="0"/>
-            </a:ext>
-          </a:extLst>
-        </p:spPr>
-        <p:txBody>
-          <a:bodyPr/>
-          <a:lstStyle>
-            <a:lvl1pPr>
-              <a:defRPr sz="800">
-                <a:solidFill>
-                  <a:srgbClr val="748494"/>
-                </a:solidFill>
-                <a:latin typeface="Aptos"/>
-                <a:ea typeface="Aptos"/>
-                <a:cs typeface="Aptos"/>
-              </a:defRPr>
-            </a:lvl1pPr>
-          </a:lstStyle>
-          <a:p>
-            <a:pPr algn="r"/>
-            <a:fld id="{F7021451-1387-4CA6-816F-3879F97B5CBC}" type="slidenum">
-              <a:rPr lang="en-US" b="0"/>
-              <a:t>3</a:t>
-            </a:fld>
-            <a:endParaRPr lang="en-US"/>
-          </a:p>
-        </p:txBody>
-      </p:sp>
+      <p:pic>
+        <p:nvPicPr>
+          <p:cNvPr id="13" name="Microsoft Foundry Agent Service Icon">
+            <a:extLst>
+              <a:ext uri="{FF2B5EF4-FFF2-40B4-BE49-F238E27FC236}">
+                <a16:creationId xmlns:a16="http://schemas.microsoft.com/office/drawing/2014/main" id="{7CA32E2E-6B9A-7AED-FDF5-EF9F21CDEB73}"/>
+              </a:ext>
+            </a:extLst>
+          </p:cNvPr>
+          <p:cNvPicPr>
+            <a:picLocks/>
+          </p:cNvPicPr>
+          <p:nvPr/>
+        </p:nvPicPr>
+        <p:blipFill>
+          <a:blip>
+            <a:extLst>
+              <a:ext uri="{96DAC541-7B7A-43D3-8B79-37D633B846F1}">
+                <asvg:svgBlip xmlns:asvg="http://schemas.microsoft.com/office/drawing/2016/SVG/main" r:embed="rId10"/>
+              </a:ext>
+            </a:extLst>
+          </a:blip>
+          <a:stretch>
+            <a:fillRect/>
+          </a:stretch>
+        </p:blipFill>
+        <p:spPr>
+          <a:xfrm>
+            <a:off x="3109214" y="2431796"/>
+            <a:ext cx="330200" cy="330200"/>
+          </a:xfrm>
+          <a:prstGeom prst="rect">
+            <a:avLst/>
+          </a:prstGeom>
+        </p:spPr>
+      </p:pic>
     </p:spTree>
   </p:cSld>
   <p:clrMapOvr>

</xml_diff>

<commit_message>
Add workshop QR code to title slide
Link the title slide to aka.ms/MCPWorkshop with a scannable QR code and clickable vanity URL.

Co-authored-by: Copilot <223556219+Copilot@users.noreply.github.com>
Copilot-Session: aa1a2148-b4d0-4cc5-94ea-497594b4b72a
</commit_message>
<xml_diff>
--- a/docs/foundry-apim-mcp-workshop.pptx
+++ b/docs/foundry-apim-mcp-workshop.pptx
@@ -2187,7 +2187,7 @@
           </a:prstGeom>
           <a:extLst>
             <a:ext uri="{C572A759-6A51-4108-AA02-DFA0A04FC94B}">
-              <ma14:wrappingTextBoxFlag xmlns="" xmlns:ma14="http://schemas.microsoft.com/office/mac/drawingml/2011/main" val="0"/>
+              <ma14:wrappingTextBoxFlag xmlns:ma14="http://schemas.microsoft.com/office/mac/drawingml/2011/main" xmlns="" val="0"/>
             </a:ext>
           </a:extLst>
         </p:spPr>
@@ -2265,7 +2265,7 @@
           </a:prstGeom>
           <a:extLst>
             <a:ext uri="{C572A759-6A51-4108-AA02-DFA0A04FC94B}">
-              <ma14:wrappingTextBoxFlag xmlns="" xmlns:ma14="http://schemas.microsoft.com/office/mac/drawingml/2011/main" val="0"/>
+              <ma14:wrappingTextBoxFlag xmlns:ma14="http://schemas.microsoft.com/office/mac/drawingml/2011/main" xmlns="" val="0"/>
             </a:ext>
           </a:extLst>
         </p:spPr>
@@ -3133,7 +3133,7 @@
         </p:nvSpPr>
         <p:spPr>
           <a:xfrm>
-            <a:off x="658368" y="6016752"/>
+            <a:off x="658368" y="6299200"/>
             <a:ext cx="3200400" cy="201168"/>
           </a:xfrm>
           <a:prstGeom prst="rect">
@@ -3161,6 +3161,118 @@
               <a:t>Public workshop edition</a:t>
             </a:r>
             <a:endParaRPr lang="en-US" sz="950" dirty="0"/>
+          </a:p>
+        </p:txBody>
+      </p:sp>
+      <p:pic>
+        <p:nvPicPr>
+          <p:cNvPr id="19" name="Workshop Repo QR" descr="QR code linking to https://aka.ms/MCPWorkshop">
+            <a:hlinkClick r:id="rId7"/>
+            <a:extLst>
+              <a:ext uri="{FF2B5EF4-FFF2-40B4-BE49-F238E27FC236}">
+                <a16:creationId xmlns:a16="http://schemas.microsoft.com/office/drawing/2014/main" id="{A73C613E-4750-90AF-FDF0-3A81E526DA7B}"/>
+              </a:ext>
+            </a:extLst>
+          </p:cNvPr>
+          <p:cNvPicPr>
+            <a:picLocks/>
+          </p:cNvPicPr>
+          <p:nvPr/>
+        </p:nvPicPr>
+        <p:blipFill>
+          <a:blip r:embed="rId8"/>
+          <a:stretch>
+            <a:fillRect/>
+          </a:stretch>
+        </p:blipFill>
+        <p:spPr>
+          <a:xfrm>
+            <a:off x="660400" y="5181600"/>
+            <a:ext cx="914400" cy="914400"/>
+          </a:xfrm>
+          <a:prstGeom prst="rect">
+            <a:avLst/>
+          </a:prstGeom>
+        </p:spPr>
+      </p:pic>
+      <p:sp>
+        <p:nvSpPr>
+          <p:cNvPr id="20" name="Workshop Repo Label">
+            <a:extLst>
+              <a:ext uri="{FF2B5EF4-FFF2-40B4-BE49-F238E27FC236}">
+                <a16:creationId xmlns:a16="http://schemas.microsoft.com/office/drawing/2014/main" id="{3ED29ABE-FEF1-FE94-4EFE-FCC2CD734316}"/>
+              </a:ext>
+            </a:extLst>
+          </p:cNvPr>
+          <p:cNvSpPr txBox="1"/>
+          <p:nvPr/>
+        </p:nvSpPr>
+        <p:spPr>
+          <a:xfrm>
+            <a:off x="1739900" y="5334000"/>
+            <a:ext cx="2286000" cy="138499"/>
+          </a:xfrm>
+          <a:prstGeom prst="rect">
+            <a:avLst/>
+          </a:prstGeom>
+          <a:noFill/>
+        </p:spPr>
+        <p:txBody>
+          <a:bodyPr vert="horz" lIns="0" tIns="0" rIns="0" bIns="0" rtlCol="0">
+            <a:spAutoFit/>
+          </a:bodyPr>
+          <a:lstStyle/>
+          <a:p>
+            <a:r>
+              <a:rPr lang="en-US" sz="900" b="1">
+                <a:solidFill>
+                  <a:srgbClr val="60D4CB"/>
+                </a:solidFill>
+                <a:latin typeface="Aptos" panose="020B0004020202020204" pitchFamily="34" charset="0"/>
+              </a:rPr>
+              <a:t>WORKSHOP REPO</a:t>
+            </a:r>
+          </a:p>
+        </p:txBody>
+      </p:sp>
+      <p:sp>
+        <p:nvSpPr>
+          <p:cNvPr id="21" name="Workshop Repo URL">
+            <a:hlinkClick r:id="rId7"/>
+            <a:extLst>
+              <a:ext uri="{FF2B5EF4-FFF2-40B4-BE49-F238E27FC236}">
+                <a16:creationId xmlns:a16="http://schemas.microsoft.com/office/drawing/2014/main" id="{B5CECEF4-17F6-8571-E785-BB9F4D6F939F}"/>
+              </a:ext>
+            </a:extLst>
+          </p:cNvPr>
+          <p:cNvSpPr txBox="1"/>
+          <p:nvPr/>
+        </p:nvSpPr>
+        <p:spPr>
+          <a:xfrm>
+            <a:off x="1739900" y="5600700"/>
+            <a:ext cx="2413000" cy="215444"/>
+          </a:xfrm>
+          <a:prstGeom prst="rect">
+            <a:avLst/>
+          </a:prstGeom>
+          <a:noFill/>
+        </p:spPr>
+        <p:txBody>
+          <a:bodyPr vert="horz" lIns="0" tIns="0" rIns="0" bIns="0" rtlCol="0">
+            <a:spAutoFit/>
+          </a:bodyPr>
+          <a:lstStyle/>
+          <a:p>
+            <a:r>
+              <a:rPr lang="en-US" sz="1400" b="1">
+                <a:solidFill>
+                  <a:srgbClr val="FFFFFF"/>
+                </a:solidFill>
+                <a:latin typeface="Aptos" panose="020B0004020202020204" pitchFamily="34" charset="0"/>
+              </a:rPr>
+              <a:t>aka.ms/MCPWorkshop</a:t>
+            </a:r>
           </a:p>
         </p:txBody>
       </p:sp>
@@ -4758,7 +4870,7 @@
           </a:prstGeom>
           <a:extLst>
             <a:ext uri="{C572A759-6A51-4108-AA02-DFA0A04FC94B}">
-              <ma14:wrappingTextBoxFlag xmlns="" xmlns:ma14="http://schemas.microsoft.com/office/mac/drawingml/2011/main" val="0"/>
+              <ma14:wrappingTextBoxFlag xmlns:ma14="http://schemas.microsoft.com/office/mac/drawingml/2011/main" xmlns="" val="0"/>
             </a:ext>
           </a:extLst>
         </p:spPr>
@@ -5716,7 +5828,7 @@
           </a:prstGeom>
           <a:extLst>
             <a:ext uri="{C572A759-6A51-4108-AA02-DFA0A04FC94B}">
-              <ma14:wrappingTextBoxFlag xmlns="" xmlns:ma14="http://schemas.microsoft.com/office/mac/drawingml/2011/main" val="0"/>
+              <ma14:wrappingTextBoxFlag xmlns:ma14="http://schemas.microsoft.com/office/mac/drawingml/2011/main" xmlns="" val="0"/>
             </a:ext>
           </a:extLst>
         </p:spPr>
@@ -6932,7 +7044,7 @@
           </a:prstGeom>
           <a:extLst>
             <a:ext uri="{C572A759-6A51-4108-AA02-DFA0A04FC94B}">
-              <ma14:wrappingTextBoxFlag xmlns="" xmlns:ma14="http://schemas.microsoft.com/office/mac/drawingml/2011/main" val="0"/>
+              <ma14:wrappingTextBoxFlag xmlns:ma14="http://schemas.microsoft.com/office/mac/drawingml/2011/main" xmlns="" val="0"/>
             </a:ext>
           </a:extLst>
         </p:spPr>
@@ -8048,7 +8160,7 @@
           </a:prstGeom>
           <a:extLst>
             <a:ext uri="{C572A759-6A51-4108-AA02-DFA0A04FC94B}">
-              <ma14:wrappingTextBoxFlag xmlns="" xmlns:ma14="http://schemas.microsoft.com/office/mac/drawingml/2011/main" val="0"/>
+              <ma14:wrappingTextBoxFlag xmlns:ma14="http://schemas.microsoft.com/office/mac/drawingml/2011/main" xmlns="" val="0"/>
             </a:ext>
           </a:extLst>
         </p:spPr>
@@ -9505,7 +9617,7 @@
           </a:prstGeom>
           <a:extLst>
             <a:ext uri="{C572A759-6A51-4108-AA02-DFA0A04FC94B}">
-              <ma14:wrappingTextBoxFlag xmlns="" xmlns:ma14="http://schemas.microsoft.com/office/mac/drawingml/2011/main" val="0"/>
+              <ma14:wrappingTextBoxFlag xmlns:ma14="http://schemas.microsoft.com/office/mac/drawingml/2011/main" xmlns="" val="0"/>
             </a:ext>
           </a:extLst>
         </p:spPr>
@@ -10522,7 +10634,7 @@
           </a:prstGeom>
           <a:extLst>
             <a:ext uri="{C572A759-6A51-4108-AA02-DFA0A04FC94B}">
-              <ma14:wrappingTextBoxFlag xmlns="" xmlns:ma14="http://schemas.microsoft.com/office/mac/drawingml/2011/main" val="0"/>
+              <ma14:wrappingTextBoxFlag xmlns:ma14="http://schemas.microsoft.com/office/mac/drawingml/2011/main" xmlns="" val="0"/>
             </a:ext>
           </a:extLst>
         </p:spPr>
@@ -11743,7 +11855,7 @@
           </a:prstGeom>
           <a:extLst>
             <a:ext uri="{C572A759-6A51-4108-AA02-DFA0A04FC94B}">
-              <ma14:wrappingTextBoxFlag xmlns="" xmlns:ma14="http://schemas.microsoft.com/office/mac/drawingml/2011/main" val="0"/>
+              <ma14:wrappingTextBoxFlag xmlns:ma14="http://schemas.microsoft.com/office/mac/drawingml/2011/main" xmlns="" val="0"/>
             </a:ext>
           </a:extLst>
         </p:spPr>
@@ -13506,7 +13618,7 @@
           </a:prstGeom>
           <a:extLst>
             <a:ext uri="{C572A759-6A51-4108-AA02-DFA0A04FC94B}">
-              <ma14:wrappingTextBoxFlag xmlns="" xmlns:ma14="http://schemas.microsoft.com/office/mac/drawingml/2011/main" val="0"/>
+              <ma14:wrappingTextBoxFlag xmlns:ma14="http://schemas.microsoft.com/office/mac/drawingml/2011/main" xmlns="" val="0"/>
             </a:ext>
           </a:extLst>
         </p:spPr>
@@ -14837,7 +14949,7 @@
           </a:prstGeom>
           <a:extLst>
             <a:ext uri="{C572A759-6A51-4108-AA02-DFA0A04FC94B}">
-              <ma14:wrappingTextBoxFlag xmlns="" xmlns:ma14="http://schemas.microsoft.com/office/mac/drawingml/2011/main" val="0"/>
+              <ma14:wrappingTextBoxFlag xmlns:ma14="http://schemas.microsoft.com/office/mac/drawingml/2011/main" xmlns="" val="0"/>
             </a:ext>
           </a:extLst>
         </p:spPr>
@@ -16459,7 +16571,7 @@
           </a:prstGeom>
           <a:extLst>
             <a:ext uri="{C572A759-6A51-4108-AA02-DFA0A04FC94B}">
-              <ma14:wrappingTextBoxFlag xmlns="" xmlns:ma14="http://schemas.microsoft.com/office/mac/drawingml/2011/main" val="0"/>
+              <ma14:wrappingTextBoxFlag xmlns:ma14="http://schemas.microsoft.com/office/mac/drawingml/2011/main" xmlns="" val="0"/>
             </a:ext>
           </a:extLst>
         </p:spPr>
@@ -17640,7 +17752,7 @@
           </a:prstGeom>
           <a:extLst>
             <a:ext uri="{C572A759-6A51-4108-AA02-DFA0A04FC94B}">
-              <ma14:wrappingTextBoxFlag xmlns="" xmlns:ma14="http://schemas.microsoft.com/office/mac/drawingml/2011/main" val="0"/>
+              <ma14:wrappingTextBoxFlag xmlns:ma14="http://schemas.microsoft.com/office/mac/drawingml/2011/main" xmlns="" val="0"/>
             </a:ext>
           </a:extLst>
         </p:spPr>
@@ -18832,7 +18944,7 @@
           </a:prstGeom>
           <a:extLst>
             <a:ext uri="{C572A759-6A51-4108-AA02-DFA0A04FC94B}">
-              <ma14:wrappingTextBoxFlag xmlns="" xmlns:ma14="http://schemas.microsoft.com/office/mac/drawingml/2011/main" val="0"/>
+              <ma14:wrappingTextBoxFlag xmlns:ma14="http://schemas.microsoft.com/office/mac/drawingml/2011/main" xmlns="" val="0"/>
             </a:ext>
           </a:extLst>
         </p:spPr>
@@ -21203,7 +21315,7 @@
           </a:prstGeom>
           <a:extLst>
             <a:ext uri="{C572A759-6A51-4108-AA02-DFA0A04FC94B}">
-              <ma14:wrappingTextBoxFlag xmlns="" xmlns:ma14="http://schemas.microsoft.com/office/mac/drawingml/2011/main" val="0"/>
+              <ma14:wrappingTextBoxFlag xmlns:ma14="http://schemas.microsoft.com/office/mac/drawingml/2011/main" xmlns="" val="0"/>
             </a:ext>
           </a:extLst>
         </p:spPr>
@@ -23836,7 +23948,7 @@
           </a:prstGeom>
           <a:extLst>
             <a:ext uri="{C572A759-6A51-4108-AA02-DFA0A04FC94B}">
-              <ma14:wrappingTextBoxFlag xmlns="" xmlns:ma14="http://schemas.microsoft.com/office/mac/drawingml/2011/main" val="0"/>
+              <ma14:wrappingTextBoxFlag xmlns:ma14="http://schemas.microsoft.com/office/mac/drawingml/2011/main" xmlns="" val="0"/>
             </a:ext>
           </a:extLst>
         </p:spPr>
@@ -24924,7 +25036,7 @@
           </a:prstGeom>
           <a:extLst>
             <a:ext uri="{C572A759-6A51-4108-AA02-DFA0A04FC94B}">
-              <ma14:wrappingTextBoxFlag xmlns="" xmlns:ma14="http://schemas.microsoft.com/office/mac/drawingml/2011/main" val="0"/>
+              <ma14:wrappingTextBoxFlag xmlns:ma14="http://schemas.microsoft.com/office/mac/drawingml/2011/main" xmlns="" val="0"/>
             </a:ext>
           </a:extLst>
         </p:spPr>
@@ -26079,7 +26191,7 @@
           </a:prstGeom>
           <a:extLst>
             <a:ext uri="{C572A759-6A51-4108-AA02-DFA0A04FC94B}">
-              <ma14:wrappingTextBoxFlag xmlns="" xmlns:ma14="http://schemas.microsoft.com/office/mac/drawingml/2011/main" val="0"/>
+              <ma14:wrappingTextBoxFlag xmlns:ma14="http://schemas.microsoft.com/office/mac/drawingml/2011/main" xmlns="" val="0"/>
             </a:ext>
           </a:extLst>
         </p:spPr>
@@ -27490,7 +27602,7 @@
           </a:prstGeom>
           <a:extLst>
             <a:ext uri="{C572A759-6A51-4108-AA02-DFA0A04FC94B}">
-              <ma14:wrappingTextBoxFlag xmlns="" xmlns:ma14="http://schemas.microsoft.com/office/mac/drawingml/2011/main" val="0"/>
+              <ma14:wrappingTextBoxFlag xmlns:ma14="http://schemas.microsoft.com/office/mac/drawingml/2011/main" xmlns="" val="0"/>
             </a:ext>
           </a:extLst>
         </p:spPr>
@@ -28477,7 +28589,7 @@
           </a:prstGeom>
           <a:extLst>
             <a:ext uri="{C572A759-6A51-4108-AA02-DFA0A04FC94B}">
-              <ma14:wrappingTextBoxFlag xmlns="" xmlns:ma14="http://schemas.microsoft.com/office/mac/drawingml/2011/main" val="0"/>
+              <ma14:wrappingTextBoxFlag xmlns:ma14="http://schemas.microsoft.com/office/mac/drawingml/2011/main" xmlns="" val="0"/>
             </a:ext>
           </a:extLst>
         </p:spPr>
@@ -29865,7 +29977,7 @@
           </a:prstGeom>
           <a:extLst>
             <a:ext uri="{C572A759-6A51-4108-AA02-DFA0A04FC94B}">
-              <ma14:wrappingTextBoxFlag xmlns="" xmlns:ma14="http://schemas.microsoft.com/office/mac/drawingml/2011/main" val="0"/>
+              <ma14:wrappingTextBoxFlag xmlns:ma14="http://schemas.microsoft.com/office/mac/drawingml/2011/main" xmlns="" val="0"/>
             </a:ext>
           </a:extLst>
         </p:spPr>

</xml_diff>

<commit_message>
Clarify slide 3 governance and telemetry
Move approvals to the agent harness, keep policies with APIM, add agent telemetry to Application Insights, and show the Microsoft Agent 365 governance plane with its official logo.

Co-authored-by: Copilot <223556219+Copilot@users.noreply.github.com>
Copilot-Session: aa1a2148-b4d0-4cc5-94ea-497594b4b72a
</commit_message>
<xml_diff>
--- a/docs/foundry-apim-mcp-workshop.pptx
+++ b/docs/foundry-apim-mcp-workshop.pptx
@@ -2166,6 +2166,13 @@
             <a:prstDash val="solid"/>
           </a:ln>
         </p:spPr>
+        <p:txBody>
+          <a:bodyPr/>
+          <a:lstStyle/>
+          <a:p>
+            <a:endParaRPr lang="en-US"/>
+          </a:p>
+        </p:txBody>
       </p:sp>
       <p:sp>
         <p:nvSpPr>
@@ -2187,7 +2194,7 @@
           </a:prstGeom>
           <a:extLst>
             <a:ext uri="{C572A759-6A51-4108-AA02-DFA0A04FC94B}">
-              <ma14:wrappingTextBoxFlag xmlns:ma14="http://schemas.microsoft.com/office/mac/drawingml/2011/main" xmlns="" val="0"/>
+              <ma14:wrappingTextBoxFlag xmlns="" xmlns:ma14="http://schemas.microsoft.com/office/mac/drawingml/2011/main" val="0"/>
             </a:ext>
           </a:extLst>
         </p:spPr>
@@ -2265,7 +2272,7 @@
           </a:prstGeom>
           <a:extLst>
             <a:ext uri="{C572A759-6A51-4108-AA02-DFA0A04FC94B}">
-              <ma14:wrappingTextBoxFlag xmlns:ma14="http://schemas.microsoft.com/office/mac/drawingml/2011/main" xmlns="" val="0"/>
+              <ma14:wrappingTextBoxFlag xmlns="" xmlns:ma14="http://schemas.microsoft.com/office/mac/drawingml/2011/main" val="0"/>
             </a:ext>
           </a:extLst>
         </p:spPr>
@@ -4870,7 +4877,7 @@
           </a:prstGeom>
           <a:extLst>
             <a:ext uri="{C572A759-6A51-4108-AA02-DFA0A04FC94B}">
-              <ma14:wrappingTextBoxFlag xmlns:ma14="http://schemas.microsoft.com/office/mac/drawingml/2011/main" xmlns="" val="0"/>
+              <ma14:wrappingTextBoxFlag xmlns="" xmlns:ma14="http://schemas.microsoft.com/office/mac/drawingml/2011/main" val="0"/>
             </a:ext>
           </a:extLst>
         </p:spPr>
@@ -5828,7 +5835,7 @@
           </a:prstGeom>
           <a:extLst>
             <a:ext uri="{C572A759-6A51-4108-AA02-DFA0A04FC94B}">
-              <ma14:wrappingTextBoxFlag xmlns:ma14="http://schemas.microsoft.com/office/mac/drawingml/2011/main" xmlns="" val="0"/>
+              <ma14:wrappingTextBoxFlag xmlns="" xmlns:ma14="http://schemas.microsoft.com/office/mac/drawingml/2011/main" val="0"/>
             </a:ext>
           </a:extLst>
         </p:spPr>
@@ -7044,7 +7051,7 @@
           </a:prstGeom>
           <a:extLst>
             <a:ext uri="{C572A759-6A51-4108-AA02-DFA0A04FC94B}">
-              <ma14:wrappingTextBoxFlag xmlns:ma14="http://schemas.microsoft.com/office/mac/drawingml/2011/main" xmlns="" val="0"/>
+              <ma14:wrappingTextBoxFlag xmlns="" xmlns:ma14="http://schemas.microsoft.com/office/mac/drawingml/2011/main" val="0"/>
             </a:ext>
           </a:extLst>
         </p:spPr>
@@ -8160,7 +8167,7 @@
           </a:prstGeom>
           <a:extLst>
             <a:ext uri="{C572A759-6A51-4108-AA02-DFA0A04FC94B}">
-              <ma14:wrappingTextBoxFlag xmlns:ma14="http://schemas.microsoft.com/office/mac/drawingml/2011/main" xmlns="" val="0"/>
+              <ma14:wrappingTextBoxFlag xmlns="" xmlns:ma14="http://schemas.microsoft.com/office/mac/drawingml/2011/main" val="0"/>
             </a:ext>
           </a:extLst>
         </p:spPr>
@@ -9617,7 +9624,7 @@
           </a:prstGeom>
           <a:extLst>
             <a:ext uri="{C572A759-6A51-4108-AA02-DFA0A04FC94B}">
-              <ma14:wrappingTextBoxFlag xmlns:ma14="http://schemas.microsoft.com/office/mac/drawingml/2011/main" xmlns="" val="0"/>
+              <ma14:wrappingTextBoxFlag xmlns="" xmlns:ma14="http://schemas.microsoft.com/office/mac/drawingml/2011/main" val="0"/>
             </a:ext>
           </a:extLst>
         </p:spPr>
@@ -10634,7 +10641,7 @@
           </a:prstGeom>
           <a:extLst>
             <a:ext uri="{C572A759-6A51-4108-AA02-DFA0A04FC94B}">
-              <ma14:wrappingTextBoxFlag xmlns:ma14="http://schemas.microsoft.com/office/mac/drawingml/2011/main" xmlns="" val="0"/>
+              <ma14:wrappingTextBoxFlag xmlns="" xmlns:ma14="http://schemas.microsoft.com/office/mac/drawingml/2011/main" val="0"/>
             </a:ext>
           </a:extLst>
         </p:spPr>
@@ -11855,7 +11862,7 @@
           </a:prstGeom>
           <a:extLst>
             <a:ext uri="{C572A759-6A51-4108-AA02-DFA0A04FC94B}">
-              <ma14:wrappingTextBoxFlag xmlns:ma14="http://schemas.microsoft.com/office/mac/drawingml/2011/main" xmlns="" val="0"/>
+              <ma14:wrappingTextBoxFlag xmlns="" xmlns:ma14="http://schemas.microsoft.com/office/mac/drawingml/2011/main" val="0"/>
             </a:ext>
           </a:extLst>
         </p:spPr>
@@ -13618,7 +13625,7 @@
           </a:prstGeom>
           <a:extLst>
             <a:ext uri="{C572A759-6A51-4108-AA02-DFA0A04FC94B}">
-              <ma14:wrappingTextBoxFlag xmlns:ma14="http://schemas.microsoft.com/office/mac/drawingml/2011/main" xmlns="" val="0"/>
+              <ma14:wrappingTextBoxFlag xmlns="" xmlns:ma14="http://schemas.microsoft.com/office/mac/drawingml/2011/main" val="0"/>
             </a:ext>
           </a:extLst>
         </p:spPr>
@@ -14949,7 +14956,7 @@
           </a:prstGeom>
           <a:extLst>
             <a:ext uri="{C572A759-6A51-4108-AA02-DFA0A04FC94B}">
-              <ma14:wrappingTextBoxFlag xmlns:ma14="http://schemas.microsoft.com/office/mac/drawingml/2011/main" xmlns="" val="0"/>
+              <ma14:wrappingTextBoxFlag xmlns="" xmlns:ma14="http://schemas.microsoft.com/office/mac/drawingml/2011/main" val="0"/>
             </a:ext>
           </a:extLst>
         </p:spPr>
@@ -16571,7 +16578,7 @@
           </a:prstGeom>
           <a:extLst>
             <a:ext uri="{C572A759-6A51-4108-AA02-DFA0A04FC94B}">
-              <ma14:wrappingTextBoxFlag xmlns:ma14="http://schemas.microsoft.com/office/mac/drawingml/2011/main" xmlns="" val="0"/>
+              <ma14:wrappingTextBoxFlag xmlns="" xmlns:ma14="http://schemas.microsoft.com/office/mac/drawingml/2011/main" val="0"/>
             </a:ext>
           </a:extLst>
         </p:spPr>
@@ -17752,7 +17759,7 @@
           </a:prstGeom>
           <a:extLst>
             <a:ext uri="{C572A759-6A51-4108-AA02-DFA0A04FC94B}">
-              <ma14:wrappingTextBoxFlag xmlns:ma14="http://schemas.microsoft.com/office/mac/drawingml/2011/main" xmlns="" val="0"/>
+              <ma14:wrappingTextBoxFlag xmlns="" xmlns:ma14="http://schemas.microsoft.com/office/mac/drawingml/2011/main" val="0"/>
             </a:ext>
           </a:extLst>
         </p:spPr>
@@ -18944,7 +18951,7 @@
           </a:prstGeom>
           <a:extLst>
             <a:ext uri="{C572A759-6A51-4108-AA02-DFA0A04FC94B}">
-              <ma14:wrappingTextBoxFlag xmlns:ma14="http://schemas.microsoft.com/office/mac/drawingml/2011/main" xmlns="" val="0"/>
+              <ma14:wrappingTextBoxFlag xmlns="" xmlns:ma14="http://schemas.microsoft.com/office/mac/drawingml/2011/main" val="0"/>
             </a:ext>
           </a:extLst>
         </p:spPr>
@@ -20273,7 +20280,7 @@
               <a:buNone/>
             </a:pPr>
             <a:r>
-              <a:rPr lang="en-US" sz="1300" b="1" dirty="0">
+              <a:rPr lang="en-US" sz="1300" b="1">
                 <a:solidFill>
                   <a:srgbClr val="102A43"/>
                 </a:solidFill>
@@ -20281,7 +20288,7 @@
                 <a:ea typeface="Aptos Display" pitchFamily="34" charset="-122"/>
                 <a:cs typeface="Aptos Display" pitchFamily="34" charset="-120"/>
               </a:rPr>
-              <a:t>Agent experience</a:t>
+              <a:t>Agent experiences</a:t>
             </a:r>
             <a:endParaRPr lang="en-US" sz="1300" dirty="0"/>
           </a:p>
@@ -20916,8 +20923,8 @@
         </p:nvSpPr>
         <p:spPr>
           <a:xfrm>
-            <a:off x="4407408" y="4224528"/>
-            <a:ext cx="2926080" cy="1042416"/>
+            <a:off x="4508500" y="4224528"/>
+            <a:ext cx="2794000" cy="1042416"/>
           </a:xfrm>
           <a:prstGeom prst="roundRect">
             <a:avLst/>
@@ -20962,7 +20969,7 @@
         </p:blipFill>
         <p:spPr>
           <a:xfrm>
-            <a:off x="4645152" y="4480560"/>
+            <a:off x="4747260" y="4480560"/>
             <a:ext cx="347472" cy="347472"/>
           </a:xfrm>
           <a:prstGeom prst="rect">
@@ -20978,8 +20985,8 @@
         </p:nvSpPr>
         <p:spPr>
           <a:xfrm>
-            <a:off x="5120640" y="4370832"/>
-            <a:ext cx="1938528" cy="228600"/>
+            <a:off x="5207000" y="4370832"/>
+            <a:ext cx="1905000" cy="228600"/>
           </a:xfrm>
           <a:prstGeom prst="rect">
             <a:avLst/>
@@ -20995,7 +21002,7 @@
               <a:buNone/>
             </a:pPr>
             <a:r>
-              <a:rPr lang="en-US" sz="1400" b="1" dirty="0">
+              <a:rPr lang="en-US" sz="1400" b="1">
                 <a:solidFill>
                   <a:srgbClr val="FFFFFF"/>
                 </a:solidFill>
@@ -21003,7 +21010,7 @@
                 <a:ea typeface="Aptos Display" pitchFamily="34" charset="-122"/>
                 <a:cs typeface="Aptos Display" pitchFamily="34" charset="-120"/>
               </a:rPr>
-              <a:t>Policies and approvals</a:t>
+              <a:t>Policies and controls</a:t>
             </a:r>
             <a:endParaRPr lang="en-US" sz="1400" dirty="0"/>
           </a:p>
@@ -21017,8 +21024,8 @@
         </p:nvSpPr>
         <p:spPr>
           <a:xfrm>
-            <a:off x="5120640" y="4645152"/>
-            <a:ext cx="1901952" cy="393192"/>
+            <a:off x="5207000" y="4645152"/>
+            <a:ext cx="1841500" cy="393192"/>
           </a:xfrm>
           <a:prstGeom prst="rect">
             <a:avLst/>
@@ -21028,7 +21035,7 @@
         </p:spPr>
         <p:txBody>
           <a:bodyPr wrap="square" lIns="0" tIns="0" rIns="0" bIns="0" rtlCol="0" anchor="ctr">
-            <a:normAutofit lnSpcReduction="10000"/>
+            <a:normAutofit/>
           </a:bodyPr>
           <a:lstStyle/>
           <a:p>
@@ -21036,7 +21043,7 @@
               <a:buNone/>
             </a:pPr>
             <a:r>
-              <a:rPr lang="en-US" sz="870" dirty="0">
+              <a:rPr lang="en-US" sz="870">
                 <a:solidFill>
                   <a:srgbClr val="DDEAF2"/>
                 </a:solidFill>
@@ -21044,7 +21051,7 @@
                 <a:ea typeface="Aptos" pitchFamily="34" charset="-122"/>
                 <a:cs typeface="Aptos" pitchFamily="34" charset="-120"/>
               </a:rPr>
-              <a:t>Authentication, rate limits, correlation, tracing, logging, and state-change consent</a:t>
+              <a:t>Authentication, rate limits, correlation, tracing, logging, and request controls</a:t>
             </a:r>
             <a:endParaRPr lang="en-US" sz="870" dirty="0"/>
           </a:p>
@@ -21211,7 +21218,7 @@
               <a:buNone/>
             </a:pPr>
             <a:r>
-              <a:rPr lang="en-US" sz="870" dirty="0">
+              <a:rPr lang="en-US" sz="870">
                 <a:solidFill>
                   <a:srgbClr val="4F6474"/>
                 </a:solidFill>
@@ -21219,40 +21226,9 @@
                 <a:ea typeface="Aptos" pitchFamily="34" charset="-122"/>
                 <a:cs typeface="Aptos" pitchFamily="34" charset="-120"/>
               </a:rPr>
-              <a:t>Latency, failures, usage, request correlation, and audit evidence</a:t>
+              <a:t>Latency, failures, usage, correlation, and audit evidence</a:t>
             </a:r>
             <a:endParaRPr lang="en-US" sz="870" dirty="0"/>
-          </a:p>
-        </p:txBody>
-      </p:sp>
-      <p:sp>
-        <p:nvSpPr>
-          <p:cNvPr id="43" name="Shape 34"/>
-          <p:cNvSpPr/>
-          <p:nvPr/>
-        </p:nvSpPr>
-        <p:spPr>
-          <a:xfrm>
-            <a:off x="6858000" y="3749040"/>
-            <a:ext cx="1691640" cy="475488"/>
-          </a:xfrm>
-          <a:prstGeom prst="line">
-            <a:avLst/>
-          </a:prstGeom>
-          <a:noFill/>
-          <a:ln w="19050">
-            <a:solidFill>
-              <a:srgbClr val="FF7A59"/>
-            </a:solidFill>
-            <a:prstDash val="solid"/>
-            <a:tailEnd type="triangle"/>
-          </a:ln>
-        </p:spPr>
-        <p:txBody>
-          <a:bodyPr/>
-          <a:lstStyle/>
-          <a:p>
-            <a:endParaRPr lang="en-US"/>
           </a:p>
         </p:txBody>
       </p:sp>
@@ -21315,7 +21291,7 @@
           </a:prstGeom>
           <a:extLst>
             <a:ext uri="{C572A759-6A51-4108-AA02-DFA0A04FC94B}">
-              <ma14:wrappingTextBoxFlag xmlns:ma14="http://schemas.microsoft.com/office/mac/drawingml/2011/main" xmlns="" val="0"/>
+              <ma14:wrappingTextBoxFlag xmlns="" xmlns:ma14="http://schemas.microsoft.com/office/mac/drawingml/2011/main" val="0"/>
             </a:ext>
           </a:extLst>
         </p:spPr>
@@ -21451,6 +21427,625 @@
           </a:prstGeom>
         </p:spPr>
       </p:pic>
+      <p:sp>
+        <p:nvSpPr>
+          <p:cNvPr id="12" name="Agent Harness Card">
+            <a:extLst>
+              <a:ext uri="{FF2B5EF4-FFF2-40B4-BE49-F238E27FC236}">
+                <a16:creationId xmlns:a16="http://schemas.microsoft.com/office/drawing/2014/main" id="{2D1F02D2-9A27-7A2A-2BB1-F5E543FDCC2D}"/>
+              </a:ext>
+            </a:extLst>
+          </p:cNvPr>
+          <p:cNvSpPr/>
+          <p:nvPr/>
+        </p:nvSpPr>
+        <p:spPr>
+          <a:xfrm>
+            <a:off x="2514600" y="4224020"/>
+            <a:ext cx="1778000" cy="1042670"/>
+          </a:xfrm>
+          <a:prstGeom prst="roundRect">
+            <a:avLst/>
+          </a:prstGeom>
+          <a:solidFill>
+            <a:srgbClr val="FFFFFF"/>
+          </a:solidFill>
+          <a:ln w="19050">
+            <a:solidFill>
+              <a:srgbClr val="775DA6"/>
+            </a:solidFill>
+            <a:prstDash val="solid"/>
+          </a:ln>
+          <a:effectLst>
+            <a:outerShdw blurRad="25400" dist="50800" dir="2700000" algn="bl" rotWithShape="0">
+              <a:srgbClr val="102A43">
+                <a:alpha val="14000"/>
+              </a:srgbClr>
+            </a:outerShdw>
+          </a:effectLst>
+        </p:spPr>
+        <p:txBody>
+          <a:bodyPr/>
+          <a:lstStyle/>
+          <a:p>
+            <a:endParaRPr lang="en-US"/>
+          </a:p>
+        </p:txBody>
+      </p:sp>
+      <p:sp>
+        <p:nvSpPr>
+          <p:cNvPr id="18" name="Agent Harness Title">
+            <a:extLst>
+              <a:ext uri="{FF2B5EF4-FFF2-40B4-BE49-F238E27FC236}">
+                <a16:creationId xmlns:a16="http://schemas.microsoft.com/office/drawing/2014/main" id="{3C479378-2A10-F852-4225-DD925EF41B3A}"/>
+              </a:ext>
+            </a:extLst>
+          </p:cNvPr>
+          <p:cNvSpPr/>
+          <p:nvPr/>
+        </p:nvSpPr>
+        <p:spPr>
+          <a:xfrm>
+            <a:off x="2628900" y="4371340"/>
+            <a:ext cx="1549400" cy="228600"/>
+          </a:xfrm>
+          <a:prstGeom prst="rect">
+            <a:avLst/>
+          </a:prstGeom>
+          <a:noFill/>
+          <a:ln/>
+        </p:spPr>
+        <p:txBody>
+          <a:bodyPr wrap="square" lIns="0" tIns="0" rIns="0" bIns="0" rtlCol="0" anchor="ctr">
+            <a:normAutofit/>
+          </a:bodyPr>
+          <a:lstStyle/>
+          <a:p>
+            <a:pPr marL="0" indent="0" algn="ctr">
+              <a:buNone/>
+            </a:pPr>
+            <a:r>
+              <a:rPr lang="en-US" sz="1400" b="1">
+                <a:solidFill>
+                  <a:srgbClr val="102A43"/>
+                </a:solidFill>
+                <a:latin typeface="Aptos Display" pitchFamily="34" charset="0"/>
+                <a:ea typeface="Aptos Display" pitchFamily="34" charset="-122"/>
+                <a:cs typeface="Aptos Display" pitchFamily="34" charset="-120"/>
+              </a:rPr>
+              <a:t>Agent harness</a:t>
+            </a:r>
+            <a:endParaRPr lang="en-US" sz="1400" dirty="0"/>
+          </a:p>
+        </p:txBody>
+      </p:sp>
+      <p:sp>
+        <p:nvSpPr>
+          <p:cNvPr id="19" name="Agent Harness Body">
+            <a:extLst>
+              <a:ext uri="{FF2B5EF4-FFF2-40B4-BE49-F238E27FC236}">
+                <a16:creationId xmlns:a16="http://schemas.microsoft.com/office/drawing/2014/main" id="{EC528A1A-0704-0B47-3016-5C26AF458388}"/>
+              </a:ext>
+            </a:extLst>
+          </p:cNvPr>
+          <p:cNvSpPr/>
+          <p:nvPr/>
+        </p:nvSpPr>
+        <p:spPr>
+          <a:xfrm>
+            <a:off x="2628900" y="4660900"/>
+            <a:ext cx="1549400" cy="381000"/>
+          </a:xfrm>
+          <a:prstGeom prst="rect">
+            <a:avLst/>
+          </a:prstGeom>
+          <a:noFill/>
+          <a:ln/>
+        </p:spPr>
+        <p:txBody>
+          <a:bodyPr wrap="square" lIns="0" tIns="0" rIns="0" bIns="0" rtlCol="0" anchor="ctr">
+            <a:normAutofit/>
+          </a:bodyPr>
+          <a:lstStyle/>
+          <a:p>
+            <a:pPr marL="0" indent="0" algn="ctr">
+              <a:buNone/>
+            </a:pPr>
+            <a:r>
+              <a:rPr lang="en-US" sz="1050">
+                <a:solidFill>
+                  <a:srgbClr val="4F6474"/>
+                </a:solidFill>
+                <a:latin typeface="Aptos" pitchFamily="34" charset="0"/>
+                <a:ea typeface="Aptos" pitchFamily="34" charset="-122"/>
+                <a:cs typeface="Aptos" pitchFamily="34" charset="-120"/>
+              </a:rPr>
+              <a:t>Tool selection and</a:t>
+            </a:r>
+          </a:p>
+          <a:p>
+            <a:pPr marL="0" indent="0" algn="ctr">
+              <a:buNone/>
+            </a:pPr>
+            <a:r>
+              <a:rPr lang="en-US" sz="1050">
+                <a:solidFill>
+                  <a:srgbClr val="4F6474"/>
+                </a:solidFill>
+                <a:latin typeface="Aptos" pitchFamily="34" charset="0"/>
+                <a:ea typeface="Aptos" pitchFamily="34" charset="-122"/>
+                <a:cs typeface="Aptos" pitchFamily="34" charset="-120"/>
+              </a:rPr>
+              <a:t>approvals</a:t>
+            </a:r>
+            <a:endParaRPr lang="en-US" sz="1050" dirty="0"/>
+          </a:p>
+        </p:txBody>
+      </p:sp>
+      <p:cxnSp>
+        <p:nvCxnSpPr>
+          <p:cNvPr id="46" name="Agent Harness Arrow">
+            <a:extLst>
+              <a:ext uri="{FF2B5EF4-FFF2-40B4-BE49-F238E27FC236}">
+                <a16:creationId xmlns:a16="http://schemas.microsoft.com/office/drawing/2014/main" id="{FA9AC0A2-7565-7D1E-0A0D-62DBEE29D9D4}"/>
+              </a:ext>
+            </a:extLst>
+          </p:cNvPr>
+          <p:cNvCxnSpPr/>
+          <p:nvPr/>
+        </p:nvCxnSpPr>
+        <p:spPr>
+          <a:xfrm>
+            <a:off x="3483610" y="3752850"/>
+            <a:ext cx="0" cy="471170"/>
+          </a:xfrm>
+          <a:prstGeom prst="line">
+            <a:avLst/>
+          </a:prstGeom>
+          <a:ln w="19050">
+            <a:solidFill>
+              <a:srgbClr val="775DA6"/>
+            </a:solidFill>
+            <a:tailEnd type="arrow"/>
+          </a:ln>
+        </p:spPr>
+        <p:style>
+          <a:lnRef idx="1">
+            <a:schemeClr val="accent1"/>
+          </a:lnRef>
+          <a:fillRef idx="0">
+            <a:schemeClr val="accent1"/>
+          </a:fillRef>
+          <a:effectRef idx="0">
+            <a:schemeClr val="accent1"/>
+          </a:effectRef>
+          <a:fontRef idx="minor">
+            <a:schemeClr val="tx1"/>
+          </a:fontRef>
+        </p:style>
+      </p:cxnSp>
+      <p:cxnSp>
+        <p:nvCxnSpPr>
+          <p:cNvPr id="47" name="Agent Telemetry Down">
+            <a:extLst>
+              <a:ext uri="{FF2B5EF4-FFF2-40B4-BE49-F238E27FC236}">
+                <a16:creationId xmlns:a16="http://schemas.microsoft.com/office/drawing/2014/main" id="{321ED40C-19D4-6A16-C32E-AF1686FFF715}"/>
+              </a:ext>
+            </a:extLst>
+          </p:cNvPr>
+          <p:cNvCxnSpPr/>
+          <p:nvPr/>
+        </p:nvCxnSpPr>
+        <p:spPr>
+          <a:xfrm>
+            <a:off x="3403600" y="5266690"/>
+            <a:ext cx="0" cy="321310"/>
+          </a:xfrm>
+          <a:prstGeom prst="line">
+            <a:avLst/>
+          </a:prstGeom>
+          <a:ln w="17780">
+            <a:solidFill>
+              <a:srgbClr val="775DA6"/>
+            </a:solidFill>
+            <a:prstDash val="dash"/>
+          </a:ln>
+        </p:spPr>
+        <p:style>
+          <a:lnRef idx="1">
+            <a:schemeClr val="accent1"/>
+          </a:lnRef>
+          <a:fillRef idx="0">
+            <a:schemeClr val="accent1"/>
+          </a:fillRef>
+          <a:effectRef idx="0">
+            <a:schemeClr val="accent1"/>
+          </a:effectRef>
+          <a:fontRef idx="minor">
+            <a:schemeClr val="tx1"/>
+          </a:fontRef>
+        </p:style>
+      </p:cxnSp>
+      <p:cxnSp>
+        <p:nvCxnSpPr>
+          <p:cNvPr id="48" name="Agent Telemetry Across">
+            <a:extLst>
+              <a:ext uri="{FF2B5EF4-FFF2-40B4-BE49-F238E27FC236}">
+                <a16:creationId xmlns:a16="http://schemas.microsoft.com/office/drawing/2014/main" id="{C2DB856A-B82E-D8EF-9F9A-3DC496E0ED9C}"/>
+              </a:ext>
+            </a:extLst>
+          </p:cNvPr>
+          <p:cNvCxnSpPr/>
+          <p:nvPr/>
+        </p:nvCxnSpPr>
+        <p:spPr>
+          <a:xfrm>
+            <a:off x="3403600" y="5588000"/>
+            <a:ext cx="5715000" cy="0"/>
+          </a:xfrm>
+          <a:prstGeom prst="line">
+            <a:avLst/>
+          </a:prstGeom>
+          <a:ln w="17780">
+            <a:solidFill>
+              <a:srgbClr val="775DA6"/>
+            </a:solidFill>
+            <a:prstDash val="dash"/>
+          </a:ln>
+        </p:spPr>
+        <p:style>
+          <a:lnRef idx="1">
+            <a:schemeClr val="accent1"/>
+          </a:lnRef>
+          <a:fillRef idx="0">
+            <a:schemeClr val="accent1"/>
+          </a:fillRef>
+          <a:effectRef idx="0">
+            <a:schemeClr val="accent1"/>
+          </a:effectRef>
+          <a:fontRef idx="minor">
+            <a:schemeClr val="tx1"/>
+          </a:fontRef>
+        </p:style>
+      </p:cxnSp>
+      <p:cxnSp>
+        <p:nvCxnSpPr>
+          <p:cNvPr id="50" name="Agent Telemetry Up">
+            <a:extLst>
+              <a:ext uri="{FF2B5EF4-FFF2-40B4-BE49-F238E27FC236}">
+                <a16:creationId xmlns:a16="http://schemas.microsoft.com/office/drawing/2014/main" id="{8F88F55E-16F6-0D19-7A4C-209702CA3521}"/>
+              </a:ext>
+            </a:extLst>
+          </p:cNvPr>
+          <p:cNvCxnSpPr/>
+          <p:nvPr/>
+        </p:nvCxnSpPr>
+        <p:spPr>
+          <a:xfrm flipV="1">
+            <a:off x="9118600" y="5266690"/>
+            <a:ext cx="0" cy="321310"/>
+          </a:xfrm>
+          <a:prstGeom prst="line">
+            <a:avLst/>
+          </a:prstGeom>
+          <a:ln w="17780">
+            <a:solidFill>
+              <a:srgbClr val="775DA6"/>
+            </a:solidFill>
+            <a:prstDash val="dash"/>
+            <a:tailEnd type="arrow"/>
+          </a:ln>
+        </p:spPr>
+        <p:style>
+          <a:lnRef idx="1">
+            <a:schemeClr val="accent1"/>
+          </a:lnRef>
+          <a:fillRef idx="0">
+            <a:schemeClr val="accent1"/>
+          </a:fillRef>
+          <a:effectRef idx="0">
+            <a:schemeClr val="accent1"/>
+          </a:effectRef>
+          <a:fontRef idx="minor">
+            <a:schemeClr val="tx1"/>
+          </a:fontRef>
+        </p:style>
+      </p:cxnSp>
+      <p:sp>
+        <p:nvSpPr>
+          <p:cNvPr id="52" name="Agent Telemetry Label">
+            <a:extLst>
+              <a:ext uri="{FF2B5EF4-FFF2-40B4-BE49-F238E27FC236}">
+                <a16:creationId xmlns:a16="http://schemas.microsoft.com/office/drawing/2014/main" id="{416A440F-3289-2310-7139-65D5B9CD4ED9}"/>
+              </a:ext>
+            </a:extLst>
+          </p:cNvPr>
+          <p:cNvSpPr txBox="1"/>
+          <p:nvPr/>
+        </p:nvSpPr>
+        <p:spPr>
+          <a:xfrm>
+            <a:off x="5308600" y="5384800"/>
+            <a:ext cx="1333500" cy="138499"/>
+          </a:xfrm>
+          <a:prstGeom prst="rect">
+            <a:avLst/>
+          </a:prstGeom>
+          <a:noFill/>
+        </p:spPr>
+        <p:txBody>
+          <a:bodyPr vert="horz" lIns="0" tIns="0" rIns="0" bIns="0" rtlCol="0">
+            <a:spAutoFit/>
+          </a:bodyPr>
+          <a:lstStyle/>
+          <a:p>
+            <a:r>
+              <a:rPr lang="en-US" sz="900" b="1">
+                <a:solidFill>
+                  <a:srgbClr val="775DA6"/>
+                </a:solidFill>
+                <a:latin typeface="Aptos" panose="020B0004020202020204" pitchFamily="34" charset="0"/>
+              </a:rPr>
+              <a:t>Agent telemetry</a:t>
+            </a:r>
+          </a:p>
+        </p:txBody>
+      </p:sp>
+      <p:sp>
+        <p:nvSpPr>
+          <p:cNvPr id="53" name="Agent 365 Badge">
+            <a:extLst>
+              <a:ext uri="{FF2B5EF4-FFF2-40B4-BE49-F238E27FC236}">
+                <a16:creationId xmlns:a16="http://schemas.microsoft.com/office/drawing/2014/main" id="{020CD871-57B2-8109-AB9B-98269BA65176}"/>
+              </a:ext>
+            </a:extLst>
+          </p:cNvPr>
+          <p:cNvSpPr/>
+          <p:nvPr/>
+        </p:nvSpPr>
+        <p:spPr>
+          <a:xfrm>
+            <a:off x="2514600" y="1587500"/>
+            <a:ext cx="1938020" cy="355600"/>
+          </a:xfrm>
+          <a:prstGeom prst="roundRect">
+            <a:avLst/>
+          </a:prstGeom>
+          <a:solidFill>
+            <a:srgbClr val="FFFFFF"/>
+          </a:solidFill>
+          <a:ln w="15240">
+            <a:solidFill>
+              <a:srgbClr val="775DA6"/>
+            </a:solidFill>
+          </a:ln>
+        </p:spPr>
+        <p:style>
+          <a:lnRef idx="2">
+            <a:schemeClr val="accent1">
+              <a:shade val="15000"/>
+            </a:schemeClr>
+          </a:lnRef>
+          <a:fillRef idx="1">
+            <a:schemeClr val="accent1"/>
+          </a:fillRef>
+          <a:effectRef idx="0">
+            <a:schemeClr val="accent1"/>
+          </a:effectRef>
+          <a:fontRef idx="minor">
+            <a:schemeClr val="lt1"/>
+          </a:fontRef>
+        </p:style>
+        <p:txBody>
+          <a:bodyPr rtlCol="0" anchor="ctr"/>
+          <a:lstStyle/>
+          <a:p>
+            <a:pPr algn="ctr"/>
+            <a:endParaRPr lang="en-US"/>
+          </a:p>
+        </p:txBody>
+      </p:sp>
+      <p:pic>
+        <p:nvPicPr>
+          <p:cNvPr id="55" name="Agent 365 Icon" descr="Microsoft Agent 365 logo">
+            <a:extLst>
+              <a:ext uri="{FF2B5EF4-FFF2-40B4-BE49-F238E27FC236}">
+                <a16:creationId xmlns:a16="http://schemas.microsoft.com/office/drawing/2014/main" id="{0E01942D-C819-6E73-4C24-976FDCFB9D6F}"/>
+              </a:ext>
+            </a:extLst>
+          </p:cNvPr>
+          <p:cNvPicPr>
+            <a:picLocks/>
+          </p:cNvPicPr>
+          <p:nvPr/>
+        </p:nvPicPr>
+        <p:blipFill>
+          <a:blip>
+            <a:extLst>
+              <a:ext uri="{96DAC541-7B7A-43D3-8B79-37D633B846F1}">
+                <asvg:svgBlip xmlns:asvg="http://schemas.microsoft.com/office/drawing/2016/SVG/main" r:embed="rId11"/>
+              </a:ext>
+            </a:extLst>
+          </a:blip>
+          <a:stretch>
+            <a:fillRect/>
+          </a:stretch>
+        </p:blipFill>
+        <p:spPr>
+          <a:xfrm>
+            <a:off x="2628900" y="1651000"/>
+            <a:ext cx="228600" cy="228600"/>
+          </a:xfrm>
+          <a:prstGeom prst="rect">
+            <a:avLst/>
+          </a:prstGeom>
+        </p:spPr>
+      </p:pic>
+      <p:sp>
+        <p:nvSpPr>
+          <p:cNvPr id="56" name="Agent 365 Title">
+            <a:extLst>
+              <a:ext uri="{FF2B5EF4-FFF2-40B4-BE49-F238E27FC236}">
+                <a16:creationId xmlns:a16="http://schemas.microsoft.com/office/drawing/2014/main" id="{D56BD24A-C115-90CB-34D8-507DA2801959}"/>
+              </a:ext>
+            </a:extLst>
+          </p:cNvPr>
+          <p:cNvSpPr txBox="1"/>
+          <p:nvPr/>
+        </p:nvSpPr>
+        <p:spPr>
+          <a:xfrm>
+            <a:off x="2933700" y="1619250"/>
+            <a:ext cx="1422400" cy="146194"/>
+          </a:xfrm>
+          <a:prstGeom prst="rect">
+            <a:avLst/>
+          </a:prstGeom>
+          <a:noFill/>
+        </p:spPr>
+        <p:txBody>
+          <a:bodyPr vert="horz" lIns="0" tIns="0" rIns="0" bIns="0" rtlCol="0">
+            <a:spAutoFit/>
+          </a:bodyPr>
+          <a:lstStyle/>
+          <a:p>
+            <a:r>
+              <a:rPr lang="en-US" sz="950" b="1">
+                <a:solidFill>
+                  <a:srgbClr val="102A43"/>
+                </a:solidFill>
+                <a:latin typeface="Aptos" panose="020B0004020202020204" pitchFamily="34" charset="0"/>
+              </a:rPr>
+              <a:t>Microsoft Agent 365</a:t>
+            </a:r>
+          </a:p>
+        </p:txBody>
+      </p:sp>
+      <p:sp>
+        <p:nvSpPr>
+          <p:cNvPr id="57" name="Agent 365 Subtitle">
+            <a:extLst>
+              <a:ext uri="{FF2B5EF4-FFF2-40B4-BE49-F238E27FC236}">
+                <a16:creationId xmlns:a16="http://schemas.microsoft.com/office/drawing/2014/main" id="{A60B4BAF-6633-7728-5907-FDA6E77638D7}"/>
+              </a:ext>
+            </a:extLst>
+          </p:cNvPr>
+          <p:cNvSpPr txBox="1"/>
+          <p:nvPr/>
+        </p:nvSpPr>
+        <p:spPr>
+          <a:xfrm>
+            <a:off x="2933700" y="1784350"/>
+            <a:ext cx="1422400" cy="115416"/>
+          </a:xfrm>
+          <a:prstGeom prst="rect">
+            <a:avLst/>
+          </a:prstGeom>
+          <a:noFill/>
+        </p:spPr>
+        <p:txBody>
+          <a:bodyPr vert="horz" lIns="0" tIns="0" rIns="0" bIns="0" rtlCol="0">
+            <a:spAutoFit/>
+          </a:bodyPr>
+          <a:lstStyle/>
+          <a:p>
+            <a:r>
+              <a:rPr lang="en-US" sz="750">
+                <a:solidFill>
+                  <a:srgbClr val="526980"/>
+                </a:solidFill>
+                <a:latin typeface="Aptos" panose="020B0004020202020204" pitchFamily="34" charset="0"/>
+              </a:rPr>
+              <a:t>Governance plane</a:t>
+            </a:r>
+          </a:p>
+        </p:txBody>
+      </p:sp>
+      <p:cxnSp>
+        <p:nvCxnSpPr>
+          <p:cNvPr id="58" name="Agent 365 Connector">
+            <a:extLst>
+              <a:ext uri="{FF2B5EF4-FFF2-40B4-BE49-F238E27FC236}">
+                <a16:creationId xmlns:a16="http://schemas.microsoft.com/office/drawing/2014/main" id="{D736F929-2089-7C86-D8F3-2E549E293323}"/>
+              </a:ext>
+            </a:extLst>
+          </p:cNvPr>
+          <p:cNvCxnSpPr/>
+          <p:nvPr/>
+        </p:nvCxnSpPr>
+        <p:spPr>
+          <a:xfrm>
+            <a:off x="3483610" y="1943100"/>
+            <a:ext cx="0" cy="160020"/>
+          </a:xfrm>
+          <a:prstGeom prst="line">
+            <a:avLst/>
+          </a:prstGeom>
+          <a:ln w="15240">
+            <a:solidFill>
+              <a:srgbClr val="775DA6"/>
+            </a:solidFill>
+            <a:prstDash val="dash"/>
+            <a:tailEnd type="arrow"/>
+          </a:ln>
+        </p:spPr>
+        <p:style>
+          <a:lnRef idx="1">
+            <a:schemeClr val="accent1"/>
+          </a:lnRef>
+          <a:fillRef idx="0">
+            <a:schemeClr val="accent1"/>
+          </a:fillRef>
+          <a:effectRef idx="0">
+            <a:schemeClr val="accent1"/>
+          </a:effectRef>
+          <a:fontRef idx="minor">
+            <a:schemeClr val="tx1"/>
+          </a:fontRef>
+        </p:style>
+      </p:cxnSp>
+      <p:cxnSp>
+        <p:nvCxnSpPr>
+          <p:cNvPr id="59" name="APIM Telemetry Arrow">
+            <a:extLst>
+              <a:ext uri="{FF2B5EF4-FFF2-40B4-BE49-F238E27FC236}">
+                <a16:creationId xmlns:a16="http://schemas.microsoft.com/office/drawing/2014/main" id="{A488F9CD-B0E1-A76B-B990-6CA08965FDE4}"/>
+              </a:ext>
+            </a:extLst>
+          </p:cNvPr>
+          <p:cNvCxnSpPr/>
+          <p:nvPr/>
+        </p:nvCxnSpPr>
+        <p:spPr>
+          <a:xfrm>
+            <a:off x="6604000" y="3703320"/>
+            <a:ext cx="1968500" cy="520700"/>
+          </a:xfrm>
+          <a:prstGeom prst="line">
+            <a:avLst/>
+          </a:prstGeom>
+          <a:ln w="19050">
+            <a:solidFill>
+              <a:srgbClr val="FF7A59"/>
+            </a:solidFill>
+            <a:tailEnd type="arrow"/>
+          </a:ln>
+        </p:spPr>
+        <p:style>
+          <a:lnRef idx="1">
+            <a:schemeClr val="accent1"/>
+          </a:lnRef>
+          <a:fillRef idx="0">
+            <a:schemeClr val="accent1"/>
+          </a:fillRef>
+          <a:effectRef idx="0">
+            <a:schemeClr val="accent1"/>
+          </a:effectRef>
+          <a:fontRef idx="minor">
+            <a:schemeClr val="tx1"/>
+          </a:fontRef>
+        </p:style>
+      </p:cxnSp>
     </p:spTree>
   </p:cSld>
   <p:clrMapOvr>
@@ -23948,7 +24543,7 @@
           </a:prstGeom>
           <a:extLst>
             <a:ext uri="{C572A759-6A51-4108-AA02-DFA0A04FC94B}">
-              <ma14:wrappingTextBoxFlag xmlns:ma14="http://schemas.microsoft.com/office/mac/drawingml/2011/main" xmlns="" val="0"/>
+              <ma14:wrappingTextBoxFlag xmlns="" xmlns:ma14="http://schemas.microsoft.com/office/mac/drawingml/2011/main" val="0"/>
             </a:ext>
           </a:extLst>
         </p:spPr>
@@ -25036,7 +25631,7 @@
           </a:prstGeom>
           <a:extLst>
             <a:ext uri="{C572A759-6A51-4108-AA02-DFA0A04FC94B}">
-              <ma14:wrappingTextBoxFlag xmlns:ma14="http://schemas.microsoft.com/office/mac/drawingml/2011/main" xmlns="" val="0"/>
+              <ma14:wrappingTextBoxFlag xmlns="" xmlns:ma14="http://schemas.microsoft.com/office/mac/drawingml/2011/main" val="0"/>
             </a:ext>
           </a:extLst>
         </p:spPr>
@@ -26191,7 +26786,7 @@
           </a:prstGeom>
           <a:extLst>
             <a:ext uri="{C572A759-6A51-4108-AA02-DFA0A04FC94B}">
-              <ma14:wrappingTextBoxFlag xmlns:ma14="http://schemas.microsoft.com/office/mac/drawingml/2011/main" xmlns="" val="0"/>
+              <ma14:wrappingTextBoxFlag xmlns="" xmlns:ma14="http://schemas.microsoft.com/office/mac/drawingml/2011/main" val="0"/>
             </a:ext>
           </a:extLst>
         </p:spPr>
@@ -27602,7 +28197,7 @@
           </a:prstGeom>
           <a:extLst>
             <a:ext uri="{C572A759-6A51-4108-AA02-DFA0A04FC94B}">
-              <ma14:wrappingTextBoxFlag xmlns:ma14="http://schemas.microsoft.com/office/mac/drawingml/2011/main" xmlns="" val="0"/>
+              <ma14:wrappingTextBoxFlag xmlns="" xmlns:ma14="http://schemas.microsoft.com/office/mac/drawingml/2011/main" val="0"/>
             </a:ext>
           </a:extLst>
         </p:spPr>
@@ -28589,7 +29184,7 @@
           </a:prstGeom>
           <a:extLst>
             <a:ext uri="{C572A759-6A51-4108-AA02-DFA0A04FC94B}">
-              <ma14:wrappingTextBoxFlag xmlns:ma14="http://schemas.microsoft.com/office/mac/drawingml/2011/main" xmlns="" val="0"/>
+              <ma14:wrappingTextBoxFlag xmlns="" xmlns:ma14="http://schemas.microsoft.com/office/mac/drawingml/2011/main" val="0"/>
             </a:ext>
           </a:extLst>
         </p:spPr>
@@ -29977,7 +30572,7 @@
           </a:prstGeom>
           <a:extLst>
             <a:ext uri="{C572A759-6A51-4108-AA02-DFA0A04FC94B}">
-              <ma14:wrappingTextBoxFlag xmlns:ma14="http://schemas.microsoft.com/office/mac/drawingml/2011/main" xmlns="" val="0"/>
+              <ma14:wrappingTextBoxFlag xmlns="" xmlns:ma14="http://schemas.microsoft.com/office/mac/drawingml/2011/main" val="0"/>
             </a:ext>
           </a:extLst>
         </p:spPr>

</xml_diff>

<commit_message>
Simplify slide 3 governance layers
Rename the agent runtime to Agent Harness, move APIM policies into an APIM Control Plane, and consolidate agent and gateway telemetry into one Application Insights observability layer. Use the APIM, MCP, and Application Insights product icons in their corresponding layers.

Co-authored-by: Copilot <223556219+Copilot@users.noreply.github.com>
Copilot-Session: aa1a2148-b4d0-4cc5-94ea-497594b4b72a
</commit_message>
<xml_diff>
--- a/docs/foundry-apim-mcp-workshop.pptx
+++ b/docs/foundry-apim-mcp-workshop.pptx
@@ -2194,7 +2194,7 @@
           </a:prstGeom>
           <a:extLst>
             <a:ext uri="{C572A759-6A51-4108-AA02-DFA0A04FC94B}">
-              <ma14:wrappingTextBoxFlag xmlns="" xmlns:ma14="http://schemas.microsoft.com/office/mac/drawingml/2011/main" val="0"/>
+              <ma14:wrappingTextBoxFlag xmlns:ma14="http://schemas.microsoft.com/office/mac/drawingml/2011/main" xmlns="" val="0"/>
             </a:ext>
           </a:extLst>
         </p:spPr>
@@ -2272,7 +2272,7 @@
           </a:prstGeom>
           <a:extLst>
             <a:ext uri="{C572A759-6A51-4108-AA02-DFA0A04FC94B}">
-              <ma14:wrappingTextBoxFlag xmlns="" xmlns:ma14="http://schemas.microsoft.com/office/mac/drawingml/2011/main" val="0"/>
+              <ma14:wrappingTextBoxFlag xmlns:ma14="http://schemas.microsoft.com/office/mac/drawingml/2011/main" xmlns="" val="0"/>
             </a:ext>
           </a:extLst>
         </p:spPr>
@@ -4877,7 +4877,7 @@
           </a:prstGeom>
           <a:extLst>
             <a:ext uri="{C572A759-6A51-4108-AA02-DFA0A04FC94B}">
-              <ma14:wrappingTextBoxFlag xmlns="" xmlns:ma14="http://schemas.microsoft.com/office/mac/drawingml/2011/main" val="0"/>
+              <ma14:wrappingTextBoxFlag xmlns:ma14="http://schemas.microsoft.com/office/mac/drawingml/2011/main" xmlns="" val="0"/>
             </a:ext>
           </a:extLst>
         </p:spPr>
@@ -5835,7 +5835,7 @@
           </a:prstGeom>
           <a:extLst>
             <a:ext uri="{C572A759-6A51-4108-AA02-DFA0A04FC94B}">
-              <ma14:wrappingTextBoxFlag xmlns="" xmlns:ma14="http://schemas.microsoft.com/office/mac/drawingml/2011/main" val="0"/>
+              <ma14:wrappingTextBoxFlag xmlns:ma14="http://schemas.microsoft.com/office/mac/drawingml/2011/main" xmlns="" val="0"/>
             </a:ext>
           </a:extLst>
         </p:spPr>
@@ -7051,7 +7051,7 @@
           </a:prstGeom>
           <a:extLst>
             <a:ext uri="{C572A759-6A51-4108-AA02-DFA0A04FC94B}">
-              <ma14:wrappingTextBoxFlag xmlns="" xmlns:ma14="http://schemas.microsoft.com/office/mac/drawingml/2011/main" val="0"/>
+              <ma14:wrappingTextBoxFlag xmlns:ma14="http://schemas.microsoft.com/office/mac/drawingml/2011/main" xmlns="" val="0"/>
             </a:ext>
           </a:extLst>
         </p:spPr>
@@ -8167,7 +8167,7 @@
           </a:prstGeom>
           <a:extLst>
             <a:ext uri="{C572A759-6A51-4108-AA02-DFA0A04FC94B}">
-              <ma14:wrappingTextBoxFlag xmlns="" xmlns:ma14="http://schemas.microsoft.com/office/mac/drawingml/2011/main" val="0"/>
+              <ma14:wrappingTextBoxFlag xmlns:ma14="http://schemas.microsoft.com/office/mac/drawingml/2011/main" xmlns="" val="0"/>
             </a:ext>
           </a:extLst>
         </p:spPr>
@@ -9624,7 +9624,7 @@
           </a:prstGeom>
           <a:extLst>
             <a:ext uri="{C572A759-6A51-4108-AA02-DFA0A04FC94B}">
-              <ma14:wrappingTextBoxFlag xmlns="" xmlns:ma14="http://schemas.microsoft.com/office/mac/drawingml/2011/main" val="0"/>
+              <ma14:wrappingTextBoxFlag xmlns:ma14="http://schemas.microsoft.com/office/mac/drawingml/2011/main" xmlns="" val="0"/>
             </a:ext>
           </a:extLst>
         </p:spPr>
@@ -10641,7 +10641,7 @@
           </a:prstGeom>
           <a:extLst>
             <a:ext uri="{C572A759-6A51-4108-AA02-DFA0A04FC94B}">
-              <ma14:wrappingTextBoxFlag xmlns="" xmlns:ma14="http://schemas.microsoft.com/office/mac/drawingml/2011/main" val="0"/>
+              <ma14:wrappingTextBoxFlag xmlns:ma14="http://schemas.microsoft.com/office/mac/drawingml/2011/main" xmlns="" val="0"/>
             </a:ext>
           </a:extLst>
         </p:spPr>
@@ -11862,7 +11862,7 @@
           </a:prstGeom>
           <a:extLst>
             <a:ext uri="{C572A759-6A51-4108-AA02-DFA0A04FC94B}">
-              <ma14:wrappingTextBoxFlag xmlns="" xmlns:ma14="http://schemas.microsoft.com/office/mac/drawingml/2011/main" val="0"/>
+              <ma14:wrappingTextBoxFlag xmlns:ma14="http://schemas.microsoft.com/office/mac/drawingml/2011/main" xmlns="" val="0"/>
             </a:ext>
           </a:extLst>
         </p:spPr>
@@ -13625,7 +13625,7 @@
           </a:prstGeom>
           <a:extLst>
             <a:ext uri="{C572A759-6A51-4108-AA02-DFA0A04FC94B}">
-              <ma14:wrappingTextBoxFlag xmlns="" xmlns:ma14="http://schemas.microsoft.com/office/mac/drawingml/2011/main" val="0"/>
+              <ma14:wrappingTextBoxFlag xmlns:ma14="http://schemas.microsoft.com/office/mac/drawingml/2011/main" xmlns="" val="0"/>
             </a:ext>
           </a:extLst>
         </p:spPr>
@@ -14956,7 +14956,7 @@
           </a:prstGeom>
           <a:extLst>
             <a:ext uri="{C572A759-6A51-4108-AA02-DFA0A04FC94B}">
-              <ma14:wrappingTextBoxFlag xmlns="" xmlns:ma14="http://schemas.microsoft.com/office/mac/drawingml/2011/main" val="0"/>
+              <ma14:wrappingTextBoxFlag xmlns:ma14="http://schemas.microsoft.com/office/mac/drawingml/2011/main" xmlns="" val="0"/>
             </a:ext>
           </a:extLst>
         </p:spPr>
@@ -16578,7 +16578,7 @@
           </a:prstGeom>
           <a:extLst>
             <a:ext uri="{C572A759-6A51-4108-AA02-DFA0A04FC94B}">
-              <ma14:wrappingTextBoxFlag xmlns="" xmlns:ma14="http://schemas.microsoft.com/office/mac/drawingml/2011/main" val="0"/>
+              <ma14:wrappingTextBoxFlag xmlns:ma14="http://schemas.microsoft.com/office/mac/drawingml/2011/main" xmlns="" val="0"/>
             </a:ext>
           </a:extLst>
         </p:spPr>
@@ -17759,7 +17759,7 @@
           </a:prstGeom>
           <a:extLst>
             <a:ext uri="{C572A759-6A51-4108-AA02-DFA0A04FC94B}">
-              <ma14:wrappingTextBoxFlag xmlns="" xmlns:ma14="http://schemas.microsoft.com/office/mac/drawingml/2011/main" val="0"/>
+              <ma14:wrappingTextBoxFlag xmlns:ma14="http://schemas.microsoft.com/office/mac/drawingml/2011/main" xmlns="" val="0"/>
             </a:ext>
           </a:extLst>
         </p:spPr>
@@ -18951,7 +18951,7 @@
           </a:prstGeom>
           <a:extLst>
             <a:ext uri="{C572A759-6A51-4108-AA02-DFA0A04FC94B}">
-              <ma14:wrappingTextBoxFlag xmlns="" xmlns:ma14="http://schemas.microsoft.com/office/mac/drawingml/2011/main" val="0"/>
+              <ma14:wrappingTextBoxFlag xmlns:ma14="http://schemas.microsoft.com/office/mac/drawingml/2011/main" xmlns="" val="0"/>
             </a:ext>
           </a:extLst>
         </p:spPr>
@@ -19881,6 +19881,81 @@
       </p:grpSpPr>
       <p:sp>
         <p:nvSpPr>
+          <p:cNvPr id="38" name="APIM Telemetry Arrow"/>
+          <p:cNvSpPr/>
+          <p:nvPr/>
+        </p:nvSpPr>
+        <p:spPr>
+          <a:xfrm>
+            <a:off x="5857240" y="3703320"/>
+            <a:ext cx="0" cy="520700"/>
+          </a:xfrm>
+          <a:prstGeom prst="line">
+            <a:avLst/>
+          </a:prstGeom>
+          <a:noFill/>
+          <a:ln w="22225">
+            <a:solidFill>
+              <a:srgbClr val="5BD6C5"/>
+            </a:solidFill>
+            <a:prstDash val="solid"/>
+            <a:headEnd type="none"/>
+            <a:tailEnd type="arrow"/>
+          </a:ln>
+        </p:spPr>
+        <p:txBody>
+          <a:bodyPr/>
+          <a:lstStyle/>
+          <a:p>
+            <a:endParaRPr lang="en-US"/>
+          </a:p>
+        </p:txBody>
+      </p:sp>
+      <p:cxnSp>
+        <p:nvCxnSpPr>
+          <p:cNvPr id="46" name="Agent Telemetry Arrow">
+            <a:extLst>
+              <a:ext uri="{FF2B5EF4-FFF2-40B4-BE49-F238E27FC236}">
+                <a16:creationId xmlns:a16="http://schemas.microsoft.com/office/drawing/2014/main" id="{FA9AC0A2-7565-7D1E-0A0D-62DBEE29D9D4}"/>
+              </a:ext>
+            </a:extLst>
+          </p:cNvPr>
+          <p:cNvCxnSpPr/>
+          <p:nvPr/>
+        </p:nvCxnSpPr>
+        <p:spPr>
+          <a:xfrm>
+            <a:off x="3483610" y="3703320"/>
+            <a:ext cx="0" cy="520700"/>
+          </a:xfrm>
+          <a:prstGeom prst="line">
+            <a:avLst/>
+          </a:prstGeom>
+          <a:ln w="22225">
+            <a:solidFill>
+              <a:srgbClr val="775DA6"/>
+            </a:solidFill>
+            <a:headEnd type="none"/>
+            <a:tailEnd type="arrow"/>
+          </a:ln>
+        </p:spPr>
+        <p:style>
+          <a:lnRef idx="1">
+            <a:schemeClr val="accent1"/>
+          </a:lnRef>
+          <a:fillRef idx="0">
+            <a:schemeClr val="accent1"/>
+          </a:fillRef>
+          <a:effectRef idx="0">
+            <a:schemeClr val="accent1"/>
+          </a:effectRef>
+          <a:fontRef idx="minor">
+            <a:schemeClr val="tx1"/>
+          </a:fontRef>
+        </p:style>
+      </p:cxnSp>
+      <p:sp>
+        <p:nvSpPr>
           <p:cNvPr id="2" name="Text 0"/>
           <p:cNvSpPr/>
           <p:nvPr/>
@@ -20191,14 +20266,14 @@
         </p:nvSpPr>
         <p:spPr>
           <a:xfrm>
-            <a:off x="2185416" y="2907792"/>
-            <a:ext cx="283464" cy="0"/>
+            <a:off x="2138680" y="2907792"/>
+            <a:ext cx="375920" cy="0"/>
           </a:xfrm>
           <a:prstGeom prst="line">
             <a:avLst/>
           </a:prstGeom>
           <a:noFill/>
-          <a:ln w="25400">
+          <a:ln w="22225">
             <a:solidFill>
               <a:srgbClr val="748494"/>
             </a:solidFill>
@@ -20288,7 +20363,7 @@
                 <a:ea typeface="Aptos Display" pitchFamily="34" charset="-122"/>
                 <a:cs typeface="Aptos Display" pitchFamily="34" charset="-120"/>
               </a:rPr>
-              <a:t>Agent experiences</a:t>
+              <a:t>Agent Harness</a:t>
             </a:r>
             <a:endParaRPr lang="en-US" sz="1300" dirty="0"/>
           </a:p>
@@ -20343,14 +20418,14 @@
         </p:nvSpPr>
         <p:spPr>
           <a:xfrm>
-            <a:off x="4498848" y="2907792"/>
-            <a:ext cx="329184" cy="0"/>
+            <a:off x="4452620" y="2907792"/>
+            <a:ext cx="421640" cy="0"/>
           </a:xfrm>
           <a:prstGeom prst="line">
             <a:avLst/>
           </a:prstGeom>
           <a:noFill/>
-          <a:ln w="25400">
+          <a:ln w="22225">
             <a:solidFill>
               <a:srgbClr val="748494"/>
             </a:solidFill>
@@ -20495,14 +20570,14 @@
         </p:nvSpPr>
         <p:spPr>
           <a:xfrm>
-            <a:off x="6885432" y="2907792"/>
-            <a:ext cx="338328" cy="0"/>
+            <a:off x="6840220" y="2907792"/>
+            <a:ext cx="429260" cy="0"/>
           </a:xfrm>
           <a:prstGeom prst="line">
             <a:avLst/>
           </a:prstGeom>
           <a:noFill/>
-          <a:ln w="25400">
+          <a:ln w="22225">
             <a:solidFill>
               <a:srgbClr val="748494"/>
             </a:solidFill>
@@ -20709,14 +20784,14 @@
         </p:nvSpPr>
         <p:spPr>
           <a:xfrm>
-            <a:off x="9189720" y="2907792"/>
-            <a:ext cx="338328" cy="0"/>
+            <a:off x="9144000" y="2907792"/>
+            <a:ext cx="429260" cy="0"/>
           </a:xfrm>
           <a:prstGeom prst="line">
             <a:avLst/>
           </a:prstGeom>
           <a:noFill/>
-          <a:ln w="25400">
+          <a:ln w="22225">
             <a:solidFill>
               <a:srgbClr val="748494"/>
             </a:solidFill>
@@ -20915,43 +20990,17 @@
           </a:p>
         </p:txBody>
       </p:sp>
-      <p:sp>
-        <p:nvSpPr>
-          <p:cNvPr id="34" name="Shape 27"/>
-          <p:cNvSpPr/>
-          <p:nvPr/>
-        </p:nvSpPr>
-        <p:spPr>
-          <a:xfrm>
-            <a:off x="4508500" y="4224528"/>
-            <a:ext cx="2794000" cy="1042416"/>
-          </a:xfrm>
-          <a:prstGeom prst="roundRect">
-            <a:avLst/>
-          </a:prstGeom>
-          <a:solidFill>
-            <a:srgbClr val="102A43"/>
-          </a:solidFill>
-          <a:ln w="12700">
-            <a:solidFill>
-              <a:srgbClr val="102A43"/>
-            </a:solidFill>
-            <a:prstDash val="solid"/>
-          </a:ln>
-        </p:spPr>
-        <p:txBody>
-          <a:bodyPr/>
-          <a:lstStyle/>
-          <a:p>
-            <a:endParaRPr lang="en-US"/>
-          </a:p>
-        </p:txBody>
-      </p:sp>
       <p:pic>
         <p:nvPicPr>
-          <p:cNvPr id="35" name="Image 5" descr="preencoded.png"/>
+          <p:cNvPr id="49" name="Microsoft Copilot Studio Icon">
+            <a:extLst>
+              <a:ext uri="{FF2B5EF4-FFF2-40B4-BE49-F238E27FC236}">
+                <a16:creationId xmlns:a16="http://schemas.microsoft.com/office/drawing/2014/main" id="{7D163EBB-95FE-D701-C53B-0FDA5E90DB9F}"/>
+              </a:ext>
+            </a:extLst>
+          </p:cNvPr>
           <p:cNvPicPr>
-            <a:picLocks noChangeAspect="1"/>
+            <a:picLocks/>
           </p:cNvPicPr>
           <p:nvPr/>
         </p:nvPicPr>
@@ -20969,162 +21018,25 @@
         </p:blipFill>
         <p:spPr>
           <a:xfrm>
-            <a:off x="4747260" y="4480560"/>
-            <a:ext cx="347472" cy="347472"/>
+            <a:off x="3528314" y="2431796"/>
+            <a:ext cx="330200" cy="330200"/>
           </a:xfrm>
           <a:prstGeom prst="rect">
             <a:avLst/>
           </a:prstGeom>
         </p:spPr>
       </p:pic>
-      <p:sp>
-        <p:nvSpPr>
-          <p:cNvPr id="36" name="Text 28"/>
-          <p:cNvSpPr/>
-          <p:nvPr/>
-        </p:nvSpPr>
-        <p:spPr>
-          <a:xfrm>
-            <a:off x="5207000" y="4370832"/>
-            <a:ext cx="1905000" cy="228600"/>
-          </a:xfrm>
-          <a:prstGeom prst="rect">
-            <a:avLst/>
-          </a:prstGeom>
-          <a:noFill/>
-          <a:ln/>
-        </p:spPr>
-        <p:txBody>
-          <a:bodyPr wrap="square" lIns="0" tIns="0" rIns="0" bIns="0" rtlCol="0" anchor="ctr"/>
-          <a:lstStyle/>
-          <a:p>
-            <a:pPr marL="0" indent="0">
-              <a:buNone/>
-            </a:pPr>
-            <a:r>
-              <a:rPr lang="en-US" sz="1400" b="1">
-                <a:solidFill>
-                  <a:srgbClr val="FFFFFF"/>
-                </a:solidFill>
-                <a:latin typeface="Aptos Display" pitchFamily="34" charset="0"/>
-                <a:ea typeface="Aptos Display" pitchFamily="34" charset="-122"/>
-                <a:cs typeface="Aptos Display" pitchFamily="34" charset="-120"/>
-              </a:rPr>
-              <a:t>Policies and controls</a:t>
-            </a:r>
-            <a:endParaRPr lang="en-US" sz="1400" dirty="0"/>
-          </a:p>
-        </p:txBody>
-      </p:sp>
-      <p:sp>
-        <p:nvSpPr>
-          <p:cNvPr id="37" name="Text 29"/>
-          <p:cNvSpPr/>
-          <p:nvPr/>
-        </p:nvSpPr>
-        <p:spPr>
-          <a:xfrm>
-            <a:off x="5207000" y="4645152"/>
-            <a:ext cx="1841500" cy="393192"/>
-          </a:xfrm>
-          <a:prstGeom prst="rect">
-            <a:avLst/>
-          </a:prstGeom>
-          <a:noFill/>
-          <a:ln/>
-        </p:spPr>
-        <p:txBody>
-          <a:bodyPr wrap="square" lIns="0" tIns="0" rIns="0" bIns="0" rtlCol="0" anchor="ctr">
-            <a:normAutofit/>
-          </a:bodyPr>
-          <a:lstStyle/>
-          <a:p>
-            <a:pPr marL="0" indent="0">
-              <a:buNone/>
-            </a:pPr>
-            <a:r>
-              <a:rPr lang="en-US" sz="870">
-                <a:solidFill>
-                  <a:srgbClr val="DDEAF2"/>
-                </a:solidFill>
-                <a:latin typeface="Aptos" pitchFamily="34" charset="0"/>
-                <a:ea typeface="Aptos" pitchFamily="34" charset="-122"/>
-                <a:cs typeface="Aptos" pitchFamily="34" charset="-120"/>
-              </a:rPr>
-              <a:t>Authentication, rate limits, correlation, tracing, logging, and request controls</a:t>
-            </a:r>
-            <a:endParaRPr lang="en-US" sz="870" dirty="0"/>
-          </a:p>
-        </p:txBody>
-      </p:sp>
-      <p:sp>
-        <p:nvSpPr>
-          <p:cNvPr id="38" name="Shape 30"/>
-          <p:cNvSpPr/>
-          <p:nvPr/>
-        </p:nvSpPr>
-        <p:spPr>
-          <a:xfrm>
-            <a:off x="5870448" y="3758184"/>
-            <a:ext cx="0" cy="457200"/>
-          </a:xfrm>
-          <a:prstGeom prst="line">
-            <a:avLst/>
-          </a:prstGeom>
-          <a:noFill/>
-          <a:ln w="25400">
-            <a:solidFill>
-              <a:srgbClr val="5BD6C5"/>
-            </a:solidFill>
-            <a:prstDash val="solid"/>
-            <a:headEnd type="triangle"/>
-          </a:ln>
-        </p:spPr>
-        <p:txBody>
-          <a:bodyPr/>
-          <a:lstStyle/>
-          <a:p>
-            <a:endParaRPr lang="en-US"/>
-          </a:p>
-        </p:txBody>
-      </p:sp>
-      <p:sp>
-        <p:nvSpPr>
-          <p:cNvPr id="39" name="Shape 31"/>
-          <p:cNvSpPr/>
-          <p:nvPr/>
-        </p:nvSpPr>
-        <p:spPr>
-          <a:xfrm>
-            <a:off x="7680960" y="4224528"/>
-            <a:ext cx="2880360" cy="1042416"/>
-          </a:xfrm>
-          <a:prstGeom prst="roundRect">
-            <a:avLst/>
-          </a:prstGeom>
-          <a:solidFill>
-            <a:srgbClr val="FFFFFF"/>
-          </a:solidFill>
-          <a:ln w="12700">
-            <a:solidFill>
-              <a:srgbClr val="DDE6EC"/>
-            </a:solidFill>
-            <a:prstDash val="solid"/>
-          </a:ln>
-        </p:spPr>
-        <p:txBody>
-          <a:bodyPr/>
-          <a:lstStyle/>
-          <a:p>
-            <a:endParaRPr lang="en-US"/>
-          </a:p>
-        </p:txBody>
-      </p:sp>
       <p:pic>
         <p:nvPicPr>
-          <p:cNvPr id="40" name="Image 6" descr="preencoded.png"/>
+          <p:cNvPr id="13" name="Microsoft Foundry Agent Service Icon">
+            <a:extLst>
+              <a:ext uri="{FF2B5EF4-FFF2-40B4-BE49-F238E27FC236}">
+                <a16:creationId xmlns:a16="http://schemas.microsoft.com/office/drawing/2014/main" id="{7CA32E2E-6B9A-7AED-FDF5-EF9F21CDEB73}"/>
+              </a:ext>
+            </a:extLst>
+          </p:cNvPr>
           <p:cNvPicPr>
-            <a:picLocks noChangeAspect="1"/>
+            <a:picLocks/>
           </p:cNvPicPr>
           <p:nvPr/>
         </p:nvPicPr>
@@ -21142,283 +21054,6 @@
         </p:blipFill>
         <p:spPr>
           <a:xfrm>
-            <a:off x="7936992" y="4480560"/>
-            <a:ext cx="329184" cy="329184"/>
-          </a:xfrm>
-          <a:prstGeom prst="rect">
-            <a:avLst/>
-          </a:prstGeom>
-        </p:spPr>
-      </p:pic>
-      <p:sp>
-        <p:nvSpPr>
-          <p:cNvPr id="41" name="Text 32"/>
-          <p:cNvSpPr/>
-          <p:nvPr/>
-        </p:nvSpPr>
-        <p:spPr>
-          <a:xfrm>
-            <a:off x="8394192" y="4370832"/>
-            <a:ext cx="1874520" cy="228600"/>
-          </a:xfrm>
-          <a:prstGeom prst="rect">
-            <a:avLst/>
-          </a:prstGeom>
-          <a:noFill/>
-          <a:ln/>
-        </p:spPr>
-        <p:txBody>
-          <a:bodyPr wrap="square" lIns="0" tIns="0" rIns="0" bIns="0" rtlCol="0" anchor="ctr">
-            <a:normAutofit fontScale="92500"/>
-          </a:bodyPr>
-          <a:lstStyle/>
-          <a:p>
-            <a:pPr marL="0" indent="0">
-              <a:buNone/>
-            </a:pPr>
-            <a:r>
-              <a:rPr lang="en-US" sz="1300" b="1" dirty="0">
-                <a:solidFill>
-                  <a:srgbClr val="102A43"/>
-                </a:solidFill>
-                <a:latin typeface="Aptos Display" pitchFamily="34" charset="0"/>
-                <a:ea typeface="Aptos Display" pitchFamily="34" charset="-122"/>
-                <a:cs typeface="Aptos Display" pitchFamily="34" charset="-120"/>
-              </a:rPr>
-              <a:t>Azure Monitor + App Insights</a:t>
-            </a:r>
-            <a:endParaRPr lang="en-US" sz="1300" dirty="0"/>
-          </a:p>
-        </p:txBody>
-      </p:sp>
-      <p:sp>
-        <p:nvSpPr>
-          <p:cNvPr id="42" name="Text 33"/>
-          <p:cNvSpPr/>
-          <p:nvPr/>
-        </p:nvSpPr>
-        <p:spPr>
-          <a:xfrm>
-            <a:off x="8394192" y="4645152"/>
-            <a:ext cx="1874520" cy="365760"/>
-          </a:xfrm>
-          <a:prstGeom prst="rect">
-            <a:avLst/>
-          </a:prstGeom>
-          <a:noFill/>
-          <a:ln/>
-        </p:spPr>
-        <p:txBody>
-          <a:bodyPr wrap="square" lIns="0" tIns="0" rIns="0" bIns="0" rtlCol="0" anchor="ctr">
-            <a:normAutofit/>
-          </a:bodyPr>
-          <a:lstStyle/>
-          <a:p>
-            <a:pPr marL="0" indent="0">
-              <a:buNone/>
-            </a:pPr>
-            <a:r>
-              <a:rPr lang="en-US" sz="870">
-                <a:solidFill>
-                  <a:srgbClr val="4F6474"/>
-                </a:solidFill>
-                <a:latin typeface="Aptos" pitchFamily="34" charset="0"/>
-                <a:ea typeface="Aptos" pitchFamily="34" charset="-122"/>
-                <a:cs typeface="Aptos" pitchFamily="34" charset="-120"/>
-              </a:rPr>
-              <a:t>Latency, failures, usage, correlation, and audit evidence</a:t>
-            </a:r>
-            <a:endParaRPr lang="en-US" sz="870" dirty="0"/>
-          </a:p>
-        </p:txBody>
-      </p:sp>
-      <p:sp>
-        <p:nvSpPr>
-          <p:cNvPr id="44" name="Text 35"/>
-          <p:cNvSpPr/>
-          <p:nvPr/>
-        </p:nvSpPr>
-        <p:spPr>
-          <a:xfrm>
-            <a:off x="566928" y="6528816"/>
-            <a:ext cx="4389120" cy="146304"/>
-          </a:xfrm>
-          <a:prstGeom prst="rect">
-            <a:avLst/>
-          </a:prstGeom>
-          <a:noFill/>
-          <a:ln/>
-        </p:spPr>
-        <p:txBody>
-          <a:bodyPr wrap="square" lIns="0" tIns="0" rIns="0" bIns="0" rtlCol="0" anchor="ctr"/>
-          <a:lstStyle/>
-          <a:p>
-            <a:pPr marL="0" indent="0">
-              <a:buNone/>
-            </a:pPr>
-            <a:r>
-              <a:rPr lang="en-US" sz="750" dirty="0">
-                <a:solidFill>
-                  <a:srgbClr val="748494"/>
-                </a:solidFill>
-                <a:latin typeface="Aptos" pitchFamily="34" charset="0"/>
-                <a:ea typeface="Aptos" pitchFamily="34" charset="-122"/>
-                <a:cs typeface="Aptos" pitchFamily="34" charset="-120"/>
-              </a:rPr>
-              <a:t>Architecture: intent stays with the agent, controls stay at the boundary</a:t>
-            </a:r>
-            <a:endParaRPr lang="en-US" sz="750" dirty="0"/>
-          </a:p>
-        </p:txBody>
-      </p:sp>
-      <p:sp>
-        <p:nvSpPr>
-          <p:cNvPr id="45" name="Slide Number Placeholder 0"/>
-          <p:cNvSpPr>
-            <a:spLocks noGrp="1"/>
-          </p:cNvSpPr>
-          <p:nvPr>
-            <p:ph type="sldNum" sz="quarter" idx="4294967295"/>
-          </p:nvPr>
-        </p:nvSpPr>
-        <p:spPr>
-          <a:xfrm>
-            <a:off x="11109960" y="6510528"/>
-            <a:ext cx="548640" cy="164592"/>
-          </a:xfrm>
-          <a:prstGeom prst="rect">
-            <a:avLst/>
-          </a:prstGeom>
-          <a:extLst>
-            <a:ext uri="{C572A759-6A51-4108-AA02-DFA0A04FC94B}">
-              <ma14:wrappingTextBoxFlag xmlns="" xmlns:ma14="http://schemas.microsoft.com/office/mac/drawingml/2011/main" val="0"/>
-            </a:ext>
-          </a:extLst>
-        </p:spPr>
-        <p:txBody>
-          <a:bodyPr/>
-          <a:lstStyle>
-            <a:lvl1pPr>
-              <a:defRPr sz="800">
-                <a:solidFill>
-                  <a:srgbClr val="748494"/>
-                </a:solidFill>
-                <a:latin typeface="Aptos"/>
-                <a:ea typeface="Aptos"/>
-                <a:cs typeface="Aptos"/>
-              </a:defRPr>
-            </a:lvl1pPr>
-          </a:lstStyle>
-          <a:p>
-            <a:pPr algn="r"/>
-            <a:fld id="{F7021451-1387-4CA6-816F-3879F97B5CBC}" type="slidenum">
-              <a:rPr lang="en-US" b="0"/>
-              <a:t>3</a:t>
-            </a:fld>
-            <a:endParaRPr lang="en-US"/>
-          </a:p>
-        </p:txBody>
-      </p:sp>
-      <p:pic>
-        <p:nvPicPr>
-          <p:cNvPr id="49" name="Microsoft Copilot Studio Icon">
-            <a:extLst>
-              <a:ext uri="{FF2B5EF4-FFF2-40B4-BE49-F238E27FC236}">
-                <a16:creationId xmlns:a16="http://schemas.microsoft.com/office/drawing/2014/main" id="{7D163EBB-95FE-D701-C53B-0FDA5E90DB9F}"/>
-              </a:ext>
-            </a:extLst>
-          </p:cNvPr>
-          <p:cNvPicPr>
-            <a:picLocks/>
-          </p:cNvPicPr>
-          <p:nvPr/>
-        </p:nvPicPr>
-        <p:blipFill>
-          <a:blip>
-            <a:extLst>
-              <a:ext uri="{96DAC541-7B7A-43D3-8B79-37D633B846F1}">
-                <asvg:svgBlip xmlns:asvg="http://schemas.microsoft.com/office/drawing/2016/SVG/main" r:embed="rId8"/>
-              </a:ext>
-            </a:extLst>
-          </a:blip>
-          <a:stretch>
-            <a:fillRect/>
-          </a:stretch>
-        </p:blipFill>
-        <p:spPr>
-          <a:xfrm>
-            <a:off x="3528314" y="2431796"/>
-            <a:ext cx="330200" cy="330200"/>
-          </a:xfrm>
-          <a:prstGeom prst="rect">
-            <a:avLst/>
-          </a:prstGeom>
-        </p:spPr>
-      </p:pic>
-      <p:pic>
-        <p:nvPicPr>
-          <p:cNvPr id="51" name="Azure API Management Icon">
-            <a:extLst>
-              <a:ext uri="{FF2B5EF4-FFF2-40B4-BE49-F238E27FC236}">
-                <a16:creationId xmlns:a16="http://schemas.microsoft.com/office/drawing/2014/main" id="{AAFB1189-5C1B-9BD4-7D9F-53793DC99227}"/>
-              </a:ext>
-            </a:extLst>
-          </p:cNvPr>
-          <p:cNvPicPr>
-            <a:picLocks/>
-          </p:cNvPicPr>
-          <p:nvPr/>
-        </p:nvPicPr>
-        <p:blipFill>
-          <a:blip>
-            <a:extLst>
-              <a:ext uri="{96DAC541-7B7A-43D3-8B79-37D633B846F1}">
-                <asvg:svgBlip xmlns:asvg="http://schemas.microsoft.com/office/drawing/2016/SVG/main" r:embed="rId9"/>
-              </a:ext>
-            </a:extLst>
-          </a:blip>
-          <a:stretch>
-            <a:fillRect/>
-          </a:stretch>
-        </p:blipFill>
-        <p:spPr>
-          <a:xfrm>
-            <a:off x="5590032" y="2330196"/>
-            <a:ext cx="533400" cy="533400"/>
-          </a:xfrm>
-          <a:prstGeom prst="rect">
-            <a:avLst/>
-          </a:prstGeom>
-        </p:spPr>
-      </p:pic>
-      <p:pic>
-        <p:nvPicPr>
-          <p:cNvPr id="13" name="Microsoft Foundry Agent Service Icon">
-            <a:extLst>
-              <a:ext uri="{FF2B5EF4-FFF2-40B4-BE49-F238E27FC236}">
-                <a16:creationId xmlns:a16="http://schemas.microsoft.com/office/drawing/2014/main" id="{7CA32E2E-6B9A-7AED-FDF5-EF9F21CDEB73}"/>
-              </a:ext>
-            </a:extLst>
-          </p:cNvPr>
-          <p:cNvPicPr>
-            <a:picLocks/>
-          </p:cNvPicPr>
-          <p:nvPr/>
-        </p:nvPicPr>
-        <p:blipFill>
-          <a:blip>
-            <a:extLst>
-              <a:ext uri="{96DAC541-7B7A-43D3-8B79-37D633B846F1}">
-                <asvg:svgBlip xmlns:asvg="http://schemas.microsoft.com/office/drawing/2016/SVG/main" r:embed="rId10"/>
-              </a:ext>
-            </a:extLst>
-          </a:blip>
-          <a:stretch>
-            <a:fillRect/>
-          </a:stretch>
-        </p:blipFill>
-        <p:spPr>
-          <a:xfrm>
             <a:off x="3109214" y="2431796"/>
             <a:ext cx="330200" cy="330200"/>
           </a:xfrm>
@@ -21427,370 +21062,6 @@
           </a:prstGeom>
         </p:spPr>
       </p:pic>
-      <p:sp>
-        <p:nvSpPr>
-          <p:cNvPr id="12" name="Agent Harness Card">
-            <a:extLst>
-              <a:ext uri="{FF2B5EF4-FFF2-40B4-BE49-F238E27FC236}">
-                <a16:creationId xmlns:a16="http://schemas.microsoft.com/office/drawing/2014/main" id="{2D1F02D2-9A27-7A2A-2BB1-F5E543FDCC2D}"/>
-              </a:ext>
-            </a:extLst>
-          </p:cNvPr>
-          <p:cNvSpPr/>
-          <p:nvPr/>
-        </p:nvSpPr>
-        <p:spPr>
-          <a:xfrm>
-            <a:off x="2514600" y="4224020"/>
-            <a:ext cx="1778000" cy="1042670"/>
-          </a:xfrm>
-          <a:prstGeom prst="roundRect">
-            <a:avLst/>
-          </a:prstGeom>
-          <a:solidFill>
-            <a:srgbClr val="FFFFFF"/>
-          </a:solidFill>
-          <a:ln w="19050">
-            <a:solidFill>
-              <a:srgbClr val="775DA6"/>
-            </a:solidFill>
-            <a:prstDash val="solid"/>
-          </a:ln>
-          <a:effectLst>
-            <a:outerShdw blurRad="25400" dist="50800" dir="2700000" algn="bl" rotWithShape="0">
-              <a:srgbClr val="102A43">
-                <a:alpha val="14000"/>
-              </a:srgbClr>
-            </a:outerShdw>
-          </a:effectLst>
-        </p:spPr>
-        <p:txBody>
-          <a:bodyPr/>
-          <a:lstStyle/>
-          <a:p>
-            <a:endParaRPr lang="en-US"/>
-          </a:p>
-        </p:txBody>
-      </p:sp>
-      <p:sp>
-        <p:nvSpPr>
-          <p:cNvPr id="18" name="Agent Harness Title">
-            <a:extLst>
-              <a:ext uri="{FF2B5EF4-FFF2-40B4-BE49-F238E27FC236}">
-                <a16:creationId xmlns:a16="http://schemas.microsoft.com/office/drawing/2014/main" id="{3C479378-2A10-F852-4225-DD925EF41B3A}"/>
-              </a:ext>
-            </a:extLst>
-          </p:cNvPr>
-          <p:cNvSpPr/>
-          <p:nvPr/>
-        </p:nvSpPr>
-        <p:spPr>
-          <a:xfrm>
-            <a:off x="2628900" y="4371340"/>
-            <a:ext cx="1549400" cy="228600"/>
-          </a:xfrm>
-          <a:prstGeom prst="rect">
-            <a:avLst/>
-          </a:prstGeom>
-          <a:noFill/>
-          <a:ln/>
-        </p:spPr>
-        <p:txBody>
-          <a:bodyPr wrap="square" lIns="0" tIns="0" rIns="0" bIns="0" rtlCol="0" anchor="ctr">
-            <a:normAutofit/>
-          </a:bodyPr>
-          <a:lstStyle/>
-          <a:p>
-            <a:pPr marL="0" indent="0" algn="ctr">
-              <a:buNone/>
-            </a:pPr>
-            <a:r>
-              <a:rPr lang="en-US" sz="1400" b="1">
-                <a:solidFill>
-                  <a:srgbClr val="102A43"/>
-                </a:solidFill>
-                <a:latin typeface="Aptos Display" pitchFamily="34" charset="0"/>
-                <a:ea typeface="Aptos Display" pitchFamily="34" charset="-122"/>
-                <a:cs typeface="Aptos Display" pitchFamily="34" charset="-120"/>
-              </a:rPr>
-              <a:t>Agent harness</a:t>
-            </a:r>
-            <a:endParaRPr lang="en-US" sz="1400" dirty="0"/>
-          </a:p>
-        </p:txBody>
-      </p:sp>
-      <p:sp>
-        <p:nvSpPr>
-          <p:cNvPr id="19" name="Agent Harness Body">
-            <a:extLst>
-              <a:ext uri="{FF2B5EF4-FFF2-40B4-BE49-F238E27FC236}">
-                <a16:creationId xmlns:a16="http://schemas.microsoft.com/office/drawing/2014/main" id="{EC528A1A-0704-0B47-3016-5C26AF458388}"/>
-              </a:ext>
-            </a:extLst>
-          </p:cNvPr>
-          <p:cNvSpPr/>
-          <p:nvPr/>
-        </p:nvSpPr>
-        <p:spPr>
-          <a:xfrm>
-            <a:off x="2628900" y="4660900"/>
-            <a:ext cx="1549400" cy="381000"/>
-          </a:xfrm>
-          <a:prstGeom prst="rect">
-            <a:avLst/>
-          </a:prstGeom>
-          <a:noFill/>
-          <a:ln/>
-        </p:spPr>
-        <p:txBody>
-          <a:bodyPr wrap="square" lIns="0" tIns="0" rIns="0" bIns="0" rtlCol="0" anchor="ctr">
-            <a:normAutofit/>
-          </a:bodyPr>
-          <a:lstStyle/>
-          <a:p>
-            <a:pPr marL="0" indent="0" algn="ctr">
-              <a:buNone/>
-            </a:pPr>
-            <a:r>
-              <a:rPr lang="en-US" sz="1050">
-                <a:solidFill>
-                  <a:srgbClr val="4F6474"/>
-                </a:solidFill>
-                <a:latin typeface="Aptos" pitchFamily="34" charset="0"/>
-                <a:ea typeface="Aptos" pitchFamily="34" charset="-122"/>
-                <a:cs typeface="Aptos" pitchFamily="34" charset="-120"/>
-              </a:rPr>
-              <a:t>Tool selection and</a:t>
-            </a:r>
-          </a:p>
-          <a:p>
-            <a:pPr marL="0" indent="0" algn="ctr">
-              <a:buNone/>
-            </a:pPr>
-            <a:r>
-              <a:rPr lang="en-US" sz="1050">
-                <a:solidFill>
-                  <a:srgbClr val="4F6474"/>
-                </a:solidFill>
-                <a:latin typeface="Aptos" pitchFamily="34" charset="0"/>
-                <a:ea typeface="Aptos" pitchFamily="34" charset="-122"/>
-                <a:cs typeface="Aptos" pitchFamily="34" charset="-120"/>
-              </a:rPr>
-              <a:t>approvals</a:t>
-            </a:r>
-            <a:endParaRPr lang="en-US" sz="1050" dirty="0"/>
-          </a:p>
-        </p:txBody>
-      </p:sp>
-      <p:cxnSp>
-        <p:nvCxnSpPr>
-          <p:cNvPr id="46" name="Agent Harness Arrow">
-            <a:extLst>
-              <a:ext uri="{FF2B5EF4-FFF2-40B4-BE49-F238E27FC236}">
-                <a16:creationId xmlns:a16="http://schemas.microsoft.com/office/drawing/2014/main" id="{FA9AC0A2-7565-7D1E-0A0D-62DBEE29D9D4}"/>
-              </a:ext>
-            </a:extLst>
-          </p:cNvPr>
-          <p:cNvCxnSpPr/>
-          <p:nvPr/>
-        </p:nvCxnSpPr>
-        <p:spPr>
-          <a:xfrm>
-            <a:off x="3483610" y="3752850"/>
-            <a:ext cx="0" cy="471170"/>
-          </a:xfrm>
-          <a:prstGeom prst="line">
-            <a:avLst/>
-          </a:prstGeom>
-          <a:ln w="19050">
-            <a:solidFill>
-              <a:srgbClr val="775DA6"/>
-            </a:solidFill>
-            <a:tailEnd type="arrow"/>
-          </a:ln>
-        </p:spPr>
-        <p:style>
-          <a:lnRef idx="1">
-            <a:schemeClr val="accent1"/>
-          </a:lnRef>
-          <a:fillRef idx="0">
-            <a:schemeClr val="accent1"/>
-          </a:fillRef>
-          <a:effectRef idx="0">
-            <a:schemeClr val="accent1"/>
-          </a:effectRef>
-          <a:fontRef idx="minor">
-            <a:schemeClr val="tx1"/>
-          </a:fontRef>
-        </p:style>
-      </p:cxnSp>
-      <p:cxnSp>
-        <p:nvCxnSpPr>
-          <p:cNvPr id="47" name="Agent Telemetry Down">
-            <a:extLst>
-              <a:ext uri="{FF2B5EF4-FFF2-40B4-BE49-F238E27FC236}">
-                <a16:creationId xmlns:a16="http://schemas.microsoft.com/office/drawing/2014/main" id="{321ED40C-19D4-6A16-C32E-AF1686FFF715}"/>
-              </a:ext>
-            </a:extLst>
-          </p:cNvPr>
-          <p:cNvCxnSpPr/>
-          <p:nvPr/>
-        </p:nvCxnSpPr>
-        <p:spPr>
-          <a:xfrm>
-            <a:off x="3403600" y="5266690"/>
-            <a:ext cx="0" cy="321310"/>
-          </a:xfrm>
-          <a:prstGeom prst="line">
-            <a:avLst/>
-          </a:prstGeom>
-          <a:ln w="17780">
-            <a:solidFill>
-              <a:srgbClr val="775DA6"/>
-            </a:solidFill>
-            <a:prstDash val="dash"/>
-          </a:ln>
-        </p:spPr>
-        <p:style>
-          <a:lnRef idx="1">
-            <a:schemeClr val="accent1"/>
-          </a:lnRef>
-          <a:fillRef idx="0">
-            <a:schemeClr val="accent1"/>
-          </a:fillRef>
-          <a:effectRef idx="0">
-            <a:schemeClr val="accent1"/>
-          </a:effectRef>
-          <a:fontRef idx="minor">
-            <a:schemeClr val="tx1"/>
-          </a:fontRef>
-        </p:style>
-      </p:cxnSp>
-      <p:cxnSp>
-        <p:nvCxnSpPr>
-          <p:cNvPr id="48" name="Agent Telemetry Across">
-            <a:extLst>
-              <a:ext uri="{FF2B5EF4-FFF2-40B4-BE49-F238E27FC236}">
-                <a16:creationId xmlns:a16="http://schemas.microsoft.com/office/drawing/2014/main" id="{C2DB856A-B82E-D8EF-9F9A-3DC496E0ED9C}"/>
-              </a:ext>
-            </a:extLst>
-          </p:cNvPr>
-          <p:cNvCxnSpPr/>
-          <p:nvPr/>
-        </p:nvCxnSpPr>
-        <p:spPr>
-          <a:xfrm>
-            <a:off x="3403600" y="5588000"/>
-            <a:ext cx="5715000" cy="0"/>
-          </a:xfrm>
-          <a:prstGeom prst="line">
-            <a:avLst/>
-          </a:prstGeom>
-          <a:ln w="17780">
-            <a:solidFill>
-              <a:srgbClr val="775DA6"/>
-            </a:solidFill>
-            <a:prstDash val="dash"/>
-          </a:ln>
-        </p:spPr>
-        <p:style>
-          <a:lnRef idx="1">
-            <a:schemeClr val="accent1"/>
-          </a:lnRef>
-          <a:fillRef idx="0">
-            <a:schemeClr val="accent1"/>
-          </a:fillRef>
-          <a:effectRef idx="0">
-            <a:schemeClr val="accent1"/>
-          </a:effectRef>
-          <a:fontRef idx="minor">
-            <a:schemeClr val="tx1"/>
-          </a:fontRef>
-        </p:style>
-      </p:cxnSp>
-      <p:cxnSp>
-        <p:nvCxnSpPr>
-          <p:cNvPr id="50" name="Agent Telemetry Up">
-            <a:extLst>
-              <a:ext uri="{FF2B5EF4-FFF2-40B4-BE49-F238E27FC236}">
-                <a16:creationId xmlns:a16="http://schemas.microsoft.com/office/drawing/2014/main" id="{8F88F55E-16F6-0D19-7A4C-209702CA3521}"/>
-              </a:ext>
-            </a:extLst>
-          </p:cNvPr>
-          <p:cNvCxnSpPr/>
-          <p:nvPr/>
-        </p:nvCxnSpPr>
-        <p:spPr>
-          <a:xfrm flipV="1">
-            <a:off x="9118600" y="5266690"/>
-            <a:ext cx="0" cy="321310"/>
-          </a:xfrm>
-          <a:prstGeom prst="line">
-            <a:avLst/>
-          </a:prstGeom>
-          <a:ln w="17780">
-            <a:solidFill>
-              <a:srgbClr val="775DA6"/>
-            </a:solidFill>
-            <a:prstDash val="dash"/>
-            <a:tailEnd type="arrow"/>
-          </a:ln>
-        </p:spPr>
-        <p:style>
-          <a:lnRef idx="1">
-            <a:schemeClr val="accent1"/>
-          </a:lnRef>
-          <a:fillRef idx="0">
-            <a:schemeClr val="accent1"/>
-          </a:fillRef>
-          <a:effectRef idx="0">
-            <a:schemeClr val="accent1"/>
-          </a:effectRef>
-          <a:fontRef idx="minor">
-            <a:schemeClr val="tx1"/>
-          </a:fontRef>
-        </p:style>
-      </p:cxnSp>
-      <p:sp>
-        <p:nvSpPr>
-          <p:cNvPr id="52" name="Agent Telemetry Label">
-            <a:extLst>
-              <a:ext uri="{FF2B5EF4-FFF2-40B4-BE49-F238E27FC236}">
-                <a16:creationId xmlns:a16="http://schemas.microsoft.com/office/drawing/2014/main" id="{416A440F-3289-2310-7139-65D5B9CD4ED9}"/>
-              </a:ext>
-            </a:extLst>
-          </p:cNvPr>
-          <p:cNvSpPr txBox="1"/>
-          <p:nvPr/>
-        </p:nvSpPr>
-        <p:spPr>
-          <a:xfrm>
-            <a:off x="5308600" y="5384800"/>
-            <a:ext cx="1333500" cy="138499"/>
-          </a:xfrm>
-          <a:prstGeom prst="rect">
-            <a:avLst/>
-          </a:prstGeom>
-          <a:noFill/>
-        </p:spPr>
-        <p:txBody>
-          <a:bodyPr vert="horz" lIns="0" tIns="0" rIns="0" bIns="0" rtlCol="0">
-            <a:spAutoFit/>
-          </a:bodyPr>
-          <a:lstStyle/>
-          <a:p>
-            <a:r>
-              <a:rPr lang="en-US" sz="900" b="1">
-                <a:solidFill>
-                  <a:srgbClr val="775DA6"/>
-                </a:solidFill>
-                <a:latin typeface="Aptos" panose="020B0004020202020204" pitchFamily="34" charset="0"/>
-              </a:rPr>
-              <a:t>Agent telemetry</a:t>
-            </a:r>
-          </a:p>
-        </p:txBody>
-      </p:sp>
       <p:sp>
         <p:nvSpPr>
           <p:cNvPr id="53" name="Agent 365 Badge">
@@ -21863,7 +21134,7 @@
           <a:blip>
             <a:extLst>
               <a:ext uri="{96DAC541-7B7A-43D3-8B79-37D633B846F1}">
-                <asvg:svgBlip xmlns:asvg="http://schemas.microsoft.com/office/drawing/2016/SVG/main" r:embed="rId11"/>
+                <asvg:svgBlip xmlns:asvg="http://schemas.microsoft.com/office/drawing/2016/SVG/main" r:embed="rId8"/>
               </a:ext>
             </a:extLst>
           </a:blip>
@@ -22004,12 +21275,146 @@
           </a:fontRef>
         </p:style>
       </p:cxnSp>
+      <p:sp>
+        <p:nvSpPr>
+          <p:cNvPr id="43" name="APIM Control Plane Badge">
+            <a:extLst>
+              <a:ext uri="{FF2B5EF4-FFF2-40B4-BE49-F238E27FC236}">
+                <a16:creationId xmlns:a16="http://schemas.microsoft.com/office/drawing/2014/main" id="{98D26CB3-9376-F472-7DD8-F24ED57C4915}"/>
+              </a:ext>
+            </a:extLst>
+          </p:cNvPr>
+          <p:cNvSpPr/>
+          <p:nvPr/>
+        </p:nvSpPr>
+        <p:spPr>
+          <a:xfrm>
+            <a:off x="4888230" y="1587500"/>
+            <a:ext cx="1938020" cy="355600"/>
+          </a:xfrm>
+          <a:prstGeom prst="roundRect">
+            <a:avLst/>
+          </a:prstGeom>
+          <a:solidFill>
+            <a:srgbClr val="FFFFFF"/>
+          </a:solidFill>
+          <a:ln w="15240">
+            <a:solidFill>
+              <a:srgbClr val="775DA6"/>
+            </a:solidFill>
+          </a:ln>
+        </p:spPr>
+        <p:style>
+          <a:lnRef idx="2">
+            <a:schemeClr val="accent1">
+              <a:shade val="15000"/>
+            </a:schemeClr>
+          </a:lnRef>
+          <a:fillRef idx="1">
+            <a:schemeClr val="accent1"/>
+          </a:fillRef>
+          <a:effectRef idx="0">
+            <a:schemeClr val="accent1"/>
+          </a:effectRef>
+          <a:fontRef idx="minor">
+            <a:schemeClr val="lt1"/>
+          </a:fontRef>
+        </p:style>
+        <p:txBody>
+          <a:bodyPr rtlCol="0" anchor="ctr"/>
+          <a:lstStyle/>
+          <a:p>
+            <a:pPr algn="ctr"/>
+            <a:endParaRPr lang="en-US"/>
+          </a:p>
+        </p:txBody>
+      </p:sp>
+      <p:sp>
+        <p:nvSpPr>
+          <p:cNvPr id="54" name="APIM Control Plane Title">
+            <a:extLst>
+              <a:ext uri="{FF2B5EF4-FFF2-40B4-BE49-F238E27FC236}">
+                <a16:creationId xmlns:a16="http://schemas.microsoft.com/office/drawing/2014/main" id="{801203E0-1ECC-B010-5318-48DBDD9F61E4}"/>
+              </a:ext>
+            </a:extLst>
+          </p:cNvPr>
+          <p:cNvSpPr txBox="1"/>
+          <p:nvPr/>
+        </p:nvSpPr>
+        <p:spPr>
+          <a:xfrm>
+            <a:off x="5307330" y="1619250"/>
+            <a:ext cx="1422400" cy="146050"/>
+          </a:xfrm>
+          <a:prstGeom prst="rect">
+            <a:avLst/>
+          </a:prstGeom>
+          <a:noFill/>
+        </p:spPr>
+        <p:txBody>
+          <a:bodyPr vert="horz" lIns="0" tIns="0" rIns="0" bIns="0" rtlCol="0">
+            <a:spAutoFit/>
+          </a:bodyPr>
+          <a:lstStyle/>
+          <a:p>
+            <a:r>
+              <a:rPr lang="en-US" sz="950" b="1">
+                <a:solidFill>
+                  <a:srgbClr val="102A43"/>
+                </a:solidFill>
+                <a:latin typeface="Aptos" panose="020B0004020202020204" pitchFamily="34" charset="0"/>
+              </a:rPr>
+              <a:t>APIM Control Plane</a:t>
+            </a:r>
+          </a:p>
+        </p:txBody>
+      </p:sp>
+      <p:sp>
+        <p:nvSpPr>
+          <p:cNvPr id="60" name="APIM Control Plane Subtitle">
+            <a:extLst>
+              <a:ext uri="{FF2B5EF4-FFF2-40B4-BE49-F238E27FC236}">
+                <a16:creationId xmlns:a16="http://schemas.microsoft.com/office/drawing/2014/main" id="{71299352-C14F-9B05-9938-70E48A87CCB8}"/>
+              </a:ext>
+            </a:extLst>
+          </p:cNvPr>
+          <p:cNvSpPr txBox="1"/>
+          <p:nvPr/>
+        </p:nvSpPr>
+        <p:spPr>
+          <a:xfrm>
+            <a:off x="5307330" y="1784350"/>
+            <a:ext cx="1422400" cy="115570"/>
+          </a:xfrm>
+          <a:prstGeom prst="rect">
+            <a:avLst/>
+          </a:prstGeom>
+          <a:noFill/>
+        </p:spPr>
+        <p:txBody>
+          <a:bodyPr vert="horz" lIns="0" tIns="0" rIns="0" bIns="0" rtlCol="0">
+            <a:spAutoFit/>
+          </a:bodyPr>
+          <a:lstStyle/>
+          <a:p>
+            <a:r>
+              <a:rPr lang="en-US" sz="750">
+                <a:solidFill>
+                  <a:srgbClr val="526980"/>
+                </a:solidFill>
+                <a:latin typeface="Aptos" panose="020B0004020202020204" pitchFamily="34" charset="0"/>
+              </a:rPr>
+              <a:t>Policies and controls</a:t>
+            </a:r>
+          </a:p>
+        </p:txBody>
+      </p:sp>
       <p:cxnSp>
         <p:nvCxnSpPr>
-          <p:cNvPr id="59" name="APIM Telemetry Arrow">
+          <p:cNvPr id="61" name="APIM Control Plane Connector">
             <a:extLst>
               <a:ext uri="{FF2B5EF4-FFF2-40B4-BE49-F238E27FC236}">
-                <a16:creationId xmlns:a16="http://schemas.microsoft.com/office/drawing/2014/main" id="{A488F9CD-B0E1-A76B-B990-6CA08965FDE4}"/>
+                <a16:creationId xmlns:a16="http://schemas.microsoft.com/office/drawing/2014/main" id="{BE07AF09-DCC1-5A6D-64B0-E7024656B9E7}"/>
               </a:ext>
             </a:extLst>
           </p:cNvPr>
@@ -22018,16 +21423,17 @@
         </p:nvCxnSpPr>
         <p:spPr>
           <a:xfrm>
-            <a:off x="6604000" y="3703320"/>
-            <a:ext cx="1968500" cy="520700"/>
+            <a:off x="5857240" y="1943100"/>
+            <a:ext cx="0" cy="160020"/>
           </a:xfrm>
           <a:prstGeom prst="line">
             <a:avLst/>
           </a:prstGeom>
-          <a:ln w="19050">
+          <a:ln w="15240">
             <a:solidFill>
-              <a:srgbClr val="FF7A59"/>
+              <a:srgbClr val="775DA6"/>
             </a:solidFill>
+            <a:prstDash val="dash"/>
             <a:tailEnd type="arrow"/>
           </a:ln>
         </p:spPr>
@@ -22046,6 +21452,315 @@
           </a:fontRef>
         </p:style>
       </p:cxnSp>
+      <p:sp>
+        <p:nvSpPr>
+          <p:cNvPr id="44" name="Text 35"/>
+          <p:cNvSpPr/>
+          <p:nvPr/>
+        </p:nvSpPr>
+        <p:spPr>
+          <a:xfrm>
+            <a:off x="566928" y="6528816"/>
+            <a:ext cx="7112000" cy="146304"/>
+          </a:xfrm>
+          <a:prstGeom prst="rect">
+            <a:avLst/>
+          </a:prstGeom>
+          <a:noFill/>
+          <a:ln/>
+        </p:spPr>
+        <p:txBody>
+          <a:bodyPr wrap="square" lIns="0" tIns="0" rIns="0" bIns="0" rtlCol="0" anchor="ctr"/>
+          <a:lstStyle/>
+          <a:p>
+            <a:pPr marL="0" indent="0">
+              <a:buNone/>
+            </a:pPr>
+            <a:r>
+              <a:rPr lang="en-US" sz="750">
+                <a:solidFill>
+                  <a:srgbClr val="748494"/>
+                </a:solidFill>
+                <a:latin typeface="Aptos" pitchFamily="34" charset="0"/>
+                <a:ea typeface="Aptos" pitchFamily="34" charset="-122"/>
+                <a:cs typeface="Aptos" pitchFamily="34" charset="-120"/>
+              </a:rPr>
+              <a:t>Architecture: intent stays with the agent harness, controls stay in APIM, and telemetry converges in Application Insights</a:t>
+            </a:r>
+            <a:endParaRPr lang="en-US" sz="750" dirty="0"/>
+          </a:p>
+        </p:txBody>
+      </p:sp>
+      <p:sp>
+        <p:nvSpPr>
+          <p:cNvPr id="45" name="Slide Number Placeholder 0"/>
+          <p:cNvSpPr>
+            <a:spLocks noGrp="1"/>
+          </p:cNvSpPr>
+          <p:nvPr>
+            <p:ph type="sldNum" sz="quarter" idx="4294967295"/>
+          </p:nvPr>
+        </p:nvSpPr>
+        <p:spPr>
+          <a:xfrm>
+            <a:off x="11109960" y="6510528"/>
+            <a:ext cx="548640" cy="164592"/>
+          </a:xfrm>
+          <a:prstGeom prst="rect">
+            <a:avLst/>
+          </a:prstGeom>
+          <a:extLst>
+            <a:ext uri="{C572A759-6A51-4108-AA02-DFA0A04FC94B}">
+              <ma14:wrappingTextBoxFlag xmlns:ma14="http://schemas.microsoft.com/office/mac/drawingml/2011/main" xmlns="" val="0"/>
+            </a:ext>
+          </a:extLst>
+        </p:spPr>
+        <p:txBody>
+          <a:bodyPr/>
+          <a:lstStyle>
+            <a:lvl1pPr>
+              <a:defRPr sz="800">
+                <a:solidFill>
+                  <a:srgbClr val="748494"/>
+                </a:solidFill>
+                <a:latin typeface="Aptos"/>
+                <a:ea typeface="Aptos"/>
+                <a:cs typeface="Aptos"/>
+              </a:defRPr>
+            </a:lvl1pPr>
+          </a:lstStyle>
+          <a:p>
+            <a:pPr algn="r"/>
+            <a:fld id="{F7021451-1387-4CA6-816F-3879F97B5CBC}" type="slidenum">
+              <a:rPr lang="en-US" b="0"/>
+              <a:t>3</a:t>
+            </a:fld>
+            <a:endParaRPr lang="en-US"/>
+          </a:p>
+        </p:txBody>
+      </p:sp>
+      <p:pic>
+        <p:nvPicPr>
+          <p:cNvPr id="12" name="APIM Control Plane Icon">
+            <a:extLst>
+              <a:ext uri="{FF2B5EF4-FFF2-40B4-BE49-F238E27FC236}">
+                <a16:creationId xmlns:a16="http://schemas.microsoft.com/office/drawing/2014/main" id="{C0B8048B-43C1-A91F-B283-A31417C0F3D0}"/>
+              </a:ext>
+            </a:extLst>
+          </p:cNvPr>
+          <p:cNvPicPr>
+            <a:picLocks/>
+          </p:cNvPicPr>
+          <p:nvPr/>
+        </p:nvPicPr>
+        <p:blipFill>
+          <a:blip>
+            <a:extLst>
+              <a:ext uri="{96DAC541-7B7A-43D3-8B79-37D633B846F1}">
+                <asvg:svgBlip xmlns:asvg="http://schemas.microsoft.com/office/drawing/2016/SVG/main" r:embed="rId9"/>
+              </a:ext>
+            </a:extLst>
+          </a:blip>
+          <a:stretch>
+            <a:fillRect/>
+          </a:stretch>
+        </p:blipFill>
+        <p:spPr>
+          <a:xfrm>
+            <a:off x="5002530" y="1651000"/>
+            <a:ext cx="228600" cy="228600"/>
+          </a:xfrm>
+          <a:prstGeom prst="rect">
+            <a:avLst/>
+          </a:prstGeom>
+        </p:spPr>
+      </p:pic>
+      <p:pic>
+        <p:nvPicPr>
+          <p:cNvPr id="19" name="MCP Logo">
+            <a:extLst>
+              <a:ext uri="{FF2B5EF4-FFF2-40B4-BE49-F238E27FC236}">
+                <a16:creationId xmlns:a16="http://schemas.microsoft.com/office/drawing/2014/main" id="{C3017197-2A60-8421-3387-1932A693B652}"/>
+              </a:ext>
+            </a:extLst>
+          </p:cNvPr>
+          <p:cNvPicPr>
+            <a:picLocks/>
+          </p:cNvPicPr>
+          <p:nvPr/>
+        </p:nvPicPr>
+        <p:blipFill>
+          <a:blip>
+            <a:extLst>
+              <a:ext uri="{96DAC541-7B7A-43D3-8B79-37D633B846F1}">
+                <asvg:svgBlip xmlns:asvg="http://schemas.microsoft.com/office/drawing/2016/SVG/main" r:embed="rId10"/>
+              </a:ext>
+            </a:extLst>
+          </a:blip>
+          <a:stretch>
+            <a:fillRect/>
+          </a:stretch>
+        </p:blipFill>
+        <p:spPr>
+          <a:xfrm>
+            <a:off x="5641340" y="2381250"/>
+            <a:ext cx="431800" cy="431800"/>
+          </a:xfrm>
+          <a:prstGeom prst="rect">
+            <a:avLst/>
+          </a:prstGeom>
+        </p:spPr>
+      </p:pic>
+      <p:sp>
+        <p:nvSpPr>
+          <p:cNvPr id="39" name="Application Insights Layer"/>
+          <p:cNvSpPr/>
+          <p:nvPr/>
+        </p:nvSpPr>
+        <p:spPr>
+          <a:xfrm>
+            <a:off x="2514600" y="4224020"/>
+            <a:ext cx="6629400" cy="1042670"/>
+          </a:xfrm>
+          <a:prstGeom prst="roundRect">
+            <a:avLst/>
+          </a:prstGeom>
+          <a:solidFill>
+            <a:srgbClr val="FFFFFF"/>
+          </a:solidFill>
+          <a:ln w="12700">
+            <a:solidFill>
+              <a:srgbClr val="DDE6EC"/>
+            </a:solidFill>
+            <a:prstDash val="solid"/>
+          </a:ln>
+        </p:spPr>
+        <p:txBody>
+          <a:bodyPr/>
+          <a:lstStyle/>
+          <a:p>
+            <a:endParaRPr lang="en-US"/>
+          </a:p>
+        </p:txBody>
+      </p:sp>
+      <p:pic>
+        <p:nvPicPr>
+          <p:cNvPr id="36" name="Application Insights Icon">
+            <a:extLst>
+              <a:ext uri="{FF2B5EF4-FFF2-40B4-BE49-F238E27FC236}">
+                <a16:creationId xmlns:a16="http://schemas.microsoft.com/office/drawing/2014/main" id="{04534135-1108-534F-0976-55C24FE7C67C}"/>
+              </a:ext>
+            </a:extLst>
+          </p:cNvPr>
+          <p:cNvPicPr>
+            <a:picLocks/>
+          </p:cNvPicPr>
+          <p:nvPr/>
+        </p:nvPicPr>
+        <p:blipFill>
+          <a:blip>
+            <a:extLst>
+              <a:ext uri="{96DAC541-7B7A-43D3-8B79-37D633B846F1}">
+                <asvg:svgBlip xmlns:asvg="http://schemas.microsoft.com/office/drawing/2016/SVG/main" r:embed="rId11"/>
+              </a:ext>
+            </a:extLst>
+          </a:blip>
+          <a:stretch>
+            <a:fillRect/>
+          </a:stretch>
+        </p:blipFill>
+        <p:spPr>
+          <a:xfrm>
+            <a:off x="2768600" y="4452620"/>
+            <a:ext cx="406400" cy="406400"/>
+          </a:xfrm>
+          <a:prstGeom prst="rect">
+            <a:avLst/>
+          </a:prstGeom>
+        </p:spPr>
+      </p:pic>
+      <p:sp>
+        <p:nvSpPr>
+          <p:cNvPr id="41" name="Application Insights Title"/>
+          <p:cNvSpPr/>
+          <p:nvPr/>
+        </p:nvSpPr>
+        <p:spPr>
+          <a:xfrm>
+            <a:off x="3327400" y="4371340"/>
+            <a:ext cx="5461000" cy="228600"/>
+          </a:xfrm>
+          <a:prstGeom prst="rect">
+            <a:avLst/>
+          </a:prstGeom>
+          <a:noFill/>
+          <a:ln/>
+        </p:spPr>
+        <p:txBody>
+          <a:bodyPr wrap="square" lIns="0" tIns="0" rIns="0" bIns="0" rtlCol="0" anchor="ctr">
+            <a:normAutofit/>
+          </a:bodyPr>
+          <a:lstStyle/>
+          <a:p>
+            <a:pPr marL="0" indent="0">
+              <a:buNone/>
+            </a:pPr>
+            <a:r>
+              <a:rPr lang="en-US" sz="1300" b="1">
+                <a:solidFill>
+                  <a:srgbClr val="102A43"/>
+                </a:solidFill>
+                <a:latin typeface="Aptos Display" pitchFamily="34" charset="0"/>
+                <a:ea typeface="Aptos Display" pitchFamily="34" charset="-122"/>
+                <a:cs typeface="Aptos Display" pitchFamily="34" charset="-120"/>
+              </a:rPr>
+              <a:t>Application Insights</a:t>
+            </a:r>
+            <a:endParaRPr lang="en-US" sz="1300" dirty="0"/>
+          </a:p>
+        </p:txBody>
+      </p:sp>
+      <p:sp>
+        <p:nvSpPr>
+          <p:cNvPr id="42" name="Application Insights Body"/>
+          <p:cNvSpPr/>
+          <p:nvPr/>
+        </p:nvSpPr>
+        <p:spPr>
+          <a:xfrm>
+            <a:off x="3327400" y="4645660"/>
+            <a:ext cx="5461000" cy="381000"/>
+          </a:xfrm>
+          <a:prstGeom prst="rect">
+            <a:avLst/>
+          </a:prstGeom>
+          <a:noFill/>
+          <a:ln/>
+        </p:spPr>
+        <p:txBody>
+          <a:bodyPr wrap="square" lIns="0" tIns="0" rIns="0" bIns="0" rtlCol="0" anchor="ctr">
+            <a:normAutofit/>
+          </a:bodyPr>
+          <a:lstStyle/>
+          <a:p>
+            <a:pPr marL="0" indent="0">
+              <a:buNone/>
+            </a:pPr>
+            <a:r>
+              <a:rPr lang="en-US" sz="870">
+                <a:solidFill>
+                  <a:srgbClr val="4F6474"/>
+                </a:solidFill>
+                <a:latin typeface="Aptos" pitchFamily="34" charset="0"/>
+                <a:ea typeface="Aptos" pitchFamily="34" charset="-122"/>
+                <a:cs typeface="Aptos" pitchFamily="34" charset="-120"/>
+              </a:rPr>
+              <a:t>Agent and APIM telemetry for latency, failures, usage, correlation, and audit evidence</a:t>
+            </a:r>
+            <a:endParaRPr lang="en-US" sz="870" dirty="0"/>
+          </a:p>
+        </p:txBody>
+      </p:sp>
     </p:spTree>
   </p:cSld>
   <p:clrMapOvr>
@@ -24543,7 +24258,7 @@
           </a:prstGeom>
           <a:extLst>
             <a:ext uri="{C572A759-6A51-4108-AA02-DFA0A04FC94B}">
-              <ma14:wrappingTextBoxFlag xmlns="" xmlns:ma14="http://schemas.microsoft.com/office/mac/drawingml/2011/main" val="0"/>
+              <ma14:wrappingTextBoxFlag xmlns:ma14="http://schemas.microsoft.com/office/mac/drawingml/2011/main" xmlns="" val="0"/>
             </a:ext>
           </a:extLst>
         </p:spPr>
@@ -25631,7 +25346,7 @@
           </a:prstGeom>
           <a:extLst>
             <a:ext uri="{C572A759-6A51-4108-AA02-DFA0A04FC94B}">
-              <ma14:wrappingTextBoxFlag xmlns="" xmlns:ma14="http://schemas.microsoft.com/office/mac/drawingml/2011/main" val="0"/>
+              <ma14:wrappingTextBoxFlag xmlns:ma14="http://schemas.microsoft.com/office/mac/drawingml/2011/main" xmlns="" val="0"/>
             </a:ext>
           </a:extLst>
         </p:spPr>
@@ -26786,7 +26501,7 @@
           </a:prstGeom>
           <a:extLst>
             <a:ext uri="{C572A759-6A51-4108-AA02-DFA0A04FC94B}">
-              <ma14:wrappingTextBoxFlag xmlns="" xmlns:ma14="http://schemas.microsoft.com/office/mac/drawingml/2011/main" val="0"/>
+              <ma14:wrappingTextBoxFlag xmlns:ma14="http://schemas.microsoft.com/office/mac/drawingml/2011/main" xmlns="" val="0"/>
             </a:ext>
           </a:extLst>
         </p:spPr>
@@ -28197,7 +27912,7 @@
           </a:prstGeom>
           <a:extLst>
             <a:ext uri="{C572A759-6A51-4108-AA02-DFA0A04FC94B}">
-              <ma14:wrappingTextBoxFlag xmlns="" xmlns:ma14="http://schemas.microsoft.com/office/mac/drawingml/2011/main" val="0"/>
+              <ma14:wrappingTextBoxFlag xmlns:ma14="http://schemas.microsoft.com/office/mac/drawingml/2011/main" xmlns="" val="0"/>
             </a:ext>
           </a:extLst>
         </p:spPr>
@@ -29184,7 +28899,7 @@
           </a:prstGeom>
           <a:extLst>
             <a:ext uri="{C572A759-6A51-4108-AA02-DFA0A04FC94B}">
-              <ma14:wrappingTextBoxFlag xmlns="" xmlns:ma14="http://schemas.microsoft.com/office/mac/drawingml/2011/main" val="0"/>
+              <ma14:wrappingTextBoxFlag xmlns:ma14="http://schemas.microsoft.com/office/mac/drawingml/2011/main" xmlns="" val="0"/>
             </a:ext>
           </a:extLst>
         </p:spPr>
@@ -30572,7 +30287,7 @@
           </a:prstGeom>
           <a:extLst>
             <a:ext uri="{C572A759-6A51-4108-AA02-DFA0A04FC94B}">
-              <ma14:wrappingTextBoxFlag xmlns="" xmlns:ma14="http://schemas.microsoft.com/office/mac/drawingml/2011/main" val="0"/>
+              <ma14:wrappingTextBoxFlag xmlns:ma14="http://schemas.microsoft.com/office/mac/drawingml/2011/main" xmlns="" val="0"/>
             </a:ext>
           </a:extLst>
         </p:spPr>

</xml_diff>

<commit_message>
Refine slide 3 governance spans
Clarify the layered architecture with Agent 365 over the agent and MCP server, APIM controls over MCP and the REST contract, and shared Application Insights telemetry. Update the runtime labels and use the official MCP, OpenAPI, APIM, and Application Insights icons.

Co-authored-by: Copilot <223556219+Copilot@users.noreply.github.com>
Copilot-Session: aa1a2148-b4d0-4cc5-94ea-497594b4b72a
</commit_message>
<xml_diff>
--- a/docs/foundry-apim-mcp-workshop.pptx
+++ b/docs/foundry-apim-mcp-workshop.pptx
@@ -19881,14 +19881,52 @@
       </p:grpSpPr>
       <p:sp>
         <p:nvSpPr>
+          <p:cNvPr id="25" name="REST Telemetry Arrow">
+            <a:extLst>
+              <a:ext uri="{FF2B5EF4-FFF2-40B4-BE49-F238E27FC236}">
+                <a16:creationId xmlns:a16="http://schemas.microsoft.com/office/drawing/2014/main" id="{7E4B0AB1-5054-6D6B-7006-3BEE6C8341C0}"/>
+              </a:ext>
+            </a:extLst>
+          </p:cNvPr>
+          <p:cNvSpPr/>
+          <p:nvPr/>
+        </p:nvSpPr>
+        <p:spPr>
+          <a:xfrm>
+            <a:off x="8206740" y="4445000"/>
+            <a:ext cx="0" cy="558800"/>
+          </a:xfrm>
+          <a:prstGeom prst="line">
+            <a:avLst/>
+          </a:prstGeom>
+          <a:noFill/>
+          <a:ln w="22225">
+            <a:solidFill>
+              <a:srgbClr val="5BD6C5"/>
+            </a:solidFill>
+            <a:prstDash val="solid"/>
+            <a:headEnd type="none"/>
+            <a:tailEnd type="arrow"/>
+          </a:ln>
+        </p:spPr>
+        <p:txBody>
+          <a:bodyPr/>
+          <a:lstStyle/>
+          <a:p>
+            <a:endParaRPr lang="en-US"/>
+          </a:p>
+        </p:txBody>
+      </p:sp>
+      <p:sp>
+        <p:nvSpPr>
           <p:cNvPr id="38" name="APIM Telemetry Arrow"/>
           <p:cNvSpPr/>
           <p:nvPr/>
         </p:nvSpPr>
         <p:spPr>
           <a:xfrm>
-            <a:off x="5857240" y="3703320"/>
-            <a:ext cx="0" cy="520700"/>
+            <a:off x="5857240" y="4445000"/>
+            <a:ext cx="0" cy="558800"/>
           </a:xfrm>
           <a:prstGeom prst="line">
             <a:avLst/>
@@ -19925,8 +19963,8 @@
         </p:nvCxnSpPr>
         <p:spPr>
           <a:xfrm>
-            <a:off x="3483610" y="3703320"/>
-            <a:ext cx="0" cy="520700"/>
+            <a:off x="3483610" y="4445000"/>
+            <a:ext cx="0" cy="558800"/>
           </a:xfrm>
           <a:prstGeom prst="line">
             <a:avLst/>
@@ -19954,6 +19992,182 @@
           </a:fontRef>
         </p:style>
       </p:cxnSp>
+      <p:cxnSp>
+        <p:nvCxnSpPr>
+          <p:cNvPr id="24" name="APIM REST Connector">
+            <a:extLst>
+              <a:ext uri="{FF2B5EF4-FFF2-40B4-BE49-F238E27FC236}">
+                <a16:creationId xmlns:a16="http://schemas.microsoft.com/office/drawing/2014/main" id="{545BE33A-AB25-9E5F-0E83-963B511BE5DF}"/>
+              </a:ext>
+            </a:extLst>
+          </p:cNvPr>
+          <p:cNvCxnSpPr/>
+          <p:nvPr/>
+        </p:nvCxnSpPr>
+        <p:spPr>
+          <a:xfrm>
+            <a:off x="8206740" y="2641600"/>
+            <a:ext cx="0" cy="203200"/>
+          </a:xfrm>
+          <a:prstGeom prst="line">
+            <a:avLst/>
+          </a:prstGeom>
+          <a:ln w="15240">
+            <a:solidFill>
+              <a:srgbClr val="775DA6"/>
+            </a:solidFill>
+            <a:prstDash val="dash"/>
+            <a:headEnd type="none"/>
+            <a:tailEnd type="arrow"/>
+          </a:ln>
+        </p:spPr>
+        <p:style>
+          <a:lnRef idx="1">
+            <a:schemeClr val="accent1"/>
+          </a:lnRef>
+          <a:fillRef idx="0">
+            <a:schemeClr val="accent1"/>
+          </a:fillRef>
+          <a:effectRef idx="0">
+            <a:schemeClr val="accent1"/>
+          </a:effectRef>
+          <a:fontRef idx="minor">
+            <a:schemeClr val="tx1"/>
+          </a:fontRef>
+        </p:style>
+      </p:cxnSp>
+      <p:cxnSp>
+        <p:nvCxnSpPr>
+          <p:cNvPr id="61" name="APIM Control Plane Connector">
+            <a:extLst>
+              <a:ext uri="{FF2B5EF4-FFF2-40B4-BE49-F238E27FC236}">
+                <a16:creationId xmlns:a16="http://schemas.microsoft.com/office/drawing/2014/main" id="{BE07AF09-DCC1-5A6D-64B0-E7024656B9E7}"/>
+              </a:ext>
+            </a:extLst>
+          </p:cNvPr>
+          <p:cNvCxnSpPr/>
+          <p:nvPr/>
+        </p:nvCxnSpPr>
+        <p:spPr>
+          <a:xfrm>
+            <a:off x="5857240" y="2641600"/>
+            <a:ext cx="0" cy="203200"/>
+          </a:xfrm>
+          <a:prstGeom prst="line">
+            <a:avLst/>
+          </a:prstGeom>
+          <a:ln w="15240">
+            <a:solidFill>
+              <a:srgbClr val="775DA6"/>
+            </a:solidFill>
+            <a:prstDash val="dash"/>
+            <a:headEnd type="none"/>
+            <a:tailEnd type="arrow"/>
+          </a:ln>
+        </p:spPr>
+        <p:style>
+          <a:lnRef idx="1">
+            <a:schemeClr val="accent1"/>
+          </a:lnRef>
+          <a:fillRef idx="0">
+            <a:schemeClr val="accent1"/>
+          </a:fillRef>
+          <a:effectRef idx="0">
+            <a:schemeClr val="accent1"/>
+          </a:effectRef>
+          <a:fontRef idx="minor">
+            <a:schemeClr val="tx1"/>
+          </a:fontRef>
+        </p:style>
+      </p:cxnSp>
+      <p:cxnSp>
+        <p:nvCxnSpPr>
+          <p:cNvPr id="58" name="Agent 365 Connector">
+            <a:extLst>
+              <a:ext uri="{FF2B5EF4-FFF2-40B4-BE49-F238E27FC236}">
+                <a16:creationId xmlns:a16="http://schemas.microsoft.com/office/drawing/2014/main" id="{D736F929-2089-7C86-D8F3-2E549E293323}"/>
+              </a:ext>
+            </a:extLst>
+          </p:cNvPr>
+          <p:cNvCxnSpPr/>
+          <p:nvPr/>
+        </p:nvCxnSpPr>
+        <p:spPr>
+          <a:xfrm>
+            <a:off x="3483610" y="1981200"/>
+            <a:ext cx="0" cy="863600"/>
+          </a:xfrm>
+          <a:prstGeom prst="line">
+            <a:avLst/>
+          </a:prstGeom>
+          <a:ln w="15240">
+            <a:solidFill>
+              <a:srgbClr val="775DA6"/>
+            </a:solidFill>
+            <a:prstDash val="dash"/>
+            <a:headEnd type="none"/>
+            <a:tailEnd type="arrow"/>
+          </a:ln>
+        </p:spPr>
+        <p:style>
+          <a:lnRef idx="1">
+            <a:schemeClr val="accent1"/>
+          </a:lnRef>
+          <a:fillRef idx="0">
+            <a:schemeClr val="accent1"/>
+          </a:fillRef>
+          <a:effectRef idx="0">
+            <a:schemeClr val="accent1"/>
+          </a:effectRef>
+          <a:fontRef idx="minor">
+            <a:schemeClr val="tx1"/>
+          </a:fontRef>
+        </p:style>
+      </p:cxnSp>
+      <p:cxnSp>
+        <p:nvCxnSpPr>
+          <p:cNvPr id="18" name="Agent 365 APIM Connector">
+            <a:extLst>
+              <a:ext uri="{FF2B5EF4-FFF2-40B4-BE49-F238E27FC236}">
+                <a16:creationId xmlns:a16="http://schemas.microsoft.com/office/drawing/2014/main" id="{C98DA599-5661-3FAD-E212-F71F7E71723C}"/>
+              </a:ext>
+            </a:extLst>
+          </p:cNvPr>
+          <p:cNvCxnSpPr/>
+          <p:nvPr/>
+        </p:nvCxnSpPr>
+        <p:spPr>
+          <a:xfrm>
+            <a:off x="5857240" y="1981200"/>
+            <a:ext cx="0" cy="203200"/>
+          </a:xfrm>
+          <a:prstGeom prst="line">
+            <a:avLst/>
+          </a:prstGeom>
+          <a:ln w="15240">
+            <a:solidFill>
+              <a:srgbClr val="775DA6"/>
+            </a:solidFill>
+            <a:prstDash val="dash"/>
+            <a:headEnd type="none"/>
+            <a:tailEnd type="arrow"/>
+          </a:ln>
+        </p:spPr>
+        <p:style>
+          <a:lnRef idx="1">
+            <a:schemeClr val="accent1"/>
+          </a:lnRef>
+          <a:fillRef idx="0">
+            <a:schemeClr val="accent1"/>
+          </a:fillRef>
+          <a:effectRef idx="0">
+            <a:schemeClr val="accent1"/>
+          </a:effectRef>
+          <a:fontRef idx="minor">
+            <a:schemeClr val="tx1"/>
+          </a:fontRef>
+        </p:style>
+      </p:cxnSp>
       <p:sp>
         <p:nvSpPr>
           <p:cNvPr id="2" name="Text 0"/>
@@ -20083,7 +20297,7 @@
         </p:nvSpPr>
         <p:spPr>
           <a:xfrm>
-            <a:off x="566928" y="2103120"/>
+            <a:off x="566928" y="2844800"/>
             <a:ext cx="1572768" cy="1600200"/>
           </a:xfrm>
           <a:prstGeom prst="roundRect">
@@ -20122,7 +20336,7 @@
         </p:nvSpPr>
         <p:spPr>
           <a:xfrm>
-            <a:off x="1088136" y="2331720"/>
+            <a:off x="1088136" y="3073400"/>
             <a:ext cx="530352" cy="530352"/>
           </a:xfrm>
           <a:prstGeom prst="ellipse">
@@ -20168,7 +20382,7 @@
         </p:blipFill>
         <p:spPr>
           <a:xfrm>
-            <a:off x="1216152" y="2459736"/>
+            <a:off x="1216152" y="3201670"/>
             <a:ext cx="274320" cy="274320"/>
           </a:xfrm>
           <a:prstGeom prst="rect">
@@ -20184,7 +20398,7 @@
         </p:nvSpPr>
         <p:spPr>
           <a:xfrm>
-            <a:off x="676656" y="2999232"/>
+            <a:off x="676656" y="3741420"/>
             <a:ext cx="1353312" cy="256032"/>
           </a:xfrm>
           <a:prstGeom prst="rect">
@@ -20225,7 +20439,7 @@
         </p:nvSpPr>
         <p:spPr>
           <a:xfrm>
-            <a:off x="676656" y="3328416"/>
+            <a:off x="676656" y="4070350"/>
             <a:ext cx="1353312" cy="182880"/>
           </a:xfrm>
           <a:prstGeom prst="rect">
@@ -20266,7 +20480,7 @@
         </p:nvSpPr>
         <p:spPr>
           <a:xfrm>
-            <a:off x="2138680" y="2907792"/>
+            <a:off x="2138680" y="3649980"/>
             <a:ext cx="375920" cy="0"/>
           </a:xfrm>
           <a:prstGeom prst="line">
@@ -20297,7 +20511,7 @@
         </p:nvSpPr>
         <p:spPr>
           <a:xfrm>
-            <a:off x="2514600" y="2103120"/>
+            <a:off x="2514600" y="2844800"/>
             <a:ext cx="1938528" cy="1600200"/>
           </a:xfrm>
           <a:prstGeom prst="roundRect">
@@ -20336,7 +20550,7 @@
         </p:nvSpPr>
         <p:spPr>
           <a:xfrm>
-            <a:off x="2624328" y="2999232"/>
+            <a:off x="2624328" y="3741420"/>
             <a:ext cx="1719072" cy="256032"/>
           </a:xfrm>
           <a:prstGeom prst="rect">
@@ -20377,7 +20591,7 @@
         </p:nvSpPr>
         <p:spPr>
           <a:xfrm>
-            <a:off x="2624328" y="3328416"/>
+            <a:off x="2624328" y="4070350"/>
             <a:ext cx="1719072" cy="182880"/>
           </a:xfrm>
           <a:prstGeom prst="rect">
@@ -20418,7 +20632,7 @@
         </p:nvSpPr>
         <p:spPr>
           <a:xfrm>
-            <a:off x="4452620" y="2907792"/>
+            <a:off x="4452620" y="3649980"/>
             <a:ext cx="421640" cy="0"/>
           </a:xfrm>
           <a:prstGeom prst="line">
@@ -20449,7 +20663,7 @@
         </p:nvSpPr>
         <p:spPr>
           <a:xfrm>
-            <a:off x="4873752" y="2103120"/>
+            <a:off x="4873752" y="2844800"/>
             <a:ext cx="1965960" cy="1600200"/>
           </a:xfrm>
           <a:prstGeom prst="roundRect">
@@ -20488,7 +20702,7 @@
         </p:nvSpPr>
         <p:spPr>
           <a:xfrm>
-            <a:off x="4983480" y="2999232"/>
+            <a:off x="4983480" y="3741420"/>
             <a:ext cx="1746504" cy="256032"/>
           </a:xfrm>
           <a:prstGeom prst="rect">
@@ -20507,7 +20721,7 @@
               <a:buNone/>
             </a:pPr>
             <a:r>
-              <a:rPr lang="en-US" sz="1300" b="1" dirty="0">
+              <a:rPr lang="en-US" sz="1300" b="1">
                 <a:solidFill>
                   <a:srgbClr val="102A43"/>
                 </a:solidFill>
@@ -20515,7 +20729,7 @@
                 <a:ea typeface="Aptos Display" pitchFamily="34" charset="-122"/>
                 <a:cs typeface="Aptos Display" pitchFamily="34" charset="-120"/>
               </a:rPr>
-              <a:t>APIM MCP server</a:t>
+              <a:t>MCP Server</a:t>
             </a:r>
             <a:endParaRPr lang="en-US" sz="1300" dirty="0"/>
           </a:p>
@@ -20529,7 +20743,7 @@
         </p:nvSpPr>
         <p:spPr>
           <a:xfrm>
-            <a:off x="4983480" y="3328416"/>
+            <a:off x="4983480" y="4070350"/>
             <a:ext cx="1746504" cy="182880"/>
           </a:xfrm>
           <a:prstGeom prst="rect">
@@ -20570,7 +20784,7 @@
         </p:nvSpPr>
         <p:spPr>
           <a:xfrm>
-            <a:off x="6840220" y="2907792"/>
+            <a:off x="6840220" y="3649980"/>
             <a:ext cx="429260" cy="0"/>
           </a:xfrm>
           <a:prstGeom prst="line">
@@ -20601,7 +20815,7 @@
         </p:nvSpPr>
         <p:spPr>
           <a:xfrm>
-            <a:off x="7269480" y="2103120"/>
+            <a:off x="7269480" y="2844800"/>
             <a:ext cx="1874520" cy="1600200"/>
           </a:xfrm>
           <a:prstGeom prst="roundRect">
@@ -20634,75 +20848,13 @@
       </p:sp>
       <p:sp>
         <p:nvSpPr>
-          <p:cNvPr id="24" name="Shape 19"/>
-          <p:cNvSpPr/>
-          <p:nvPr/>
-        </p:nvSpPr>
-        <p:spPr>
-          <a:xfrm>
-            <a:off x="7941564" y="2331720"/>
-            <a:ext cx="530352" cy="530352"/>
-          </a:xfrm>
-          <a:prstGeom prst="ellipse">
-            <a:avLst/>
-          </a:prstGeom>
-          <a:solidFill>
-            <a:srgbClr val="4F8EF7"/>
-          </a:solidFill>
-          <a:ln w="12700">
-            <a:solidFill>
-              <a:srgbClr val="4F8EF7"/>
-            </a:solidFill>
-            <a:prstDash val="solid"/>
-          </a:ln>
-        </p:spPr>
-        <p:txBody>
-          <a:bodyPr/>
-          <a:lstStyle/>
-          <a:p>
-            <a:endParaRPr lang="en-US"/>
-          </a:p>
-        </p:txBody>
-      </p:sp>
-      <p:pic>
-        <p:nvPicPr>
-          <p:cNvPr id="25" name="Image 3" descr="preencoded.png"/>
-          <p:cNvPicPr>
-            <a:picLocks noChangeAspect="1"/>
-          </p:cNvPicPr>
-          <p:nvPr/>
-        </p:nvPicPr>
-        <p:blipFill>
-          <a:blip>
-            <a:extLst>
-              <a:ext uri="{96DAC541-7B7A-43D3-8B79-37D633B846F1}">
-                <asvg:svgBlip xmlns:asvg="http://schemas.microsoft.com/office/drawing/2016/SVG/main" r:embed="rId4"/>
-              </a:ext>
-            </a:extLst>
-          </a:blip>
-          <a:stretch>
-            <a:fillRect/>
-          </a:stretch>
-        </p:blipFill>
-        <p:spPr>
-          <a:xfrm>
-            <a:off x="8069580" y="2459736"/>
-            <a:ext cx="274320" cy="274320"/>
-          </a:xfrm>
-          <a:prstGeom prst="rect">
-            <a:avLst/>
-          </a:prstGeom>
-        </p:spPr>
-      </p:pic>
-      <p:sp>
-        <p:nvSpPr>
           <p:cNvPr id="26" name="Text 20"/>
           <p:cNvSpPr/>
           <p:nvPr/>
         </p:nvSpPr>
         <p:spPr>
           <a:xfrm>
-            <a:off x="7379208" y="2999232"/>
+            <a:off x="7379208" y="3741420"/>
             <a:ext cx="1655064" cy="256032"/>
           </a:xfrm>
           <a:prstGeom prst="rect">
@@ -20743,7 +20895,7 @@
         </p:nvSpPr>
         <p:spPr>
           <a:xfrm>
-            <a:off x="7379208" y="3328416"/>
+            <a:off x="7379208" y="4070350"/>
             <a:ext cx="1655064" cy="182880"/>
           </a:xfrm>
           <a:prstGeom prst="rect">
@@ -20784,7 +20936,7 @@
         </p:nvSpPr>
         <p:spPr>
           <a:xfrm>
-            <a:off x="9144000" y="2907792"/>
+            <a:off x="9144000" y="3649980"/>
             <a:ext cx="429260" cy="0"/>
           </a:xfrm>
           <a:prstGeom prst="line">
@@ -20815,7 +20967,7 @@
         </p:nvSpPr>
         <p:spPr>
           <a:xfrm>
-            <a:off x="9573768" y="2103120"/>
+            <a:off x="9573768" y="2844800"/>
             <a:ext cx="2029968" cy="1600200"/>
           </a:xfrm>
           <a:prstGeom prst="roundRect">
@@ -20854,7 +21006,7 @@
         </p:nvSpPr>
         <p:spPr>
           <a:xfrm>
-            <a:off x="10323576" y="2331720"/>
+            <a:off x="10323576" y="3073400"/>
             <a:ext cx="530352" cy="530352"/>
           </a:xfrm>
           <a:prstGeom prst="ellipse">
@@ -20883,6 +21035,124 @@
           <p:cNvPr id="31" name="Image 4" descr="preencoded.png"/>
           <p:cNvPicPr>
             <a:picLocks noChangeAspect="1"/>
+          </p:cNvPicPr>
+          <p:nvPr/>
+        </p:nvPicPr>
+        <p:blipFill>
+          <a:blip>
+            <a:extLst>
+              <a:ext uri="{96DAC541-7B7A-43D3-8B79-37D633B846F1}">
+                <asvg:svgBlip xmlns:asvg="http://schemas.microsoft.com/office/drawing/2016/SVG/main" r:embed="rId4"/>
+              </a:ext>
+            </a:extLst>
+          </a:blip>
+          <a:stretch>
+            <a:fillRect/>
+          </a:stretch>
+        </p:blipFill>
+        <p:spPr>
+          <a:xfrm>
+            <a:off x="10451592" y="3201670"/>
+            <a:ext cx="274320" cy="274320"/>
+          </a:xfrm>
+          <a:prstGeom prst="rect">
+            <a:avLst/>
+          </a:prstGeom>
+        </p:spPr>
+      </p:pic>
+      <p:sp>
+        <p:nvSpPr>
+          <p:cNvPr id="32" name="Text 25"/>
+          <p:cNvSpPr/>
+          <p:nvPr/>
+        </p:nvSpPr>
+        <p:spPr>
+          <a:xfrm>
+            <a:off x="9683496" y="3741420"/>
+            <a:ext cx="1810512" cy="256032"/>
+          </a:xfrm>
+          <a:prstGeom prst="rect">
+            <a:avLst/>
+          </a:prstGeom>
+          <a:noFill/>
+          <a:ln/>
+        </p:spPr>
+        <p:txBody>
+          <a:bodyPr wrap="square" lIns="0" tIns="0" rIns="0" bIns="0" rtlCol="0" anchor="ctr">
+            <a:normAutofit/>
+          </a:bodyPr>
+          <a:lstStyle/>
+          <a:p>
+            <a:pPr marL="0" indent="0" algn="ctr">
+              <a:buNone/>
+            </a:pPr>
+            <a:r>
+              <a:rPr lang="en-US" sz="1300" b="1" dirty="0">
+                <a:solidFill>
+                  <a:srgbClr val="102A43"/>
+                </a:solidFill>
+                <a:latin typeface="Aptos Display" pitchFamily="34" charset="0"/>
+                <a:ea typeface="Aptos Display" pitchFamily="34" charset="-122"/>
+                <a:cs typeface="Aptos Display" pitchFamily="34" charset="-120"/>
+              </a:rPr>
+              <a:t>Backend</a:t>
+            </a:r>
+            <a:endParaRPr lang="en-US" sz="1300" dirty="0"/>
+          </a:p>
+        </p:txBody>
+      </p:sp>
+      <p:sp>
+        <p:nvSpPr>
+          <p:cNvPr id="33" name="Text 26"/>
+          <p:cNvSpPr/>
+          <p:nvPr/>
+        </p:nvSpPr>
+        <p:spPr>
+          <a:xfrm>
+            <a:off x="9683496" y="4070350"/>
+            <a:ext cx="1810512" cy="182880"/>
+          </a:xfrm>
+          <a:prstGeom prst="rect">
+            <a:avLst/>
+          </a:prstGeom>
+          <a:noFill/>
+          <a:ln/>
+        </p:spPr>
+        <p:txBody>
+          <a:bodyPr wrap="square" lIns="0" tIns="0" rIns="0" bIns="0" rtlCol="0" anchor="ctr">
+            <a:normAutofit/>
+          </a:bodyPr>
+          <a:lstStyle/>
+          <a:p>
+            <a:pPr marL="0" indent="0" algn="ctr">
+              <a:buNone/>
+            </a:pPr>
+            <a:r>
+              <a:rPr lang="en-US" sz="870" dirty="0">
+                <a:solidFill>
+                  <a:srgbClr val="4F6474"/>
+                </a:solidFill>
+                <a:latin typeface="Aptos" pitchFamily="34" charset="0"/>
+                <a:ea typeface="Aptos" pitchFamily="34" charset="-122"/>
+                <a:cs typeface="Aptos" pitchFamily="34" charset="-120"/>
+              </a:rPr>
+              <a:t>Mock response or Petstore</a:t>
+            </a:r>
+            <a:endParaRPr lang="en-US" sz="870" dirty="0"/>
+          </a:p>
+        </p:txBody>
+      </p:sp>
+      <p:pic>
+        <p:nvPicPr>
+          <p:cNvPr id="49" name="Microsoft Copilot Studio Icon">
+            <a:extLst>
+              <a:ext uri="{FF2B5EF4-FFF2-40B4-BE49-F238E27FC236}">
+                <a16:creationId xmlns:a16="http://schemas.microsoft.com/office/drawing/2014/main" id="{7D163EBB-95FE-D701-C53B-0FDA5E90DB9F}"/>
+              </a:ext>
+            </a:extLst>
+          </p:cNvPr>
+          <p:cNvPicPr>
+            <a:picLocks/>
           </p:cNvPicPr>
           <p:nvPr/>
         </p:nvPicPr>
@@ -20900,102 +21170,20 @@
         </p:blipFill>
         <p:spPr>
           <a:xfrm>
-            <a:off x="10451592" y="2459736"/>
-            <a:ext cx="274320" cy="274320"/>
+            <a:off x="3528314" y="3173730"/>
+            <a:ext cx="330200" cy="330200"/>
           </a:xfrm>
           <a:prstGeom prst="rect">
             <a:avLst/>
           </a:prstGeom>
         </p:spPr>
       </p:pic>
-      <p:sp>
-        <p:nvSpPr>
-          <p:cNvPr id="32" name="Text 25"/>
-          <p:cNvSpPr/>
-          <p:nvPr/>
-        </p:nvSpPr>
-        <p:spPr>
-          <a:xfrm>
-            <a:off x="9683496" y="2999232"/>
-            <a:ext cx="1810512" cy="256032"/>
-          </a:xfrm>
-          <a:prstGeom prst="rect">
-            <a:avLst/>
-          </a:prstGeom>
-          <a:noFill/>
-          <a:ln/>
-        </p:spPr>
-        <p:txBody>
-          <a:bodyPr wrap="square" lIns="0" tIns="0" rIns="0" bIns="0" rtlCol="0" anchor="ctr">
-            <a:normAutofit/>
-          </a:bodyPr>
-          <a:lstStyle/>
-          <a:p>
-            <a:pPr marL="0" indent="0" algn="ctr">
-              <a:buNone/>
-            </a:pPr>
-            <a:r>
-              <a:rPr lang="en-US" sz="1300" b="1" dirty="0">
-                <a:solidFill>
-                  <a:srgbClr val="102A43"/>
-                </a:solidFill>
-                <a:latin typeface="Aptos Display" pitchFamily="34" charset="0"/>
-                <a:ea typeface="Aptos Display" pitchFamily="34" charset="-122"/>
-                <a:cs typeface="Aptos Display" pitchFamily="34" charset="-120"/>
-              </a:rPr>
-              <a:t>Backend</a:t>
-            </a:r>
-            <a:endParaRPr lang="en-US" sz="1300" dirty="0"/>
-          </a:p>
-        </p:txBody>
-      </p:sp>
-      <p:sp>
-        <p:nvSpPr>
-          <p:cNvPr id="33" name="Text 26"/>
-          <p:cNvSpPr/>
-          <p:nvPr/>
-        </p:nvSpPr>
-        <p:spPr>
-          <a:xfrm>
-            <a:off x="9683496" y="3328416"/>
-            <a:ext cx="1810512" cy="182880"/>
-          </a:xfrm>
-          <a:prstGeom prst="rect">
-            <a:avLst/>
-          </a:prstGeom>
-          <a:noFill/>
-          <a:ln/>
-        </p:spPr>
-        <p:txBody>
-          <a:bodyPr wrap="square" lIns="0" tIns="0" rIns="0" bIns="0" rtlCol="0" anchor="ctr">
-            <a:normAutofit/>
-          </a:bodyPr>
-          <a:lstStyle/>
-          <a:p>
-            <a:pPr marL="0" indent="0" algn="ctr">
-              <a:buNone/>
-            </a:pPr>
-            <a:r>
-              <a:rPr lang="en-US" sz="870" dirty="0">
-                <a:solidFill>
-                  <a:srgbClr val="4F6474"/>
-                </a:solidFill>
-                <a:latin typeface="Aptos" pitchFamily="34" charset="0"/>
-                <a:ea typeface="Aptos" pitchFamily="34" charset="-122"/>
-                <a:cs typeface="Aptos" pitchFamily="34" charset="-120"/>
-              </a:rPr>
-              <a:t>Mock response or Petstore</a:t>
-            </a:r>
-            <a:endParaRPr lang="en-US" sz="870" dirty="0"/>
-          </a:p>
-        </p:txBody>
-      </p:sp>
       <p:pic>
         <p:nvPicPr>
-          <p:cNvPr id="49" name="Microsoft Copilot Studio Icon">
+          <p:cNvPr id="13" name="Microsoft Foundry Agent Service Icon">
             <a:extLst>
               <a:ext uri="{FF2B5EF4-FFF2-40B4-BE49-F238E27FC236}">
-                <a16:creationId xmlns:a16="http://schemas.microsoft.com/office/drawing/2014/main" id="{7D163EBB-95FE-D701-C53B-0FDA5E90DB9F}"/>
+                <a16:creationId xmlns:a16="http://schemas.microsoft.com/office/drawing/2014/main" id="{7CA32E2E-6B9A-7AED-FDF5-EF9F21CDEB73}"/>
               </a:ext>
             </a:extLst>
           </p:cNvPr>
@@ -21018,7 +21206,7 @@
         </p:blipFill>
         <p:spPr>
           <a:xfrm>
-            <a:off x="3528314" y="2431796"/>
+            <a:off x="3109214" y="3173730"/>
             <a:ext cx="330200" cy="330200"/>
           </a:xfrm>
           <a:prstGeom prst="rect">
@@ -21026,12 +21214,99 @@
           </a:prstGeom>
         </p:spPr>
       </p:pic>
+      <p:sp>
+        <p:nvSpPr>
+          <p:cNvPr id="44" name="Text 35"/>
+          <p:cNvSpPr/>
+          <p:nvPr/>
+        </p:nvSpPr>
+        <p:spPr>
+          <a:xfrm>
+            <a:off x="566928" y="6528816"/>
+            <a:ext cx="7112000" cy="146304"/>
+          </a:xfrm>
+          <a:prstGeom prst="rect">
+            <a:avLst/>
+          </a:prstGeom>
+          <a:noFill/>
+          <a:ln/>
+        </p:spPr>
+        <p:txBody>
+          <a:bodyPr wrap="square" lIns="0" tIns="0" rIns="0" bIns="0" rtlCol="0" anchor="ctr"/>
+          <a:lstStyle/>
+          <a:p>
+            <a:pPr marL="0" indent="0">
+              <a:buNone/>
+            </a:pPr>
+            <a:r>
+              <a:rPr lang="en-US" sz="750">
+                <a:solidFill>
+                  <a:srgbClr val="748494"/>
+                </a:solidFill>
+                <a:latin typeface="Aptos" pitchFamily="34" charset="0"/>
+                <a:ea typeface="Aptos" pitchFamily="34" charset="-122"/>
+                <a:cs typeface="Aptos" pitchFamily="34" charset="-120"/>
+              </a:rPr>
+              <a:t>Architecture: intent stays with the agent harness, controls stay in APIM, and telemetry converges in Application Insights</a:t>
+            </a:r>
+            <a:endParaRPr lang="en-US" sz="750" dirty="0"/>
+          </a:p>
+        </p:txBody>
+      </p:sp>
+      <p:sp>
+        <p:nvSpPr>
+          <p:cNvPr id="45" name="Slide Number Placeholder 0"/>
+          <p:cNvSpPr>
+            <a:spLocks noGrp="1"/>
+          </p:cNvSpPr>
+          <p:nvPr>
+            <p:ph type="sldNum" sz="quarter" idx="4294967295"/>
+          </p:nvPr>
+        </p:nvSpPr>
+        <p:spPr>
+          <a:xfrm>
+            <a:off x="11109960" y="6510528"/>
+            <a:ext cx="548640" cy="164592"/>
+          </a:xfrm>
+          <a:prstGeom prst="rect">
+            <a:avLst/>
+          </a:prstGeom>
+          <a:extLst>
+            <a:ext uri="{C572A759-6A51-4108-AA02-DFA0A04FC94B}">
+              <ma14:wrappingTextBoxFlag xmlns:ma14="http://schemas.microsoft.com/office/mac/drawingml/2011/main" xmlns="" val="0"/>
+            </a:ext>
+          </a:extLst>
+        </p:spPr>
+        <p:txBody>
+          <a:bodyPr/>
+          <a:lstStyle>
+            <a:lvl1pPr>
+              <a:defRPr sz="800">
+                <a:solidFill>
+                  <a:srgbClr val="748494"/>
+                </a:solidFill>
+                <a:latin typeface="Aptos"/>
+                <a:ea typeface="Aptos"/>
+                <a:cs typeface="Aptos"/>
+              </a:defRPr>
+            </a:lvl1pPr>
+          </a:lstStyle>
+          <a:p>
+            <a:pPr algn="r"/>
+            <a:fld id="{F7021451-1387-4CA6-816F-3879F97B5CBC}" type="slidenum">
+              <a:rPr lang="en-US" b="0"/>
+              <a:t>3</a:t>
+            </a:fld>
+            <a:endParaRPr lang="en-US"/>
+          </a:p>
+        </p:txBody>
+      </p:sp>
       <p:pic>
         <p:nvPicPr>
-          <p:cNvPr id="13" name="Microsoft Foundry Agent Service Icon">
+          <p:cNvPr id="19" name="MCP Logo">
             <a:extLst>
               <a:ext uri="{FF2B5EF4-FFF2-40B4-BE49-F238E27FC236}">
-                <a16:creationId xmlns:a16="http://schemas.microsoft.com/office/drawing/2014/main" id="{7CA32E2E-6B9A-7AED-FDF5-EF9F21CDEB73}"/>
+                <a16:creationId xmlns:a16="http://schemas.microsoft.com/office/drawing/2014/main" id="{C3017197-2A60-8421-3387-1932A693B652}"/>
               </a:ext>
             </a:extLst>
           </p:cNvPr>
@@ -21054,8 +21329,44 @@
         </p:blipFill>
         <p:spPr>
           <a:xfrm>
-            <a:off x="3109214" y="2431796"/>
-            <a:ext cx="330200" cy="330200"/>
+            <a:off x="5654040" y="3135630"/>
+            <a:ext cx="406400" cy="406400"/>
+          </a:xfrm>
+          <a:prstGeom prst="rect">
+            <a:avLst/>
+          </a:prstGeom>
+        </p:spPr>
+      </p:pic>
+      <p:pic>
+        <p:nvPicPr>
+          <p:cNvPr id="34" name="OpenAPI Logo">
+            <a:extLst>
+              <a:ext uri="{FF2B5EF4-FFF2-40B4-BE49-F238E27FC236}">
+                <a16:creationId xmlns:a16="http://schemas.microsoft.com/office/drawing/2014/main" id="{22A7C1B4-D38F-A410-EF85-2FEFA5CA8DB6}"/>
+              </a:ext>
+            </a:extLst>
+          </p:cNvPr>
+          <p:cNvPicPr>
+            <a:picLocks/>
+          </p:cNvPicPr>
+          <p:nvPr/>
+        </p:nvPicPr>
+        <p:blipFill>
+          <a:blip>
+            <a:extLst>
+              <a:ext uri="{96DAC541-7B7A-43D3-8B79-37D633B846F1}">
+                <asvg:svgBlip xmlns:asvg="http://schemas.microsoft.com/office/drawing/2016/SVG/main" r:embed="rId8"/>
+              </a:ext>
+            </a:extLst>
+          </a:blip>
+          <a:stretch>
+            <a:fillRect/>
+          </a:stretch>
+        </p:blipFill>
+        <p:spPr>
+          <a:xfrm>
+            <a:off x="7762240" y="2997200"/>
+            <a:ext cx="889000" cy="635000"/>
           </a:xfrm>
           <a:prstGeom prst="rect">
             <a:avLst/>
@@ -21076,8 +21387,8 @@
         </p:nvSpPr>
         <p:spPr>
           <a:xfrm>
-            <a:off x="2514600" y="1587500"/>
-            <a:ext cx="1938020" cy="355600"/>
+            <a:off x="2514600" y="1524000"/>
+            <a:ext cx="4328160" cy="457200"/>
           </a:xfrm>
           <a:prstGeom prst="roundRect">
             <a:avLst/>
@@ -21134,7 +21445,7 @@
           <a:blip>
             <a:extLst>
               <a:ext uri="{96DAC541-7B7A-43D3-8B79-37D633B846F1}">
-                <asvg:svgBlip xmlns:asvg="http://schemas.microsoft.com/office/drawing/2016/SVG/main" r:embed="rId8"/>
+                <asvg:svgBlip xmlns:asvg="http://schemas.microsoft.com/office/drawing/2016/SVG/main" r:embed="rId9"/>
               </a:ext>
             </a:extLst>
           </a:blip>
@@ -21144,7 +21455,7 @@
         </p:blipFill>
         <p:spPr>
           <a:xfrm>
-            <a:off x="2628900" y="1651000"/>
+            <a:off x="3810000" y="1638300"/>
             <a:ext cx="228600" cy="228600"/>
           </a:xfrm>
           <a:prstGeom prst="rect">
@@ -21166,8 +21477,8 @@
         </p:nvSpPr>
         <p:spPr>
           <a:xfrm>
-            <a:off x="2933700" y="1619250"/>
-            <a:ext cx="1422400" cy="146194"/>
+            <a:off x="4114800" y="1600200"/>
+            <a:ext cx="1625600" cy="146050"/>
           </a:xfrm>
           <a:prstGeom prst="rect">
             <a:avLst/>
@@ -21206,8 +21517,8 @@
         </p:nvSpPr>
         <p:spPr>
           <a:xfrm>
-            <a:off x="2933700" y="1784350"/>
-            <a:ext cx="1422400" cy="115416"/>
+            <a:off x="4114800" y="1771650"/>
+            <a:ext cx="1625600" cy="115570"/>
           </a:xfrm>
           <a:prstGeom prst="rect">
             <a:avLst/>
@@ -21232,49 +21543,6 @@
           </a:p>
         </p:txBody>
       </p:sp>
-      <p:cxnSp>
-        <p:nvCxnSpPr>
-          <p:cNvPr id="58" name="Agent 365 Connector">
-            <a:extLst>
-              <a:ext uri="{FF2B5EF4-FFF2-40B4-BE49-F238E27FC236}">
-                <a16:creationId xmlns:a16="http://schemas.microsoft.com/office/drawing/2014/main" id="{D736F929-2089-7C86-D8F3-2E549E293323}"/>
-              </a:ext>
-            </a:extLst>
-          </p:cNvPr>
-          <p:cNvCxnSpPr/>
-          <p:nvPr/>
-        </p:nvCxnSpPr>
-        <p:spPr>
-          <a:xfrm>
-            <a:off x="3483610" y="1943100"/>
-            <a:ext cx="0" cy="160020"/>
-          </a:xfrm>
-          <a:prstGeom prst="line">
-            <a:avLst/>
-          </a:prstGeom>
-          <a:ln w="15240">
-            <a:solidFill>
-              <a:srgbClr val="775DA6"/>
-            </a:solidFill>
-            <a:prstDash val="dash"/>
-            <a:tailEnd type="arrow"/>
-          </a:ln>
-        </p:spPr>
-        <p:style>
-          <a:lnRef idx="1">
-            <a:schemeClr val="accent1"/>
-          </a:lnRef>
-          <a:fillRef idx="0">
-            <a:schemeClr val="accent1"/>
-          </a:fillRef>
-          <a:effectRef idx="0">
-            <a:schemeClr val="accent1"/>
-          </a:effectRef>
-          <a:fontRef idx="minor">
-            <a:schemeClr val="tx1"/>
-          </a:fontRef>
-        </p:style>
-      </p:cxnSp>
       <p:sp>
         <p:nvSpPr>
           <p:cNvPr id="43" name="APIM Control Plane Badge">
@@ -21289,8 +21557,8 @@
         </p:nvSpPr>
         <p:spPr>
           <a:xfrm>
-            <a:off x="4888230" y="1587500"/>
-            <a:ext cx="1938020" cy="355600"/>
+            <a:off x="4874260" y="2184400"/>
+            <a:ext cx="4269740" cy="457200"/>
           </a:xfrm>
           <a:prstGeom prst="roundRect">
             <a:avLst/>
@@ -21329,258 +21597,12 @@
           </a:p>
         </p:txBody>
       </p:sp>
-      <p:sp>
-        <p:nvSpPr>
-          <p:cNvPr id="54" name="APIM Control Plane Title">
-            <a:extLst>
-              <a:ext uri="{FF2B5EF4-FFF2-40B4-BE49-F238E27FC236}">
-                <a16:creationId xmlns:a16="http://schemas.microsoft.com/office/drawing/2014/main" id="{801203E0-1ECC-B010-5318-48DBDD9F61E4}"/>
-              </a:ext>
-            </a:extLst>
-          </p:cNvPr>
-          <p:cNvSpPr txBox="1"/>
-          <p:nvPr/>
-        </p:nvSpPr>
-        <p:spPr>
-          <a:xfrm>
-            <a:off x="5307330" y="1619250"/>
-            <a:ext cx="1422400" cy="146050"/>
-          </a:xfrm>
-          <a:prstGeom prst="rect">
-            <a:avLst/>
-          </a:prstGeom>
-          <a:noFill/>
-        </p:spPr>
-        <p:txBody>
-          <a:bodyPr vert="horz" lIns="0" tIns="0" rIns="0" bIns="0" rtlCol="0">
-            <a:spAutoFit/>
-          </a:bodyPr>
-          <a:lstStyle/>
-          <a:p>
-            <a:r>
-              <a:rPr lang="en-US" sz="950" b="1">
-                <a:solidFill>
-                  <a:srgbClr val="102A43"/>
-                </a:solidFill>
-                <a:latin typeface="Aptos" panose="020B0004020202020204" pitchFamily="34" charset="0"/>
-              </a:rPr>
-              <a:t>APIM Control Plane</a:t>
-            </a:r>
-          </a:p>
-        </p:txBody>
-      </p:sp>
-      <p:sp>
-        <p:nvSpPr>
-          <p:cNvPr id="60" name="APIM Control Plane Subtitle">
-            <a:extLst>
-              <a:ext uri="{FF2B5EF4-FFF2-40B4-BE49-F238E27FC236}">
-                <a16:creationId xmlns:a16="http://schemas.microsoft.com/office/drawing/2014/main" id="{71299352-C14F-9B05-9938-70E48A87CCB8}"/>
-              </a:ext>
-            </a:extLst>
-          </p:cNvPr>
-          <p:cNvSpPr txBox="1"/>
-          <p:nvPr/>
-        </p:nvSpPr>
-        <p:spPr>
-          <a:xfrm>
-            <a:off x="5307330" y="1784350"/>
-            <a:ext cx="1422400" cy="115570"/>
-          </a:xfrm>
-          <a:prstGeom prst="rect">
-            <a:avLst/>
-          </a:prstGeom>
-          <a:noFill/>
-        </p:spPr>
-        <p:txBody>
-          <a:bodyPr vert="horz" lIns="0" tIns="0" rIns="0" bIns="0" rtlCol="0">
-            <a:spAutoFit/>
-          </a:bodyPr>
-          <a:lstStyle/>
-          <a:p>
-            <a:r>
-              <a:rPr lang="en-US" sz="750">
-                <a:solidFill>
-                  <a:srgbClr val="526980"/>
-                </a:solidFill>
-                <a:latin typeface="Aptos" panose="020B0004020202020204" pitchFamily="34" charset="0"/>
-              </a:rPr>
-              <a:t>Policies and controls</a:t>
-            </a:r>
-          </a:p>
-        </p:txBody>
-      </p:sp>
-      <p:cxnSp>
-        <p:nvCxnSpPr>
-          <p:cNvPr id="61" name="APIM Control Plane Connector">
-            <a:extLst>
-              <a:ext uri="{FF2B5EF4-FFF2-40B4-BE49-F238E27FC236}">
-                <a16:creationId xmlns:a16="http://schemas.microsoft.com/office/drawing/2014/main" id="{BE07AF09-DCC1-5A6D-64B0-E7024656B9E7}"/>
-              </a:ext>
-            </a:extLst>
-          </p:cNvPr>
-          <p:cNvCxnSpPr/>
-          <p:nvPr/>
-        </p:nvCxnSpPr>
-        <p:spPr>
-          <a:xfrm>
-            <a:off x="5857240" y="1943100"/>
-            <a:ext cx="0" cy="160020"/>
-          </a:xfrm>
-          <a:prstGeom prst="line">
-            <a:avLst/>
-          </a:prstGeom>
-          <a:ln w="15240">
-            <a:solidFill>
-              <a:srgbClr val="775DA6"/>
-            </a:solidFill>
-            <a:prstDash val="dash"/>
-            <a:tailEnd type="arrow"/>
-          </a:ln>
-        </p:spPr>
-        <p:style>
-          <a:lnRef idx="1">
-            <a:schemeClr val="accent1"/>
-          </a:lnRef>
-          <a:fillRef idx="0">
-            <a:schemeClr val="accent1"/>
-          </a:fillRef>
-          <a:effectRef idx="0">
-            <a:schemeClr val="accent1"/>
-          </a:effectRef>
-          <a:fontRef idx="minor">
-            <a:schemeClr val="tx1"/>
-          </a:fontRef>
-        </p:style>
-      </p:cxnSp>
-      <p:sp>
-        <p:nvSpPr>
-          <p:cNvPr id="44" name="Text 35"/>
-          <p:cNvSpPr/>
-          <p:nvPr/>
-        </p:nvSpPr>
-        <p:spPr>
-          <a:xfrm>
-            <a:off x="566928" y="6528816"/>
-            <a:ext cx="7112000" cy="146304"/>
-          </a:xfrm>
-          <a:prstGeom prst="rect">
-            <a:avLst/>
-          </a:prstGeom>
-          <a:noFill/>
-          <a:ln/>
-        </p:spPr>
-        <p:txBody>
-          <a:bodyPr wrap="square" lIns="0" tIns="0" rIns="0" bIns="0" rtlCol="0" anchor="ctr"/>
-          <a:lstStyle/>
-          <a:p>
-            <a:pPr marL="0" indent="0">
-              <a:buNone/>
-            </a:pPr>
-            <a:r>
-              <a:rPr lang="en-US" sz="750">
-                <a:solidFill>
-                  <a:srgbClr val="748494"/>
-                </a:solidFill>
-                <a:latin typeface="Aptos" pitchFamily="34" charset="0"/>
-                <a:ea typeface="Aptos" pitchFamily="34" charset="-122"/>
-                <a:cs typeface="Aptos" pitchFamily="34" charset="-120"/>
-              </a:rPr>
-              <a:t>Architecture: intent stays with the agent harness, controls stay in APIM, and telemetry converges in Application Insights</a:t>
-            </a:r>
-            <a:endParaRPr lang="en-US" sz="750" dirty="0"/>
-          </a:p>
-        </p:txBody>
-      </p:sp>
-      <p:sp>
-        <p:nvSpPr>
-          <p:cNvPr id="45" name="Slide Number Placeholder 0"/>
-          <p:cNvSpPr>
-            <a:spLocks noGrp="1"/>
-          </p:cNvSpPr>
-          <p:nvPr>
-            <p:ph type="sldNum" sz="quarter" idx="4294967295"/>
-          </p:nvPr>
-        </p:nvSpPr>
-        <p:spPr>
-          <a:xfrm>
-            <a:off x="11109960" y="6510528"/>
-            <a:ext cx="548640" cy="164592"/>
-          </a:xfrm>
-          <a:prstGeom prst="rect">
-            <a:avLst/>
-          </a:prstGeom>
-          <a:extLst>
-            <a:ext uri="{C572A759-6A51-4108-AA02-DFA0A04FC94B}">
-              <ma14:wrappingTextBoxFlag xmlns:ma14="http://schemas.microsoft.com/office/mac/drawingml/2011/main" xmlns="" val="0"/>
-            </a:ext>
-          </a:extLst>
-        </p:spPr>
-        <p:txBody>
-          <a:bodyPr/>
-          <a:lstStyle>
-            <a:lvl1pPr>
-              <a:defRPr sz="800">
-                <a:solidFill>
-                  <a:srgbClr val="748494"/>
-                </a:solidFill>
-                <a:latin typeface="Aptos"/>
-                <a:ea typeface="Aptos"/>
-                <a:cs typeface="Aptos"/>
-              </a:defRPr>
-            </a:lvl1pPr>
-          </a:lstStyle>
-          <a:p>
-            <a:pPr algn="r"/>
-            <a:fld id="{F7021451-1387-4CA6-816F-3879F97B5CBC}" type="slidenum">
-              <a:rPr lang="en-US" b="0"/>
-              <a:t>3</a:t>
-            </a:fld>
-            <a:endParaRPr lang="en-US"/>
-          </a:p>
-        </p:txBody>
-      </p:sp>
       <p:pic>
         <p:nvPicPr>
           <p:cNvPr id="12" name="APIM Control Plane Icon">
             <a:extLst>
               <a:ext uri="{FF2B5EF4-FFF2-40B4-BE49-F238E27FC236}">
                 <a16:creationId xmlns:a16="http://schemas.microsoft.com/office/drawing/2014/main" id="{C0B8048B-43C1-A91F-B283-A31417C0F3D0}"/>
-              </a:ext>
-            </a:extLst>
-          </p:cNvPr>
-          <p:cNvPicPr>
-            <a:picLocks/>
-          </p:cNvPicPr>
-          <p:nvPr/>
-        </p:nvPicPr>
-        <p:blipFill>
-          <a:blip>
-            <a:extLst>
-              <a:ext uri="{96DAC541-7B7A-43D3-8B79-37D633B846F1}">
-                <asvg:svgBlip xmlns:asvg="http://schemas.microsoft.com/office/drawing/2016/SVG/main" r:embed="rId9"/>
-              </a:ext>
-            </a:extLst>
-          </a:blip>
-          <a:stretch>
-            <a:fillRect/>
-          </a:stretch>
-        </p:blipFill>
-        <p:spPr>
-          <a:xfrm>
-            <a:off x="5002530" y="1651000"/>
-            <a:ext cx="228600" cy="228600"/>
-          </a:xfrm>
-          <a:prstGeom prst="rect">
-            <a:avLst/>
-          </a:prstGeom>
-        </p:spPr>
-      </p:pic>
-      <p:pic>
-        <p:nvPicPr>
-          <p:cNvPr id="19" name="MCP Logo">
-            <a:extLst>
-              <a:ext uri="{FF2B5EF4-FFF2-40B4-BE49-F238E27FC236}">
-                <a16:creationId xmlns:a16="http://schemas.microsoft.com/office/drawing/2014/main" id="{C3017197-2A60-8421-3387-1932A693B652}"/>
               </a:ext>
             </a:extLst>
           </p:cNvPr>
@@ -21603,8 +21625,8 @@
         </p:blipFill>
         <p:spPr>
           <a:xfrm>
-            <a:off x="5641340" y="2381250"/>
-            <a:ext cx="431800" cy="431800"/>
+            <a:off x="6261100" y="2298700"/>
+            <a:ext cx="228600" cy="228600"/>
           </a:xfrm>
           <a:prstGeom prst="rect">
             <a:avLst/>
@@ -21613,14 +21635,96 @@
       </p:pic>
       <p:sp>
         <p:nvSpPr>
+          <p:cNvPr id="54" name="APIM Control Plane Title">
+            <a:extLst>
+              <a:ext uri="{FF2B5EF4-FFF2-40B4-BE49-F238E27FC236}">
+                <a16:creationId xmlns:a16="http://schemas.microsoft.com/office/drawing/2014/main" id="{801203E0-1ECC-B010-5318-48DBDD9F61E4}"/>
+              </a:ext>
+            </a:extLst>
+          </p:cNvPr>
+          <p:cNvSpPr txBox="1"/>
+          <p:nvPr/>
+        </p:nvSpPr>
+        <p:spPr>
+          <a:xfrm>
+            <a:off x="6565900" y="2260600"/>
+            <a:ext cx="1270000" cy="146050"/>
+          </a:xfrm>
+          <a:prstGeom prst="rect">
+            <a:avLst/>
+          </a:prstGeom>
+          <a:noFill/>
+        </p:spPr>
+        <p:txBody>
+          <a:bodyPr vert="horz" lIns="0" tIns="0" rIns="0" bIns="0" rtlCol="0">
+            <a:spAutoFit/>
+          </a:bodyPr>
+          <a:lstStyle/>
+          <a:p>
+            <a:pPr algn="ctr"/>
+            <a:r>
+              <a:rPr lang="en-US" sz="950" b="1">
+                <a:solidFill>
+                  <a:srgbClr val="102A43"/>
+                </a:solidFill>
+                <a:latin typeface="Aptos" panose="020B0004020202020204" pitchFamily="34" charset="0"/>
+              </a:rPr>
+              <a:t>APIM Control Plane</a:t>
+            </a:r>
+          </a:p>
+        </p:txBody>
+      </p:sp>
+      <p:sp>
+        <p:nvSpPr>
+          <p:cNvPr id="60" name="APIM Control Plane Subtitle">
+            <a:extLst>
+              <a:ext uri="{FF2B5EF4-FFF2-40B4-BE49-F238E27FC236}">
+                <a16:creationId xmlns:a16="http://schemas.microsoft.com/office/drawing/2014/main" id="{71299352-C14F-9B05-9938-70E48A87CCB8}"/>
+              </a:ext>
+            </a:extLst>
+          </p:cNvPr>
+          <p:cNvSpPr txBox="1"/>
+          <p:nvPr/>
+        </p:nvSpPr>
+        <p:spPr>
+          <a:xfrm>
+            <a:off x="6565900" y="2432050"/>
+            <a:ext cx="1270000" cy="115570"/>
+          </a:xfrm>
+          <a:prstGeom prst="rect">
+            <a:avLst/>
+          </a:prstGeom>
+          <a:noFill/>
+        </p:spPr>
+        <p:txBody>
+          <a:bodyPr vert="horz" lIns="0" tIns="0" rIns="0" bIns="0" rtlCol="0">
+            <a:spAutoFit/>
+          </a:bodyPr>
+          <a:lstStyle/>
+          <a:p>
+            <a:pPr algn="ctr"/>
+            <a:r>
+              <a:rPr lang="en-US" sz="750">
+                <a:solidFill>
+                  <a:srgbClr val="526980"/>
+                </a:solidFill>
+                <a:latin typeface="Aptos" panose="020B0004020202020204" pitchFamily="34" charset="0"/>
+              </a:rPr>
+              <a:t>Policies and controls</a:t>
+            </a:r>
+          </a:p>
+        </p:txBody>
+      </p:sp>
+      <p:sp>
+        <p:nvSpPr>
           <p:cNvPr id="39" name="Application Insights Layer"/>
           <p:cNvSpPr/>
           <p:nvPr/>
         </p:nvSpPr>
         <p:spPr>
           <a:xfrm>
-            <a:off x="2514600" y="4224020"/>
-            <a:ext cx="6629400" cy="1042670"/>
+            <a:off x="2514600" y="5003800"/>
+            <a:ext cx="6629400" cy="457200"/>
           </a:xfrm>
           <a:prstGeom prst="roundRect">
             <a:avLst/>
@@ -21671,8 +21775,8 @@
         </p:blipFill>
         <p:spPr>
           <a:xfrm>
-            <a:off x="2768600" y="4452620"/>
-            <a:ext cx="406400" cy="406400"/>
+            <a:off x="4914900" y="5118100"/>
+            <a:ext cx="228600" cy="228600"/>
           </a:xfrm>
           <a:prstGeom prst="rect">
             <a:avLst/>
@@ -21687,8 +21791,8 @@
         </p:nvSpPr>
         <p:spPr>
           <a:xfrm>
-            <a:off x="3327400" y="4371340"/>
-            <a:ext cx="5461000" cy="228600"/>
+            <a:off x="5219700" y="5080000"/>
+            <a:ext cx="1524000" cy="146050"/>
           </a:xfrm>
           <a:prstGeom prst="rect">
             <a:avLst/>
@@ -21698,11 +21802,11 @@
         </p:spPr>
         <p:txBody>
           <a:bodyPr wrap="square" lIns="0" tIns="0" rIns="0" bIns="0" rtlCol="0" anchor="ctr">
-            <a:normAutofit/>
+            <a:normAutofit fontScale="85000" lnSpcReduction="20000"/>
           </a:bodyPr>
           <a:lstStyle/>
           <a:p>
-            <a:pPr marL="0" indent="0">
+            <a:pPr marL="0" indent="0" algn="ctr">
               <a:buNone/>
             </a:pPr>
             <a:r>
@@ -21728,8 +21832,8 @@
         </p:nvSpPr>
         <p:spPr>
           <a:xfrm>
-            <a:off x="3327400" y="4645660"/>
-            <a:ext cx="5461000" cy="381000"/>
+            <a:off x="5219700" y="5251450"/>
+            <a:ext cx="1524000" cy="115570"/>
           </a:xfrm>
           <a:prstGeom prst="rect">
             <a:avLst/>
@@ -21739,23 +21843,16 @@
         </p:spPr>
         <p:txBody>
           <a:bodyPr wrap="square" lIns="0" tIns="0" rIns="0" bIns="0" rtlCol="0" anchor="ctr">
-            <a:normAutofit/>
+            <a:normAutofit fontScale="92500" lnSpcReduction="10000"/>
           </a:bodyPr>
           <a:lstStyle/>
           <a:p>
-            <a:pPr marL="0" indent="0">
-              <a:buNone/>
-            </a:pPr>
-            <a:r>
-              <a:rPr lang="en-US" sz="870">
-                <a:solidFill>
-                  <a:srgbClr val="4F6474"/>
-                </a:solidFill>
-                <a:latin typeface="Aptos" pitchFamily="34" charset="0"/>
-                <a:ea typeface="Aptos" pitchFamily="34" charset="-122"/>
-                <a:cs typeface="Aptos" pitchFamily="34" charset="-120"/>
-              </a:rPr>
-              <a:t>Agent and APIM telemetry for latency, failures, usage, correlation, and audit evidence</a:t>
+            <a:pPr marL="0" indent="0" algn="ctr">
+              <a:buNone/>
+            </a:pPr>
+            <a:r>
+              <a:rPr lang="en-US" sz="870"/>
+              <a:t>Agent and APIM telemetry</a:t>
             </a:r>
             <a:endParaRPr lang="en-US" sz="870" dirty="0"/>
           </a:p>

</xml_diff>

<commit_message>
Remove slide 14 table background artifact
Delete the redundant rounded background behind the comparison table that left a visible curved edge and shadow beneath the final row.

Co-authored-by: Copilot <223556219+Copilot@users.noreply.github.com>
Copilot-Session: aa1a2148-b4d0-4cc5-94ea-497594b4b72a
</commit_message>
<xml_diff>
--- a/docs/foundry-apim-mcp-workshop.pptx
+++ b/docs/foundry-apim-mcp-workshop.pptx
@@ -2194,7 +2194,7 @@
           </a:prstGeom>
           <a:extLst>
             <a:ext uri="{C572A759-6A51-4108-AA02-DFA0A04FC94B}">
-              <ma14:wrappingTextBoxFlag xmlns:ma14="http://schemas.microsoft.com/office/mac/drawingml/2011/main" xmlns="" val="0"/>
+              <ma14:wrappingTextBoxFlag xmlns="" xmlns:ma14="http://schemas.microsoft.com/office/mac/drawingml/2011/main" val="0"/>
             </a:ext>
           </a:extLst>
         </p:spPr>
@@ -2272,7 +2272,7 @@
           </a:prstGeom>
           <a:extLst>
             <a:ext uri="{C572A759-6A51-4108-AA02-DFA0A04FC94B}">
-              <ma14:wrappingTextBoxFlag xmlns:ma14="http://schemas.microsoft.com/office/mac/drawingml/2011/main" xmlns="" val="0"/>
+              <ma14:wrappingTextBoxFlag xmlns="" xmlns:ma14="http://schemas.microsoft.com/office/mac/drawingml/2011/main" val="0"/>
             </a:ext>
           </a:extLst>
         </p:spPr>
@@ -4877,7 +4877,7 @@
           </a:prstGeom>
           <a:extLst>
             <a:ext uri="{C572A759-6A51-4108-AA02-DFA0A04FC94B}">
-              <ma14:wrappingTextBoxFlag xmlns:ma14="http://schemas.microsoft.com/office/mac/drawingml/2011/main" xmlns="" val="0"/>
+              <ma14:wrappingTextBoxFlag xmlns="" xmlns:ma14="http://schemas.microsoft.com/office/mac/drawingml/2011/main" val="0"/>
             </a:ext>
           </a:extLst>
         </p:spPr>
@@ -5835,7 +5835,7 @@
           </a:prstGeom>
           <a:extLst>
             <a:ext uri="{C572A759-6A51-4108-AA02-DFA0A04FC94B}">
-              <ma14:wrappingTextBoxFlag xmlns:ma14="http://schemas.microsoft.com/office/mac/drawingml/2011/main" xmlns="" val="0"/>
+              <ma14:wrappingTextBoxFlag xmlns="" xmlns:ma14="http://schemas.microsoft.com/office/mac/drawingml/2011/main" val="0"/>
             </a:ext>
           </a:extLst>
         </p:spPr>
@@ -7051,7 +7051,7 @@
           </a:prstGeom>
           <a:extLst>
             <a:ext uri="{C572A759-6A51-4108-AA02-DFA0A04FC94B}">
-              <ma14:wrappingTextBoxFlag xmlns:ma14="http://schemas.microsoft.com/office/mac/drawingml/2011/main" xmlns="" val="0"/>
+              <ma14:wrappingTextBoxFlag xmlns="" xmlns:ma14="http://schemas.microsoft.com/office/mac/drawingml/2011/main" val="0"/>
             </a:ext>
           </a:extLst>
         </p:spPr>
@@ -8167,7 +8167,7 @@
           </a:prstGeom>
           <a:extLst>
             <a:ext uri="{C572A759-6A51-4108-AA02-DFA0A04FC94B}">
-              <ma14:wrappingTextBoxFlag xmlns:ma14="http://schemas.microsoft.com/office/mac/drawingml/2011/main" xmlns="" val="0"/>
+              <ma14:wrappingTextBoxFlag xmlns="" xmlns:ma14="http://schemas.microsoft.com/office/mac/drawingml/2011/main" val="0"/>
             </a:ext>
           </a:extLst>
         </p:spPr>
@@ -8503,45 +8503,6 @@
       </p:sp>
       <p:sp>
         <p:nvSpPr>
-          <p:cNvPr id="5" name="Shape 3"/>
-          <p:cNvSpPr/>
-          <p:nvPr/>
-        </p:nvSpPr>
-        <p:spPr>
-          <a:xfrm>
-            <a:off x="658368" y="1755648"/>
-            <a:ext cx="10972800" cy="4041648"/>
-          </a:xfrm>
-          <a:prstGeom prst="roundRect">
-            <a:avLst/>
-          </a:prstGeom>
-          <a:solidFill>
-            <a:srgbClr val="FFFFFF"/>
-          </a:solidFill>
-          <a:ln w="12700">
-            <a:solidFill>
-              <a:srgbClr val="DDE6EC"/>
-            </a:solidFill>
-            <a:prstDash val="solid"/>
-          </a:ln>
-          <a:effectLst>
-            <a:outerShdw blurRad="25400" dist="50800" dir="2700000" algn="bl" rotWithShape="0">
-              <a:srgbClr val="102A43">
-                <a:alpha val="14000"/>
-              </a:srgbClr>
-            </a:outerShdw>
-          </a:effectLst>
-        </p:spPr>
-        <p:txBody>
-          <a:bodyPr/>
-          <a:lstStyle/>
-          <a:p>
-            <a:endParaRPr lang="en-US"/>
-          </a:p>
-        </p:txBody>
-      </p:sp>
-      <p:sp>
-        <p:nvSpPr>
           <p:cNvPr id="6" name="Shape 4"/>
           <p:cNvSpPr/>
           <p:nvPr/>
@@ -9624,7 +9585,7 @@
           </a:prstGeom>
           <a:extLst>
             <a:ext uri="{C572A759-6A51-4108-AA02-DFA0A04FC94B}">
-              <ma14:wrappingTextBoxFlag xmlns:ma14="http://schemas.microsoft.com/office/mac/drawingml/2011/main" xmlns="" val="0"/>
+              <ma14:wrappingTextBoxFlag xmlns="" xmlns:ma14="http://schemas.microsoft.com/office/mac/drawingml/2011/main" val="0"/>
             </a:ext>
           </a:extLst>
         </p:spPr>
@@ -10641,7 +10602,7 @@
           </a:prstGeom>
           <a:extLst>
             <a:ext uri="{C572A759-6A51-4108-AA02-DFA0A04FC94B}">
-              <ma14:wrappingTextBoxFlag xmlns:ma14="http://schemas.microsoft.com/office/mac/drawingml/2011/main" xmlns="" val="0"/>
+              <ma14:wrappingTextBoxFlag xmlns="" xmlns:ma14="http://schemas.microsoft.com/office/mac/drawingml/2011/main" val="0"/>
             </a:ext>
           </a:extLst>
         </p:spPr>
@@ -11862,7 +11823,7 @@
           </a:prstGeom>
           <a:extLst>
             <a:ext uri="{C572A759-6A51-4108-AA02-DFA0A04FC94B}">
-              <ma14:wrappingTextBoxFlag xmlns:ma14="http://schemas.microsoft.com/office/mac/drawingml/2011/main" xmlns="" val="0"/>
+              <ma14:wrappingTextBoxFlag xmlns="" xmlns:ma14="http://schemas.microsoft.com/office/mac/drawingml/2011/main" val="0"/>
             </a:ext>
           </a:extLst>
         </p:spPr>
@@ -13625,7 +13586,7 @@
           </a:prstGeom>
           <a:extLst>
             <a:ext uri="{C572A759-6A51-4108-AA02-DFA0A04FC94B}">
-              <ma14:wrappingTextBoxFlag xmlns:ma14="http://schemas.microsoft.com/office/mac/drawingml/2011/main" xmlns="" val="0"/>
+              <ma14:wrappingTextBoxFlag xmlns="" xmlns:ma14="http://schemas.microsoft.com/office/mac/drawingml/2011/main" val="0"/>
             </a:ext>
           </a:extLst>
         </p:spPr>
@@ -14956,7 +14917,7 @@
           </a:prstGeom>
           <a:extLst>
             <a:ext uri="{C572A759-6A51-4108-AA02-DFA0A04FC94B}">
-              <ma14:wrappingTextBoxFlag xmlns:ma14="http://schemas.microsoft.com/office/mac/drawingml/2011/main" xmlns="" val="0"/>
+              <ma14:wrappingTextBoxFlag xmlns="" xmlns:ma14="http://schemas.microsoft.com/office/mac/drawingml/2011/main" val="0"/>
             </a:ext>
           </a:extLst>
         </p:spPr>
@@ -16578,7 +16539,7 @@
           </a:prstGeom>
           <a:extLst>
             <a:ext uri="{C572A759-6A51-4108-AA02-DFA0A04FC94B}">
-              <ma14:wrappingTextBoxFlag xmlns:ma14="http://schemas.microsoft.com/office/mac/drawingml/2011/main" xmlns="" val="0"/>
+              <ma14:wrappingTextBoxFlag xmlns="" xmlns:ma14="http://schemas.microsoft.com/office/mac/drawingml/2011/main" val="0"/>
             </a:ext>
           </a:extLst>
         </p:spPr>
@@ -17759,7 +17720,7 @@
           </a:prstGeom>
           <a:extLst>
             <a:ext uri="{C572A759-6A51-4108-AA02-DFA0A04FC94B}">
-              <ma14:wrappingTextBoxFlag xmlns:ma14="http://schemas.microsoft.com/office/mac/drawingml/2011/main" xmlns="" val="0"/>
+              <ma14:wrappingTextBoxFlag xmlns="" xmlns:ma14="http://schemas.microsoft.com/office/mac/drawingml/2011/main" val="0"/>
             </a:ext>
           </a:extLst>
         </p:spPr>
@@ -18951,7 +18912,7 @@
           </a:prstGeom>
           <a:extLst>
             <a:ext uri="{C572A759-6A51-4108-AA02-DFA0A04FC94B}">
-              <ma14:wrappingTextBoxFlag xmlns:ma14="http://schemas.microsoft.com/office/mac/drawingml/2011/main" xmlns="" val="0"/>
+              <ma14:wrappingTextBoxFlag xmlns="" xmlns:ma14="http://schemas.microsoft.com/office/mac/drawingml/2011/main" val="0"/>
             </a:ext>
           </a:extLst>
         </p:spPr>
@@ -21273,7 +21234,7 @@
           </a:prstGeom>
           <a:extLst>
             <a:ext uri="{C572A759-6A51-4108-AA02-DFA0A04FC94B}">
-              <ma14:wrappingTextBoxFlag xmlns:ma14="http://schemas.microsoft.com/office/mac/drawingml/2011/main" xmlns="" val="0"/>
+              <ma14:wrappingTextBoxFlag xmlns="" xmlns:ma14="http://schemas.microsoft.com/office/mac/drawingml/2011/main" val="0"/>
             </a:ext>
           </a:extLst>
         </p:spPr>
@@ -24355,7 +24316,7 @@
           </a:prstGeom>
           <a:extLst>
             <a:ext uri="{C572A759-6A51-4108-AA02-DFA0A04FC94B}">
-              <ma14:wrappingTextBoxFlag xmlns:ma14="http://schemas.microsoft.com/office/mac/drawingml/2011/main" xmlns="" val="0"/>
+              <ma14:wrappingTextBoxFlag xmlns="" xmlns:ma14="http://schemas.microsoft.com/office/mac/drawingml/2011/main" val="0"/>
             </a:ext>
           </a:extLst>
         </p:spPr>
@@ -25443,7 +25404,7 @@
           </a:prstGeom>
           <a:extLst>
             <a:ext uri="{C572A759-6A51-4108-AA02-DFA0A04FC94B}">
-              <ma14:wrappingTextBoxFlag xmlns:ma14="http://schemas.microsoft.com/office/mac/drawingml/2011/main" xmlns="" val="0"/>
+              <ma14:wrappingTextBoxFlag xmlns="" xmlns:ma14="http://schemas.microsoft.com/office/mac/drawingml/2011/main" val="0"/>
             </a:ext>
           </a:extLst>
         </p:spPr>
@@ -26598,7 +26559,7 @@
           </a:prstGeom>
           <a:extLst>
             <a:ext uri="{C572A759-6A51-4108-AA02-DFA0A04FC94B}">
-              <ma14:wrappingTextBoxFlag xmlns:ma14="http://schemas.microsoft.com/office/mac/drawingml/2011/main" xmlns="" val="0"/>
+              <ma14:wrappingTextBoxFlag xmlns="" xmlns:ma14="http://schemas.microsoft.com/office/mac/drawingml/2011/main" val="0"/>
             </a:ext>
           </a:extLst>
         </p:spPr>
@@ -28009,7 +27970,7 @@
           </a:prstGeom>
           <a:extLst>
             <a:ext uri="{C572A759-6A51-4108-AA02-DFA0A04FC94B}">
-              <ma14:wrappingTextBoxFlag xmlns:ma14="http://schemas.microsoft.com/office/mac/drawingml/2011/main" xmlns="" val="0"/>
+              <ma14:wrappingTextBoxFlag xmlns="" xmlns:ma14="http://schemas.microsoft.com/office/mac/drawingml/2011/main" val="0"/>
             </a:ext>
           </a:extLst>
         </p:spPr>
@@ -28996,7 +28957,7 @@
           </a:prstGeom>
           <a:extLst>
             <a:ext uri="{C572A759-6A51-4108-AA02-DFA0A04FC94B}">
-              <ma14:wrappingTextBoxFlag xmlns:ma14="http://schemas.microsoft.com/office/mac/drawingml/2011/main" xmlns="" val="0"/>
+              <ma14:wrappingTextBoxFlag xmlns="" xmlns:ma14="http://schemas.microsoft.com/office/mac/drawingml/2011/main" val="0"/>
             </a:ext>
           </a:extLst>
         </p:spPr>
@@ -30384,7 +30345,7 @@
           </a:prstGeom>
           <a:extLst>
             <a:ext uri="{C572A759-6A51-4108-AA02-DFA0A04FC94B}">
-              <ma14:wrappingTextBoxFlag xmlns:ma14="http://schemas.microsoft.com/office/mac/drawingml/2011/main" xmlns="" val="0"/>
+              <ma14:wrappingTextBoxFlag xmlns="" xmlns:ma14="http://schemas.microsoft.com/office/mac/drawingml/2011/main" val="0"/>
             </a:ext>
           </a:extLst>
         </p:spPr>

</xml_diff>

<commit_message>
Increase slide 15 governance padding
Expand the Agent 365 governance boundary and reposition the nested controls to create balanced spacing around the identity and monitoring layers.

Co-authored-by: Copilot <223556219+Copilot@users.noreply.github.com>
Copilot-Session: aa1a2148-b4d0-4cc5-94ea-497594b4b72a
</commit_message>
<xml_diff>
--- a/docs/foundry-apim-mcp-workshop.pptx
+++ b/docs/foundry-apim-mcp-workshop.pptx
@@ -2194,7 +2194,7 @@
           </a:prstGeom>
           <a:extLst>
             <a:ext uri="{C572A759-6A51-4108-AA02-DFA0A04FC94B}">
-              <ma14:wrappingTextBoxFlag xmlns="" xmlns:ma14="http://schemas.microsoft.com/office/mac/drawingml/2011/main" val="0"/>
+              <ma14:wrappingTextBoxFlag xmlns:ma14="http://schemas.microsoft.com/office/mac/drawingml/2011/main" xmlns="" val="0"/>
             </a:ext>
           </a:extLst>
         </p:spPr>
@@ -2272,7 +2272,7 @@
           </a:prstGeom>
           <a:extLst>
             <a:ext uri="{C572A759-6A51-4108-AA02-DFA0A04FC94B}">
-              <ma14:wrappingTextBoxFlag xmlns="" xmlns:ma14="http://schemas.microsoft.com/office/mac/drawingml/2011/main" val="0"/>
+              <ma14:wrappingTextBoxFlag xmlns:ma14="http://schemas.microsoft.com/office/mac/drawingml/2011/main" xmlns="" val="0"/>
             </a:ext>
           </a:extLst>
         </p:spPr>
@@ -4877,7 +4877,7 @@
           </a:prstGeom>
           <a:extLst>
             <a:ext uri="{C572A759-6A51-4108-AA02-DFA0A04FC94B}">
-              <ma14:wrappingTextBoxFlag xmlns="" xmlns:ma14="http://schemas.microsoft.com/office/mac/drawingml/2011/main" val="0"/>
+              <ma14:wrappingTextBoxFlag xmlns:ma14="http://schemas.microsoft.com/office/mac/drawingml/2011/main" xmlns="" val="0"/>
             </a:ext>
           </a:extLst>
         </p:spPr>
@@ -5835,7 +5835,7 @@
           </a:prstGeom>
           <a:extLst>
             <a:ext uri="{C572A759-6A51-4108-AA02-DFA0A04FC94B}">
-              <ma14:wrappingTextBoxFlag xmlns="" xmlns:ma14="http://schemas.microsoft.com/office/mac/drawingml/2011/main" val="0"/>
+              <ma14:wrappingTextBoxFlag xmlns:ma14="http://schemas.microsoft.com/office/mac/drawingml/2011/main" xmlns="" val="0"/>
             </a:ext>
           </a:extLst>
         </p:spPr>
@@ -7051,7 +7051,7 @@
           </a:prstGeom>
           <a:extLst>
             <a:ext uri="{C572A759-6A51-4108-AA02-DFA0A04FC94B}">
-              <ma14:wrappingTextBoxFlag xmlns="" xmlns:ma14="http://schemas.microsoft.com/office/mac/drawingml/2011/main" val="0"/>
+              <ma14:wrappingTextBoxFlag xmlns:ma14="http://schemas.microsoft.com/office/mac/drawingml/2011/main" xmlns="" val="0"/>
             </a:ext>
           </a:extLst>
         </p:spPr>
@@ -8167,7 +8167,7 @@
           </a:prstGeom>
           <a:extLst>
             <a:ext uri="{C572A759-6A51-4108-AA02-DFA0A04FC94B}">
-              <ma14:wrappingTextBoxFlag xmlns="" xmlns:ma14="http://schemas.microsoft.com/office/mac/drawingml/2011/main" val="0"/>
+              <ma14:wrappingTextBoxFlag xmlns:ma14="http://schemas.microsoft.com/office/mac/drawingml/2011/main" xmlns="" val="0"/>
             </a:ext>
           </a:extLst>
         </p:spPr>
@@ -9585,7 +9585,7 @@
           </a:prstGeom>
           <a:extLst>
             <a:ext uri="{C572A759-6A51-4108-AA02-DFA0A04FC94B}">
-              <ma14:wrappingTextBoxFlag xmlns="" xmlns:ma14="http://schemas.microsoft.com/office/mac/drawingml/2011/main" val="0"/>
+              <ma14:wrappingTextBoxFlag xmlns:ma14="http://schemas.microsoft.com/office/mac/drawingml/2011/main" xmlns="" val="0"/>
             </a:ext>
           </a:extLst>
         </p:spPr>
@@ -9653,7 +9653,7 @@
         <p:spPr>
           <a:xfrm>
             <a:off x="736600" y="1600200"/>
-            <a:ext cx="10718800" cy="3543300"/>
+            <a:ext cx="10718800" cy="3771900"/>
           </a:xfrm>
           <a:prstGeom prst="roundRect">
             <a:avLst/>
@@ -9853,7 +9853,7 @@
         </p:nvSpPr>
         <p:spPr>
           <a:xfrm>
-            <a:off x="883768" y="1737360"/>
+            <a:off x="883768" y="1851660"/>
             <a:ext cx="10424160" cy="713232"/>
           </a:xfrm>
           <a:prstGeom prst="roundRect">
@@ -9906,7 +9906,7 @@
         </p:blipFill>
         <p:spPr>
           <a:xfrm>
-            <a:off x="1121512" y="1938528"/>
+            <a:off x="1121512" y="2052828"/>
             <a:ext cx="292608" cy="292608"/>
           </a:xfrm>
           <a:prstGeom prst="rect">
@@ -9922,7 +9922,7 @@
         </p:nvSpPr>
         <p:spPr>
           <a:xfrm>
-            <a:off x="1569568" y="1865376"/>
+            <a:off x="1569568" y="1979676"/>
             <a:ext cx="2286000" cy="210312"/>
           </a:xfrm>
           <a:prstGeom prst="rect">
@@ -9961,7 +9961,7 @@
         </p:nvSpPr>
         <p:spPr>
           <a:xfrm>
-            <a:off x="3791560" y="1892808"/>
+            <a:off x="3791560" y="2007108"/>
             <a:ext cx="7242048" cy="292608"/>
           </a:xfrm>
           <a:prstGeom prst="rect">
@@ -10002,7 +10002,7 @@
         </p:nvSpPr>
         <p:spPr>
           <a:xfrm>
-            <a:off x="1432408" y="2606040"/>
+            <a:off x="1432408" y="2720340"/>
             <a:ext cx="9326880" cy="713232"/>
           </a:xfrm>
           <a:prstGeom prst="roundRect">
@@ -10055,7 +10055,7 @@
         </p:blipFill>
         <p:spPr>
           <a:xfrm>
-            <a:off x="1670152" y="2807208"/>
+            <a:off x="1670152" y="2921508"/>
             <a:ext cx="292608" cy="292608"/>
           </a:xfrm>
           <a:prstGeom prst="rect">
@@ -10071,7 +10071,7 @@
         </p:nvSpPr>
         <p:spPr>
           <a:xfrm>
-            <a:off x="2118208" y="2734056"/>
+            <a:off x="2118208" y="2848356"/>
             <a:ext cx="2286000" cy="210312"/>
           </a:xfrm>
           <a:prstGeom prst="rect">
@@ -10110,7 +10110,7 @@
         </p:nvSpPr>
         <p:spPr>
           <a:xfrm>
-            <a:off x="4340200" y="2761488"/>
+            <a:off x="4340200" y="2875788"/>
             <a:ext cx="6144768" cy="292608"/>
           </a:xfrm>
           <a:prstGeom prst="rect">
@@ -10151,7 +10151,7 @@
         </p:nvSpPr>
         <p:spPr>
           <a:xfrm>
-            <a:off x="1981048" y="3474720"/>
+            <a:off x="1981048" y="3589020"/>
             <a:ext cx="8229600" cy="713232"/>
           </a:xfrm>
           <a:prstGeom prst="roundRect">
@@ -10204,7 +10204,7 @@
         </p:blipFill>
         <p:spPr>
           <a:xfrm>
-            <a:off x="2218792" y="3675888"/>
+            <a:off x="2218792" y="3790188"/>
             <a:ext cx="292608" cy="292608"/>
           </a:xfrm>
           <a:prstGeom prst="rect">
@@ -10220,7 +10220,7 @@
         </p:nvSpPr>
         <p:spPr>
           <a:xfrm>
-            <a:off x="2666848" y="3602736"/>
+            <a:off x="2666848" y="3717036"/>
             <a:ext cx="2286000" cy="210312"/>
           </a:xfrm>
           <a:prstGeom prst="rect">
@@ -10259,7 +10259,7 @@
         </p:nvSpPr>
         <p:spPr>
           <a:xfrm>
-            <a:off x="4888840" y="3630168"/>
+            <a:off x="4888840" y="3744468"/>
             <a:ext cx="5047488" cy="292608"/>
           </a:xfrm>
           <a:prstGeom prst="rect">
@@ -10300,7 +10300,7 @@
         </p:nvSpPr>
         <p:spPr>
           <a:xfrm>
-            <a:off x="2529688" y="4343400"/>
+            <a:off x="2529688" y="4457700"/>
             <a:ext cx="7132320" cy="713232"/>
           </a:xfrm>
           <a:prstGeom prst="roundRect">
@@ -10353,7 +10353,7 @@
         </p:blipFill>
         <p:spPr>
           <a:xfrm>
-            <a:off x="2767432" y="4544568"/>
+            <a:off x="2767432" y="4658868"/>
             <a:ext cx="292608" cy="292608"/>
           </a:xfrm>
           <a:prstGeom prst="rect">
@@ -10369,7 +10369,7 @@
         </p:nvSpPr>
         <p:spPr>
           <a:xfrm>
-            <a:off x="3215488" y="4471416"/>
+            <a:off x="3215488" y="4585716"/>
             <a:ext cx="2286000" cy="210312"/>
           </a:xfrm>
           <a:prstGeom prst="rect">
@@ -10408,7 +10408,7 @@
         </p:nvSpPr>
         <p:spPr>
           <a:xfrm>
-            <a:off x="5437480" y="4498848"/>
+            <a:off x="5437480" y="4613148"/>
             <a:ext cx="3950208" cy="292608"/>
           </a:xfrm>
           <a:prstGeom prst="rect">
@@ -10449,7 +10449,7 @@
         </p:nvSpPr>
         <p:spPr>
           <a:xfrm>
-            <a:off x="6099048" y="5056632"/>
+            <a:off x="6099048" y="5170932"/>
             <a:ext cx="0" cy="219456"/>
           </a:xfrm>
           <a:prstGeom prst="line">
@@ -10480,7 +10480,7 @@
         </p:nvSpPr>
         <p:spPr>
           <a:xfrm>
-            <a:off x="5193792" y="5285232"/>
+            <a:off x="5193792" y="5399532"/>
             <a:ext cx="1810512" cy="676656"/>
           </a:xfrm>
           <a:prstGeom prst="ellipse">
@@ -10512,7 +10512,7 @@
         </p:nvSpPr>
         <p:spPr>
           <a:xfrm>
-            <a:off x="5330952" y="5504688"/>
+            <a:off x="5330952" y="5618988"/>
             <a:ext cx="1536192" cy="164592"/>
           </a:xfrm>
           <a:prstGeom prst="rect">
@@ -10602,7 +10602,7 @@
           </a:prstGeom>
           <a:extLst>
             <a:ext uri="{C572A759-6A51-4108-AA02-DFA0A04FC94B}">
-              <ma14:wrappingTextBoxFlag xmlns="" xmlns:ma14="http://schemas.microsoft.com/office/mac/drawingml/2011/main" val="0"/>
+              <ma14:wrappingTextBoxFlag xmlns:ma14="http://schemas.microsoft.com/office/mac/drawingml/2011/main" xmlns="" val="0"/>
             </a:ext>
           </a:extLst>
         </p:spPr>
@@ -11823,7 +11823,7 @@
           </a:prstGeom>
           <a:extLst>
             <a:ext uri="{C572A759-6A51-4108-AA02-DFA0A04FC94B}">
-              <ma14:wrappingTextBoxFlag xmlns="" xmlns:ma14="http://schemas.microsoft.com/office/mac/drawingml/2011/main" val="0"/>
+              <ma14:wrappingTextBoxFlag xmlns:ma14="http://schemas.microsoft.com/office/mac/drawingml/2011/main" xmlns="" val="0"/>
             </a:ext>
           </a:extLst>
         </p:spPr>
@@ -13586,7 +13586,7 @@
           </a:prstGeom>
           <a:extLst>
             <a:ext uri="{C572A759-6A51-4108-AA02-DFA0A04FC94B}">
-              <ma14:wrappingTextBoxFlag xmlns="" xmlns:ma14="http://schemas.microsoft.com/office/mac/drawingml/2011/main" val="0"/>
+              <ma14:wrappingTextBoxFlag xmlns:ma14="http://schemas.microsoft.com/office/mac/drawingml/2011/main" xmlns="" val="0"/>
             </a:ext>
           </a:extLst>
         </p:spPr>
@@ -14917,7 +14917,7 @@
           </a:prstGeom>
           <a:extLst>
             <a:ext uri="{C572A759-6A51-4108-AA02-DFA0A04FC94B}">
-              <ma14:wrappingTextBoxFlag xmlns="" xmlns:ma14="http://schemas.microsoft.com/office/mac/drawingml/2011/main" val="0"/>
+              <ma14:wrappingTextBoxFlag xmlns:ma14="http://schemas.microsoft.com/office/mac/drawingml/2011/main" xmlns="" val="0"/>
             </a:ext>
           </a:extLst>
         </p:spPr>
@@ -16539,7 +16539,7 @@
           </a:prstGeom>
           <a:extLst>
             <a:ext uri="{C572A759-6A51-4108-AA02-DFA0A04FC94B}">
-              <ma14:wrappingTextBoxFlag xmlns="" xmlns:ma14="http://schemas.microsoft.com/office/mac/drawingml/2011/main" val="0"/>
+              <ma14:wrappingTextBoxFlag xmlns:ma14="http://schemas.microsoft.com/office/mac/drawingml/2011/main" xmlns="" val="0"/>
             </a:ext>
           </a:extLst>
         </p:spPr>
@@ -17720,7 +17720,7 @@
           </a:prstGeom>
           <a:extLst>
             <a:ext uri="{C572A759-6A51-4108-AA02-DFA0A04FC94B}">
-              <ma14:wrappingTextBoxFlag xmlns="" xmlns:ma14="http://schemas.microsoft.com/office/mac/drawingml/2011/main" val="0"/>
+              <ma14:wrappingTextBoxFlag xmlns:ma14="http://schemas.microsoft.com/office/mac/drawingml/2011/main" xmlns="" val="0"/>
             </a:ext>
           </a:extLst>
         </p:spPr>
@@ -18912,7 +18912,7 @@
           </a:prstGeom>
           <a:extLst>
             <a:ext uri="{C572A759-6A51-4108-AA02-DFA0A04FC94B}">
-              <ma14:wrappingTextBoxFlag xmlns="" xmlns:ma14="http://schemas.microsoft.com/office/mac/drawingml/2011/main" val="0"/>
+              <ma14:wrappingTextBoxFlag xmlns:ma14="http://schemas.microsoft.com/office/mac/drawingml/2011/main" xmlns="" val="0"/>
             </a:ext>
           </a:extLst>
         </p:spPr>
@@ -21234,7 +21234,7 @@
           </a:prstGeom>
           <a:extLst>
             <a:ext uri="{C572A759-6A51-4108-AA02-DFA0A04FC94B}">
-              <ma14:wrappingTextBoxFlag xmlns="" xmlns:ma14="http://schemas.microsoft.com/office/mac/drawingml/2011/main" val="0"/>
+              <ma14:wrappingTextBoxFlag xmlns:ma14="http://schemas.microsoft.com/office/mac/drawingml/2011/main" xmlns="" val="0"/>
             </a:ext>
           </a:extLst>
         </p:spPr>
@@ -24316,7 +24316,7 @@
           </a:prstGeom>
           <a:extLst>
             <a:ext uri="{C572A759-6A51-4108-AA02-DFA0A04FC94B}">
-              <ma14:wrappingTextBoxFlag xmlns="" xmlns:ma14="http://schemas.microsoft.com/office/mac/drawingml/2011/main" val="0"/>
+              <ma14:wrappingTextBoxFlag xmlns:ma14="http://schemas.microsoft.com/office/mac/drawingml/2011/main" xmlns="" val="0"/>
             </a:ext>
           </a:extLst>
         </p:spPr>
@@ -25404,7 +25404,7 @@
           </a:prstGeom>
           <a:extLst>
             <a:ext uri="{C572A759-6A51-4108-AA02-DFA0A04FC94B}">
-              <ma14:wrappingTextBoxFlag xmlns="" xmlns:ma14="http://schemas.microsoft.com/office/mac/drawingml/2011/main" val="0"/>
+              <ma14:wrappingTextBoxFlag xmlns:ma14="http://schemas.microsoft.com/office/mac/drawingml/2011/main" xmlns="" val="0"/>
             </a:ext>
           </a:extLst>
         </p:spPr>
@@ -26559,7 +26559,7 @@
           </a:prstGeom>
           <a:extLst>
             <a:ext uri="{C572A759-6A51-4108-AA02-DFA0A04FC94B}">
-              <ma14:wrappingTextBoxFlag xmlns="" xmlns:ma14="http://schemas.microsoft.com/office/mac/drawingml/2011/main" val="0"/>
+              <ma14:wrappingTextBoxFlag xmlns:ma14="http://schemas.microsoft.com/office/mac/drawingml/2011/main" xmlns="" val="0"/>
             </a:ext>
           </a:extLst>
         </p:spPr>
@@ -27970,7 +27970,7 @@
           </a:prstGeom>
           <a:extLst>
             <a:ext uri="{C572A759-6A51-4108-AA02-DFA0A04FC94B}">
-              <ma14:wrappingTextBoxFlag xmlns="" xmlns:ma14="http://schemas.microsoft.com/office/mac/drawingml/2011/main" val="0"/>
+              <ma14:wrappingTextBoxFlag xmlns:ma14="http://schemas.microsoft.com/office/mac/drawingml/2011/main" xmlns="" val="0"/>
             </a:ext>
           </a:extLst>
         </p:spPr>
@@ -28957,7 +28957,7 @@
           </a:prstGeom>
           <a:extLst>
             <a:ext uri="{C572A759-6A51-4108-AA02-DFA0A04FC94B}">
-              <ma14:wrappingTextBoxFlag xmlns="" xmlns:ma14="http://schemas.microsoft.com/office/mac/drawingml/2011/main" val="0"/>
+              <ma14:wrappingTextBoxFlag xmlns:ma14="http://schemas.microsoft.com/office/mac/drawingml/2011/main" xmlns="" val="0"/>
             </a:ext>
           </a:extLst>
         </p:spPr>
@@ -30345,7 +30345,7 @@
           </a:prstGeom>
           <a:extLst>
             <a:ext uri="{C572A759-6A51-4108-AA02-DFA0A04FC94B}">
-              <ma14:wrappingTextBoxFlag xmlns="" xmlns:ma14="http://schemas.microsoft.com/office/mac/drawingml/2011/main" val="0"/>
+              <ma14:wrappingTextBoxFlag xmlns:ma14="http://schemas.microsoft.com/office/mac/drawingml/2011/main" xmlns="" val="0"/>
             </a:ext>
           </a:extLst>
         </p:spPr>

</xml_diff>

<commit_message>
Correct slide 15 governed action flow
Move the outcome connector from the monitoring card to the complete Agent 365 governance boundary so the governed action represents all layered controls.

Co-authored-by: Copilot <223556219+Copilot@users.noreply.github.com>
Copilot-Session: aa1a2148-b4d0-4cc5-94ea-497594b4b72a
</commit_message>
<xml_diff>
--- a/docs/foundry-apim-mcp-workshop.pptx
+++ b/docs/foundry-apim-mcp-workshop.pptx
@@ -2194,7 +2194,7 @@
           </a:prstGeom>
           <a:extLst>
             <a:ext uri="{C572A759-6A51-4108-AA02-DFA0A04FC94B}">
-              <ma14:wrappingTextBoxFlag xmlns:ma14="http://schemas.microsoft.com/office/mac/drawingml/2011/main" xmlns="" val="0"/>
+              <ma14:wrappingTextBoxFlag xmlns="" xmlns:ma14="http://schemas.microsoft.com/office/mac/drawingml/2011/main" val="0"/>
             </a:ext>
           </a:extLst>
         </p:spPr>
@@ -2272,7 +2272,7 @@
           </a:prstGeom>
           <a:extLst>
             <a:ext uri="{C572A759-6A51-4108-AA02-DFA0A04FC94B}">
-              <ma14:wrappingTextBoxFlag xmlns:ma14="http://schemas.microsoft.com/office/mac/drawingml/2011/main" xmlns="" val="0"/>
+              <ma14:wrappingTextBoxFlag xmlns="" xmlns:ma14="http://schemas.microsoft.com/office/mac/drawingml/2011/main" val="0"/>
             </a:ext>
           </a:extLst>
         </p:spPr>
@@ -4877,7 +4877,7 @@
           </a:prstGeom>
           <a:extLst>
             <a:ext uri="{C572A759-6A51-4108-AA02-DFA0A04FC94B}">
-              <ma14:wrappingTextBoxFlag xmlns:ma14="http://schemas.microsoft.com/office/mac/drawingml/2011/main" xmlns="" val="0"/>
+              <ma14:wrappingTextBoxFlag xmlns="" xmlns:ma14="http://schemas.microsoft.com/office/mac/drawingml/2011/main" val="0"/>
             </a:ext>
           </a:extLst>
         </p:spPr>
@@ -5835,7 +5835,7 @@
           </a:prstGeom>
           <a:extLst>
             <a:ext uri="{C572A759-6A51-4108-AA02-DFA0A04FC94B}">
-              <ma14:wrappingTextBoxFlag xmlns:ma14="http://schemas.microsoft.com/office/mac/drawingml/2011/main" xmlns="" val="0"/>
+              <ma14:wrappingTextBoxFlag xmlns="" xmlns:ma14="http://schemas.microsoft.com/office/mac/drawingml/2011/main" val="0"/>
             </a:ext>
           </a:extLst>
         </p:spPr>
@@ -7051,7 +7051,7 @@
           </a:prstGeom>
           <a:extLst>
             <a:ext uri="{C572A759-6A51-4108-AA02-DFA0A04FC94B}">
-              <ma14:wrappingTextBoxFlag xmlns:ma14="http://schemas.microsoft.com/office/mac/drawingml/2011/main" xmlns="" val="0"/>
+              <ma14:wrappingTextBoxFlag xmlns="" xmlns:ma14="http://schemas.microsoft.com/office/mac/drawingml/2011/main" val="0"/>
             </a:ext>
           </a:extLst>
         </p:spPr>
@@ -8167,7 +8167,7 @@
           </a:prstGeom>
           <a:extLst>
             <a:ext uri="{C572A759-6A51-4108-AA02-DFA0A04FC94B}">
-              <ma14:wrappingTextBoxFlag xmlns:ma14="http://schemas.microsoft.com/office/mac/drawingml/2011/main" xmlns="" val="0"/>
+              <ma14:wrappingTextBoxFlag xmlns="" xmlns:ma14="http://schemas.microsoft.com/office/mac/drawingml/2011/main" val="0"/>
             </a:ext>
           </a:extLst>
         </p:spPr>
@@ -9585,7 +9585,7 @@
           </a:prstGeom>
           <a:extLst>
             <a:ext uri="{C572A759-6A51-4108-AA02-DFA0A04FC94B}">
-              <ma14:wrappingTextBoxFlag xmlns:ma14="http://schemas.microsoft.com/office/mac/drawingml/2011/main" xmlns="" val="0"/>
+              <ma14:wrappingTextBoxFlag xmlns="" xmlns:ma14="http://schemas.microsoft.com/office/mac/drawingml/2011/main" val="0"/>
             </a:ext>
           </a:extLst>
         </p:spPr>
@@ -10449,8 +10449,8 @@
         </p:nvSpPr>
         <p:spPr>
           <a:xfrm>
-            <a:off x="6099048" y="5170932"/>
-            <a:ext cx="0" cy="219456"/>
+            <a:off x="6098540" y="5372100"/>
+            <a:ext cx="0" cy="254000"/>
           </a:xfrm>
           <a:prstGeom prst="line">
             <a:avLst/>
@@ -10461,7 +10461,8 @@
               <a:srgbClr val="12304A"/>
             </a:solidFill>
             <a:prstDash val="solid"/>
-            <a:tailEnd type="triangle"/>
+            <a:headEnd type="none"/>
+            <a:tailEnd type="arrow"/>
           </a:ln>
         </p:spPr>
         <p:txBody>
@@ -10480,8 +10481,8 @@
         </p:nvSpPr>
         <p:spPr>
           <a:xfrm>
-            <a:off x="5193792" y="5399532"/>
-            <a:ext cx="1810512" cy="676656"/>
+            <a:off x="5193792" y="5626100"/>
+            <a:ext cx="1810512" cy="558800"/>
           </a:xfrm>
           <a:prstGeom prst="ellipse">
             <a:avLst/>
@@ -10512,8 +10513,8 @@
         </p:nvSpPr>
         <p:spPr>
           <a:xfrm>
-            <a:off x="5330952" y="5618988"/>
-            <a:ext cx="1536192" cy="164592"/>
+            <a:off x="5330952" y="5791200"/>
+            <a:ext cx="1536192" cy="165100"/>
           </a:xfrm>
           <a:prstGeom prst="rect">
             <a:avLst/>
@@ -10602,7 +10603,7 @@
           </a:prstGeom>
           <a:extLst>
             <a:ext uri="{C572A759-6A51-4108-AA02-DFA0A04FC94B}">
-              <ma14:wrappingTextBoxFlag xmlns:ma14="http://schemas.microsoft.com/office/mac/drawingml/2011/main" xmlns="" val="0"/>
+              <ma14:wrappingTextBoxFlag xmlns="" xmlns:ma14="http://schemas.microsoft.com/office/mac/drawingml/2011/main" val="0"/>
             </a:ext>
           </a:extLst>
         </p:spPr>
@@ -11823,7 +11824,7 @@
           </a:prstGeom>
           <a:extLst>
             <a:ext uri="{C572A759-6A51-4108-AA02-DFA0A04FC94B}">
-              <ma14:wrappingTextBoxFlag xmlns:ma14="http://schemas.microsoft.com/office/mac/drawingml/2011/main" xmlns="" val="0"/>
+              <ma14:wrappingTextBoxFlag xmlns="" xmlns:ma14="http://schemas.microsoft.com/office/mac/drawingml/2011/main" val="0"/>
             </a:ext>
           </a:extLst>
         </p:spPr>
@@ -13586,7 +13587,7 @@
           </a:prstGeom>
           <a:extLst>
             <a:ext uri="{C572A759-6A51-4108-AA02-DFA0A04FC94B}">
-              <ma14:wrappingTextBoxFlag xmlns:ma14="http://schemas.microsoft.com/office/mac/drawingml/2011/main" xmlns="" val="0"/>
+              <ma14:wrappingTextBoxFlag xmlns="" xmlns:ma14="http://schemas.microsoft.com/office/mac/drawingml/2011/main" val="0"/>
             </a:ext>
           </a:extLst>
         </p:spPr>
@@ -14917,7 +14918,7 @@
           </a:prstGeom>
           <a:extLst>
             <a:ext uri="{C572A759-6A51-4108-AA02-DFA0A04FC94B}">
-              <ma14:wrappingTextBoxFlag xmlns:ma14="http://schemas.microsoft.com/office/mac/drawingml/2011/main" xmlns="" val="0"/>
+              <ma14:wrappingTextBoxFlag xmlns="" xmlns:ma14="http://schemas.microsoft.com/office/mac/drawingml/2011/main" val="0"/>
             </a:ext>
           </a:extLst>
         </p:spPr>
@@ -16539,7 +16540,7 @@
           </a:prstGeom>
           <a:extLst>
             <a:ext uri="{C572A759-6A51-4108-AA02-DFA0A04FC94B}">
-              <ma14:wrappingTextBoxFlag xmlns:ma14="http://schemas.microsoft.com/office/mac/drawingml/2011/main" xmlns="" val="0"/>
+              <ma14:wrappingTextBoxFlag xmlns="" xmlns:ma14="http://schemas.microsoft.com/office/mac/drawingml/2011/main" val="0"/>
             </a:ext>
           </a:extLst>
         </p:spPr>
@@ -17720,7 +17721,7 @@
           </a:prstGeom>
           <a:extLst>
             <a:ext uri="{C572A759-6A51-4108-AA02-DFA0A04FC94B}">
-              <ma14:wrappingTextBoxFlag xmlns:ma14="http://schemas.microsoft.com/office/mac/drawingml/2011/main" xmlns="" val="0"/>
+              <ma14:wrappingTextBoxFlag xmlns="" xmlns:ma14="http://schemas.microsoft.com/office/mac/drawingml/2011/main" val="0"/>
             </a:ext>
           </a:extLst>
         </p:spPr>
@@ -18912,7 +18913,7 @@
           </a:prstGeom>
           <a:extLst>
             <a:ext uri="{C572A759-6A51-4108-AA02-DFA0A04FC94B}">
-              <ma14:wrappingTextBoxFlag xmlns:ma14="http://schemas.microsoft.com/office/mac/drawingml/2011/main" xmlns="" val="0"/>
+              <ma14:wrappingTextBoxFlag xmlns="" xmlns:ma14="http://schemas.microsoft.com/office/mac/drawingml/2011/main" val="0"/>
             </a:ext>
           </a:extLst>
         </p:spPr>
@@ -21234,7 +21235,7 @@
           </a:prstGeom>
           <a:extLst>
             <a:ext uri="{C572A759-6A51-4108-AA02-DFA0A04FC94B}">
-              <ma14:wrappingTextBoxFlag xmlns:ma14="http://schemas.microsoft.com/office/mac/drawingml/2011/main" xmlns="" val="0"/>
+              <ma14:wrappingTextBoxFlag xmlns="" xmlns:ma14="http://schemas.microsoft.com/office/mac/drawingml/2011/main" val="0"/>
             </a:ext>
           </a:extLst>
         </p:spPr>
@@ -24316,7 +24317,7 @@
           </a:prstGeom>
           <a:extLst>
             <a:ext uri="{C572A759-6A51-4108-AA02-DFA0A04FC94B}">
-              <ma14:wrappingTextBoxFlag xmlns:ma14="http://schemas.microsoft.com/office/mac/drawingml/2011/main" xmlns="" val="0"/>
+              <ma14:wrappingTextBoxFlag xmlns="" xmlns:ma14="http://schemas.microsoft.com/office/mac/drawingml/2011/main" val="0"/>
             </a:ext>
           </a:extLst>
         </p:spPr>
@@ -25404,7 +25405,7 @@
           </a:prstGeom>
           <a:extLst>
             <a:ext uri="{C572A759-6A51-4108-AA02-DFA0A04FC94B}">
-              <ma14:wrappingTextBoxFlag xmlns:ma14="http://schemas.microsoft.com/office/mac/drawingml/2011/main" xmlns="" val="0"/>
+              <ma14:wrappingTextBoxFlag xmlns="" xmlns:ma14="http://schemas.microsoft.com/office/mac/drawingml/2011/main" val="0"/>
             </a:ext>
           </a:extLst>
         </p:spPr>
@@ -26559,7 +26560,7 @@
           </a:prstGeom>
           <a:extLst>
             <a:ext uri="{C572A759-6A51-4108-AA02-DFA0A04FC94B}">
-              <ma14:wrappingTextBoxFlag xmlns:ma14="http://schemas.microsoft.com/office/mac/drawingml/2011/main" xmlns="" val="0"/>
+              <ma14:wrappingTextBoxFlag xmlns="" xmlns:ma14="http://schemas.microsoft.com/office/mac/drawingml/2011/main" val="0"/>
             </a:ext>
           </a:extLst>
         </p:spPr>
@@ -27970,7 +27971,7 @@
           </a:prstGeom>
           <a:extLst>
             <a:ext uri="{C572A759-6A51-4108-AA02-DFA0A04FC94B}">
-              <ma14:wrappingTextBoxFlag xmlns:ma14="http://schemas.microsoft.com/office/mac/drawingml/2011/main" xmlns="" val="0"/>
+              <ma14:wrappingTextBoxFlag xmlns="" xmlns:ma14="http://schemas.microsoft.com/office/mac/drawingml/2011/main" val="0"/>
             </a:ext>
           </a:extLst>
         </p:spPr>
@@ -28957,7 +28958,7 @@
           </a:prstGeom>
           <a:extLst>
             <a:ext uri="{C572A759-6A51-4108-AA02-DFA0A04FC94B}">
-              <ma14:wrappingTextBoxFlag xmlns:ma14="http://schemas.microsoft.com/office/mac/drawingml/2011/main" xmlns="" val="0"/>
+              <ma14:wrappingTextBoxFlag xmlns="" xmlns:ma14="http://schemas.microsoft.com/office/mac/drawingml/2011/main" val="0"/>
             </a:ext>
           </a:extLst>
         </p:spPr>
@@ -30345,7 +30346,7 @@
           </a:prstGeom>
           <a:extLst>
             <a:ext uri="{C572A759-6A51-4108-AA02-DFA0A04FC94B}">
-              <ma14:wrappingTextBoxFlag xmlns:ma14="http://schemas.microsoft.com/office/mac/drawingml/2011/main" xmlns="" val="0"/>
+              <ma14:wrappingTextBoxFlag xmlns="" xmlns:ma14="http://schemas.microsoft.com/office/mac/drawingml/2011/main" val="0"/>
             </a:ext>
           </a:extLst>
         </p:spPr>

</xml_diff>

<commit_message>
Improve slide 7 transformation chevron
Enlarge the APIM transformation chevron and reposition its high-contrast label within the solid body for clearer alignment and readability.

Co-authored-by: Copilot <223556219+Copilot@users.noreply.github.com>
Copilot-Session: aa1a2148-b4d0-4cc5-94ea-497594b4b72a
</commit_message>
<xml_diff>
--- a/docs/foundry-apim-mcp-workshop.pptx
+++ b/docs/foundry-apim-mcp-workshop.pptx
@@ -27198,8 +27198,8 @@
         </p:nvSpPr>
         <p:spPr>
           <a:xfrm>
-            <a:off x="4005072" y="2999232"/>
-            <a:ext cx="914400" cy="1115568"/>
+            <a:off x="3784600" y="3022600"/>
+            <a:ext cx="1320800" cy="1066800"/>
           </a:xfrm>
           <a:prstGeom prst="chevron">
             <a:avLst/>
@@ -27230,8 +27230,8 @@
         </p:nvSpPr>
         <p:spPr>
           <a:xfrm>
-            <a:off x="3977640" y="3255264"/>
-            <a:ext cx="969264" cy="347472"/>
+            <a:off x="4140200" y="3251200"/>
+            <a:ext cx="838200" cy="609600"/>
           </a:xfrm>
           <a:prstGeom prst="rect">
             <a:avLst/>
@@ -27249,9 +27249,9 @@
               <a:buNone/>
             </a:pPr>
             <a:r>
-              <a:rPr lang="en-US" sz="850" b="1" dirty="0">
-                <a:solidFill>
-                  <a:srgbClr val="102A43"/>
+              <a:rPr lang="en-US" sz="900" b="1">
+                <a:solidFill>
+                  <a:srgbClr val="FFFFFF"/>
                 </a:solidFill>
                 <a:latin typeface="Aptos" pitchFamily="34" charset="0"/>
                 <a:ea typeface="Aptos" pitchFamily="34" charset="-122"/>
@@ -27259,24 +27259,28 @@
               </a:rPr>
               <a:t>APIM</a:t>
             </a:r>
-            <a:endParaRPr lang="en-US" sz="850" dirty="0"/>
           </a:p>
           <a:p>
             <a:pPr marL="0" indent="0" algn="ctr">
               <a:buNone/>
             </a:pPr>
             <a:r>
-              <a:rPr lang="en-US" sz="850" b="1" dirty="0">
-                <a:solidFill>
-                  <a:srgbClr val="102A43"/>
+              <a:rPr lang="en-US" sz="900" b="1">
+                <a:solidFill>
+                  <a:srgbClr val="FFFFFF"/>
                 </a:solidFill>
                 <a:latin typeface="Aptos" pitchFamily="34" charset="0"/>
                 <a:ea typeface="Aptos" pitchFamily="34" charset="-122"/>
                 <a:cs typeface="Aptos" pitchFamily="34" charset="-120"/>
               </a:rPr>
-              <a:t>REST to MCP</a:t>
-            </a:r>
-            <a:endParaRPr lang="en-US" sz="850" dirty="0"/>
+              <a:t>REST → MCP</a:t>
+            </a:r>
+            <a:endParaRPr lang="en-US" sz="900" b="1" dirty="0">
+              <a:solidFill>
+                <a:srgbClr val="FFFFFF"/>
+              </a:solidFill>
+              <a:latin typeface="Aptos" panose="020B0004020202020204" pitchFamily="34" charset="0"/>
+            </a:endParaRPr>
           </a:p>
         </p:txBody>
       </p:sp>

</xml_diff>

<commit_message>
Refine slide 7 chevron padding
Shift the APIM REST-to-MCP label slightly right to add left padding within the solid chevron body.

Co-authored-by: Copilot <223556219+Copilot@users.noreply.github.com>
Copilot-Session: aa1a2148-b4d0-4cc5-94ea-497594b4b72a
</commit_message>
<xml_diff>
--- a/docs/foundry-apim-mcp-workshop.pptx
+++ b/docs/foundry-apim-mcp-workshop.pptx
@@ -27230,8 +27230,8 @@
         </p:nvSpPr>
         <p:spPr>
           <a:xfrm>
-            <a:off x="4140200" y="3251200"/>
-            <a:ext cx="838200" cy="609600"/>
+            <a:off x="4229100" y="3251200"/>
+            <a:ext cx="774700" cy="609600"/>
           </a:xfrm>
           <a:prstGeom prst="rect">
             <a:avLst/>

</xml_diff>

<commit_message>
Add presenter to title slide
Add Yuri Lausberg and the Principal Solution Engineer role to the bottom of slide 1 while preserving the QR code and title-slide layout.

Co-authored-by: Copilot <223556219+Copilot@users.noreply.github.com>
Copilot-Session: aa1a2148-b4d0-4cc5-94ea-497594b4b72a
</commit_message>
<xml_diff>
--- a/docs/foundry-apim-mcp-workshop.pptx
+++ b/docs/foundry-apim-mcp-workshop.pptx
@@ -476,10 +476,17 @@
           <a:lstStyle/>
           <a:p>
             <a:r>
-              <a:rPr lang="en-US"/>
-              <a:t>Run the ASP.NET Core web project first. Confirm that the Responses API is listening at http://localhost:8088/responses before opening either client. For the PowerShell smoke test, prepare $body from the lab request payload and run the displayed Invoke-RestMethod command. Open Agent Inspector from Foundry Toolkit for the teaching view because it exposes model input, tool discovery, tool calls, approvals, and the final response.</a:t>
-            </a:r>
-            <a:endParaRPr lang="en-US" dirty="0"/>
+              <a:rPr lang="en-US" dirty="0"/>
+              <a:t>Run the ASP.NET Core web project first. Confirm that the Responses API is listening at http://localhost:8088/responses before opening either client. For the PowerShell smoke test, prepare $body from the lab request payload and run the displayed Invoke-</a:t>
+            </a:r>
+            <a:r>
+              <a:rPr lang="en-US" dirty="0" err="1"/>
+              <a:t>RestMethod</a:t>
+            </a:r>
+            <a:r>
+              <a:rPr lang="en-US" dirty="0"/>
+              <a:t> command. Open Agent Inspector from Foundry Toolkit for the teaching view because it exposes model input, tool discovery, tool calls, approvals, and the final response.</a:t>
+            </a:r>
           </a:p>
         </p:txBody>
       </p:sp>
@@ -2194,7 +2201,7 @@
           </a:prstGeom>
           <a:extLst>
             <a:ext uri="{C572A759-6A51-4108-AA02-DFA0A04FC94B}">
-              <ma14:wrappingTextBoxFlag xmlns="" xmlns:ma14="http://schemas.microsoft.com/office/mac/drawingml/2011/main" val="0"/>
+              <ma14:wrappingTextBoxFlag xmlns:ma14="http://schemas.microsoft.com/office/mac/drawingml/2011/main" xmlns="" val="0"/>
             </a:ext>
           </a:extLst>
         </p:spPr>
@@ -2272,7 +2279,7 @@
           </a:prstGeom>
           <a:extLst>
             <a:ext uri="{C572A759-6A51-4108-AA02-DFA0A04FC94B}">
-              <ma14:wrappingTextBoxFlag xmlns="" xmlns:ma14="http://schemas.microsoft.com/office/mac/drawingml/2011/main" val="0"/>
+              <ma14:wrappingTextBoxFlag xmlns:ma14="http://schemas.microsoft.com/office/mac/drawingml/2011/main" xmlns="" val="0"/>
             </a:ext>
           </a:extLst>
         </p:spPr>
@@ -3283,6 +3290,67 @@
           </a:p>
         </p:txBody>
       </p:sp>
+      <p:sp>
+        <p:nvSpPr>
+          <p:cNvPr id="18" name="Presenter Line">
+            <a:extLst>
+              <a:ext uri="{FF2B5EF4-FFF2-40B4-BE49-F238E27FC236}">
+                <a16:creationId xmlns:a16="http://schemas.microsoft.com/office/drawing/2014/main" id="{596959E3-4555-38F3-32CA-31EAE14282EB}"/>
+              </a:ext>
+            </a:extLst>
+          </p:cNvPr>
+          <p:cNvSpPr/>
+          <p:nvPr/>
+        </p:nvSpPr>
+        <p:spPr>
+          <a:xfrm>
+            <a:off x="4191000" y="6299200"/>
+            <a:ext cx="5080000" cy="200660"/>
+          </a:xfrm>
+          <a:prstGeom prst="rect">
+            <a:avLst/>
+          </a:prstGeom>
+          <a:noFill/>
+          <a:ln/>
+        </p:spPr>
+        <p:txBody>
+          <a:bodyPr wrap="square" lIns="0" tIns="0" rIns="0" bIns="0" rtlCol="0" anchor="ctr"/>
+          <a:lstStyle/>
+          <a:p>
+            <a:pPr marL="0" indent="0">
+              <a:buNone/>
+            </a:pPr>
+            <a:r>
+              <a:rPr lang="en-US" sz="1050" b="1">
+                <a:solidFill>
+                  <a:srgbClr val="FFFFFF"/>
+                </a:solidFill>
+                <a:latin typeface="Aptos" panose="020B0004020202020204" pitchFamily="34" charset="0"/>
+                <a:ea typeface="Aptos" pitchFamily="34" charset="-122"/>
+                <a:cs typeface="Aptos" pitchFamily="34" charset="-120"/>
+              </a:rPr>
+              <a:t>Yuri Lausberg</a:t>
+            </a:r>
+            <a:r>
+              <a:rPr lang="en-US" sz="1050">
+                <a:solidFill>
+                  <a:srgbClr val="DDDDDD"/>
+                </a:solidFill>
+                <a:latin typeface="Aptos" panose="020B0004020202020204" pitchFamily="34" charset="0"/>
+                <a:ea typeface="Aptos" pitchFamily="34" charset="-122"/>
+                <a:cs typeface="Aptos" pitchFamily="34" charset="-120"/>
+              </a:rPr>
+              <a:t> | Principal Solution Engineer</a:t>
+            </a:r>
+            <a:endParaRPr lang="en-US" sz="1050" dirty="0">
+              <a:solidFill>
+                <a:srgbClr val="DDDDDD"/>
+              </a:solidFill>
+              <a:latin typeface="Aptos" panose="020B0004020202020204" pitchFamily="34" charset="0"/>
+            </a:endParaRPr>
+          </a:p>
+        </p:txBody>
+      </p:sp>
     </p:spTree>
   </p:cSld>
   <p:clrMapOvr>
@@ -4877,7 +4945,7 @@
           </a:prstGeom>
           <a:extLst>
             <a:ext uri="{C572A759-6A51-4108-AA02-DFA0A04FC94B}">
-              <ma14:wrappingTextBoxFlag xmlns="" xmlns:ma14="http://schemas.microsoft.com/office/mac/drawingml/2011/main" val="0"/>
+              <ma14:wrappingTextBoxFlag xmlns:ma14="http://schemas.microsoft.com/office/mac/drawingml/2011/main" xmlns="" val="0"/>
             </a:ext>
           </a:extLst>
         </p:spPr>
@@ -5037,7 +5105,7 @@
               <a:buNone/>
             </a:pPr>
             <a:r>
-              <a:rPr lang="en-US" sz="1250">
+              <a:rPr lang="en-US" sz="1250" dirty="0">
                 <a:solidFill>
                   <a:srgbClr val="4F6474"/>
                 </a:solidFill>
@@ -5509,7 +5577,7 @@
               <a:buNone/>
             </a:pPr>
             <a:r>
-              <a:rPr lang="en-US" sz="1500" b="1">
+              <a:rPr lang="en-US" sz="1500" b="1" dirty="0">
                 <a:solidFill>
                   <a:srgbClr val="102A43"/>
                 </a:solidFill>
@@ -5553,7 +5621,7 @@
               <a:buNone/>
             </a:pPr>
             <a:r>
-              <a:rPr lang="en-US" sz="1050">
+              <a:rPr lang="en-US" sz="1050" dirty="0">
                 <a:solidFill>
                   <a:srgbClr val="4F6474"/>
                 </a:solidFill>
@@ -5571,7 +5639,7 @@
               </a:lnSpc>
               <a:buNone/>
             </a:pPr>
-            <a:endParaRPr lang="en-US" sz="1050">
+            <a:endParaRPr lang="en-US" sz="1050" dirty="0">
               <a:solidFill>
                 <a:srgbClr val="4F6474"/>
               </a:solidFill>
@@ -5588,7 +5656,7 @@
               <a:buNone/>
             </a:pPr>
             <a:r>
-              <a:rPr lang="en-US" sz="1050">
+              <a:rPr lang="en-US" sz="1050" dirty="0">
                 <a:solidFill>
                   <a:srgbClr val="4F6474"/>
                 </a:solidFill>
@@ -5659,7 +5727,7 @@
               <a:buNone/>
             </a:pPr>
             <a:r>
-              <a:rPr lang="en-US" sz="1050" b="1">
+              <a:rPr lang="en-US" sz="1050" b="1" dirty="0">
                 <a:solidFill>
                   <a:srgbClr val="775DA6"/>
                 </a:solidFill>
@@ -5835,7 +5903,7 @@
           </a:prstGeom>
           <a:extLst>
             <a:ext uri="{C572A759-6A51-4108-AA02-DFA0A04FC94B}">
-              <ma14:wrappingTextBoxFlag xmlns="" xmlns:ma14="http://schemas.microsoft.com/office/mac/drawingml/2011/main" val="0"/>
+              <ma14:wrappingTextBoxFlag xmlns:ma14="http://schemas.microsoft.com/office/mac/drawingml/2011/main" xmlns="" val="0"/>
             </a:ext>
           </a:extLst>
         </p:spPr>
@@ -7051,7 +7119,7 @@
           </a:prstGeom>
           <a:extLst>
             <a:ext uri="{C572A759-6A51-4108-AA02-DFA0A04FC94B}">
-              <ma14:wrappingTextBoxFlag xmlns="" xmlns:ma14="http://schemas.microsoft.com/office/mac/drawingml/2011/main" val="0"/>
+              <ma14:wrappingTextBoxFlag xmlns:ma14="http://schemas.microsoft.com/office/mac/drawingml/2011/main" xmlns="" val="0"/>
             </a:ext>
           </a:extLst>
         </p:spPr>
@@ -8167,7 +8235,7 @@
           </a:prstGeom>
           <a:extLst>
             <a:ext uri="{C572A759-6A51-4108-AA02-DFA0A04FC94B}">
-              <ma14:wrappingTextBoxFlag xmlns="" xmlns:ma14="http://schemas.microsoft.com/office/mac/drawingml/2011/main" val="0"/>
+              <ma14:wrappingTextBoxFlag xmlns:ma14="http://schemas.microsoft.com/office/mac/drawingml/2011/main" xmlns="" val="0"/>
             </a:ext>
           </a:extLst>
         </p:spPr>
@@ -9585,7 +9653,7 @@
           </a:prstGeom>
           <a:extLst>
             <a:ext uri="{C572A759-6A51-4108-AA02-DFA0A04FC94B}">
-              <ma14:wrappingTextBoxFlag xmlns="" xmlns:ma14="http://schemas.microsoft.com/office/mac/drawingml/2011/main" val="0"/>
+              <ma14:wrappingTextBoxFlag xmlns:ma14="http://schemas.microsoft.com/office/mac/drawingml/2011/main" xmlns="" val="0"/>
             </a:ext>
           </a:extLst>
         </p:spPr>
@@ -10603,7 +10671,7 @@
           </a:prstGeom>
           <a:extLst>
             <a:ext uri="{C572A759-6A51-4108-AA02-DFA0A04FC94B}">
-              <ma14:wrappingTextBoxFlag xmlns="" xmlns:ma14="http://schemas.microsoft.com/office/mac/drawingml/2011/main" val="0"/>
+              <ma14:wrappingTextBoxFlag xmlns:ma14="http://schemas.microsoft.com/office/mac/drawingml/2011/main" xmlns="" val="0"/>
             </a:ext>
           </a:extLst>
         </p:spPr>
@@ -11824,7 +11892,7 @@
           </a:prstGeom>
           <a:extLst>
             <a:ext uri="{C572A759-6A51-4108-AA02-DFA0A04FC94B}">
-              <ma14:wrappingTextBoxFlag xmlns="" xmlns:ma14="http://schemas.microsoft.com/office/mac/drawingml/2011/main" val="0"/>
+              <ma14:wrappingTextBoxFlag xmlns:ma14="http://schemas.microsoft.com/office/mac/drawingml/2011/main" xmlns="" val="0"/>
             </a:ext>
           </a:extLst>
         </p:spPr>
@@ -13587,7 +13655,7 @@
           </a:prstGeom>
           <a:extLst>
             <a:ext uri="{C572A759-6A51-4108-AA02-DFA0A04FC94B}">
-              <ma14:wrappingTextBoxFlag xmlns="" xmlns:ma14="http://schemas.microsoft.com/office/mac/drawingml/2011/main" val="0"/>
+              <ma14:wrappingTextBoxFlag xmlns:ma14="http://schemas.microsoft.com/office/mac/drawingml/2011/main" xmlns="" val="0"/>
             </a:ext>
           </a:extLst>
         </p:spPr>
@@ -14918,7 +14986,7 @@
           </a:prstGeom>
           <a:extLst>
             <a:ext uri="{C572A759-6A51-4108-AA02-DFA0A04FC94B}">
-              <ma14:wrappingTextBoxFlag xmlns="" xmlns:ma14="http://schemas.microsoft.com/office/mac/drawingml/2011/main" val="0"/>
+              <ma14:wrappingTextBoxFlag xmlns:ma14="http://schemas.microsoft.com/office/mac/drawingml/2011/main" xmlns="" val="0"/>
             </a:ext>
           </a:extLst>
         </p:spPr>
@@ -16540,7 +16608,7 @@
           </a:prstGeom>
           <a:extLst>
             <a:ext uri="{C572A759-6A51-4108-AA02-DFA0A04FC94B}">
-              <ma14:wrappingTextBoxFlag xmlns="" xmlns:ma14="http://schemas.microsoft.com/office/mac/drawingml/2011/main" val="0"/>
+              <ma14:wrappingTextBoxFlag xmlns:ma14="http://schemas.microsoft.com/office/mac/drawingml/2011/main" xmlns="" val="0"/>
             </a:ext>
           </a:extLst>
         </p:spPr>
@@ -17721,7 +17789,7 @@
           </a:prstGeom>
           <a:extLst>
             <a:ext uri="{C572A759-6A51-4108-AA02-DFA0A04FC94B}">
-              <ma14:wrappingTextBoxFlag xmlns="" xmlns:ma14="http://schemas.microsoft.com/office/mac/drawingml/2011/main" val="0"/>
+              <ma14:wrappingTextBoxFlag xmlns:ma14="http://schemas.microsoft.com/office/mac/drawingml/2011/main" xmlns="" val="0"/>
             </a:ext>
           </a:extLst>
         </p:spPr>
@@ -18913,7 +18981,7 @@
           </a:prstGeom>
           <a:extLst>
             <a:ext uri="{C572A759-6A51-4108-AA02-DFA0A04FC94B}">
-              <ma14:wrappingTextBoxFlag xmlns="" xmlns:ma14="http://schemas.microsoft.com/office/mac/drawingml/2011/main" val="0"/>
+              <ma14:wrappingTextBoxFlag xmlns:ma14="http://schemas.microsoft.com/office/mac/drawingml/2011/main" xmlns="" val="0"/>
             </a:ext>
           </a:extLst>
         </p:spPr>
@@ -21235,7 +21303,7 @@
           </a:prstGeom>
           <a:extLst>
             <a:ext uri="{C572A759-6A51-4108-AA02-DFA0A04FC94B}">
-              <ma14:wrappingTextBoxFlag xmlns="" xmlns:ma14="http://schemas.microsoft.com/office/mac/drawingml/2011/main" val="0"/>
+              <ma14:wrappingTextBoxFlag xmlns:ma14="http://schemas.microsoft.com/office/mac/drawingml/2011/main" xmlns="" val="0"/>
             </a:ext>
           </a:extLst>
         </p:spPr>
@@ -24317,7 +24385,7 @@
           </a:prstGeom>
           <a:extLst>
             <a:ext uri="{C572A759-6A51-4108-AA02-DFA0A04FC94B}">
-              <ma14:wrappingTextBoxFlag xmlns="" xmlns:ma14="http://schemas.microsoft.com/office/mac/drawingml/2011/main" val="0"/>
+              <ma14:wrappingTextBoxFlag xmlns:ma14="http://schemas.microsoft.com/office/mac/drawingml/2011/main" xmlns="" val="0"/>
             </a:ext>
           </a:extLst>
         </p:spPr>
@@ -25405,7 +25473,7 @@
           </a:prstGeom>
           <a:extLst>
             <a:ext uri="{C572A759-6A51-4108-AA02-DFA0A04FC94B}">
-              <ma14:wrappingTextBoxFlag xmlns="" xmlns:ma14="http://schemas.microsoft.com/office/mac/drawingml/2011/main" val="0"/>
+              <ma14:wrappingTextBoxFlag xmlns:ma14="http://schemas.microsoft.com/office/mac/drawingml/2011/main" xmlns="" val="0"/>
             </a:ext>
           </a:extLst>
         </p:spPr>
@@ -26560,7 +26628,7 @@
           </a:prstGeom>
           <a:extLst>
             <a:ext uri="{C572A759-6A51-4108-AA02-DFA0A04FC94B}">
-              <ma14:wrappingTextBoxFlag xmlns="" xmlns:ma14="http://schemas.microsoft.com/office/mac/drawingml/2011/main" val="0"/>
+              <ma14:wrappingTextBoxFlag xmlns:ma14="http://schemas.microsoft.com/office/mac/drawingml/2011/main" xmlns="" val="0"/>
             </a:ext>
           </a:extLst>
         </p:spPr>
@@ -27975,7 +28043,7 @@
           </a:prstGeom>
           <a:extLst>
             <a:ext uri="{C572A759-6A51-4108-AA02-DFA0A04FC94B}">
-              <ma14:wrappingTextBoxFlag xmlns="" xmlns:ma14="http://schemas.microsoft.com/office/mac/drawingml/2011/main" val="0"/>
+              <ma14:wrappingTextBoxFlag xmlns:ma14="http://schemas.microsoft.com/office/mac/drawingml/2011/main" xmlns="" val="0"/>
             </a:ext>
           </a:extLst>
         </p:spPr>
@@ -28962,7 +29030,7 @@
           </a:prstGeom>
           <a:extLst>
             <a:ext uri="{C572A759-6A51-4108-AA02-DFA0A04FC94B}">
-              <ma14:wrappingTextBoxFlag xmlns="" xmlns:ma14="http://schemas.microsoft.com/office/mac/drawingml/2011/main" val="0"/>
+              <ma14:wrappingTextBoxFlag xmlns:ma14="http://schemas.microsoft.com/office/mac/drawingml/2011/main" xmlns="" val="0"/>
             </a:ext>
           </a:extLst>
         </p:spPr>
@@ -30350,7 +30418,7 @@
           </a:prstGeom>
           <a:extLst>
             <a:ext uri="{C572A759-6A51-4108-AA02-DFA0A04FC94B}">
-              <ma14:wrappingTextBoxFlag xmlns="" xmlns:ma14="http://schemas.microsoft.com/office/mac/drawingml/2011/main" val="0"/>
+              <ma14:wrappingTextBoxFlag xmlns:ma14="http://schemas.microsoft.com/office/mac/drawingml/2011/main" xmlns="" val="0"/>
             </a:ext>
           </a:extLst>
         </p:spPr>

</xml_diff>

<commit_message>
Reposition title slide presenter
Move the presenter name and role beneath the workshop URL so it aligns with the repository details beside the QR code.

Co-authored-by: Copilot <223556219+Copilot@users.noreply.github.com>
Copilot-Session: aa1a2148-b4d0-4cc5-94ea-497594b4b72a
</commit_message>
<xml_diff>
--- a/docs/foundry-apim-mcp-workshop.pptx
+++ b/docs/foundry-apim-mcp-workshop.pptx
@@ -2201,7 +2201,7 @@
           </a:prstGeom>
           <a:extLst>
             <a:ext uri="{C572A759-6A51-4108-AA02-DFA0A04FC94B}">
-              <ma14:wrappingTextBoxFlag xmlns:ma14="http://schemas.microsoft.com/office/mac/drawingml/2011/main" xmlns="" val="0"/>
+              <ma14:wrappingTextBoxFlag xmlns="" xmlns:ma14="http://schemas.microsoft.com/office/mac/drawingml/2011/main" val="0"/>
             </a:ext>
           </a:extLst>
         </p:spPr>
@@ -2279,7 +2279,7 @@
           </a:prstGeom>
           <a:extLst>
             <a:ext uri="{C572A759-6A51-4108-AA02-DFA0A04FC94B}">
-              <ma14:wrappingTextBoxFlag xmlns:ma14="http://schemas.microsoft.com/office/mac/drawingml/2011/main" xmlns="" val="0"/>
+              <ma14:wrappingTextBoxFlag xmlns="" xmlns:ma14="http://schemas.microsoft.com/office/mac/drawingml/2011/main" val="0"/>
             </a:ext>
           </a:extLst>
         </p:spPr>
@@ -3304,8 +3304,8 @@
         </p:nvSpPr>
         <p:spPr>
           <a:xfrm>
-            <a:off x="4191000" y="6299200"/>
-            <a:ext cx="5080000" cy="200660"/>
+            <a:off x="1739900" y="5918200"/>
+            <a:ext cx="4318000" cy="200660"/>
           </a:xfrm>
           <a:prstGeom prst="rect">
             <a:avLst/>
@@ -4945,7 +4945,7 @@
           </a:prstGeom>
           <a:extLst>
             <a:ext uri="{C572A759-6A51-4108-AA02-DFA0A04FC94B}">
-              <ma14:wrappingTextBoxFlag xmlns:ma14="http://schemas.microsoft.com/office/mac/drawingml/2011/main" xmlns="" val="0"/>
+              <ma14:wrappingTextBoxFlag xmlns="" xmlns:ma14="http://schemas.microsoft.com/office/mac/drawingml/2011/main" val="0"/>
             </a:ext>
           </a:extLst>
         </p:spPr>
@@ -5903,7 +5903,7 @@
           </a:prstGeom>
           <a:extLst>
             <a:ext uri="{C572A759-6A51-4108-AA02-DFA0A04FC94B}">
-              <ma14:wrappingTextBoxFlag xmlns:ma14="http://schemas.microsoft.com/office/mac/drawingml/2011/main" xmlns="" val="0"/>
+              <ma14:wrappingTextBoxFlag xmlns="" xmlns:ma14="http://schemas.microsoft.com/office/mac/drawingml/2011/main" val="0"/>
             </a:ext>
           </a:extLst>
         </p:spPr>
@@ -7119,7 +7119,7 @@
           </a:prstGeom>
           <a:extLst>
             <a:ext uri="{C572A759-6A51-4108-AA02-DFA0A04FC94B}">
-              <ma14:wrappingTextBoxFlag xmlns:ma14="http://schemas.microsoft.com/office/mac/drawingml/2011/main" xmlns="" val="0"/>
+              <ma14:wrappingTextBoxFlag xmlns="" xmlns:ma14="http://schemas.microsoft.com/office/mac/drawingml/2011/main" val="0"/>
             </a:ext>
           </a:extLst>
         </p:spPr>
@@ -8235,7 +8235,7 @@
           </a:prstGeom>
           <a:extLst>
             <a:ext uri="{C572A759-6A51-4108-AA02-DFA0A04FC94B}">
-              <ma14:wrappingTextBoxFlag xmlns:ma14="http://schemas.microsoft.com/office/mac/drawingml/2011/main" xmlns="" val="0"/>
+              <ma14:wrappingTextBoxFlag xmlns="" xmlns:ma14="http://schemas.microsoft.com/office/mac/drawingml/2011/main" val="0"/>
             </a:ext>
           </a:extLst>
         </p:spPr>
@@ -9653,7 +9653,7 @@
           </a:prstGeom>
           <a:extLst>
             <a:ext uri="{C572A759-6A51-4108-AA02-DFA0A04FC94B}">
-              <ma14:wrappingTextBoxFlag xmlns:ma14="http://schemas.microsoft.com/office/mac/drawingml/2011/main" xmlns="" val="0"/>
+              <ma14:wrappingTextBoxFlag xmlns="" xmlns:ma14="http://schemas.microsoft.com/office/mac/drawingml/2011/main" val="0"/>
             </a:ext>
           </a:extLst>
         </p:spPr>
@@ -10671,7 +10671,7 @@
           </a:prstGeom>
           <a:extLst>
             <a:ext uri="{C572A759-6A51-4108-AA02-DFA0A04FC94B}">
-              <ma14:wrappingTextBoxFlag xmlns:ma14="http://schemas.microsoft.com/office/mac/drawingml/2011/main" xmlns="" val="0"/>
+              <ma14:wrappingTextBoxFlag xmlns="" xmlns:ma14="http://schemas.microsoft.com/office/mac/drawingml/2011/main" val="0"/>
             </a:ext>
           </a:extLst>
         </p:spPr>
@@ -11892,7 +11892,7 @@
           </a:prstGeom>
           <a:extLst>
             <a:ext uri="{C572A759-6A51-4108-AA02-DFA0A04FC94B}">
-              <ma14:wrappingTextBoxFlag xmlns:ma14="http://schemas.microsoft.com/office/mac/drawingml/2011/main" xmlns="" val="0"/>
+              <ma14:wrappingTextBoxFlag xmlns="" xmlns:ma14="http://schemas.microsoft.com/office/mac/drawingml/2011/main" val="0"/>
             </a:ext>
           </a:extLst>
         </p:spPr>
@@ -13655,7 +13655,7 @@
           </a:prstGeom>
           <a:extLst>
             <a:ext uri="{C572A759-6A51-4108-AA02-DFA0A04FC94B}">
-              <ma14:wrappingTextBoxFlag xmlns:ma14="http://schemas.microsoft.com/office/mac/drawingml/2011/main" xmlns="" val="0"/>
+              <ma14:wrappingTextBoxFlag xmlns="" xmlns:ma14="http://schemas.microsoft.com/office/mac/drawingml/2011/main" val="0"/>
             </a:ext>
           </a:extLst>
         </p:spPr>
@@ -14986,7 +14986,7 @@
           </a:prstGeom>
           <a:extLst>
             <a:ext uri="{C572A759-6A51-4108-AA02-DFA0A04FC94B}">
-              <ma14:wrappingTextBoxFlag xmlns:ma14="http://schemas.microsoft.com/office/mac/drawingml/2011/main" xmlns="" val="0"/>
+              <ma14:wrappingTextBoxFlag xmlns="" xmlns:ma14="http://schemas.microsoft.com/office/mac/drawingml/2011/main" val="0"/>
             </a:ext>
           </a:extLst>
         </p:spPr>
@@ -16608,7 +16608,7 @@
           </a:prstGeom>
           <a:extLst>
             <a:ext uri="{C572A759-6A51-4108-AA02-DFA0A04FC94B}">
-              <ma14:wrappingTextBoxFlag xmlns:ma14="http://schemas.microsoft.com/office/mac/drawingml/2011/main" xmlns="" val="0"/>
+              <ma14:wrappingTextBoxFlag xmlns="" xmlns:ma14="http://schemas.microsoft.com/office/mac/drawingml/2011/main" val="0"/>
             </a:ext>
           </a:extLst>
         </p:spPr>
@@ -17789,7 +17789,7 @@
           </a:prstGeom>
           <a:extLst>
             <a:ext uri="{C572A759-6A51-4108-AA02-DFA0A04FC94B}">
-              <ma14:wrappingTextBoxFlag xmlns:ma14="http://schemas.microsoft.com/office/mac/drawingml/2011/main" xmlns="" val="0"/>
+              <ma14:wrappingTextBoxFlag xmlns="" xmlns:ma14="http://schemas.microsoft.com/office/mac/drawingml/2011/main" val="0"/>
             </a:ext>
           </a:extLst>
         </p:spPr>
@@ -18981,7 +18981,7 @@
           </a:prstGeom>
           <a:extLst>
             <a:ext uri="{C572A759-6A51-4108-AA02-DFA0A04FC94B}">
-              <ma14:wrappingTextBoxFlag xmlns:ma14="http://schemas.microsoft.com/office/mac/drawingml/2011/main" xmlns="" val="0"/>
+              <ma14:wrappingTextBoxFlag xmlns="" xmlns:ma14="http://schemas.microsoft.com/office/mac/drawingml/2011/main" val="0"/>
             </a:ext>
           </a:extLst>
         </p:spPr>
@@ -21303,7 +21303,7 @@
           </a:prstGeom>
           <a:extLst>
             <a:ext uri="{C572A759-6A51-4108-AA02-DFA0A04FC94B}">
-              <ma14:wrappingTextBoxFlag xmlns:ma14="http://schemas.microsoft.com/office/mac/drawingml/2011/main" xmlns="" val="0"/>
+              <ma14:wrappingTextBoxFlag xmlns="" xmlns:ma14="http://schemas.microsoft.com/office/mac/drawingml/2011/main" val="0"/>
             </a:ext>
           </a:extLst>
         </p:spPr>
@@ -24385,7 +24385,7 @@
           </a:prstGeom>
           <a:extLst>
             <a:ext uri="{C572A759-6A51-4108-AA02-DFA0A04FC94B}">
-              <ma14:wrappingTextBoxFlag xmlns:ma14="http://schemas.microsoft.com/office/mac/drawingml/2011/main" xmlns="" val="0"/>
+              <ma14:wrappingTextBoxFlag xmlns="" xmlns:ma14="http://schemas.microsoft.com/office/mac/drawingml/2011/main" val="0"/>
             </a:ext>
           </a:extLst>
         </p:spPr>
@@ -25473,7 +25473,7 @@
           </a:prstGeom>
           <a:extLst>
             <a:ext uri="{C572A759-6A51-4108-AA02-DFA0A04FC94B}">
-              <ma14:wrappingTextBoxFlag xmlns:ma14="http://schemas.microsoft.com/office/mac/drawingml/2011/main" xmlns="" val="0"/>
+              <ma14:wrappingTextBoxFlag xmlns="" xmlns:ma14="http://schemas.microsoft.com/office/mac/drawingml/2011/main" val="0"/>
             </a:ext>
           </a:extLst>
         </p:spPr>
@@ -26628,7 +26628,7 @@
           </a:prstGeom>
           <a:extLst>
             <a:ext uri="{C572A759-6A51-4108-AA02-DFA0A04FC94B}">
-              <ma14:wrappingTextBoxFlag xmlns:ma14="http://schemas.microsoft.com/office/mac/drawingml/2011/main" xmlns="" val="0"/>
+              <ma14:wrappingTextBoxFlag xmlns="" xmlns:ma14="http://schemas.microsoft.com/office/mac/drawingml/2011/main" val="0"/>
             </a:ext>
           </a:extLst>
         </p:spPr>
@@ -28043,7 +28043,7 @@
           </a:prstGeom>
           <a:extLst>
             <a:ext uri="{C572A759-6A51-4108-AA02-DFA0A04FC94B}">
-              <ma14:wrappingTextBoxFlag xmlns:ma14="http://schemas.microsoft.com/office/mac/drawingml/2011/main" xmlns="" val="0"/>
+              <ma14:wrappingTextBoxFlag xmlns="" xmlns:ma14="http://schemas.microsoft.com/office/mac/drawingml/2011/main" val="0"/>
             </a:ext>
           </a:extLst>
         </p:spPr>
@@ -29030,7 +29030,7 @@
           </a:prstGeom>
           <a:extLst>
             <a:ext uri="{C572A759-6A51-4108-AA02-DFA0A04FC94B}">
-              <ma14:wrappingTextBoxFlag xmlns:ma14="http://schemas.microsoft.com/office/mac/drawingml/2011/main" xmlns="" val="0"/>
+              <ma14:wrappingTextBoxFlag xmlns="" xmlns:ma14="http://schemas.microsoft.com/office/mac/drawingml/2011/main" val="0"/>
             </a:ext>
           </a:extLst>
         </p:spPr>
@@ -30418,7 +30418,7 @@
           </a:prstGeom>
           <a:extLst>
             <a:ext uri="{C572A759-6A51-4108-AA02-DFA0A04FC94B}">
-              <ma14:wrappingTextBoxFlag xmlns:ma14="http://schemas.microsoft.com/office/mac/drawingml/2011/main" xmlns="" val="0"/>
+              <ma14:wrappingTextBoxFlag xmlns="" xmlns:ma14="http://schemas.microsoft.com/office/mac/drawingml/2011/main" val="0"/>
             </a:ext>
           </a:extLst>
         </p:spPr>

</xml_diff>

<commit_message>
Update presenter title on slide 1
Append @ Microsoft to the Principal Solution Engineer title beneath the workshop repository URL.

Co-authored-by: Copilot <223556219+Copilot@users.noreply.github.com>
Copilot-Session: aa1a2148-b4d0-4cc5-94ea-497594b4b72a
</commit_message>
<xml_diff>
--- a/docs/foundry-apim-mcp-workshop.pptx
+++ b/docs/foundry-apim-mcp-workshop.pptx
@@ -2201,7 +2201,7 @@
           </a:prstGeom>
           <a:extLst>
             <a:ext uri="{C572A759-6A51-4108-AA02-DFA0A04FC94B}">
-              <ma14:wrappingTextBoxFlag xmlns="" xmlns:ma14="http://schemas.microsoft.com/office/mac/drawingml/2011/main" val="0"/>
+              <ma14:wrappingTextBoxFlag xmlns:ma14="http://schemas.microsoft.com/office/mac/drawingml/2011/main" xmlns="" val="0"/>
             </a:ext>
           </a:extLst>
         </p:spPr>
@@ -2279,7 +2279,7 @@
           </a:prstGeom>
           <a:extLst>
             <a:ext uri="{C572A759-6A51-4108-AA02-DFA0A04FC94B}">
-              <ma14:wrappingTextBoxFlag xmlns="" xmlns:ma14="http://schemas.microsoft.com/office/mac/drawingml/2011/main" val="0"/>
+              <ma14:wrappingTextBoxFlag xmlns:ma14="http://schemas.microsoft.com/office/mac/drawingml/2011/main" xmlns="" val="0"/>
             </a:ext>
           </a:extLst>
         </p:spPr>
@@ -3305,7 +3305,7 @@
         <p:spPr>
           <a:xfrm>
             <a:off x="1739900" y="5918200"/>
-            <a:ext cx="4318000" cy="200660"/>
+            <a:ext cx="4953000" cy="200660"/>
           </a:xfrm>
           <a:prstGeom prst="rect">
             <a:avLst/>
@@ -3340,7 +3340,7 @@
                 <a:ea typeface="Aptos" pitchFamily="34" charset="-122"/>
                 <a:cs typeface="Aptos" pitchFamily="34" charset="-120"/>
               </a:rPr>
-              <a:t> | Principal Solution Engineer</a:t>
+              <a:t> | Principal Solution Engineer @ Microsoft</a:t>
             </a:r>
             <a:endParaRPr lang="en-US" sz="1050" dirty="0">
               <a:solidFill>
@@ -4945,7 +4945,7 @@
           </a:prstGeom>
           <a:extLst>
             <a:ext uri="{C572A759-6A51-4108-AA02-DFA0A04FC94B}">
-              <ma14:wrappingTextBoxFlag xmlns="" xmlns:ma14="http://schemas.microsoft.com/office/mac/drawingml/2011/main" val="0"/>
+              <ma14:wrappingTextBoxFlag xmlns:ma14="http://schemas.microsoft.com/office/mac/drawingml/2011/main" xmlns="" val="0"/>
             </a:ext>
           </a:extLst>
         </p:spPr>
@@ -5903,7 +5903,7 @@
           </a:prstGeom>
           <a:extLst>
             <a:ext uri="{C572A759-6A51-4108-AA02-DFA0A04FC94B}">
-              <ma14:wrappingTextBoxFlag xmlns="" xmlns:ma14="http://schemas.microsoft.com/office/mac/drawingml/2011/main" val="0"/>
+              <ma14:wrappingTextBoxFlag xmlns:ma14="http://schemas.microsoft.com/office/mac/drawingml/2011/main" xmlns="" val="0"/>
             </a:ext>
           </a:extLst>
         </p:spPr>
@@ -7119,7 +7119,7 @@
           </a:prstGeom>
           <a:extLst>
             <a:ext uri="{C572A759-6A51-4108-AA02-DFA0A04FC94B}">
-              <ma14:wrappingTextBoxFlag xmlns="" xmlns:ma14="http://schemas.microsoft.com/office/mac/drawingml/2011/main" val="0"/>
+              <ma14:wrappingTextBoxFlag xmlns:ma14="http://schemas.microsoft.com/office/mac/drawingml/2011/main" xmlns="" val="0"/>
             </a:ext>
           </a:extLst>
         </p:spPr>
@@ -8235,7 +8235,7 @@
           </a:prstGeom>
           <a:extLst>
             <a:ext uri="{C572A759-6A51-4108-AA02-DFA0A04FC94B}">
-              <ma14:wrappingTextBoxFlag xmlns="" xmlns:ma14="http://schemas.microsoft.com/office/mac/drawingml/2011/main" val="0"/>
+              <ma14:wrappingTextBoxFlag xmlns:ma14="http://schemas.microsoft.com/office/mac/drawingml/2011/main" xmlns="" val="0"/>
             </a:ext>
           </a:extLst>
         </p:spPr>
@@ -9653,7 +9653,7 @@
           </a:prstGeom>
           <a:extLst>
             <a:ext uri="{C572A759-6A51-4108-AA02-DFA0A04FC94B}">
-              <ma14:wrappingTextBoxFlag xmlns="" xmlns:ma14="http://schemas.microsoft.com/office/mac/drawingml/2011/main" val="0"/>
+              <ma14:wrappingTextBoxFlag xmlns:ma14="http://schemas.microsoft.com/office/mac/drawingml/2011/main" xmlns="" val="0"/>
             </a:ext>
           </a:extLst>
         </p:spPr>
@@ -10671,7 +10671,7 @@
           </a:prstGeom>
           <a:extLst>
             <a:ext uri="{C572A759-6A51-4108-AA02-DFA0A04FC94B}">
-              <ma14:wrappingTextBoxFlag xmlns="" xmlns:ma14="http://schemas.microsoft.com/office/mac/drawingml/2011/main" val="0"/>
+              <ma14:wrappingTextBoxFlag xmlns:ma14="http://schemas.microsoft.com/office/mac/drawingml/2011/main" xmlns="" val="0"/>
             </a:ext>
           </a:extLst>
         </p:spPr>
@@ -11892,7 +11892,7 @@
           </a:prstGeom>
           <a:extLst>
             <a:ext uri="{C572A759-6A51-4108-AA02-DFA0A04FC94B}">
-              <ma14:wrappingTextBoxFlag xmlns="" xmlns:ma14="http://schemas.microsoft.com/office/mac/drawingml/2011/main" val="0"/>
+              <ma14:wrappingTextBoxFlag xmlns:ma14="http://schemas.microsoft.com/office/mac/drawingml/2011/main" xmlns="" val="0"/>
             </a:ext>
           </a:extLst>
         </p:spPr>
@@ -13655,7 +13655,7 @@
           </a:prstGeom>
           <a:extLst>
             <a:ext uri="{C572A759-6A51-4108-AA02-DFA0A04FC94B}">
-              <ma14:wrappingTextBoxFlag xmlns="" xmlns:ma14="http://schemas.microsoft.com/office/mac/drawingml/2011/main" val="0"/>
+              <ma14:wrappingTextBoxFlag xmlns:ma14="http://schemas.microsoft.com/office/mac/drawingml/2011/main" xmlns="" val="0"/>
             </a:ext>
           </a:extLst>
         </p:spPr>
@@ -14986,7 +14986,7 @@
           </a:prstGeom>
           <a:extLst>
             <a:ext uri="{C572A759-6A51-4108-AA02-DFA0A04FC94B}">
-              <ma14:wrappingTextBoxFlag xmlns="" xmlns:ma14="http://schemas.microsoft.com/office/mac/drawingml/2011/main" val="0"/>
+              <ma14:wrappingTextBoxFlag xmlns:ma14="http://schemas.microsoft.com/office/mac/drawingml/2011/main" xmlns="" val="0"/>
             </a:ext>
           </a:extLst>
         </p:spPr>
@@ -16608,7 +16608,7 @@
           </a:prstGeom>
           <a:extLst>
             <a:ext uri="{C572A759-6A51-4108-AA02-DFA0A04FC94B}">
-              <ma14:wrappingTextBoxFlag xmlns="" xmlns:ma14="http://schemas.microsoft.com/office/mac/drawingml/2011/main" val="0"/>
+              <ma14:wrappingTextBoxFlag xmlns:ma14="http://schemas.microsoft.com/office/mac/drawingml/2011/main" xmlns="" val="0"/>
             </a:ext>
           </a:extLst>
         </p:spPr>
@@ -17789,7 +17789,7 @@
           </a:prstGeom>
           <a:extLst>
             <a:ext uri="{C572A759-6A51-4108-AA02-DFA0A04FC94B}">
-              <ma14:wrappingTextBoxFlag xmlns="" xmlns:ma14="http://schemas.microsoft.com/office/mac/drawingml/2011/main" val="0"/>
+              <ma14:wrappingTextBoxFlag xmlns:ma14="http://schemas.microsoft.com/office/mac/drawingml/2011/main" xmlns="" val="0"/>
             </a:ext>
           </a:extLst>
         </p:spPr>
@@ -18981,7 +18981,7 @@
           </a:prstGeom>
           <a:extLst>
             <a:ext uri="{C572A759-6A51-4108-AA02-DFA0A04FC94B}">
-              <ma14:wrappingTextBoxFlag xmlns="" xmlns:ma14="http://schemas.microsoft.com/office/mac/drawingml/2011/main" val="0"/>
+              <ma14:wrappingTextBoxFlag xmlns:ma14="http://schemas.microsoft.com/office/mac/drawingml/2011/main" xmlns="" val="0"/>
             </a:ext>
           </a:extLst>
         </p:spPr>
@@ -21303,7 +21303,7 @@
           </a:prstGeom>
           <a:extLst>
             <a:ext uri="{C572A759-6A51-4108-AA02-DFA0A04FC94B}">
-              <ma14:wrappingTextBoxFlag xmlns="" xmlns:ma14="http://schemas.microsoft.com/office/mac/drawingml/2011/main" val="0"/>
+              <ma14:wrappingTextBoxFlag xmlns:ma14="http://schemas.microsoft.com/office/mac/drawingml/2011/main" xmlns="" val="0"/>
             </a:ext>
           </a:extLst>
         </p:spPr>
@@ -24385,7 +24385,7 @@
           </a:prstGeom>
           <a:extLst>
             <a:ext uri="{C572A759-6A51-4108-AA02-DFA0A04FC94B}">
-              <ma14:wrappingTextBoxFlag xmlns="" xmlns:ma14="http://schemas.microsoft.com/office/mac/drawingml/2011/main" val="0"/>
+              <ma14:wrappingTextBoxFlag xmlns:ma14="http://schemas.microsoft.com/office/mac/drawingml/2011/main" xmlns="" val="0"/>
             </a:ext>
           </a:extLst>
         </p:spPr>
@@ -25473,7 +25473,7 @@
           </a:prstGeom>
           <a:extLst>
             <a:ext uri="{C572A759-6A51-4108-AA02-DFA0A04FC94B}">
-              <ma14:wrappingTextBoxFlag xmlns="" xmlns:ma14="http://schemas.microsoft.com/office/mac/drawingml/2011/main" val="0"/>
+              <ma14:wrappingTextBoxFlag xmlns:ma14="http://schemas.microsoft.com/office/mac/drawingml/2011/main" xmlns="" val="0"/>
             </a:ext>
           </a:extLst>
         </p:spPr>
@@ -26628,7 +26628,7 @@
           </a:prstGeom>
           <a:extLst>
             <a:ext uri="{C572A759-6A51-4108-AA02-DFA0A04FC94B}">
-              <ma14:wrappingTextBoxFlag xmlns="" xmlns:ma14="http://schemas.microsoft.com/office/mac/drawingml/2011/main" val="0"/>
+              <ma14:wrappingTextBoxFlag xmlns:ma14="http://schemas.microsoft.com/office/mac/drawingml/2011/main" xmlns="" val="0"/>
             </a:ext>
           </a:extLst>
         </p:spPr>
@@ -28043,7 +28043,7 @@
           </a:prstGeom>
           <a:extLst>
             <a:ext uri="{C572A759-6A51-4108-AA02-DFA0A04FC94B}">
-              <ma14:wrappingTextBoxFlag xmlns="" xmlns:ma14="http://schemas.microsoft.com/office/mac/drawingml/2011/main" val="0"/>
+              <ma14:wrappingTextBoxFlag xmlns:ma14="http://schemas.microsoft.com/office/mac/drawingml/2011/main" xmlns="" val="0"/>
             </a:ext>
           </a:extLst>
         </p:spPr>
@@ -29030,7 +29030,7 @@
           </a:prstGeom>
           <a:extLst>
             <a:ext uri="{C572A759-6A51-4108-AA02-DFA0A04FC94B}">
-              <ma14:wrappingTextBoxFlag xmlns="" xmlns:ma14="http://schemas.microsoft.com/office/mac/drawingml/2011/main" val="0"/>
+              <ma14:wrappingTextBoxFlag xmlns:ma14="http://schemas.microsoft.com/office/mac/drawingml/2011/main" xmlns="" val="0"/>
             </a:ext>
           </a:extLst>
         </p:spPr>
@@ -30418,7 +30418,7 @@
           </a:prstGeom>
           <a:extLst>
             <a:ext uri="{C572A759-6A51-4108-AA02-DFA0A04FC94B}">
-              <ma14:wrappingTextBoxFlag xmlns="" xmlns:ma14="http://schemas.microsoft.com/office/mac/drawingml/2011/main" val="0"/>
+              <ma14:wrappingTextBoxFlag xmlns:ma14="http://schemas.microsoft.com/office/mac/drawingml/2011/main" xmlns="" val="0"/>
             </a:ext>
           </a:extLst>
         </p:spPr>

</xml_diff>

<commit_message>
Enlarge title slide repository URL
Increase the workshop vanity URL by two points and shift the repository label and URL upward to preserve spacing above the presenter line.

Co-authored-by: Copilot <223556219+Copilot@users.noreply.github.com>
Copilot-Session: aa1a2148-b4d0-4cc5-94ea-497594b4b72a
</commit_message>
<xml_diff>
--- a/docs/foundry-apim-mcp-workshop.pptx
+++ b/docs/foundry-apim-mcp-workshop.pptx
@@ -2201,7 +2201,7 @@
           </a:prstGeom>
           <a:extLst>
             <a:ext uri="{C572A759-6A51-4108-AA02-DFA0A04FC94B}">
-              <ma14:wrappingTextBoxFlag xmlns:ma14="http://schemas.microsoft.com/office/mac/drawingml/2011/main" xmlns="" val="0"/>
+              <ma14:wrappingTextBoxFlag xmlns="" xmlns:ma14="http://schemas.microsoft.com/office/mac/drawingml/2011/main" val="0"/>
             </a:ext>
           </a:extLst>
         </p:spPr>
@@ -2279,7 +2279,7 @@
           </a:prstGeom>
           <a:extLst>
             <a:ext uri="{C572A759-6A51-4108-AA02-DFA0A04FC94B}">
-              <ma14:wrappingTextBoxFlag xmlns:ma14="http://schemas.microsoft.com/office/mac/drawingml/2011/main" xmlns="" val="0"/>
+              <ma14:wrappingTextBoxFlag xmlns="" xmlns:ma14="http://schemas.microsoft.com/office/mac/drawingml/2011/main" val="0"/>
             </a:ext>
           </a:extLst>
         </p:spPr>
@@ -3223,7 +3223,7 @@
         </p:nvSpPr>
         <p:spPr>
           <a:xfrm>
-            <a:off x="1739900" y="5334000"/>
+            <a:off x="1739900" y="5283200"/>
             <a:ext cx="2286000" cy="138499"/>
           </a:xfrm>
           <a:prstGeom prst="rect">
@@ -3264,8 +3264,8 @@
         </p:nvSpPr>
         <p:spPr>
           <a:xfrm>
-            <a:off x="1739900" y="5600700"/>
-            <a:ext cx="2413000" cy="215444"/>
+            <a:off x="1739900" y="5562600"/>
+            <a:ext cx="2794000" cy="254000"/>
           </a:xfrm>
           <a:prstGeom prst="rect">
             <a:avLst/>
@@ -3279,7 +3279,7 @@
           <a:lstStyle/>
           <a:p>
             <a:r>
-              <a:rPr lang="en-US" sz="1400" b="1">
+              <a:rPr lang="en-US" sz="1600" b="1">
                 <a:solidFill>
                   <a:srgbClr val="FFFFFF"/>
                 </a:solidFill>
@@ -4945,7 +4945,7 @@
           </a:prstGeom>
           <a:extLst>
             <a:ext uri="{C572A759-6A51-4108-AA02-DFA0A04FC94B}">
-              <ma14:wrappingTextBoxFlag xmlns:ma14="http://schemas.microsoft.com/office/mac/drawingml/2011/main" xmlns="" val="0"/>
+              <ma14:wrappingTextBoxFlag xmlns="" xmlns:ma14="http://schemas.microsoft.com/office/mac/drawingml/2011/main" val="0"/>
             </a:ext>
           </a:extLst>
         </p:spPr>
@@ -5903,7 +5903,7 @@
           </a:prstGeom>
           <a:extLst>
             <a:ext uri="{C572A759-6A51-4108-AA02-DFA0A04FC94B}">
-              <ma14:wrappingTextBoxFlag xmlns:ma14="http://schemas.microsoft.com/office/mac/drawingml/2011/main" xmlns="" val="0"/>
+              <ma14:wrappingTextBoxFlag xmlns="" xmlns:ma14="http://schemas.microsoft.com/office/mac/drawingml/2011/main" val="0"/>
             </a:ext>
           </a:extLst>
         </p:spPr>
@@ -7119,7 +7119,7 @@
           </a:prstGeom>
           <a:extLst>
             <a:ext uri="{C572A759-6A51-4108-AA02-DFA0A04FC94B}">
-              <ma14:wrappingTextBoxFlag xmlns:ma14="http://schemas.microsoft.com/office/mac/drawingml/2011/main" xmlns="" val="0"/>
+              <ma14:wrappingTextBoxFlag xmlns="" xmlns:ma14="http://schemas.microsoft.com/office/mac/drawingml/2011/main" val="0"/>
             </a:ext>
           </a:extLst>
         </p:spPr>
@@ -8235,7 +8235,7 @@
           </a:prstGeom>
           <a:extLst>
             <a:ext uri="{C572A759-6A51-4108-AA02-DFA0A04FC94B}">
-              <ma14:wrappingTextBoxFlag xmlns:ma14="http://schemas.microsoft.com/office/mac/drawingml/2011/main" xmlns="" val="0"/>
+              <ma14:wrappingTextBoxFlag xmlns="" xmlns:ma14="http://schemas.microsoft.com/office/mac/drawingml/2011/main" val="0"/>
             </a:ext>
           </a:extLst>
         </p:spPr>
@@ -9653,7 +9653,7 @@
           </a:prstGeom>
           <a:extLst>
             <a:ext uri="{C572A759-6A51-4108-AA02-DFA0A04FC94B}">
-              <ma14:wrappingTextBoxFlag xmlns:ma14="http://schemas.microsoft.com/office/mac/drawingml/2011/main" xmlns="" val="0"/>
+              <ma14:wrappingTextBoxFlag xmlns="" xmlns:ma14="http://schemas.microsoft.com/office/mac/drawingml/2011/main" val="0"/>
             </a:ext>
           </a:extLst>
         </p:spPr>
@@ -10671,7 +10671,7 @@
           </a:prstGeom>
           <a:extLst>
             <a:ext uri="{C572A759-6A51-4108-AA02-DFA0A04FC94B}">
-              <ma14:wrappingTextBoxFlag xmlns:ma14="http://schemas.microsoft.com/office/mac/drawingml/2011/main" xmlns="" val="0"/>
+              <ma14:wrappingTextBoxFlag xmlns="" xmlns:ma14="http://schemas.microsoft.com/office/mac/drawingml/2011/main" val="0"/>
             </a:ext>
           </a:extLst>
         </p:spPr>
@@ -11892,7 +11892,7 @@
           </a:prstGeom>
           <a:extLst>
             <a:ext uri="{C572A759-6A51-4108-AA02-DFA0A04FC94B}">
-              <ma14:wrappingTextBoxFlag xmlns:ma14="http://schemas.microsoft.com/office/mac/drawingml/2011/main" xmlns="" val="0"/>
+              <ma14:wrappingTextBoxFlag xmlns="" xmlns:ma14="http://schemas.microsoft.com/office/mac/drawingml/2011/main" val="0"/>
             </a:ext>
           </a:extLst>
         </p:spPr>
@@ -13655,7 +13655,7 @@
           </a:prstGeom>
           <a:extLst>
             <a:ext uri="{C572A759-6A51-4108-AA02-DFA0A04FC94B}">
-              <ma14:wrappingTextBoxFlag xmlns:ma14="http://schemas.microsoft.com/office/mac/drawingml/2011/main" xmlns="" val="0"/>
+              <ma14:wrappingTextBoxFlag xmlns="" xmlns:ma14="http://schemas.microsoft.com/office/mac/drawingml/2011/main" val="0"/>
             </a:ext>
           </a:extLst>
         </p:spPr>
@@ -14986,7 +14986,7 @@
           </a:prstGeom>
           <a:extLst>
             <a:ext uri="{C572A759-6A51-4108-AA02-DFA0A04FC94B}">
-              <ma14:wrappingTextBoxFlag xmlns:ma14="http://schemas.microsoft.com/office/mac/drawingml/2011/main" xmlns="" val="0"/>
+              <ma14:wrappingTextBoxFlag xmlns="" xmlns:ma14="http://schemas.microsoft.com/office/mac/drawingml/2011/main" val="0"/>
             </a:ext>
           </a:extLst>
         </p:spPr>
@@ -16608,7 +16608,7 @@
           </a:prstGeom>
           <a:extLst>
             <a:ext uri="{C572A759-6A51-4108-AA02-DFA0A04FC94B}">
-              <ma14:wrappingTextBoxFlag xmlns:ma14="http://schemas.microsoft.com/office/mac/drawingml/2011/main" xmlns="" val="0"/>
+              <ma14:wrappingTextBoxFlag xmlns="" xmlns:ma14="http://schemas.microsoft.com/office/mac/drawingml/2011/main" val="0"/>
             </a:ext>
           </a:extLst>
         </p:spPr>
@@ -17789,7 +17789,7 @@
           </a:prstGeom>
           <a:extLst>
             <a:ext uri="{C572A759-6A51-4108-AA02-DFA0A04FC94B}">
-              <ma14:wrappingTextBoxFlag xmlns:ma14="http://schemas.microsoft.com/office/mac/drawingml/2011/main" xmlns="" val="0"/>
+              <ma14:wrappingTextBoxFlag xmlns="" xmlns:ma14="http://schemas.microsoft.com/office/mac/drawingml/2011/main" val="0"/>
             </a:ext>
           </a:extLst>
         </p:spPr>
@@ -18981,7 +18981,7 @@
           </a:prstGeom>
           <a:extLst>
             <a:ext uri="{C572A759-6A51-4108-AA02-DFA0A04FC94B}">
-              <ma14:wrappingTextBoxFlag xmlns:ma14="http://schemas.microsoft.com/office/mac/drawingml/2011/main" xmlns="" val="0"/>
+              <ma14:wrappingTextBoxFlag xmlns="" xmlns:ma14="http://schemas.microsoft.com/office/mac/drawingml/2011/main" val="0"/>
             </a:ext>
           </a:extLst>
         </p:spPr>
@@ -21303,7 +21303,7 @@
           </a:prstGeom>
           <a:extLst>
             <a:ext uri="{C572A759-6A51-4108-AA02-DFA0A04FC94B}">
-              <ma14:wrappingTextBoxFlag xmlns:ma14="http://schemas.microsoft.com/office/mac/drawingml/2011/main" xmlns="" val="0"/>
+              <ma14:wrappingTextBoxFlag xmlns="" xmlns:ma14="http://schemas.microsoft.com/office/mac/drawingml/2011/main" val="0"/>
             </a:ext>
           </a:extLst>
         </p:spPr>
@@ -24385,7 +24385,7 @@
           </a:prstGeom>
           <a:extLst>
             <a:ext uri="{C572A759-6A51-4108-AA02-DFA0A04FC94B}">
-              <ma14:wrappingTextBoxFlag xmlns:ma14="http://schemas.microsoft.com/office/mac/drawingml/2011/main" xmlns="" val="0"/>
+              <ma14:wrappingTextBoxFlag xmlns="" xmlns:ma14="http://schemas.microsoft.com/office/mac/drawingml/2011/main" val="0"/>
             </a:ext>
           </a:extLst>
         </p:spPr>
@@ -25473,7 +25473,7 @@
           </a:prstGeom>
           <a:extLst>
             <a:ext uri="{C572A759-6A51-4108-AA02-DFA0A04FC94B}">
-              <ma14:wrappingTextBoxFlag xmlns:ma14="http://schemas.microsoft.com/office/mac/drawingml/2011/main" xmlns="" val="0"/>
+              <ma14:wrappingTextBoxFlag xmlns="" xmlns:ma14="http://schemas.microsoft.com/office/mac/drawingml/2011/main" val="0"/>
             </a:ext>
           </a:extLst>
         </p:spPr>
@@ -26628,7 +26628,7 @@
           </a:prstGeom>
           <a:extLst>
             <a:ext uri="{C572A759-6A51-4108-AA02-DFA0A04FC94B}">
-              <ma14:wrappingTextBoxFlag xmlns:ma14="http://schemas.microsoft.com/office/mac/drawingml/2011/main" xmlns="" val="0"/>
+              <ma14:wrappingTextBoxFlag xmlns="" xmlns:ma14="http://schemas.microsoft.com/office/mac/drawingml/2011/main" val="0"/>
             </a:ext>
           </a:extLst>
         </p:spPr>
@@ -28043,7 +28043,7 @@
           </a:prstGeom>
           <a:extLst>
             <a:ext uri="{C572A759-6A51-4108-AA02-DFA0A04FC94B}">
-              <ma14:wrappingTextBoxFlag xmlns:ma14="http://schemas.microsoft.com/office/mac/drawingml/2011/main" xmlns="" val="0"/>
+              <ma14:wrappingTextBoxFlag xmlns="" xmlns:ma14="http://schemas.microsoft.com/office/mac/drawingml/2011/main" val="0"/>
             </a:ext>
           </a:extLst>
         </p:spPr>
@@ -29030,7 +29030,7 @@
           </a:prstGeom>
           <a:extLst>
             <a:ext uri="{C572A759-6A51-4108-AA02-DFA0A04FC94B}">
-              <ma14:wrappingTextBoxFlag xmlns:ma14="http://schemas.microsoft.com/office/mac/drawingml/2011/main" xmlns="" val="0"/>
+              <ma14:wrappingTextBoxFlag xmlns="" xmlns:ma14="http://schemas.microsoft.com/office/mac/drawingml/2011/main" val="0"/>
             </a:ext>
           </a:extLst>
         </p:spPr>
@@ -30418,7 +30418,7 @@
           </a:prstGeom>
           <a:extLst>
             <a:ext uri="{C572A759-6A51-4108-AA02-DFA0A04FC94B}">
-              <ma14:wrappingTextBoxFlag xmlns:ma14="http://schemas.microsoft.com/office/mac/drawingml/2011/main" xmlns="" val="0"/>
+              <ma14:wrappingTextBoxFlag xmlns="" xmlns:ma14="http://schemas.microsoft.com/office/mac/drawingml/2011/main" val="0"/>
             </a:ext>
           </a:extLst>
         </p:spPr>

</xml_diff>

<commit_message>
Increase title slide repository URL again
Raise the workshop vanity URL to 18 points and move it slightly upward to retain spacing above the presenter line.

Co-authored-by: Copilot <223556219+Copilot@users.noreply.github.com>
Copilot-Session: aa1a2148-b4d0-4cc5-94ea-497594b4b72a
</commit_message>
<xml_diff>
--- a/docs/foundry-apim-mcp-workshop.pptx
+++ b/docs/foundry-apim-mcp-workshop.pptx
@@ -2201,7 +2201,7 @@
           </a:prstGeom>
           <a:extLst>
             <a:ext uri="{C572A759-6A51-4108-AA02-DFA0A04FC94B}">
-              <ma14:wrappingTextBoxFlag xmlns="" xmlns:ma14="http://schemas.microsoft.com/office/mac/drawingml/2011/main" val="0"/>
+              <ma14:wrappingTextBoxFlag xmlns:ma14="http://schemas.microsoft.com/office/mac/drawingml/2011/main" xmlns="" val="0"/>
             </a:ext>
           </a:extLst>
         </p:spPr>
@@ -2279,7 +2279,7 @@
           </a:prstGeom>
           <a:extLst>
             <a:ext uri="{C572A759-6A51-4108-AA02-DFA0A04FC94B}">
-              <ma14:wrappingTextBoxFlag xmlns="" xmlns:ma14="http://schemas.microsoft.com/office/mac/drawingml/2011/main" val="0"/>
+              <ma14:wrappingTextBoxFlag xmlns:ma14="http://schemas.microsoft.com/office/mac/drawingml/2011/main" xmlns="" val="0"/>
             </a:ext>
           </a:extLst>
         </p:spPr>
@@ -3264,8 +3264,8 @@
         </p:nvSpPr>
         <p:spPr>
           <a:xfrm>
-            <a:off x="1739900" y="5562600"/>
-            <a:ext cx="2794000" cy="254000"/>
+            <a:off x="1739900" y="5537200"/>
+            <a:ext cx="3048000" cy="276999"/>
           </a:xfrm>
           <a:prstGeom prst="rect">
             <a:avLst/>
@@ -3279,7 +3279,7 @@
           <a:lstStyle/>
           <a:p>
             <a:r>
-              <a:rPr lang="en-US" sz="1600" b="1">
+              <a:rPr lang="en-US" b="1">
                 <a:solidFill>
                   <a:srgbClr val="FFFFFF"/>
                 </a:solidFill>
@@ -4945,7 +4945,7 @@
           </a:prstGeom>
           <a:extLst>
             <a:ext uri="{C572A759-6A51-4108-AA02-DFA0A04FC94B}">
-              <ma14:wrappingTextBoxFlag xmlns="" xmlns:ma14="http://schemas.microsoft.com/office/mac/drawingml/2011/main" val="0"/>
+              <ma14:wrappingTextBoxFlag xmlns:ma14="http://schemas.microsoft.com/office/mac/drawingml/2011/main" xmlns="" val="0"/>
             </a:ext>
           </a:extLst>
         </p:spPr>
@@ -5903,7 +5903,7 @@
           </a:prstGeom>
           <a:extLst>
             <a:ext uri="{C572A759-6A51-4108-AA02-DFA0A04FC94B}">
-              <ma14:wrappingTextBoxFlag xmlns="" xmlns:ma14="http://schemas.microsoft.com/office/mac/drawingml/2011/main" val="0"/>
+              <ma14:wrappingTextBoxFlag xmlns:ma14="http://schemas.microsoft.com/office/mac/drawingml/2011/main" xmlns="" val="0"/>
             </a:ext>
           </a:extLst>
         </p:spPr>
@@ -7119,7 +7119,7 @@
           </a:prstGeom>
           <a:extLst>
             <a:ext uri="{C572A759-6A51-4108-AA02-DFA0A04FC94B}">
-              <ma14:wrappingTextBoxFlag xmlns="" xmlns:ma14="http://schemas.microsoft.com/office/mac/drawingml/2011/main" val="0"/>
+              <ma14:wrappingTextBoxFlag xmlns:ma14="http://schemas.microsoft.com/office/mac/drawingml/2011/main" xmlns="" val="0"/>
             </a:ext>
           </a:extLst>
         </p:spPr>
@@ -8235,7 +8235,7 @@
           </a:prstGeom>
           <a:extLst>
             <a:ext uri="{C572A759-6A51-4108-AA02-DFA0A04FC94B}">
-              <ma14:wrappingTextBoxFlag xmlns="" xmlns:ma14="http://schemas.microsoft.com/office/mac/drawingml/2011/main" val="0"/>
+              <ma14:wrappingTextBoxFlag xmlns:ma14="http://schemas.microsoft.com/office/mac/drawingml/2011/main" xmlns="" val="0"/>
             </a:ext>
           </a:extLst>
         </p:spPr>
@@ -9653,7 +9653,7 @@
           </a:prstGeom>
           <a:extLst>
             <a:ext uri="{C572A759-6A51-4108-AA02-DFA0A04FC94B}">
-              <ma14:wrappingTextBoxFlag xmlns="" xmlns:ma14="http://schemas.microsoft.com/office/mac/drawingml/2011/main" val="0"/>
+              <ma14:wrappingTextBoxFlag xmlns:ma14="http://schemas.microsoft.com/office/mac/drawingml/2011/main" xmlns="" val="0"/>
             </a:ext>
           </a:extLst>
         </p:spPr>
@@ -10671,7 +10671,7 @@
           </a:prstGeom>
           <a:extLst>
             <a:ext uri="{C572A759-6A51-4108-AA02-DFA0A04FC94B}">
-              <ma14:wrappingTextBoxFlag xmlns="" xmlns:ma14="http://schemas.microsoft.com/office/mac/drawingml/2011/main" val="0"/>
+              <ma14:wrappingTextBoxFlag xmlns:ma14="http://schemas.microsoft.com/office/mac/drawingml/2011/main" xmlns="" val="0"/>
             </a:ext>
           </a:extLst>
         </p:spPr>
@@ -11892,7 +11892,7 @@
           </a:prstGeom>
           <a:extLst>
             <a:ext uri="{C572A759-6A51-4108-AA02-DFA0A04FC94B}">
-              <ma14:wrappingTextBoxFlag xmlns="" xmlns:ma14="http://schemas.microsoft.com/office/mac/drawingml/2011/main" val="0"/>
+              <ma14:wrappingTextBoxFlag xmlns:ma14="http://schemas.microsoft.com/office/mac/drawingml/2011/main" xmlns="" val="0"/>
             </a:ext>
           </a:extLst>
         </p:spPr>
@@ -13655,7 +13655,7 @@
           </a:prstGeom>
           <a:extLst>
             <a:ext uri="{C572A759-6A51-4108-AA02-DFA0A04FC94B}">
-              <ma14:wrappingTextBoxFlag xmlns="" xmlns:ma14="http://schemas.microsoft.com/office/mac/drawingml/2011/main" val="0"/>
+              <ma14:wrappingTextBoxFlag xmlns:ma14="http://schemas.microsoft.com/office/mac/drawingml/2011/main" xmlns="" val="0"/>
             </a:ext>
           </a:extLst>
         </p:spPr>
@@ -14986,7 +14986,7 @@
           </a:prstGeom>
           <a:extLst>
             <a:ext uri="{C572A759-6A51-4108-AA02-DFA0A04FC94B}">
-              <ma14:wrappingTextBoxFlag xmlns="" xmlns:ma14="http://schemas.microsoft.com/office/mac/drawingml/2011/main" val="0"/>
+              <ma14:wrappingTextBoxFlag xmlns:ma14="http://schemas.microsoft.com/office/mac/drawingml/2011/main" xmlns="" val="0"/>
             </a:ext>
           </a:extLst>
         </p:spPr>
@@ -16608,7 +16608,7 @@
           </a:prstGeom>
           <a:extLst>
             <a:ext uri="{C572A759-6A51-4108-AA02-DFA0A04FC94B}">
-              <ma14:wrappingTextBoxFlag xmlns="" xmlns:ma14="http://schemas.microsoft.com/office/mac/drawingml/2011/main" val="0"/>
+              <ma14:wrappingTextBoxFlag xmlns:ma14="http://schemas.microsoft.com/office/mac/drawingml/2011/main" xmlns="" val="0"/>
             </a:ext>
           </a:extLst>
         </p:spPr>
@@ -17789,7 +17789,7 @@
           </a:prstGeom>
           <a:extLst>
             <a:ext uri="{C572A759-6A51-4108-AA02-DFA0A04FC94B}">
-              <ma14:wrappingTextBoxFlag xmlns="" xmlns:ma14="http://schemas.microsoft.com/office/mac/drawingml/2011/main" val="0"/>
+              <ma14:wrappingTextBoxFlag xmlns:ma14="http://schemas.microsoft.com/office/mac/drawingml/2011/main" xmlns="" val="0"/>
             </a:ext>
           </a:extLst>
         </p:spPr>
@@ -18981,7 +18981,7 @@
           </a:prstGeom>
           <a:extLst>
             <a:ext uri="{C572A759-6A51-4108-AA02-DFA0A04FC94B}">
-              <ma14:wrappingTextBoxFlag xmlns="" xmlns:ma14="http://schemas.microsoft.com/office/mac/drawingml/2011/main" val="0"/>
+              <ma14:wrappingTextBoxFlag xmlns:ma14="http://schemas.microsoft.com/office/mac/drawingml/2011/main" xmlns="" val="0"/>
             </a:ext>
           </a:extLst>
         </p:spPr>
@@ -21303,7 +21303,7 @@
           </a:prstGeom>
           <a:extLst>
             <a:ext uri="{C572A759-6A51-4108-AA02-DFA0A04FC94B}">
-              <ma14:wrappingTextBoxFlag xmlns="" xmlns:ma14="http://schemas.microsoft.com/office/mac/drawingml/2011/main" val="0"/>
+              <ma14:wrappingTextBoxFlag xmlns:ma14="http://schemas.microsoft.com/office/mac/drawingml/2011/main" xmlns="" val="0"/>
             </a:ext>
           </a:extLst>
         </p:spPr>
@@ -24385,7 +24385,7 @@
           </a:prstGeom>
           <a:extLst>
             <a:ext uri="{C572A759-6A51-4108-AA02-DFA0A04FC94B}">
-              <ma14:wrappingTextBoxFlag xmlns="" xmlns:ma14="http://schemas.microsoft.com/office/mac/drawingml/2011/main" val="0"/>
+              <ma14:wrappingTextBoxFlag xmlns:ma14="http://schemas.microsoft.com/office/mac/drawingml/2011/main" xmlns="" val="0"/>
             </a:ext>
           </a:extLst>
         </p:spPr>
@@ -25473,7 +25473,7 @@
           </a:prstGeom>
           <a:extLst>
             <a:ext uri="{C572A759-6A51-4108-AA02-DFA0A04FC94B}">
-              <ma14:wrappingTextBoxFlag xmlns="" xmlns:ma14="http://schemas.microsoft.com/office/mac/drawingml/2011/main" val="0"/>
+              <ma14:wrappingTextBoxFlag xmlns:ma14="http://schemas.microsoft.com/office/mac/drawingml/2011/main" xmlns="" val="0"/>
             </a:ext>
           </a:extLst>
         </p:spPr>
@@ -26628,7 +26628,7 @@
           </a:prstGeom>
           <a:extLst>
             <a:ext uri="{C572A759-6A51-4108-AA02-DFA0A04FC94B}">
-              <ma14:wrappingTextBoxFlag xmlns="" xmlns:ma14="http://schemas.microsoft.com/office/mac/drawingml/2011/main" val="0"/>
+              <ma14:wrappingTextBoxFlag xmlns:ma14="http://schemas.microsoft.com/office/mac/drawingml/2011/main" xmlns="" val="0"/>
             </a:ext>
           </a:extLst>
         </p:spPr>
@@ -28043,7 +28043,7 @@
           </a:prstGeom>
           <a:extLst>
             <a:ext uri="{C572A759-6A51-4108-AA02-DFA0A04FC94B}">
-              <ma14:wrappingTextBoxFlag xmlns="" xmlns:ma14="http://schemas.microsoft.com/office/mac/drawingml/2011/main" val="0"/>
+              <ma14:wrappingTextBoxFlag xmlns:ma14="http://schemas.microsoft.com/office/mac/drawingml/2011/main" xmlns="" val="0"/>
             </a:ext>
           </a:extLst>
         </p:spPr>
@@ -29030,7 +29030,7 @@
           </a:prstGeom>
           <a:extLst>
             <a:ext uri="{C572A759-6A51-4108-AA02-DFA0A04FC94B}">
-              <ma14:wrappingTextBoxFlag xmlns="" xmlns:ma14="http://schemas.microsoft.com/office/mac/drawingml/2011/main" val="0"/>
+              <ma14:wrappingTextBoxFlag xmlns:ma14="http://schemas.microsoft.com/office/mac/drawingml/2011/main" xmlns="" val="0"/>
             </a:ext>
           </a:extLst>
         </p:spPr>
@@ -30418,7 +30418,7 @@
           </a:prstGeom>
           <a:extLst>
             <a:ext uri="{C572A759-6A51-4108-AA02-DFA0A04FC94B}">
-              <ma14:wrappingTextBoxFlag xmlns="" xmlns:ma14="http://schemas.microsoft.com/office/mac/drawingml/2011/main" val="0"/>
+              <ma14:wrappingTextBoxFlag xmlns:ma14="http://schemas.microsoft.com/office/mac/drawingml/2011/main" xmlns="" val="0"/>
             </a:ext>
           </a:extLst>
         </p:spPr>

</xml_diff>